<commit_message>
ARB deck: options comparison, chevron flow rework, component-detail slide
Slide 16 reworked from a vertical list into a horizontal seven-chevron
flow with a technical detail panel under each step. New slide 17
expands the distribution layer into its parts, each badged BUILD /
CONFIG / EXTEND. New slide 21 is the updated options table (B decided
baseline, D proposed recommendation, E noted variant) in the same
green-header style as the original A/B/C slide. Original 14 slides
untouched.

Co-Authored-By: Claude Fable 5 <noreply@anthropic.com>
Claude-Session: https://claude.ai/code/session_01J9sMjqcGkRLhakCptK95KF
</commit_message>
<xml_diff>
--- a/docs/JAMS-WriteBack-Callback-S4-Key-Design-Decision-2.pptx
+++ b/docs/JAMS-WriteBack-Callback-S4-Key-Design-Decision-2.pptx
@@ -23,10 +23,12 @@
     <p:sldId id="269" r:id="rId17"/>
     <p:sldId id="270" r:id="rId18"/>
     <p:sldId id="276" r:id="rId26"/>
-    <p:sldId id="277" r:id="rId27"/>
+    <p:sldId id="283" r:id="rId33"/>
+    <p:sldId id="282" r:id="rId32"/>
     <p:sldId id="278" r:id="rId28"/>
     <p:sldId id="279" r:id="rId29"/>
     <p:sldId id="280" r:id="rId30"/>
+    <p:sldId id="281" r:id="rId31"/>
   </p:sldIdLst>
   <p:sldSz cx="18288000" cy="10287000"/>
   <p:notesSz cx="10287000" cy="18288000"/>
@@ -15052,7 +15054,7 @@
         <p:spPr>
           <a:xfrm>
             <a:off x="640080" y="320040"/>
-            <a:ext cx="13716000" cy="548640"/>
+            <a:ext cx="14630400" cy="548640"/>
           </a:xfrm>
           <a:prstGeom prst="rect">
             <a:avLst/>
@@ -15060,7 +15062,7 @@
           <a:noFill/>
         </p:spPr>
         <p:txBody>
-          <a:bodyPr wrap="square" lIns="0" rIns="0" tIns="0" bIns="0" anchor="t">
+          <a:bodyPr wrap="square" lIns="0" rIns="0" tIns="0" bIns="0">
             <a:spAutoFit/>
           </a:bodyPr>
           <a:lstStyle/>
@@ -15073,7 +15075,7 @@
                 </a:solidFill>
                 <a:latin typeface="Arial"/>
               </a:rPr>
-              <a:t>Option D – How It Works: Seven Steps, the Same for Every Data Set and Every System</a:t>
+              <a:t>Option D – How It Works: One Flow, Seven Steps, Every Data Set and Every System</a:t>
             </a:r>
           </a:p>
         </p:txBody>
@@ -15095,7 +15097,7 @@
           <a:noFill/>
         </p:spPr>
         <p:txBody>
-          <a:bodyPr wrap="square" lIns="0" rIns="0" tIns="0" bIns="0" anchor="t">
+          <a:bodyPr wrap="square" lIns="0" rIns="0" tIns="0" bIns="0">
             <a:spAutoFit/>
           </a:bodyPr>
           <a:lstStyle/>
@@ -15108,24 +15110,26 @@
                 </a:solidFill>
                 <a:latin typeface="Arial"/>
               </a:rPr>
-              <a:t>No special cases. Only step 6’s delivery method differs per system.</a:t>
-            </a:r>
-          </a:p>
-        </p:txBody>
-      </p:sp>
-      <p:sp>
-        <p:nvSpPr>
-          <p:cNvPr id="5" name="Oval 4"/>
-          <p:cNvSpPr/>
-          <p:nvPr/>
-        </p:nvSpPr>
-        <p:spPr>
-          <a:xfrm>
-            <a:off x="731520" y="1600200"/>
-            <a:ext cx="384048" cy="384048"/>
-          </a:xfrm>
-          <a:prstGeom prst="ellipse">
-            <a:avLst/>
+              <a:t>Read left to right. The chevrons are the flow; the panel under each carries the technical detail. Only step 6’s delivery method differs per system.</a:t>
+            </a:r>
+          </a:p>
+        </p:txBody>
+      </p:sp>
+      <p:sp>
+        <p:nvSpPr>
+          <p:cNvPr id="5" name="Chevron 4"/>
+          <p:cNvSpPr/>
+          <p:nvPr/>
+        </p:nvSpPr>
+        <p:spPr>
+          <a:xfrm>
+            <a:off x="640080" y="1600200"/>
+            <a:ext cx="2664822" cy="1143000"/>
+          </a:xfrm>
+          <a:prstGeom prst="chevron">
+            <a:avLst>
+              <a:gd name="adj" fmla="val 55000"/>
+            </a:avLst>
           </a:prstGeom>
           <a:solidFill>
             <a:srgbClr val="1F3864"/>
@@ -15150,12 +15154,12 @@
           </a:fontRef>
         </p:style>
         <p:txBody>
-          <a:bodyPr rtlCol="0" anchor="ctr" lIns="0" rIns="0" tIns="0" bIns="0"/>
+          <a:bodyPr rtlCol="0" anchor="ctr" wrap="square" lIns="164592" rIns="45720" tIns="36576" bIns="27432"/>
           <a:lstStyle/>
           <a:p>
             <a:pPr algn="ctr"/>
             <a:r>
-              <a:rPr sz="1400" b="1">
+              <a:rPr sz="1500" b="1">
                 <a:solidFill>
                   <a:srgbClr val="FFFFFF"/>
                 </a:solidFill>
@@ -15164,70 +15168,55 @@
               <a:t>1</a:t>
             </a:r>
           </a:p>
-        </p:txBody>
-      </p:sp>
-      <p:sp>
-        <p:nvSpPr>
-          <p:cNvPr id="6" name="TextBox 5"/>
-          <p:cNvSpPr txBox="1"/>
-          <p:nvPr/>
-        </p:nvSpPr>
-        <p:spPr>
-          <a:xfrm>
-            <a:off x="1325880" y="1554480"/>
-            <a:ext cx="16002000" cy="868680"/>
-          </a:xfrm>
-          <a:prstGeom prst="rect">
-            <a:avLst/>
-          </a:prstGeom>
-          <a:noFill/>
-        </p:spPr>
-        <p:txBody>
-          <a:bodyPr wrap="square" lIns="0" rIns="0" tIns="0" bIns="0">
-            <a:spAutoFit/>
-          </a:bodyPr>
-          <a:lstStyle/>
-          <a:p>
-            <a:r>
-              <a:rPr sz="1300" b="1">
-                <a:solidFill>
-                  <a:srgbClr val="111111"/>
+          <a:p>
+            <a:pPr algn="ctr"/>
+            <a:r>
+              <a:rPr sz="1000" b="1">
+                <a:solidFill>
+                  <a:srgbClr val="FFFFFF"/>
                 </a:solidFill>
                 <a:latin typeface="Arial"/>
               </a:rPr>
-              <a:t>A record changes in S/4HANA.  </a:t>
-            </a:r>
-            <a:r>
-              <a:rPr sz="1200">
-                <a:solidFill>
-                  <a:srgbClr val="595959"/>
+              <a:t>RECORD</a:t>
+            </a:r>
+          </a:p>
+          <a:p>
+            <a:pPr algn="ctr"/>
+            <a:r>
+              <a:rPr sz="1000" b="1">
+                <a:solidFill>
+                  <a:srgbClr val="FFFFFF"/>
                 </a:solidFill>
                 <a:latin typeface="Arial"/>
               </a:rPr>
-              <a:t>Created by a field system’s own message, typed in by a user, or posted by another system — it makes no difference.</a:t>
-            </a:r>
-          </a:p>
-        </p:txBody>
-      </p:sp>
-      <p:sp>
-        <p:nvSpPr>
-          <p:cNvPr id="7" name="Oval 6"/>
-          <p:cNvSpPr/>
-          <p:nvPr/>
-        </p:nvSpPr>
-        <p:spPr>
-          <a:xfrm>
-            <a:off x="731520" y="2496312"/>
-            <a:ext cx="384048" cy="384048"/>
-          </a:xfrm>
-          <a:prstGeom prst="ellipse">
-            <a:avLst/>
+              <a:t>CHANGES</a:t>
+            </a:r>
+          </a:p>
+        </p:txBody>
+      </p:sp>
+      <p:sp>
+        <p:nvSpPr>
+          <p:cNvPr id="6" name="Rounded Rectangle 5"/>
+          <p:cNvSpPr/>
+          <p:nvPr/>
+        </p:nvSpPr>
+        <p:spPr>
+          <a:xfrm>
+            <a:off x="749808" y="2999232"/>
+            <a:ext cx="2299062" cy="5120640"/>
+          </a:xfrm>
+          <a:prstGeom prst="roundRect">
+            <a:avLst>
+              <a:gd name="adj" fmla="val 4000"/>
+            </a:avLst>
           </a:prstGeom>
           <a:solidFill>
-            <a:srgbClr val="1F3864"/>
+            <a:srgbClr val="F4F6F9"/>
           </a:solidFill>
-          <a:ln>
-            <a:noFill/>
+          <a:ln w="12700">
+            <a:solidFill>
+              <a:srgbClr val="C9CFD8"/>
+            </a:solidFill>
           </a:ln>
           <a:effectLst/>
         </p:spPr>
@@ -15246,81 +15235,72 @@
           </a:fontRef>
         </p:style>
         <p:txBody>
-          <a:bodyPr rtlCol="0" anchor="ctr" lIns="0" rIns="0" tIns="0" bIns="0"/>
+          <a:bodyPr rtlCol="0" anchor="ctr" wrap="square" tIns="91440" bIns="54864"/>
           <a:lstStyle/>
           <a:p>
             <a:pPr algn="ctr"/>
             <a:r>
-              <a:rPr sz="1400" b="1">
-                <a:solidFill>
-                  <a:srgbClr val="FFFFFF"/>
+              <a:rPr sz="1050" b="1">
+                <a:solidFill>
+                  <a:srgbClr val="1F3864"/>
                 </a:solidFill>
                 <a:latin typeface="Arial"/>
               </a:rPr>
-              <a:t>2</a:t>
-            </a:r>
-          </a:p>
-        </p:txBody>
-      </p:sp>
-      <p:sp>
-        <p:nvSpPr>
-          <p:cNvPr id="8" name="TextBox 7"/>
-          <p:cNvSpPr txBox="1"/>
-          <p:nvPr/>
-        </p:nvSpPr>
-        <p:spPr>
-          <a:xfrm>
-            <a:off x="1325880" y="2450592"/>
-            <a:ext cx="16002000" cy="868680"/>
-          </a:xfrm>
-          <a:prstGeom prst="rect">
-            <a:avLst/>
-          </a:prstGeom>
-          <a:noFill/>
-        </p:spPr>
-        <p:txBody>
-          <a:bodyPr wrap="square" lIns="0" rIns="0" tIns="0" bIns="0">
-            <a:spAutoFit/>
-          </a:bodyPr>
-          <a:lstStyle/>
-          <a:p>
-            <a:r>
-              <a:rPr sz="1300" b="1">
+              <a:t>In S/4HANA</a:t>
+            </a:r>
+          </a:p>
+          <a:p>
+            <a:pPr algn="l">
+              <a:spcBef>
+                <a:spcPts val="600"/>
+              </a:spcBef>
+            </a:pPr>
+            <a:r>
+              <a:rPr sz="900">
                 <a:solidFill>
                   <a:srgbClr val="111111"/>
                 </a:solidFill>
                 <a:latin typeface="Arial"/>
               </a:rPr>
-              <a:t>CPI finds out.  </a:t>
-            </a:r>
-            <a:r>
-              <a:rPr sz="1200">
-                <a:solidFill>
-                  <a:srgbClr val="595959"/>
+              <a:t>Any source: a field system’s own message, a user in S/4, another integration.</a:t>
+            </a:r>
+          </a:p>
+          <a:p>
+            <a:pPr algn="l">
+              <a:spcBef>
+                <a:spcPts val="600"/>
+              </a:spcBef>
+            </a:pPr>
+            <a:r>
+              <a:rPr sz="900">
+                <a:solidFill>
+                  <a:srgbClr val="111111"/>
                 </a:solidFill>
                 <a:latin typeface="Arial"/>
               </a:rPr>
-              <a:t>S/4 sends a change notice the moment it happens; where no notice exists, CPI asks on a timer “what changed since last time?”. The notice channel is already switched on and working in our tenant.</a:t>
-            </a:r>
-          </a:p>
-        </p:txBody>
-      </p:sp>
-      <p:sp>
-        <p:nvSpPr>
-          <p:cNvPr id="9" name="Oval 8"/>
-          <p:cNvSpPr/>
-          <p:nvPr/>
-        </p:nvSpPr>
-        <p:spPr>
-          <a:xfrm>
-            <a:off x="731520" y="3392424"/>
-            <a:ext cx="384048" cy="384048"/>
-          </a:xfrm>
-          <a:prstGeom prst="ellipse">
-            <a:avLst/>
+              <a:t>No difference in what follows — one path for all.</a:t>
+            </a:r>
+          </a:p>
+        </p:txBody>
+      </p:sp>
+      <p:sp>
+        <p:nvSpPr>
+          <p:cNvPr id="7" name="Chevron 6"/>
+          <p:cNvSpPr/>
+          <p:nvPr/>
+        </p:nvSpPr>
+        <p:spPr>
+          <a:xfrm>
+            <a:off x="3030582" y="1600200"/>
+            <a:ext cx="2664822" cy="1143000"/>
+          </a:xfrm>
+          <a:prstGeom prst="chevron">
+            <a:avLst>
+              <a:gd name="adj" fmla="val 55000"/>
+            </a:avLst>
           </a:prstGeom>
           <a:solidFill>
-            <a:srgbClr val="1F3864"/>
+            <a:srgbClr val="2E4E8A"/>
           </a:solidFill>
           <a:ln>
             <a:noFill/>
@@ -15342,84 +15322,69 @@
           </a:fontRef>
         </p:style>
         <p:txBody>
-          <a:bodyPr rtlCol="0" anchor="ctr" lIns="0" rIns="0" tIns="0" bIns="0"/>
+          <a:bodyPr rtlCol="0" anchor="ctr" wrap="square" lIns="164592" rIns="45720" tIns="36576" bIns="27432"/>
           <a:lstStyle/>
           <a:p>
             <a:pPr algn="ctr"/>
             <a:r>
-              <a:rPr sz="1400" b="1">
+              <a:rPr sz="1500" b="1">
                 <a:solidFill>
                   <a:srgbClr val="FFFFFF"/>
                 </a:solidFill>
                 <a:latin typeface="Arial"/>
               </a:rPr>
-              <a:t>3</a:t>
-            </a:r>
-          </a:p>
-        </p:txBody>
-      </p:sp>
-      <p:sp>
-        <p:nvSpPr>
-          <p:cNvPr id="10" name="TextBox 9"/>
-          <p:cNvSpPr txBox="1"/>
-          <p:nvPr/>
-        </p:nvSpPr>
-        <p:spPr>
-          <a:xfrm>
-            <a:off x="1325880" y="3346704"/>
-            <a:ext cx="16002000" cy="868680"/>
-          </a:xfrm>
-          <a:prstGeom prst="rect">
-            <a:avLst/>
-          </a:prstGeom>
-          <a:noFill/>
-        </p:spPr>
-        <p:txBody>
-          <a:bodyPr wrap="square" lIns="0" rIns="0" tIns="0" bIns="0">
-            <a:spAutoFit/>
-          </a:bodyPr>
-          <a:lstStyle/>
-          <a:p>
-            <a:r>
-              <a:rPr sz="1300" b="1">
-                <a:solidFill>
-                  <a:srgbClr val="111111"/>
+              <a:t>2</a:t>
+            </a:r>
+          </a:p>
+          <a:p>
+            <a:pPr algn="ctr"/>
+            <a:r>
+              <a:rPr sz="1000" b="1">
+                <a:solidFill>
+                  <a:srgbClr val="FFFFFF"/>
                 </a:solidFill>
                 <a:latin typeface="Arial"/>
               </a:rPr>
-              <a:t>CPI reads the full record fresh from S/4.  </a:t>
-            </a:r>
-            <a:r>
-              <a:rPr sz="1200">
-                <a:solidFill>
-                  <a:srgbClr val="595959"/>
+              <a:t>CPI IS</a:t>
+            </a:r>
+          </a:p>
+          <a:p>
+            <a:pPr algn="ctr"/>
+            <a:r>
+              <a:rPr sz="1000" b="1">
+                <a:solidFill>
+                  <a:srgbClr val="FFFFFF"/>
                 </a:solidFill>
                 <a:latin typeface="Arial"/>
               </a:rPr>
-              <a:t>So what goes out is always the current state — never stale, even if notices arrive late or out of order.</a:t>
-            </a:r>
-          </a:p>
-        </p:txBody>
-      </p:sp>
-      <p:sp>
-        <p:nvSpPr>
-          <p:cNvPr id="11" name="Oval 10"/>
-          <p:cNvSpPr/>
-          <p:nvPr/>
-        </p:nvSpPr>
-        <p:spPr>
-          <a:xfrm>
-            <a:off x="731520" y="4288536"/>
-            <a:ext cx="384048" cy="384048"/>
-          </a:xfrm>
-          <a:prstGeom prst="ellipse">
-            <a:avLst/>
+              <a:t>NOTIFIED</a:t>
+            </a:r>
+          </a:p>
+        </p:txBody>
+      </p:sp>
+      <p:sp>
+        <p:nvSpPr>
+          <p:cNvPr id="8" name="Rounded Rectangle 7"/>
+          <p:cNvSpPr/>
+          <p:nvPr/>
+        </p:nvSpPr>
+        <p:spPr>
+          <a:xfrm>
+            <a:off x="3140310" y="2999232"/>
+            <a:ext cx="2299062" cy="5120640"/>
+          </a:xfrm>
+          <a:prstGeom prst="roundRect">
+            <a:avLst>
+              <a:gd name="adj" fmla="val 4000"/>
+            </a:avLst>
           </a:prstGeom>
           <a:solidFill>
-            <a:srgbClr val="1F3864"/>
+            <a:srgbClr val="F4F6F9"/>
           </a:solidFill>
-          <a:ln>
-            <a:noFill/>
+          <a:ln w="12700">
+            <a:solidFill>
+              <a:srgbClr val="C9CFD8"/>
+            </a:solidFill>
           </a:ln>
           <a:effectLst/>
         </p:spPr>
@@ -15438,78 +15403,85 @@
           </a:fontRef>
         </p:style>
         <p:txBody>
-          <a:bodyPr rtlCol="0" anchor="ctr" lIns="0" rIns="0" tIns="0" bIns="0"/>
+          <a:bodyPr rtlCol="0" anchor="ctr" wrap="square" tIns="91440" bIns="54864"/>
           <a:lstStyle/>
           <a:p>
             <a:pPr algn="ctr"/>
             <a:r>
-              <a:rPr sz="1400" b="1">
-                <a:solidFill>
-                  <a:srgbClr val="FFFFFF"/>
+              <a:rPr sz="1050" b="1">
+                <a:solidFill>
+                  <a:srgbClr val="1F3864"/>
                 </a:solidFill>
                 <a:latin typeface="Arial"/>
               </a:rPr>
-              <a:t>4</a:t>
-            </a:r>
-          </a:p>
-        </p:txBody>
-      </p:sp>
-      <p:sp>
-        <p:nvSpPr>
-          <p:cNvPr id="12" name="TextBox 11"/>
-          <p:cNvSpPr txBox="1"/>
-          <p:nvPr/>
-        </p:nvSpPr>
-        <p:spPr>
-          <a:xfrm>
-            <a:off x="1325880" y="4242816"/>
-            <a:ext cx="16002000" cy="868680"/>
-          </a:xfrm>
-          <a:prstGeom prst="rect">
-            <a:avLst/>
-          </a:prstGeom>
-          <a:noFill/>
-        </p:spPr>
-        <p:txBody>
-          <a:bodyPr wrap="square" lIns="0" rIns="0" tIns="0" bIns="0">
-            <a:spAutoFit/>
-          </a:bodyPr>
-          <a:lstStyle/>
-          <a:p>
-            <a:r>
-              <a:rPr sz="1300" b="1">
+              <a:t>Notice or timer</a:t>
+            </a:r>
+          </a:p>
+          <a:p>
+            <a:pPr algn="l">
+              <a:spcBef>
+                <a:spcPts val="600"/>
+              </a:spcBef>
+            </a:pPr>
+            <a:r>
+              <a:rPr sz="900">
                 <a:solidFill>
                   <a:srgbClr val="111111"/>
                 </a:solidFill>
                 <a:latin typeface="Arial"/>
               </a:rPr>
-              <a:t>CPI wraps it in the one standard message.  </a:t>
-            </a:r>
-            <a:r>
-              <a:rPr sz="1200">
-                <a:solidFill>
-                  <a:srgbClr val="595959"/>
+              <a:t>Change notice from S/4 on the active channel EMIS_COM_0092 (carries the record ID only)</a:t>
+            </a:r>
+          </a:p>
+          <a:p>
+            <a:pPr algn="l">
+              <a:spcBef>
+                <a:spcPts val="600"/>
+              </a:spcBef>
+            </a:pPr>
+            <a:r>
+              <a:rPr sz="900">
+                <a:solidFill>
+                  <a:srgbClr val="111111"/>
                 </a:solidFill>
                 <a:latin typeface="Arial"/>
               </a:rPr>
-              <a:t>Including the tracking reference the sending system already holds, so it can match the delivery to what it sent.</a:t>
-            </a:r>
-          </a:p>
-        </p:txBody>
-      </p:sp>
-      <p:sp>
-        <p:nvSpPr>
-          <p:cNvPr id="13" name="Oval 12"/>
-          <p:cNvSpPr/>
-          <p:nvPr/>
-        </p:nvSpPr>
-        <p:spPr>
-          <a:xfrm>
-            <a:off x="731520" y="5184648"/>
-            <a:ext cx="384048" cy="384048"/>
-          </a:xfrm>
-          <a:prstGeom prst="ellipse">
-            <a:avLst/>
+              <a:t>— or the timed check asks the S/4 API: changed since last run?</a:t>
+            </a:r>
+          </a:p>
+          <a:p>
+            <a:pPr algn="l">
+              <a:spcBef>
+                <a:spcPts val="600"/>
+              </a:spcBef>
+            </a:pPr>
+            <a:r>
+              <a:rPr sz="900">
+                <a:solidFill>
+                  <a:srgbClr val="111111"/>
+                </a:solidFill>
+                <a:latin typeface="Arial"/>
+              </a:rPr>
+              <a:t>Chosen per kind of data; both feed step 3.</a:t>
+            </a:r>
+          </a:p>
+        </p:txBody>
+      </p:sp>
+      <p:sp>
+        <p:nvSpPr>
+          <p:cNvPr id="9" name="Chevron 8"/>
+          <p:cNvSpPr/>
+          <p:nvPr/>
+        </p:nvSpPr>
+        <p:spPr>
+          <a:xfrm>
+            <a:off x="5421085" y="1600200"/>
+            <a:ext cx="2664822" cy="1143000"/>
+          </a:xfrm>
+          <a:prstGeom prst="chevron">
+            <a:avLst>
+              <a:gd name="adj" fmla="val 55000"/>
+            </a:avLst>
           </a:prstGeom>
           <a:solidFill>
             <a:srgbClr val="1F3864"/>
@@ -15534,84 +15506,69 @@
           </a:fontRef>
         </p:style>
         <p:txBody>
-          <a:bodyPr rtlCol="0" anchor="ctr" lIns="0" rIns="0" tIns="0" bIns="0"/>
+          <a:bodyPr rtlCol="0" anchor="ctr" wrap="square" lIns="164592" rIns="45720" tIns="36576" bIns="27432"/>
           <a:lstStyle/>
           <a:p>
             <a:pPr algn="ctr"/>
             <a:r>
-              <a:rPr sz="1400" b="1">
+              <a:rPr sz="1500" b="1">
                 <a:solidFill>
                   <a:srgbClr val="FFFFFF"/>
                 </a:solidFill>
                 <a:latin typeface="Arial"/>
               </a:rPr>
-              <a:t>5</a:t>
-            </a:r>
-          </a:p>
-        </p:txBody>
-      </p:sp>
-      <p:sp>
-        <p:nvSpPr>
-          <p:cNvPr id="14" name="TextBox 13"/>
-          <p:cNvSpPr txBox="1"/>
-          <p:nvPr/>
-        </p:nvSpPr>
-        <p:spPr>
-          <a:xfrm>
-            <a:off x="1325880" y="5138928"/>
-            <a:ext cx="16002000" cy="868680"/>
-          </a:xfrm>
-          <a:prstGeom prst="rect">
-            <a:avLst/>
-          </a:prstGeom>
-          <a:noFill/>
-        </p:spPr>
-        <p:txBody>
-          <a:bodyPr wrap="square" lIns="0" rIns="0" tIns="0" bIns="0">
-            <a:spAutoFit/>
-          </a:bodyPr>
-          <a:lstStyle/>
-          <a:p>
-            <a:r>
-              <a:rPr sz="1300" b="1">
-                <a:solidFill>
-                  <a:srgbClr val="111111"/>
+              <a:t>3</a:t>
+            </a:r>
+          </a:p>
+          <a:p>
+            <a:pPr algn="ctr"/>
+            <a:r>
+              <a:rPr sz="1000" b="1">
+                <a:solidFill>
+                  <a:srgbClr val="FFFFFF"/>
                 </a:solidFill>
                 <a:latin typeface="Arial"/>
               </a:rPr>
-              <a:t>CPI checks the subscription list.  </a:t>
-            </a:r>
-            <a:r>
-              <a:rPr sz="1200">
-                <a:solidFill>
-                  <a:srgbClr val="595959"/>
+              <a:t>READ FULL</a:t>
+            </a:r>
+          </a:p>
+          <a:p>
+            <a:pPr algn="ctr"/>
+            <a:r>
+              <a:rPr sz="1000" b="1">
+                <a:solidFill>
+                  <a:srgbClr val="FFFFFF"/>
                 </a:solidFill>
                 <a:latin typeface="Arial"/>
               </a:rPr>
-              <a:t>Which systems want this kind of data, for this contract. A system can never receive data outside its own contracts — this is how Defence separation is enforced, centrally and auditably.</a:t>
-            </a:r>
-          </a:p>
-        </p:txBody>
-      </p:sp>
-      <p:sp>
-        <p:nvSpPr>
-          <p:cNvPr id="15" name="Oval 14"/>
-          <p:cNvSpPr/>
-          <p:nvPr/>
-        </p:nvSpPr>
-        <p:spPr>
-          <a:xfrm>
-            <a:off x="731520" y="6080760"/>
-            <a:ext cx="384048" cy="384048"/>
-          </a:xfrm>
-          <a:prstGeom prst="ellipse">
-            <a:avLst/>
+              <a:t>RECORD</a:t>
+            </a:r>
+          </a:p>
+        </p:txBody>
+      </p:sp>
+      <p:sp>
+        <p:nvSpPr>
+          <p:cNvPr id="10" name="Rounded Rectangle 9"/>
+          <p:cNvSpPr/>
+          <p:nvPr/>
+        </p:nvSpPr>
+        <p:spPr>
+          <a:xfrm>
+            <a:off x="5530813" y="2999232"/>
+            <a:ext cx="2299062" cy="5120640"/>
+          </a:xfrm>
+          <a:prstGeom prst="roundRect">
+            <a:avLst>
+              <a:gd name="adj" fmla="val 4000"/>
+            </a:avLst>
           </a:prstGeom>
           <a:solidFill>
-            <a:srgbClr val="1F3864"/>
+            <a:srgbClr val="F4F6F9"/>
           </a:solidFill>
-          <a:ln>
-            <a:noFill/>
+          <a:ln w="12700">
+            <a:solidFill>
+              <a:srgbClr val="C9CFD8"/>
+            </a:solidFill>
           </a:ln>
           <a:effectLst/>
         </p:spPr>
@@ -15630,81 +15587,72 @@
           </a:fontRef>
         </p:style>
         <p:txBody>
-          <a:bodyPr rtlCol="0" anchor="ctr" lIns="0" rIns="0" tIns="0" bIns="0"/>
+          <a:bodyPr rtlCol="0" anchor="ctr" wrap="square" tIns="91440" bIns="54864"/>
           <a:lstStyle/>
           <a:p>
             <a:pPr algn="ctr"/>
             <a:r>
-              <a:rPr sz="1400" b="1">
-                <a:solidFill>
-                  <a:srgbClr val="FFFFFF"/>
+              <a:rPr sz="1050" b="1">
+                <a:solidFill>
+                  <a:srgbClr val="1F3864"/>
                 </a:solidFill>
                 <a:latin typeface="Arial"/>
               </a:rPr>
-              <a:t>6</a:t>
-            </a:r>
-          </a:p>
-        </p:txBody>
-      </p:sp>
-      <p:sp>
-        <p:nvSpPr>
-          <p:cNvPr id="16" name="TextBox 15"/>
-          <p:cNvSpPr txBox="1"/>
-          <p:nvPr/>
-        </p:nvSpPr>
-        <p:spPr>
-          <a:xfrm>
-            <a:off x="1325880" y="6035040"/>
-            <a:ext cx="16002000" cy="868680"/>
-          </a:xfrm>
-          <a:prstGeom prst="rect">
-            <a:avLst/>
-          </a:prstGeom>
-          <a:noFill/>
-        </p:spPr>
-        <p:txBody>
-          <a:bodyPr wrap="square" lIns="0" rIns="0" tIns="0" bIns="0">
-            <a:spAutoFit/>
-          </a:bodyPr>
-          <a:lstStyle/>
-          <a:p>
-            <a:r>
-              <a:rPr sz="1300" b="1">
+              <a:t>From S/4, fresh</a:t>
+            </a:r>
+          </a:p>
+          <a:p>
+            <a:pPr algn="l">
+              <a:spcBef>
+                <a:spcPts val="600"/>
+              </a:spcBef>
+            </a:pPr>
+            <a:r>
+              <a:rPr sz="900">
                 <a:solidFill>
                   <a:srgbClr val="111111"/>
                 </a:solidFill>
                 <a:latin typeface="Arial"/>
               </a:rPr>
-              <a:t>CPI delivers it the way each system accepts.  </a:t>
-            </a:r>
-            <a:r>
-              <a:rPr sz="1200">
-                <a:solidFill>
-                  <a:srgbClr val="595959"/>
+              <a:t>GET on the released S/4 API — the same APIs already proven for the pull design (systemId + filters).</a:t>
+            </a:r>
+          </a:p>
+          <a:p>
+            <a:pPr algn="l">
+              <a:spcBef>
+                <a:spcPts val="600"/>
+              </a:spcBef>
+            </a:pPr>
+            <a:r>
+              <a:rPr sz="900">
+                <a:solidFill>
+                  <a:srgbClr val="111111"/>
                 </a:solidFill>
                 <a:latin typeface="Arial"/>
               </a:rPr>
-              <a:t>A web service call or a file. If a system is down, messages queue and retry automatically; one system being down never delays another; nothing is silently lost.</a:t>
-            </a:r>
-          </a:p>
-        </p:txBody>
-      </p:sp>
-      <p:sp>
-        <p:nvSpPr>
-          <p:cNvPr id="17" name="Oval 16"/>
-          <p:cNvSpPr/>
-          <p:nvPr/>
-        </p:nvSpPr>
-        <p:spPr>
-          <a:xfrm>
-            <a:off x="731520" y="6976872"/>
-            <a:ext cx="384048" cy="384048"/>
-          </a:xfrm>
-          <a:prstGeom prst="ellipse">
-            <a:avLst/>
+              <a:t>Always current state, even if notices arrive late or out of order.</a:t>
+            </a:r>
+          </a:p>
+        </p:txBody>
+      </p:sp>
+      <p:sp>
+        <p:nvSpPr>
+          <p:cNvPr id="11" name="Chevron 10"/>
+          <p:cNvSpPr/>
+          <p:nvPr/>
+        </p:nvSpPr>
+        <p:spPr>
+          <a:xfrm>
+            <a:off x="7811588" y="1600200"/>
+            <a:ext cx="2664822" cy="1143000"/>
+          </a:xfrm>
+          <a:prstGeom prst="chevron">
+            <a:avLst>
+              <a:gd name="adj" fmla="val 55000"/>
+            </a:avLst>
           </a:prstGeom>
           <a:solidFill>
-            <a:srgbClr val="1F3864"/>
+            <a:srgbClr val="2E4E8A"/>
           </a:solidFill>
           <a:ln>
             <a:noFill/>
@@ -15726,32 +15674,649 @@
           </a:fontRef>
         </p:style>
         <p:txBody>
-          <a:bodyPr rtlCol="0" anchor="ctr" lIns="0" rIns="0" tIns="0" bIns="0"/>
+          <a:bodyPr rtlCol="0" anchor="ctr" wrap="square" lIns="164592" rIns="45720" tIns="36576" bIns="27432"/>
           <a:lstStyle/>
           <a:p>
             <a:pPr algn="ctr"/>
             <a:r>
-              <a:rPr sz="1400" b="1">
+              <a:rPr sz="1500" b="1">
                 <a:solidFill>
                   <a:srgbClr val="FFFFFF"/>
                 </a:solidFill>
                 <a:latin typeface="Arial"/>
               </a:rPr>
+              <a:t>4</a:t>
+            </a:r>
+          </a:p>
+          <a:p>
+            <a:pPr algn="ctr"/>
+            <a:r>
+              <a:rPr sz="1000" b="1">
+                <a:solidFill>
+                  <a:srgbClr val="FFFFFF"/>
+                </a:solidFill>
+                <a:latin typeface="Arial"/>
+              </a:rPr>
+              <a:t>WRAP IN</a:t>
+            </a:r>
+          </a:p>
+          <a:p>
+            <a:pPr algn="ctr"/>
+            <a:r>
+              <a:rPr sz="1000" b="1">
+                <a:solidFill>
+                  <a:srgbClr val="FFFFFF"/>
+                </a:solidFill>
+                <a:latin typeface="Arial"/>
+              </a:rPr>
+              <a:t>STANDARD MSG</a:t>
+            </a:r>
+          </a:p>
+        </p:txBody>
+      </p:sp>
+      <p:sp>
+        <p:nvSpPr>
+          <p:cNvPr id="12" name="Rounded Rectangle 11"/>
+          <p:cNvSpPr/>
+          <p:nvPr/>
+        </p:nvSpPr>
+        <p:spPr>
+          <a:xfrm>
+            <a:off x="7921316" y="2999232"/>
+            <a:ext cx="2299062" cy="5120640"/>
+          </a:xfrm>
+          <a:prstGeom prst="roundRect">
+            <a:avLst>
+              <a:gd name="adj" fmla="val 4000"/>
+            </a:avLst>
+          </a:prstGeom>
+          <a:solidFill>
+            <a:srgbClr val="F4F6F9"/>
+          </a:solidFill>
+          <a:ln w="12700">
+            <a:solidFill>
+              <a:srgbClr val="C9CFD8"/>
+            </a:solidFill>
+          </a:ln>
+          <a:effectLst/>
+        </p:spPr>
+        <p:style>
+          <a:lnRef idx="1">
+            <a:schemeClr val="accent1"/>
+          </a:lnRef>
+          <a:fillRef idx="3">
+            <a:schemeClr val="accent1"/>
+          </a:fillRef>
+          <a:effectRef idx="2">
+            <a:schemeClr val="accent1"/>
+          </a:effectRef>
+          <a:fontRef idx="minor">
+            <a:schemeClr val="lt1"/>
+          </a:fontRef>
+        </p:style>
+        <p:txBody>
+          <a:bodyPr rtlCol="0" anchor="ctr" wrap="square" tIns="91440" bIns="54864"/>
+          <a:lstStyle/>
+          <a:p>
+            <a:pPr algn="ctr"/>
+            <a:r>
+              <a:rPr sz="1050" b="1">
+                <a:solidFill>
+                  <a:srgbClr val="1F3864"/>
+                </a:solidFill>
+                <a:latin typeface="Arial"/>
+              </a:rPr>
+              <a:t>One format for all</a:t>
+            </a:r>
+          </a:p>
+          <a:p>
+            <a:pPr algn="l">
+              <a:spcBef>
+                <a:spcPts val="600"/>
+              </a:spcBef>
+            </a:pPr>
+            <a:r>
+              <a:rPr sz="900">
+                <a:solidFill>
+                  <a:srgbClr val="111111"/>
+                </a:solidFill>
+                <a:latin typeface="Arial"/>
+              </a:rPr>
+              <a:t>Adds tracking fields: message ID, correlation ID, record ID, contract, changed-at, format version.</a:t>
+            </a:r>
+          </a:p>
+          <a:p>
+            <a:pPr algn="l">
+              <a:spcBef>
+                <a:spcPts val="600"/>
+              </a:spcBef>
+            </a:pPr>
+            <a:r>
+              <a:rPr sz="900">
+                <a:solidFill>
+                  <a:srgbClr val="111111"/>
+                </a:solidFill>
+                <a:latin typeface="Arial"/>
+              </a:rPr>
+              <a:t>The correlation ID lets the sender match this delivery to what it sent.</a:t>
+            </a:r>
+          </a:p>
+        </p:txBody>
+      </p:sp>
+      <p:sp>
+        <p:nvSpPr>
+          <p:cNvPr id="13" name="Chevron 12"/>
+          <p:cNvSpPr/>
+          <p:nvPr/>
+        </p:nvSpPr>
+        <p:spPr>
+          <a:xfrm>
+            <a:off x="10202091" y="1600200"/>
+            <a:ext cx="2664822" cy="1143000"/>
+          </a:xfrm>
+          <a:prstGeom prst="chevron">
+            <a:avLst>
+              <a:gd name="adj" fmla="val 55000"/>
+            </a:avLst>
+          </a:prstGeom>
+          <a:solidFill>
+            <a:srgbClr val="1F3864"/>
+          </a:solidFill>
+          <a:ln>
+            <a:noFill/>
+          </a:ln>
+          <a:effectLst/>
+        </p:spPr>
+        <p:style>
+          <a:lnRef idx="1">
+            <a:schemeClr val="accent1"/>
+          </a:lnRef>
+          <a:fillRef idx="3">
+            <a:schemeClr val="accent1"/>
+          </a:fillRef>
+          <a:effectRef idx="2">
+            <a:schemeClr val="accent1"/>
+          </a:effectRef>
+          <a:fontRef idx="minor">
+            <a:schemeClr val="lt1"/>
+          </a:fontRef>
+        </p:style>
+        <p:txBody>
+          <a:bodyPr rtlCol="0" anchor="ctr" wrap="square" lIns="164592" rIns="45720" tIns="36576" bIns="27432"/>
+          <a:lstStyle/>
+          <a:p>
+            <a:pPr algn="ctr"/>
+            <a:r>
+              <a:rPr sz="1500" b="1">
+                <a:solidFill>
+                  <a:srgbClr val="FFFFFF"/>
+                </a:solidFill>
+                <a:latin typeface="Arial"/>
+              </a:rPr>
+              <a:t>5</a:t>
+            </a:r>
+          </a:p>
+          <a:p>
+            <a:pPr algn="ctr"/>
+            <a:r>
+              <a:rPr sz="1000" b="1">
+                <a:solidFill>
+                  <a:srgbClr val="FFFFFF"/>
+                </a:solidFill>
+                <a:latin typeface="Arial"/>
+              </a:rPr>
+              <a:t>CHECK</a:t>
+            </a:r>
+          </a:p>
+          <a:p>
+            <a:pPr algn="ctr"/>
+            <a:r>
+              <a:rPr sz="1000" b="1">
+                <a:solidFill>
+                  <a:srgbClr val="FFFFFF"/>
+                </a:solidFill>
+                <a:latin typeface="Arial"/>
+              </a:rPr>
+              <a:t>SUBSCRIPTIONS</a:t>
+            </a:r>
+          </a:p>
+        </p:txBody>
+      </p:sp>
+      <p:sp>
+        <p:nvSpPr>
+          <p:cNvPr id="14" name="Rounded Rectangle 13"/>
+          <p:cNvSpPr/>
+          <p:nvPr/>
+        </p:nvSpPr>
+        <p:spPr>
+          <a:xfrm>
+            <a:off x="10311819" y="2999232"/>
+            <a:ext cx="2299062" cy="5120640"/>
+          </a:xfrm>
+          <a:prstGeom prst="roundRect">
+            <a:avLst>
+              <a:gd name="adj" fmla="val 4000"/>
+            </a:avLst>
+          </a:prstGeom>
+          <a:solidFill>
+            <a:srgbClr val="F4F6F9"/>
+          </a:solidFill>
+          <a:ln w="12700">
+            <a:solidFill>
+              <a:srgbClr val="C9CFD8"/>
+            </a:solidFill>
+          </a:ln>
+          <a:effectLst/>
+        </p:spPr>
+        <p:style>
+          <a:lnRef idx="1">
+            <a:schemeClr val="accent1"/>
+          </a:lnRef>
+          <a:fillRef idx="3">
+            <a:schemeClr val="accent1"/>
+          </a:fillRef>
+          <a:effectRef idx="2">
+            <a:schemeClr val="accent1"/>
+          </a:effectRef>
+          <a:fontRef idx="minor">
+            <a:schemeClr val="lt1"/>
+          </a:fontRef>
+        </p:style>
+        <p:txBody>
+          <a:bodyPr rtlCol="0" anchor="ctr" wrap="square" tIns="91440" bIns="54864"/>
+          <a:lstStyle/>
+          <a:p>
+            <a:pPr algn="ctr"/>
+            <a:r>
+              <a:rPr sz="1050" b="1">
+                <a:solidFill>
+                  <a:srgbClr val="1F3864"/>
+                </a:solidFill>
+                <a:latin typeface="Arial"/>
+              </a:rPr>
+              <a:t>Who gets it</a:t>
+            </a:r>
+          </a:p>
+          <a:p>
+            <a:pPr algn="l">
+              <a:spcBef>
+                <a:spcPts val="600"/>
+              </a:spcBef>
+            </a:pPr>
+            <a:r>
+              <a:rPr sz="900">
+                <a:solidFill>
+                  <a:srgbClr val="111111"/>
+                </a:solidFill>
+                <a:latin typeface="Arial"/>
+              </a:rPr>
+              <a:t>Subscription list: system × kind of data × contract scope. One copy per matching system.</a:t>
+            </a:r>
+          </a:p>
+          <a:p>
+            <a:pPr algn="l">
+              <a:spcBef>
+                <a:spcPts val="600"/>
+              </a:spcBef>
+            </a:pPr>
+            <a:r>
+              <a:rPr sz="900">
+                <a:solidFill>
+                  <a:srgbClr val="111111"/>
+                </a:solidFill>
+                <a:latin typeface="Arial"/>
+              </a:rPr>
+              <a:t>No other path exists — Defence can only ever receive Defence contracts. Central, auditable.</a:t>
+            </a:r>
+          </a:p>
+        </p:txBody>
+      </p:sp>
+      <p:sp>
+        <p:nvSpPr>
+          <p:cNvPr id="15" name="Chevron 14"/>
+          <p:cNvSpPr/>
+          <p:nvPr/>
+        </p:nvSpPr>
+        <p:spPr>
+          <a:xfrm>
+            <a:off x="12592594" y="1600200"/>
+            <a:ext cx="2664822" cy="1143000"/>
+          </a:xfrm>
+          <a:prstGeom prst="chevron">
+            <a:avLst>
+              <a:gd name="adj" fmla="val 55000"/>
+            </a:avLst>
+          </a:prstGeom>
+          <a:solidFill>
+            <a:srgbClr val="2E4E8A"/>
+          </a:solidFill>
+          <a:ln>
+            <a:noFill/>
+          </a:ln>
+          <a:effectLst/>
+        </p:spPr>
+        <p:style>
+          <a:lnRef idx="1">
+            <a:schemeClr val="accent1"/>
+          </a:lnRef>
+          <a:fillRef idx="3">
+            <a:schemeClr val="accent1"/>
+          </a:fillRef>
+          <a:effectRef idx="2">
+            <a:schemeClr val="accent1"/>
+          </a:effectRef>
+          <a:fontRef idx="minor">
+            <a:schemeClr val="lt1"/>
+          </a:fontRef>
+        </p:style>
+        <p:txBody>
+          <a:bodyPr rtlCol="0" anchor="ctr" wrap="square" lIns="164592" rIns="45720" tIns="36576" bIns="27432"/>
+          <a:lstStyle/>
+          <a:p>
+            <a:pPr algn="ctr"/>
+            <a:r>
+              <a:rPr sz="1500" b="1">
+                <a:solidFill>
+                  <a:srgbClr val="FFFFFF"/>
+                </a:solidFill>
+                <a:latin typeface="Arial"/>
+              </a:rPr>
+              <a:t>6</a:t>
+            </a:r>
+          </a:p>
+          <a:p>
+            <a:pPr algn="ctr"/>
+            <a:r>
+              <a:rPr sz="1000" b="1">
+                <a:solidFill>
+                  <a:srgbClr val="FFFFFF"/>
+                </a:solidFill>
+                <a:latin typeface="Arial"/>
+              </a:rPr>
+              <a:t>DELIVER</a:t>
+            </a:r>
+          </a:p>
+          <a:p>
+            <a:pPr algn="ctr"/>
+            <a:r>
+              <a:rPr sz="1000" b="1">
+                <a:solidFill>
+                  <a:srgbClr val="FFFFFF"/>
+                </a:solidFill>
+                <a:latin typeface="Arial"/>
+              </a:rPr>
+              <a:t>PER SYSTEM</a:t>
+            </a:r>
+          </a:p>
+        </p:txBody>
+      </p:sp>
+      <p:sp>
+        <p:nvSpPr>
+          <p:cNvPr id="16" name="Rounded Rectangle 15"/>
+          <p:cNvSpPr/>
+          <p:nvPr/>
+        </p:nvSpPr>
+        <p:spPr>
+          <a:xfrm>
+            <a:off x="12702322" y="2999232"/>
+            <a:ext cx="2299062" cy="5120640"/>
+          </a:xfrm>
+          <a:prstGeom prst="roundRect">
+            <a:avLst>
+              <a:gd name="adj" fmla="val 4000"/>
+            </a:avLst>
+          </a:prstGeom>
+          <a:solidFill>
+            <a:srgbClr val="F4F6F9"/>
+          </a:solidFill>
+          <a:ln w="12700">
+            <a:solidFill>
+              <a:srgbClr val="C9CFD8"/>
+            </a:solidFill>
+          </a:ln>
+          <a:effectLst/>
+        </p:spPr>
+        <p:style>
+          <a:lnRef idx="1">
+            <a:schemeClr val="accent1"/>
+          </a:lnRef>
+          <a:fillRef idx="3">
+            <a:schemeClr val="accent1"/>
+          </a:fillRef>
+          <a:effectRef idx="2">
+            <a:schemeClr val="accent1"/>
+          </a:effectRef>
+          <a:fontRef idx="minor">
+            <a:schemeClr val="lt1"/>
+          </a:fontRef>
+        </p:style>
+        <p:txBody>
+          <a:bodyPr rtlCol="0" anchor="ctr" wrap="square" tIns="91440" bIns="54864"/>
+          <a:lstStyle/>
+          <a:p>
+            <a:pPr algn="ctr"/>
+            <a:r>
+              <a:rPr sz="1050" b="1">
+                <a:solidFill>
+                  <a:srgbClr val="1F3864"/>
+                </a:solidFill>
+                <a:latin typeface="Arial"/>
+              </a:rPr>
+              <a:t>Push or file</a:t>
+            </a:r>
+          </a:p>
+          <a:p>
+            <a:pPr algn="l">
+              <a:spcBef>
+                <a:spcPts val="600"/>
+              </a:spcBef>
+            </a:pPr>
+            <a:r>
+              <a:rPr sz="900">
+                <a:solidFill>
+                  <a:srgbClr val="111111"/>
+                </a:solidFill>
+                <a:latin typeface="Arial"/>
+              </a:rPr>
+              <a:t>HTTPS call (JAMS service · ServiceNow import · Salesforce save) or SFTP file.</a:t>
+            </a:r>
+          </a:p>
+          <a:p>
+            <a:pPr algn="l">
+              <a:spcBef>
+                <a:spcPts val="600"/>
+              </a:spcBef>
+            </a:pPr>
+            <a:r>
+              <a:rPr sz="900">
+                <a:solidFill>
+                  <a:srgbClr val="111111"/>
+                </a:solidFill>
+                <a:latin typeface="Arial"/>
+              </a:rPr>
+              <a:t>Auto-retry with growing gaps (~1h); then error queue + alert to a named owner. One system down never delays another.</a:t>
+            </a:r>
+          </a:p>
+        </p:txBody>
+      </p:sp>
+      <p:sp>
+        <p:nvSpPr>
+          <p:cNvPr id="17" name="Chevron 16"/>
+          <p:cNvSpPr/>
+          <p:nvPr/>
+        </p:nvSpPr>
+        <p:spPr>
+          <a:xfrm>
+            <a:off x="14983097" y="1600200"/>
+            <a:ext cx="2664822" cy="1143000"/>
+          </a:xfrm>
+          <a:prstGeom prst="chevron">
+            <a:avLst>
+              <a:gd name="adj" fmla="val 55000"/>
+            </a:avLst>
+          </a:prstGeom>
+          <a:solidFill>
+            <a:srgbClr val="1F3864"/>
+          </a:solidFill>
+          <a:ln>
+            <a:noFill/>
+          </a:ln>
+          <a:effectLst/>
+        </p:spPr>
+        <p:style>
+          <a:lnRef idx="1">
+            <a:schemeClr val="accent1"/>
+          </a:lnRef>
+          <a:fillRef idx="3">
+            <a:schemeClr val="accent1"/>
+          </a:fillRef>
+          <a:effectRef idx="2">
+            <a:schemeClr val="accent1"/>
+          </a:effectRef>
+          <a:fontRef idx="minor">
+            <a:schemeClr val="lt1"/>
+          </a:fontRef>
+        </p:style>
+        <p:txBody>
+          <a:bodyPr rtlCol="0" anchor="ctr" wrap="square" lIns="164592" rIns="45720" tIns="36576" bIns="27432"/>
+          <a:lstStyle/>
+          <a:p>
+            <a:pPr algn="ctr"/>
+            <a:r>
+              <a:rPr sz="1500" b="1">
+                <a:solidFill>
+                  <a:srgbClr val="FFFFFF"/>
+                </a:solidFill>
+                <a:latin typeface="Arial"/>
+              </a:rPr>
               <a:t>7</a:t>
             </a:r>
           </a:p>
-        </p:txBody>
-      </p:sp>
-      <p:sp>
-        <p:nvSpPr>
-          <p:cNvPr id="18" name="TextBox 17"/>
+          <a:p>
+            <a:pPr algn="ctr"/>
+            <a:r>
+              <a:rPr sz="1000" b="1">
+                <a:solidFill>
+                  <a:srgbClr val="FFFFFF"/>
+                </a:solidFill>
+                <a:latin typeface="Arial"/>
+              </a:rPr>
+              <a:t>SYSTEM</a:t>
+            </a:r>
+          </a:p>
+          <a:p>
+            <a:pPr algn="ctr"/>
+            <a:r>
+              <a:rPr sz="1000" b="1">
+                <a:solidFill>
+                  <a:srgbClr val="FFFFFF"/>
+                </a:solidFill>
+                <a:latin typeface="Arial"/>
+              </a:rPr>
+              <a:t>SAVES IT</a:t>
+            </a:r>
+          </a:p>
+        </p:txBody>
+      </p:sp>
+      <p:sp>
+        <p:nvSpPr>
+          <p:cNvPr id="18" name="Rounded Rectangle 17"/>
+          <p:cNvSpPr/>
+          <p:nvPr/>
+        </p:nvSpPr>
+        <p:spPr>
+          <a:xfrm>
+            <a:off x="15092825" y="2999232"/>
+            <a:ext cx="2299062" cy="5120640"/>
+          </a:xfrm>
+          <a:prstGeom prst="roundRect">
+            <a:avLst>
+              <a:gd name="adj" fmla="val 4000"/>
+            </a:avLst>
+          </a:prstGeom>
+          <a:solidFill>
+            <a:srgbClr val="F4F6F9"/>
+          </a:solidFill>
+          <a:ln w="12700">
+            <a:solidFill>
+              <a:srgbClr val="C9CFD8"/>
+            </a:solidFill>
+          </a:ln>
+          <a:effectLst/>
+        </p:spPr>
+        <p:style>
+          <a:lnRef idx="1">
+            <a:schemeClr val="accent1"/>
+          </a:lnRef>
+          <a:fillRef idx="3">
+            <a:schemeClr val="accent1"/>
+          </a:fillRef>
+          <a:effectRef idx="2">
+            <a:schemeClr val="accent1"/>
+          </a:effectRef>
+          <a:fontRef idx="minor">
+            <a:schemeClr val="lt1"/>
+          </a:fontRef>
+        </p:style>
+        <p:txBody>
+          <a:bodyPr rtlCol="0" anchor="ctr" wrap="square" tIns="91440" bIns="54864"/>
+          <a:lstStyle/>
+          <a:p>
+            <a:pPr algn="ctr"/>
+            <a:r>
+              <a:rPr sz="1050" b="1">
+                <a:solidFill>
+                  <a:srgbClr val="1F3864"/>
+                </a:solidFill>
+                <a:latin typeface="Arial"/>
+              </a:rPr>
+              <a:t>Create or update</a:t>
+            </a:r>
+          </a:p>
+          <a:p>
+            <a:pPr algn="l">
+              <a:spcBef>
+                <a:spcPts val="600"/>
+              </a:spcBef>
+            </a:pPr>
+            <a:r>
+              <a:rPr sz="900">
+                <a:solidFill>
+                  <a:srgbClr val="111111"/>
+                </a:solidFill>
+                <a:latin typeface="Arial"/>
+              </a:rPr>
+              <a:t>Matched on the S/4 document number: create if new, update if existing; newest change wins.</a:t>
+            </a:r>
+          </a:p>
+          <a:p>
+            <a:pPr algn="l">
+              <a:spcBef>
+                <a:spcPts val="600"/>
+              </a:spcBef>
+            </a:pPr>
+            <a:r>
+              <a:rPr sz="900">
+                <a:solidFill>
+                  <a:srgbClr val="111111"/>
+                </a:solidFill>
+                <a:latin typeface="Arial"/>
+              </a:rPr>
+              <a:t>Replies saved (200) or rejected + reason (400). Same message twice = no harm.</a:t>
+            </a:r>
+          </a:p>
+        </p:txBody>
+      </p:sp>
+      <p:sp>
+        <p:nvSpPr>
+          <p:cNvPr id="19" name="TextBox 18"/>
           <p:cNvSpPr txBox="1"/>
           <p:nvPr/>
         </p:nvSpPr>
         <p:spPr>
           <a:xfrm>
-            <a:off x="1325880" y="6931152"/>
-            <a:ext cx="16002000" cy="868680"/>
+            <a:off x="640080" y="8321040"/>
+            <a:ext cx="17007840" cy="411480"/>
           </a:xfrm>
           <a:prstGeom prst="rect">
             <a:avLst/>
@@ -15764,37 +16329,29 @@
           </a:bodyPr>
           <a:lstStyle/>
           <a:p>
-            <a:r>
-              <a:rPr sz="1300" b="1">
-                <a:solidFill>
-                  <a:srgbClr val="111111"/>
+            <a:pPr algn="l"/>
+            <a:r>
+              <a:rPr sz="1200" b="1" i="0">
+                <a:solidFill>
+                  <a:srgbClr val="0F7A3D"/>
                 </a:solidFill>
                 <a:latin typeface="Arial"/>
               </a:rPr>
-              <a:t>The receiving system saves it itself.  </a:t>
-            </a:r>
-            <a:r>
-              <a:rPr sz="1200">
-                <a:solidFill>
-                  <a:srgbClr val="595959"/>
-                </a:solidFill>
-                <a:latin typeface="Arial"/>
-              </a:rPr>
-              <a:t>Create if new, update if existing, matched on the S/4 document number — so receiving the same message twice causes no harm.</a:t>
-            </a:r>
-          </a:p>
-        </p:txBody>
-      </p:sp>
-      <p:sp>
-        <p:nvSpPr>
-          <p:cNvPr id="19" name="TextBox 18"/>
+              <a:t>This closes the loop the ARB asked about: a work order JAMS sends to S/4 comes back to JAMS automatically with its S/4 document number and status — replacing today’s database queries against the Jobpac data warehouse.</a:t>
+            </a:r>
+          </a:p>
+        </p:txBody>
+      </p:sp>
+      <p:sp>
+        <p:nvSpPr>
+          <p:cNvPr id="20" name="TextBox 19"/>
           <p:cNvSpPr txBox="1"/>
           <p:nvPr/>
         </p:nvSpPr>
         <p:spPr>
           <a:xfrm>
-            <a:off x="731520" y="7982712"/>
-            <a:ext cx="16642080" cy="548640"/>
+            <a:off x="640080" y="8778240"/>
+            <a:ext cx="17007840" cy="365760"/>
           </a:xfrm>
           <a:prstGeom prst="rect">
             <a:avLst/>
@@ -15802,20 +16359,20 @@
           <a:noFill/>
         </p:spPr>
         <p:txBody>
-          <a:bodyPr wrap="square" lIns="0" rIns="0" tIns="0" bIns="0" anchor="t">
+          <a:bodyPr wrap="square" lIns="0" rIns="0" tIns="0" bIns="0">
             <a:spAutoFit/>
           </a:bodyPr>
           <a:lstStyle/>
           <a:p>
             <a:pPr algn="l"/>
             <a:r>
-              <a:rPr sz="1200" b="1" i="0">
-                <a:solidFill>
-                  <a:srgbClr val="0F7A3D"/>
+              <a:rPr sz="1100" b="0" i="0">
+                <a:solidFill>
+                  <a:srgbClr val="595959"/>
                 </a:solidFill>
                 <a:latin typeface="Arial"/>
               </a:rPr>
-              <a:t>This closes the loop the ARB asked about: a work order JAMS sends to S/4 comes back to JAMS automatically with its S/4 document number and status — replacing today’s database queries against the Jobpac data warehouse.</a:t>
+              <a:t>Safety built into the flow: steps 3 + 7 together make deliveries repeat-safe and order-safe; step 5 makes data separation structural; step 6 makes failure visible, never silent.</a:t>
             </a:r>
           </a:p>
         </p:txBody>
@@ -17607,6 +18164,3061 @@
               <a:t>Overview</a:t>
             </a:r>
             <a:endParaRPr lang="en-US" sz="5700"/>
+          </a:p>
+        </p:txBody>
+      </p:sp>
+    </p:spTree>
+  </p:cSld>
+  <p:clrMapOvr>
+    <a:masterClrMapping/>
+  </p:clrMapOvr>
+</p:sld>
+</file>
+
+<file path=ppt/slides/slide20.xml><?xml version="1.0" encoding="utf-8"?>
+<p:sld xmlns:a="http://schemas.openxmlformats.org/drawingml/2006/main" xmlns:p="http://schemas.openxmlformats.org/presentationml/2006/main" xmlns:r="http://schemas.openxmlformats.org/officeDocument/2006/relationships">
+  <p:cSld>
+    <p:spTree>
+      <p:nvGrpSpPr>
+        <p:cNvPr id="1" name=""/>
+        <p:cNvGrpSpPr/>
+        <p:nvPr/>
+      </p:nvGrpSpPr>
+      <p:grpSpPr/>
+      <p:pic>
+        <p:nvPicPr>
+          <p:cNvPr id="2" name="Picture 1" descr="image.png"/>
+          <p:cNvPicPr>
+            <a:picLocks noChangeAspect="1"/>
+          </p:cNvPicPr>
+          <p:nvPr/>
+        </p:nvPicPr>
+        <p:blipFill>
+          <a:blip r:embed="rId2"/>
+          <a:stretch>
+            <a:fillRect/>
+          </a:stretch>
+        </p:blipFill>
+        <p:spPr>
+          <a:xfrm>
+            <a:off x="16188779" y="476250"/>
+            <a:ext cx="1337221" cy="419075"/>
+          </a:xfrm>
+          <a:prstGeom prst="rect">
+            <a:avLst/>
+          </a:prstGeom>
+        </p:spPr>
+      </p:pic>
+      <p:sp>
+        <p:nvSpPr>
+          <p:cNvPr id="3" name="TextBox 2"/>
+          <p:cNvSpPr txBox="1"/>
+          <p:nvPr/>
+        </p:nvSpPr>
+        <p:spPr>
+          <a:xfrm>
+            <a:off x="640080" y="320040"/>
+            <a:ext cx="13716000" cy="548640"/>
+          </a:xfrm>
+          <a:prstGeom prst="rect">
+            <a:avLst/>
+          </a:prstGeom>
+          <a:noFill/>
+        </p:spPr>
+        <p:txBody>
+          <a:bodyPr wrap="square" lIns="0" rIns="0" tIns="0" bIns="0">
+            <a:spAutoFit/>
+          </a:bodyPr>
+          <a:lstStyle/>
+          <a:p>
+            <a:r>
+              <a:rPr sz="2200" b="1">
+                <a:solidFill>
+                  <a:srgbClr val="1F3864"/>
+                </a:solidFill>
+                <a:latin typeface="Arial"/>
+              </a:rPr>
+              <a:t>Options (Updated) – Where the Work of Returning S/4 Data Lives</a:t>
+            </a:r>
+          </a:p>
+        </p:txBody>
+      </p:sp>
+      <p:sp>
+        <p:nvSpPr>
+          <p:cNvPr id="4" name="TextBox 3"/>
+          <p:cNvSpPr txBox="1"/>
+          <p:nvPr/>
+        </p:nvSpPr>
+        <p:spPr>
+          <a:xfrm>
+            <a:off x="640080" y="868680"/>
+            <a:ext cx="16002000" cy="365760"/>
+          </a:xfrm>
+          <a:prstGeom prst="rect">
+            <a:avLst/>
+          </a:prstGeom>
+          <a:noFill/>
+        </p:spPr>
+        <p:txBody>
+          <a:bodyPr wrap="square" lIns="0" rIns="0" tIns="0" bIns="0">
+            <a:spAutoFit/>
+          </a:bodyPr>
+          <a:lstStyle/>
+          <a:p>
+            <a:r>
+              <a:rPr sz="1200">
+                <a:solidFill>
+                  <a:srgbClr val="595959"/>
+                </a:solidFill>
+                <a:latin typeface="Arial"/>
+              </a:rPr>
+              <a:t>All three deliver the same data. They differ in who does the fetching, filtering and converting — each field system, or CPI once for everyone.</a:t>
+            </a:r>
+          </a:p>
+        </p:txBody>
+      </p:sp>
+      <p:graphicFrame>
+        <p:nvGraphicFramePr>
+          <p:cNvPr id="5" name="Table 4"/>
+          <p:cNvGraphicFramePr>
+            <a:graphicFrameLocks noGrp="1"/>
+          </p:cNvGraphicFramePr>
+          <p:nvPr/>
+        </p:nvGraphicFramePr>
+        <p:xfrm>
+          <a:off x="502920" y="1417320"/>
+          <a:ext cx="17556480" cy="4892040"/>
+        </p:xfrm>
+        <a:graphic>
+          <a:graphicData uri="http://schemas.openxmlformats.org/drawingml/2006/table">
+            <a:tbl>
+              <a:tblPr firstRow="1" bandRow="1">
+                <a:tableStyleId>{5C22544A-7EE6-4342-B048-85BDC9FD1C3A}</a:tableStyleId>
+              </a:tblPr>
+              <a:tblGrid>
+                <a:gridCol w="2834640"/>
+                <a:gridCol w="3291840"/>
+                <a:gridCol w="3017520"/>
+                <a:gridCol w="2468880"/>
+                <a:gridCol w="2743200"/>
+                <a:gridCol w="3200400"/>
+              </a:tblGrid>
+              <a:tr h="365760">
+                <a:tc>
+                  <a:txBody>
+                    <a:bodyPr wrap="square"/>
+                    <a:lstStyle/>
+                    <a:p>
+                      <a:r>
+                        <a:rPr sz="1200" b="1">
+                          <a:solidFill>
+                            <a:srgbClr val="111111"/>
+                          </a:solidFill>
+                          <a:latin typeface="Arial"/>
+                        </a:rPr>
+                        <a:t>Option</a:t>
+                      </a:r>
+                    </a:p>
+                  </a:txBody>
+                  <a:tcPr marL="73152" marR="73152" marT="45720" marB="45720">
+                    <a:solidFill>
+                      <a:srgbClr val="92D050"/>
+                    </a:solidFill>
+                  </a:tcPr>
+                </a:tc>
+                <a:tc>
+                  <a:txBody>
+                    <a:bodyPr wrap="square"/>
+                    <a:lstStyle/>
+                    <a:p>
+                      <a:r>
+                        <a:rPr sz="1200" b="1">
+                          <a:solidFill>
+                            <a:srgbClr val="111111"/>
+                          </a:solidFill>
+                          <a:latin typeface="Arial"/>
+                        </a:rPr>
+                        <a:t>Approach</a:t>
+                      </a:r>
+                    </a:p>
+                  </a:txBody>
+                  <a:tcPr marL="73152" marR="73152" marT="45720" marB="45720">
+                    <a:solidFill>
+                      <a:srgbClr val="92D050"/>
+                    </a:solidFill>
+                  </a:tcPr>
+                </a:tc>
+                <a:tc>
+                  <a:txBody>
+                    <a:bodyPr wrap="square"/>
+                    <a:lstStyle/>
+                    <a:p>
+                      <a:r>
+                        <a:rPr sz="1200" b="1">
+                          <a:solidFill>
+                            <a:srgbClr val="111111"/>
+                          </a:solidFill>
+                          <a:latin typeface="Arial"/>
+                        </a:rPr>
+                        <a:t>Build Cost &amp; Duration</a:t>
+                      </a:r>
+                    </a:p>
+                  </a:txBody>
+                  <a:tcPr marL="73152" marR="73152" marT="45720" marB="45720">
+                    <a:solidFill>
+                      <a:srgbClr val="92D050"/>
+                    </a:solidFill>
+                  </a:tcPr>
+                </a:tc>
+                <a:tc>
+                  <a:txBody>
+                    <a:bodyPr wrap="square"/>
+                    <a:lstStyle/>
+                    <a:p>
+                      <a:r>
+                        <a:rPr sz="1200" b="1">
+                          <a:solidFill>
+                            <a:srgbClr val="111111"/>
+                          </a:solidFill>
+                          <a:latin typeface="Arial"/>
+                        </a:rPr>
+                        <a:t>Ongoing Cost</a:t>
+                      </a:r>
+                    </a:p>
+                  </a:txBody>
+                  <a:tcPr marL="73152" marR="73152" marT="45720" marB="45720">
+                    <a:solidFill>
+                      <a:srgbClr val="92D050"/>
+                    </a:solidFill>
+                  </a:tcPr>
+                </a:tc>
+                <a:tc>
+                  <a:txBody>
+                    <a:bodyPr wrap="square"/>
+                    <a:lstStyle/>
+                    <a:p>
+                      <a:r>
+                        <a:rPr sz="1200" b="1">
+                          <a:solidFill>
+                            <a:srgbClr val="111111"/>
+                          </a:solidFill>
+                          <a:latin typeface="Arial"/>
+                        </a:rPr>
+                        <a:t>Ongoing Benefit</a:t>
+                      </a:r>
+                    </a:p>
+                  </a:txBody>
+                  <a:tcPr marL="73152" marR="73152" marT="45720" marB="45720">
+                    <a:solidFill>
+                      <a:srgbClr val="92D050"/>
+                    </a:solidFill>
+                  </a:tcPr>
+                </a:tc>
+                <a:tc>
+                  <a:txBody>
+                    <a:bodyPr wrap="square"/>
+                    <a:lstStyle/>
+                    <a:p>
+                      <a:r>
+                        <a:rPr sz="1200" b="1">
+                          <a:solidFill>
+                            <a:srgbClr val="111111"/>
+                          </a:solidFill>
+                          <a:latin typeface="Arial"/>
+                        </a:rPr>
+                        <a:t>Key Risks</a:t>
+                      </a:r>
+                    </a:p>
+                  </a:txBody>
+                  <a:tcPr marL="73152" marR="73152" marT="45720" marB="45720">
+                    <a:solidFill>
+                      <a:srgbClr val="92D050"/>
+                    </a:solidFill>
+                  </a:tcPr>
+                </a:tc>
+              </a:tr>
+              <a:tr h="1508760">
+                <a:tc>
+                  <a:txBody>
+                    <a:bodyPr wrap="square"/>
+                    <a:lstStyle/>
+                    <a:p>
+                      <a:r>
+                        <a:rPr sz="1150" b="1">
+                          <a:solidFill>
+                            <a:srgbClr val="111111"/>
+                          </a:solidFill>
+                          <a:latin typeface="Arial"/>
+                        </a:rPr>
+                        <a:t>B – Each system fetches from a published query on CPI</a:t>
+                      </a:r>
+                    </a:p>
+                    <a:p>
+                      <a:r>
+                        <a:rPr sz="1150" b="1" i="1">
+                          <a:solidFill>
+                            <a:srgbClr val="1F3864"/>
+                          </a:solidFill>
+                          <a:latin typeface="Arial"/>
+                        </a:rPr>
+                        <a:t>(Decided baseline — kept)</a:t>
+                      </a:r>
+                    </a:p>
+                  </a:txBody>
+                  <a:tcPr marL="73152" marR="73152" marT="45720" marB="45720">
+                    <a:solidFill>
+                      <a:srgbClr val="FFFFFF"/>
+                    </a:solidFill>
+                  </a:tcPr>
+                </a:tc>
+                <a:tc>
+                  <a:txBody>
+                    <a:bodyPr wrap="square"/>
+                    <a:lstStyle/>
+                    <a:p>
+                      <a:r>
+                        <a:rPr sz="1000">
+                          <a:solidFill>
+                            <a:srgbClr val="111111"/>
+                          </a:solidFill>
+                          <a:latin typeface="Arial"/>
+                        </a:rPr>
+                        <a:t>CPI publishes one query per system; each field system fetches on its own schedule with its own filters.</a:t>
+                      </a:r>
+                    </a:p>
+                  </a:txBody>
+                  <a:tcPr marL="73152" marR="73152" marT="45720" marB="45720">
+                    <a:solidFill>
+                      <a:srgbClr val="FFFFFF"/>
+                    </a:solidFill>
+                  </a:tcPr>
+                </a:tc>
+                <a:tc>
+                  <a:txBody>
+                    <a:bodyPr wrap="square"/>
+                    <a:lstStyle/>
+                    <a:p>
+                      <a:r>
+                        <a:rPr sz="1000" b="1">
+                          <a:solidFill>
+                            <a:srgbClr val="111111"/>
+                          </a:solidFill>
+                          <a:latin typeface="Arial"/>
+                        </a:rPr>
+                        <a:t>Medium.</a:t>
+                      </a:r>
+                      <a:r>
+                        <a:rPr sz="1000">
+                          <a:solidFill>
+                            <a:srgbClr val="111111"/>
+                          </a:solidFill>
+                          <a:latin typeface="Arial"/>
+                        </a:rPr>
+                        <a:t> Build mostly in CPI. But every field system also builds scheduling, data fetching and filtering — ten times, in ten toolsets.</a:t>
+                      </a:r>
+                    </a:p>
+                  </a:txBody>
+                  <a:tcPr marL="73152" marR="73152" marT="45720" marB="45720">
+                    <a:solidFill>
+                      <a:srgbClr val="FFFFFF"/>
+                    </a:solidFill>
+                  </a:tcPr>
+                </a:tc>
+                <a:tc>
+                  <a:txBody>
+                    <a:bodyPr wrap="square"/>
+                    <a:lstStyle/>
+                    <a:p>
+                      <a:r>
+                        <a:rPr sz="1000" b="1">
+                          <a:solidFill>
+                            <a:srgbClr val="111111"/>
+                          </a:solidFill>
+                          <a:latin typeface="Arial"/>
+                        </a:rPr>
+                        <a:t>Medium.</a:t>
+                      </a:r>
+                      <a:r>
+                        <a:rPr sz="1000">
+                          <a:solidFill>
+                            <a:srgbClr val="111111"/>
+                          </a:solidFill>
+                          <a:latin typeface="Arial"/>
+                        </a:rPr>
+                        <a:t> Each system runs and supports its own fetching; skills spread across every vendor.</a:t>
+                      </a:r>
+                    </a:p>
+                  </a:txBody>
+                  <a:tcPr marL="73152" marR="73152" marT="45720" marB="45720">
+                    <a:solidFill>
+                      <a:srgbClr val="FFFFFF"/>
+                    </a:solidFill>
+                  </a:tcPr>
+                </a:tc>
+                <a:tc>
+                  <a:txBody>
+                    <a:bodyPr wrap="square"/>
+                    <a:lstStyle/>
+                    <a:p>
+                      <a:r>
+                        <a:rPr sz="1000">
+                          <a:solidFill>
+                            <a:srgbClr val="111111"/>
+                          </a:solidFill>
+                          <a:latin typeface="Arial"/>
+                        </a:rPr>
+                        <a:t>Simple CPI. Each system controls its own timing.</a:t>
+                      </a:r>
+                    </a:p>
+                  </a:txBody>
+                  <a:tcPr marL="73152" marR="73152" marT="45720" marB="45720">
+                    <a:solidFill>
+                      <a:srgbClr val="FFFFFF"/>
+                    </a:solidFill>
+                  </a:tcPr>
+                </a:tc>
+                <a:tc>
+                  <a:txBody>
+                    <a:bodyPr wrap="square"/>
+                    <a:lstStyle/>
+                    <a:p>
+                      <a:r>
+                        <a:rPr sz="1000">
+                          <a:solidFill>
+                            <a:srgbClr val="111111"/>
+                          </a:solidFill>
+                          <a:latin typeface="Arial"/>
+                        </a:rPr>
+                        <a:t>Orchestration is duplicated in every system. An acquired company's system must be modified before it can see its own data. Filtering correctness must be trusted and audited ten times — including Defence.</a:t>
+                      </a:r>
+                    </a:p>
+                  </a:txBody>
+                  <a:tcPr marL="73152" marR="73152" marT="45720" marB="45720">
+                    <a:solidFill>
+                      <a:srgbClr val="FFFFFF"/>
+                    </a:solidFill>
+                  </a:tcPr>
+                </a:tc>
+              </a:tr>
+              <a:tr h="1508760">
+                <a:tc>
+                  <a:txBody>
+                    <a:bodyPr wrap="square"/>
+                    <a:lstStyle/>
+                    <a:p>
+                      <a:r>
+                        <a:rPr sz="1150" b="1">
+                          <a:solidFill>
+                            <a:srgbClr val="111111"/>
+                          </a:solidFill>
+                          <a:latin typeface="Arial"/>
+                        </a:rPr>
+                        <a:t>D – CPI delivers each system's data to it</a:t>
+                      </a:r>
+                    </a:p>
+                    <a:p>
+                      <a:r>
+                        <a:rPr sz="1150" b="1" i="1">
+                          <a:solidFill>
+                            <a:srgbClr val="008A3E"/>
+                          </a:solidFill>
+                          <a:latin typeface="Arial"/>
+                        </a:rPr>
+                        <a:t>(Proposed – Recommended)</a:t>
+                      </a:r>
+                    </a:p>
+                  </a:txBody>
+                  <a:tcPr marL="73152" marR="73152" marT="45720" marB="45720">
+                    <a:solidFill>
+                      <a:srgbClr val="FFFFFF"/>
+                    </a:solidFill>
+                  </a:tcPr>
+                </a:tc>
+                <a:tc>
+                  <a:txBody>
+                    <a:bodyPr wrap="square"/>
+                    <a:lstStyle/>
+                    <a:p>
+                      <a:r>
+                        <a:rPr sz="1000">
+                          <a:solidFill>
+                            <a:srgbClr val="111111"/>
+                          </a:solidFill>
+                          <a:latin typeface="Arial"/>
+                        </a:rPr>
+                        <a:t>CPI detects each change once, reads the full record, filters by a central subscription list, and delivers it the way each system accepts (web service call or file). The Option B query stays as the fallback.</a:t>
+                      </a:r>
+                    </a:p>
+                  </a:txBody>
+                  <a:tcPr marL="73152" marR="73152" marT="45720" marB="45720">
+                    <a:solidFill>
+                      <a:srgbClr val="FFFFFF"/>
+                    </a:solidFill>
+                  </a:tcPr>
+                </a:tc>
+                <a:tc>
+                  <a:txBody>
+                    <a:bodyPr wrap="square"/>
+                    <a:lstStyle/>
+                    <a:p>
+                      <a:r>
+                        <a:rPr sz="1000" b="1">
+                          <a:solidFill>
+                            <a:srgbClr val="111111"/>
+                          </a:solidFill>
+                          <a:latin typeface="Arial"/>
+                        </a:rPr>
+                        <a:t>Medium.</a:t>
+                      </a:r>
+                      <a:r>
+                        <a:rPr sz="1000">
+                          <a:solidFill>
+                            <a:srgbClr val="111111"/>
+                          </a:solidFill>
+                          <a:latin typeface="Arial"/>
+                        </a:rPr>
+                        <a:t> All development in CPI, from standard delivered parts. S/4: configuration only. Field systems: configuration only, except six small JAMS receiving services.</a:t>
+                      </a:r>
+                    </a:p>
+                  </a:txBody>
+                  <a:tcPr marL="73152" marR="73152" marT="45720" marB="45720">
+                    <a:solidFill>
+                      <a:srgbClr val="FFFFFF"/>
+                    </a:solidFill>
+                  </a:tcPr>
+                </a:tc>
+                <a:tc>
+                  <a:txBody>
+                    <a:bodyPr wrap="square"/>
+                    <a:lstStyle/>
+                    <a:p>
+                      <a:r>
+                        <a:rPr sz="1000" b="1">
+                          <a:solidFill>
+                            <a:srgbClr val="111111"/>
+                          </a:solidFill>
+                          <a:latin typeface="Arial"/>
+                        </a:rPr>
+                        <a:t>Medium.</a:t>
+                      </a:r>
+                      <a:r>
+                        <a:rPr sz="1000">
+                          <a:solidFill>
+                            <a:srgbClr val="111111"/>
+                          </a:solidFill>
+                          <a:latin typeface="Arial"/>
+                        </a:rPr>
+                        <a:t> One team, one toolset, one monitoring view for everything. Nothing new to buy — all inside licences already held.</a:t>
+                      </a:r>
+                    </a:p>
+                  </a:txBody>
+                  <a:tcPr marL="73152" marR="73152" marT="45720" marB="45720">
+                    <a:solidFill>
+                      <a:srgbClr val="FFFFFF"/>
+                    </a:solidFill>
+                  </a:tcPr>
+                </a:tc>
+                <a:tc>
+                  <a:txBody>
+                    <a:bodyPr wrap="square"/>
+                    <a:lstStyle/>
+                    <a:p>
+                      <a:r>
+                        <a:rPr sz="1000">
+                          <a:solidFill>
+                            <a:srgbClr val="111111"/>
+                          </a:solidFill>
+                          <a:latin typeface="Arial"/>
+                        </a:rPr>
+                        <a:t>Field systems stop building orchestration. Defence separation enforced centrally and auditably. A new or acquired system = configuration rows plus one converter. Data arrives as it changes.</a:t>
+                      </a:r>
+                    </a:p>
+                  </a:txBody>
+                  <a:tcPr marL="73152" marR="73152" marT="45720" marB="45720">
+                    <a:solidFill>
+                      <a:srgbClr val="FFFFFF"/>
+                    </a:solidFill>
+                  </a:tcPr>
+                </a:tc>
+                <a:tc>
+                  <a:txBody>
+                    <a:bodyPr wrap="square"/>
+                    <a:lstStyle/>
+                    <a:p>
+                      <a:r>
+                        <a:rPr sz="1000">
+                          <a:solidFill>
+                            <a:srgbClr val="111111"/>
+                          </a:solidFill>
+                          <a:latin typeface="Arial"/>
+                        </a:rPr>
+                        <a:t>CPI becomes an operational platform — queues, alerts and a run book to own. Message volumes are metered under the existing licence (sizing in progress). Standard-message format needs version discipline.</a:t>
+                      </a:r>
+                    </a:p>
+                  </a:txBody>
+                  <a:tcPr marL="73152" marR="73152" marT="45720" marB="45720">
+                    <a:solidFill>
+                      <a:srgbClr val="FFFFFF"/>
+                    </a:solidFill>
+                  </a:tcPr>
+                </a:tc>
+              </a:tr>
+              <a:tr h="1508760">
+                <a:tc>
+                  <a:txBody>
+                    <a:bodyPr wrap="square"/>
+                    <a:lstStyle/>
+                    <a:p>
+                      <a:r>
+                        <a:rPr sz="1150" b="1">
+                          <a:solidFill>
+                            <a:srgbClr val="111111"/>
+                          </a:solidFill>
+                          <a:latin typeface="Arial"/>
+                        </a:rPr>
+                        <a:t>E – Fully event-driven delivery</a:t>
+                      </a:r>
+                    </a:p>
+                    <a:p>
+                      <a:r>
+                        <a:rPr sz="1150" b="1" i="1">
+                          <a:solidFill>
+                            <a:srgbClr val="595959"/>
+                          </a:solidFill>
+                          <a:latin typeface="Arial"/>
+                        </a:rPr>
+                        <a:t>(Noted — a per-system variant, not the rule)</a:t>
+                      </a:r>
+                    </a:p>
+                  </a:txBody>
+                  <a:tcPr marL="73152" marR="73152" marT="45720" marB="45720">
+                    <a:solidFill>
+                      <a:srgbClr val="FFFFFF"/>
+                    </a:solidFill>
+                  </a:tcPr>
+                </a:tc>
+                <a:tc>
+                  <a:txBody>
+                    <a:bodyPr wrap="square"/>
+                    <a:lstStyle/>
+                    <a:p>
+                      <a:r>
+                        <a:rPr sz="1000">
+                          <a:solidFill>
+                            <a:srgbClr val="111111"/>
+                          </a:solidFill>
+                          <a:latin typeface="Arial"/>
+                        </a:rPr>
+                        <a:t>CPI still detects, reads, filters and wraps — then publishes finished messages to event topics; SAP's event service delivers them by web call to each subscribed system.</a:t>
+                      </a:r>
+                    </a:p>
+                  </a:txBody>
+                  <a:tcPr marL="73152" marR="73152" marT="45720" marB="45720">
+                    <a:solidFill>
+                      <a:srgbClr val="FFFFFF"/>
+                    </a:solidFill>
+                  </a:tcPr>
+                </a:tc>
+                <a:tc>
+                  <a:txBody>
+                    <a:bodyPr wrap="square"/>
+                    <a:lstStyle/>
+                    <a:p>
+                      <a:r>
+                        <a:rPr sz="1000">
+                          <a:solidFill>
+                            <a:srgbClr val="111111"/>
+                          </a:solidFill>
+                          <a:latin typeface="Arial"/>
+                        </a:rPr>
+                        <a:t>Lower in CPI (no delivery plumbing) but higher in each field system: every receiver must accept the standard message itself.</a:t>
+                      </a:r>
+                    </a:p>
+                  </a:txBody>
+                  <a:tcPr marL="73152" marR="73152" marT="45720" marB="45720">
+                    <a:solidFill>
+                      <a:srgbClr val="FFFFFF"/>
+                    </a:solidFill>
+                  </a:tcPr>
+                </a:tc>
+                <a:tc>
+                  <a:txBody>
+                    <a:bodyPr wrap="square"/>
+                    <a:lstStyle/>
+                    <a:p>
+                      <a:r>
+                        <a:rPr sz="1000" b="1">
+                          <a:solidFill>
+                            <a:srgbClr val="111111"/>
+                          </a:solidFill>
+                          <a:latin typeface="Arial"/>
+                        </a:rPr>
+                        <a:t>Split operations across CPI and the event service consoles.</a:t>
+                      </a:r>
+                      <a:r>
+                        <a:rPr sz="1000">
+                          <a:solidFill>
+                            <a:srgbClr val="111111"/>
+                          </a:solidFill>
+                          <a:latin typeface="Arial"/>
+                        </a:rPr>
+                        <a:t/>
+                      </a:r>
+                    </a:p>
+                  </a:txBody>
+                  <a:tcPr marL="73152" marR="73152" marT="45720" marB="45720">
+                    <a:solidFill>
+                      <a:srgbClr val="FFFFFF"/>
+                    </a:solidFill>
+                  </a:tcPr>
+                </a:tc>
+                <a:tc>
+                  <a:txBody>
+                    <a:bodyPr wrap="square"/>
+                    <a:lstStyle/>
+                    <a:p>
+                      <a:r>
+                        <a:rPr sz="1000">
+                          <a:solidFill>
+                            <a:srgbClr val="111111"/>
+                          </a:solidFill>
+                          <a:latin typeface="Arial"/>
+                        </a:rPr>
+                        <a:t>Native one-to-many delivery with built-in retry. Suits systems willing to accept the standard message directly (JAMS could).</a:t>
+                      </a:r>
+                    </a:p>
+                  </a:txBody>
+                  <a:tcPr marL="73152" marR="73152" marT="45720" marB="45720">
+                    <a:solidFill>
+                      <a:srgbClr val="FFFFFF"/>
+                    </a:solidFill>
+                  </a:tcPr>
+                </a:tc>
+                <a:tc>
+                  <a:txBody>
+                    <a:bodyPr wrap="square"/>
+                    <a:lstStyle/>
+                    <a:p>
+                      <a:r>
+                        <a:rPr sz="1000">
+                          <a:solidFill>
+                            <a:srgbClr val="111111"/>
+                          </a:solidFill>
+                          <a:latin typeface="Arial"/>
+                        </a:rPr>
+                        <a:t>Change notices carry the record ID only. No filtering by contract (SAP documents content filtering as an anti-pattern) — Defence separation cannot be enforced this way. No format conversion — ServiceNow and Sitetracker still need a converter in front, which is CPI again.</a:t>
+                      </a:r>
+                    </a:p>
+                  </a:txBody>
+                  <a:tcPr marL="73152" marR="73152" marT="45720" marB="45720">
+                    <a:solidFill>
+                      <a:srgbClr val="FFFFFF"/>
+                    </a:solidFill>
+                  </a:tcPr>
+                </a:tc>
+              </a:tr>
+            </a:tbl>
+          </a:graphicData>
+        </a:graphic>
+      </p:graphicFrame>
+      <p:sp>
+        <p:nvSpPr>
+          <p:cNvPr id="6" name="Rounded Rectangle 5"/>
+          <p:cNvSpPr/>
+          <p:nvPr/>
+        </p:nvSpPr>
+        <p:spPr>
+          <a:xfrm>
+            <a:off x="502920" y="7726679"/>
+            <a:ext cx="17556480" cy="1828800"/>
+          </a:xfrm>
+          <a:prstGeom prst="roundRect">
+            <a:avLst>
+              <a:gd name="adj" fmla="val 8000"/>
+            </a:avLst>
+          </a:prstGeom>
+          <a:solidFill>
+            <a:srgbClr val="E2F0D9"/>
+          </a:solidFill>
+          <a:ln w="22225">
+            <a:solidFill>
+              <a:srgbClr val="00B050"/>
+            </a:solidFill>
+          </a:ln>
+          <a:effectLst/>
+        </p:spPr>
+        <p:style>
+          <a:lnRef idx="1">
+            <a:schemeClr val="accent1"/>
+          </a:lnRef>
+          <a:fillRef idx="3">
+            <a:schemeClr val="accent1"/>
+          </a:fillRef>
+          <a:effectRef idx="2">
+            <a:schemeClr val="accent1"/>
+          </a:effectRef>
+          <a:fontRef idx="minor">
+            <a:schemeClr val="lt1"/>
+          </a:fontRef>
+        </p:style>
+        <p:txBody>
+          <a:bodyPr rtlCol="0" anchor="ctr" wrap="square" lIns="228600" rIns="228600" tIns="109728" bIns="91440"/>
+          <a:lstStyle/>
+          <a:p>
+            <a:pPr algn="ctr"/>
+            <a:r>
+              <a:rPr sz="1500" b="1">
+                <a:solidFill>
+                  <a:srgbClr val="008A3E"/>
+                </a:solidFill>
+                <a:latin typeface="Arial"/>
+              </a:rPr>
+              <a:t>Recommendation: Option D as the rule, Option B kept as the fallback</a:t>
+            </a:r>
+          </a:p>
+          <a:p>
+            <a:r>
+              <a:rPr sz="1150">
+                <a:solidFill>
+                  <a:srgbClr val="111111"/>
+                </a:solidFill>
+                <a:latin typeface="Arial"/>
+              </a:rPr>
+              <a:t>CPI does the work once — detect, read, filter, deliver — and every field system just receives its own data through an interface it already has. Where a system cannot receive, it falls back to Option B's query, and Option E remains a per-system variant that can be adopted later by swapping only the delivery plumbing. Effort is roughly the same overall as Option B, but it lands in one team and one toolset instead of inside every field system — and an acquired company's system can be connected without modifying it.</a:t>
+            </a:r>
+          </a:p>
+        </p:txBody>
+      </p:sp>
+    </p:spTree>
+  </p:cSld>
+  <p:clrMapOvr>
+    <a:masterClrMapping/>
+  </p:clrMapOvr>
+</p:sld>
+</file>
+
+<file path=ppt/slides/slide21.xml><?xml version="1.0" encoding="utf-8"?>
+<p:sld xmlns:a="http://schemas.openxmlformats.org/drawingml/2006/main" xmlns:p="http://schemas.openxmlformats.org/presentationml/2006/main" xmlns:r="http://schemas.openxmlformats.org/officeDocument/2006/relationships">
+  <p:cSld>
+    <p:spTree>
+      <p:nvGrpSpPr>
+        <p:cNvPr id="1" name=""/>
+        <p:cNvGrpSpPr/>
+        <p:nvPr/>
+      </p:nvGrpSpPr>
+      <p:grpSpPr/>
+      <p:pic>
+        <p:nvPicPr>
+          <p:cNvPr id="2" name="Picture 1" descr="image.png"/>
+          <p:cNvPicPr>
+            <a:picLocks noChangeAspect="1"/>
+          </p:cNvPicPr>
+          <p:nvPr/>
+        </p:nvPicPr>
+        <p:blipFill>
+          <a:blip r:embed="rId2"/>
+          <a:stretch>
+            <a:fillRect/>
+          </a:stretch>
+        </p:blipFill>
+        <p:spPr>
+          <a:xfrm>
+            <a:off x="16188779" y="476250"/>
+            <a:ext cx="1337221" cy="419075"/>
+          </a:xfrm>
+          <a:prstGeom prst="rect">
+            <a:avLst/>
+          </a:prstGeom>
+        </p:spPr>
+      </p:pic>
+      <p:sp>
+        <p:nvSpPr>
+          <p:cNvPr id="3" name="TextBox 2"/>
+          <p:cNvSpPr txBox="1"/>
+          <p:nvPr/>
+        </p:nvSpPr>
+        <p:spPr>
+          <a:xfrm>
+            <a:off x="640080" y="320040"/>
+            <a:ext cx="14630400" cy="548640"/>
+          </a:xfrm>
+          <a:prstGeom prst="rect">
+            <a:avLst/>
+          </a:prstGeom>
+          <a:noFill/>
+        </p:spPr>
+        <p:txBody>
+          <a:bodyPr wrap="square" lIns="0" rIns="0" tIns="0" bIns="0">
+            <a:spAutoFit/>
+          </a:bodyPr>
+          <a:lstStyle/>
+          <a:p>
+            <a:pPr algn="l"/>
+            <a:r>
+              <a:rPr sz="2200" b="1" i="0">
+                <a:solidFill>
+                  <a:srgbClr val="1F3864"/>
+                </a:solidFill>
+                <a:latin typeface="Arial"/>
+              </a:rPr>
+              <a:t>Option D – The Distribution Layer Expanded: Every Part, and Whether It Is Built or Configured</a:t>
+            </a:r>
+          </a:p>
+        </p:txBody>
+      </p:sp>
+      <p:sp>
+        <p:nvSpPr>
+          <p:cNvPr id="4" name="TextBox 3"/>
+          <p:cNvSpPr txBox="1"/>
+          <p:nvPr/>
+        </p:nvSpPr>
+        <p:spPr>
+          <a:xfrm>
+            <a:off x="640080" y="868680"/>
+            <a:ext cx="16002000" cy="365760"/>
+          </a:xfrm>
+          <a:prstGeom prst="rect">
+            <a:avLst/>
+          </a:prstGeom>
+          <a:noFill/>
+        </p:spPr>
+        <p:txBody>
+          <a:bodyPr wrap="square" lIns="0" rIns="0" tIns="0" bIns="0">
+            <a:spAutoFit/>
+          </a:bodyPr>
+          <a:lstStyle/>
+          <a:p>
+            <a:pPr algn="l"/>
+            <a:r>
+              <a:rPr sz="1200" b="0" i="0">
+                <a:solidFill>
+                  <a:srgbClr val="595959"/>
+                </a:solidFill>
+                <a:latin typeface="Arial"/>
+              </a:rPr>
+              <a:t>The same box from the proposal slide, opened up. Six parts are development (assembled in CPI from standard delivered pieces), three are configuration, one extends what already exists.</a:t>
+            </a:r>
+          </a:p>
+        </p:txBody>
+      </p:sp>
+      <p:sp>
+        <p:nvSpPr>
+          <p:cNvPr id="5" name="Rounded Rectangle 4"/>
+          <p:cNvSpPr/>
+          <p:nvPr/>
+        </p:nvSpPr>
+        <p:spPr>
+          <a:xfrm>
+            <a:off x="3977639" y="1417320"/>
+            <a:ext cx="10515600" cy="7635240"/>
+          </a:xfrm>
+          <a:prstGeom prst="roundRect">
+            <a:avLst>
+              <a:gd name="adj" fmla="val 8000"/>
+            </a:avLst>
+          </a:prstGeom>
+          <a:solidFill>
+            <a:srgbClr val="FFFFFF"/>
+          </a:solidFill>
+          <a:ln w="25400">
+            <a:solidFill>
+              <a:srgbClr val="111111"/>
+            </a:solidFill>
+          </a:ln>
+          <a:effectLst/>
+        </p:spPr>
+        <p:style>
+          <a:lnRef idx="1">
+            <a:schemeClr val="accent1"/>
+          </a:lnRef>
+          <a:fillRef idx="3">
+            <a:schemeClr val="accent1"/>
+          </a:fillRef>
+          <a:effectRef idx="2">
+            <a:schemeClr val="accent1"/>
+          </a:effectRef>
+          <a:fontRef idx="minor">
+            <a:schemeClr val="lt1"/>
+          </a:fontRef>
+        </p:style>
+        <p:txBody>
+          <a:bodyPr rtlCol="0" anchor="ctr"/>
+          <a:lstStyle/>
+          <a:p>
+            <a:pPr algn="ctr"/>
+          </a:p>
+        </p:txBody>
+      </p:sp>
+      <p:sp>
+        <p:nvSpPr>
+          <p:cNvPr id="6" name="Rounded Rectangle 5"/>
+          <p:cNvSpPr/>
+          <p:nvPr/>
+        </p:nvSpPr>
+        <p:spPr>
+          <a:xfrm>
+            <a:off x="4114800" y="1289304"/>
+            <a:ext cx="2834640" cy="256032"/>
+          </a:xfrm>
+          <a:prstGeom prst="roundRect">
+            <a:avLst>
+              <a:gd name="adj" fmla="val 8000"/>
+            </a:avLst>
+          </a:prstGeom>
+          <a:solidFill>
+            <a:srgbClr val="111111"/>
+          </a:solidFill>
+          <a:ln w="9525">
+            <a:solidFill>
+              <a:srgbClr val="111111"/>
+            </a:solidFill>
+          </a:ln>
+          <a:effectLst/>
+        </p:spPr>
+        <p:style>
+          <a:lnRef idx="1">
+            <a:schemeClr val="accent1"/>
+          </a:lnRef>
+          <a:fillRef idx="3">
+            <a:schemeClr val="accent1"/>
+          </a:fillRef>
+          <a:effectRef idx="2">
+            <a:schemeClr val="accent1"/>
+          </a:effectRef>
+          <a:fontRef idx="minor">
+            <a:schemeClr val="lt1"/>
+          </a:fontRef>
+        </p:style>
+        <p:txBody>
+          <a:bodyPr rtlCol="0" anchor="ctr" lIns="36576" rIns="36576" tIns="0" bIns="0"/>
+          <a:lstStyle/>
+          <a:p>
+            <a:pPr algn="ctr"/>
+            <a:r>
+              <a:rPr sz="900" b="1">
+                <a:solidFill>
+                  <a:srgbClr val="FFFFFF"/>
+                </a:solidFill>
+                <a:latin typeface="Arial"/>
+              </a:rPr>
+              <a:t>SAP BTP · SAP CPI — expanded</a:t>
+            </a:r>
+          </a:p>
+        </p:txBody>
+      </p:sp>
+      <p:sp>
+        <p:nvSpPr>
+          <p:cNvPr id="7" name="TextBox 6"/>
+          <p:cNvSpPr txBox="1"/>
+          <p:nvPr/>
+        </p:nvSpPr>
+        <p:spPr>
+          <a:xfrm>
+            <a:off x="4206240" y="1600200"/>
+            <a:ext cx="10058400" cy="274320"/>
+          </a:xfrm>
+          <a:prstGeom prst="rect">
+            <a:avLst/>
+          </a:prstGeom>
+          <a:noFill/>
+        </p:spPr>
+        <p:txBody>
+          <a:bodyPr wrap="square" lIns="0" rIns="0" tIns="0" bIns="0">
+            <a:spAutoFit/>
+          </a:bodyPr>
+          <a:lstStyle/>
+          <a:p>
+            <a:pPr algn="l"/>
+            <a:r>
+              <a:rPr sz="950" b="1" i="0">
+                <a:solidFill>
+                  <a:srgbClr val="595959"/>
+                </a:solidFill>
+                <a:latin typeface="Arial"/>
+              </a:rPr>
+              <a:t>STEP 1–2 · FIND OUT AND KNOW WHERE YOU ARE</a:t>
+            </a:r>
+          </a:p>
+        </p:txBody>
+      </p:sp>
+      <p:sp>
+        <p:nvSpPr>
+          <p:cNvPr id="8" name="Rounded Rectangle 7"/>
+          <p:cNvSpPr/>
+          <p:nvPr/>
+        </p:nvSpPr>
+        <p:spPr>
+          <a:xfrm>
+            <a:off x="4343400" y="2011680"/>
+            <a:ext cx="3246120" cy="960120"/>
+          </a:xfrm>
+          <a:prstGeom prst="roundRect">
+            <a:avLst>
+              <a:gd name="adj" fmla="val 8000"/>
+            </a:avLst>
+          </a:prstGeom>
+          <a:solidFill>
+            <a:srgbClr val="F4F6F9"/>
+          </a:solidFill>
+          <a:ln w="12700">
+            <a:solidFill>
+              <a:srgbClr val="111111"/>
+            </a:solidFill>
+          </a:ln>
+          <a:effectLst/>
+        </p:spPr>
+        <p:style>
+          <a:lnRef idx="1">
+            <a:schemeClr val="accent1"/>
+          </a:lnRef>
+          <a:fillRef idx="3">
+            <a:schemeClr val="accent1"/>
+          </a:fillRef>
+          <a:effectRef idx="2">
+            <a:schemeClr val="accent1"/>
+          </a:effectRef>
+          <a:fontRef idx="minor">
+            <a:schemeClr val="lt1"/>
+          </a:fontRef>
+        </p:style>
+        <p:txBody>
+          <a:bodyPr rtlCol="0" anchor="ctr" wrap="square" lIns="73152" rIns="73152" tIns="36576" bIns="27432"/>
+          <a:lstStyle/>
+          <a:p>
+            <a:pPr algn="ctr"/>
+            <a:r>
+              <a:rPr sz="1150" b="1">
+                <a:solidFill>
+                  <a:srgbClr val="111111"/>
+                </a:solidFill>
+                <a:latin typeface="Arial"/>
+              </a:rPr>
+              <a:t>Change-notice receiver</a:t>
+            </a:r>
+          </a:p>
+          <a:p>
+            <a:pPr algn="ctr"/>
+            <a:r>
+              <a:rPr sz="900">
+                <a:solidFill>
+                  <a:srgbClr val="595959"/>
+                </a:solidFill>
+                <a:latin typeface="Arial"/>
+              </a:rPr>
+              <a:t>one per kind of data · listens to the S/4 channel already active in our tenant</a:t>
+            </a:r>
+          </a:p>
+        </p:txBody>
+      </p:sp>
+      <p:sp>
+        <p:nvSpPr>
+          <p:cNvPr id="9" name="Rounded Rectangle 8"/>
+          <p:cNvSpPr/>
+          <p:nvPr/>
+        </p:nvSpPr>
+        <p:spPr>
+          <a:xfrm>
+            <a:off x="6981444" y="1892808"/>
+            <a:ext cx="534924" cy="237744"/>
+          </a:xfrm>
+          <a:prstGeom prst="roundRect">
+            <a:avLst>
+              <a:gd name="adj" fmla="val 8000"/>
+            </a:avLst>
+          </a:prstGeom>
+          <a:solidFill>
+            <a:srgbClr val="1E56A0"/>
+          </a:solidFill>
+          <a:ln w="9525">
+            <a:solidFill>
+              <a:srgbClr val="1E56A0"/>
+            </a:solidFill>
+          </a:ln>
+          <a:effectLst/>
+        </p:spPr>
+        <p:style>
+          <a:lnRef idx="1">
+            <a:schemeClr val="accent1"/>
+          </a:lnRef>
+          <a:fillRef idx="3">
+            <a:schemeClr val="accent1"/>
+          </a:fillRef>
+          <a:effectRef idx="2">
+            <a:schemeClr val="accent1"/>
+          </a:effectRef>
+          <a:fontRef idx="minor">
+            <a:schemeClr val="lt1"/>
+          </a:fontRef>
+        </p:style>
+        <p:txBody>
+          <a:bodyPr rtlCol="0" anchor="ctr" lIns="27432" rIns="27432" tIns="0" bIns="0"/>
+          <a:lstStyle/>
+          <a:p>
+            <a:pPr algn="ctr"/>
+            <a:r>
+              <a:rPr sz="850" b="1">
+                <a:solidFill>
+                  <a:srgbClr val="FFFFFF"/>
+                </a:solidFill>
+                <a:latin typeface="Arial"/>
+              </a:rPr>
+              <a:t>BUILD</a:t>
+            </a:r>
+          </a:p>
+        </p:txBody>
+      </p:sp>
+      <p:sp>
+        <p:nvSpPr>
+          <p:cNvPr id="10" name="Rounded Rectangle 9"/>
+          <p:cNvSpPr/>
+          <p:nvPr/>
+        </p:nvSpPr>
+        <p:spPr>
+          <a:xfrm>
+            <a:off x="7726679" y="2011680"/>
+            <a:ext cx="3108960" cy="960120"/>
+          </a:xfrm>
+          <a:prstGeom prst="roundRect">
+            <a:avLst>
+              <a:gd name="adj" fmla="val 8000"/>
+            </a:avLst>
+          </a:prstGeom>
+          <a:solidFill>
+            <a:srgbClr val="F4F6F9"/>
+          </a:solidFill>
+          <a:ln w="12700">
+            <a:solidFill>
+              <a:srgbClr val="111111"/>
+            </a:solidFill>
+          </a:ln>
+          <a:effectLst/>
+        </p:spPr>
+        <p:style>
+          <a:lnRef idx="1">
+            <a:schemeClr val="accent1"/>
+          </a:lnRef>
+          <a:fillRef idx="3">
+            <a:schemeClr val="accent1"/>
+          </a:fillRef>
+          <a:effectRef idx="2">
+            <a:schemeClr val="accent1"/>
+          </a:effectRef>
+          <a:fontRef idx="minor">
+            <a:schemeClr val="lt1"/>
+          </a:fontRef>
+        </p:style>
+        <p:txBody>
+          <a:bodyPr rtlCol="0" anchor="ctr" wrap="square" lIns="73152" rIns="73152" tIns="36576" bIns="27432"/>
+          <a:lstStyle/>
+          <a:p>
+            <a:pPr algn="ctr"/>
+            <a:r>
+              <a:rPr sz="1150" b="1">
+                <a:solidFill>
+                  <a:srgbClr val="111111"/>
+                </a:solidFill>
+                <a:latin typeface="Arial"/>
+              </a:rPr>
+              <a:t>Timed check</a:t>
+            </a:r>
+          </a:p>
+          <a:p>
+            <a:pPr algn="ctr"/>
+            <a:r>
+              <a:rPr sz="900">
+                <a:solidFill>
+                  <a:srgbClr val="595959"/>
+                </a:solidFill>
+                <a:latin typeface="Arial"/>
+              </a:rPr>
+              <a:t>one job · asks S/4 “what changed since last run?” · frequency set per kind of data</a:t>
+            </a:r>
+          </a:p>
+        </p:txBody>
+      </p:sp>
+      <p:sp>
+        <p:nvSpPr>
+          <p:cNvPr id="11" name="Rounded Rectangle 10"/>
+          <p:cNvSpPr/>
+          <p:nvPr/>
+        </p:nvSpPr>
+        <p:spPr>
+          <a:xfrm>
+            <a:off x="10227563" y="1892808"/>
+            <a:ext cx="534924" cy="237744"/>
+          </a:xfrm>
+          <a:prstGeom prst="roundRect">
+            <a:avLst>
+              <a:gd name="adj" fmla="val 8000"/>
+            </a:avLst>
+          </a:prstGeom>
+          <a:solidFill>
+            <a:srgbClr val="1E56A0"/>
+          </a:solidFill>
+          <a:ln w="9525">
+            <a:solidFill>
+              <a:srgbClr val="1E56A0"/>
+            </a:solidFill>
+          </a:ln>
+          <a:effectLst/>
+        </p:spPr>
+        <p:style>
+          <a:lnRef idx="1">
+            <a:schemeClr val="accent1"/>
+          </a:lnRef>
+          <a:fillRef idx="3">
+            <a:schemeClr val="accent1"/>
+          </a:fillRef>
+          <a:effectRef idx="2">
+            <a:schemeClr val="accent1"/>
+          </a:effectRef>
+          <a:fontRef idx="minor">
+            <a:schemeClr val="lt1"/>
+          </a:fontRef>
+        </p:style>
+        <p:txBody>
+          <a:bodyPr rtlCol="0" anchor="ctr" lIns="27432" rIns="27432" tIns="0" bIns="0"/>
+          <a:lstStyle/>
+          <a:p>
+            <a:pPr algn="ctr"/>
+            <a:r>
+              <a:rPr sz="850" b="1">
+                <a:solidFill>
+                  <a:srgbClr val="FFFFFF"/>
+                </a:solidFill>
+                <a:latin typeface="Arial"/>
+              </a:rPr>
+              <a:t>BUILD</a:t>
+            </a:r>
+          </a:p>
+        </p:txBody>
+      </p:sp>
+      <p:sp>
+        <p:nvSpPr>
+          <p:cNvPr id="12" name="Rounded Rectangle 11"/>
+          <p:cNvSpPr/>
+          <p:nvPr/>
+        </p:nvSpPr>
+        <p:spPr>
+          <a:xfrm>
+            <a:off x="10972800" y="2011680"/>
+            <a:ext cx="3246120" cy="960120"/>
+          </a:xfrm>
+          <a:prstGeom prst="roundRect">
+            <a:avLst>
+              <a:gd name="adj" fmla="val 8000"/>
+            </a:avLst>
+          </a:prstGeom>
+          <a:solidFill>
+            <a:srgbClr val="F4F6F9"/>
+          </a:solidFill>
+          <a:ln w="12700">
+            <a:solidFill>
+              <a:srgbClr val="111111"/>
+            </a:solidFill>
+          </a:ln>
+          <a:effectLst/>
+        </p:spPr>
+        <p:style>
+          <a:lnRef idx="1">
+            <a:schemeClr val="accent1"/>
+          </a:lnRef>
+          <a:fillRef idx="3">
+            <a:schemeClr val="accent1"/>
+          </a:fillRef>
+          <a:effectRef idx="2">
+            <a:schemeClr val="accent1"/>
+          </a:effectRef>
+          <a:fontRef idx="minor">
+            <a:schemeClr val="lt1"/>
+          </a:fontRef>
+        </p:style>
+        <p:txBody>
+          <a:bodyPr rtlCol="0" anchor="ctr" wrap="square" lIns="73152" rIns="73152" tIns="36576" bIns="27432"/>
+          <a:lstStyle/>
+          <a:p>
+            <a:pPr algn="ctr"/>
+            <a:r>
+              <a:rPr sz="1150" b="1">
+                <a:solidFill>
+                  <a:srgbClr val="111111"/>
+                </a:solidFill>
+                <a:latin typeface="Arial"/>
+              </a:rPr>
+              <a:t>Last-run-time store</a:t>
+            </a:r>
+          </a:p>
+          <a:p>
+            <a:pPr algn="ctr"/>
+            <a:r>
+              <a:rPr sz="900">
+                <a:solidFill>
+                  <a:srgbClr val="595959"/>
+                </a:solidFill>
+                <a:latin typeface="Arial"/>
+              </a:rPr>
+              <a:t>remembers where the timer got to · CPI’s own variable store</a:t>
+            </a:r>
+          </a:p>
+        </p:txBody>
+      </p:sp>
+      <p:sp>
+        <p:nvSpPr>
+          <p:cNvPr id="13" name="Rounded Rectangle 12"/>
+          <p:cNvSpPr/>
+          <p:nvPr/>
+        </p:nvSpPr>
+        <p:spPr>
+          <a:xfrm>
+            <a:off x="13533120" y="1892808"/>
+            <a:ext cx="612648" cy="237744"/>
+          </a:xfrm>
+          <a:prstGeom prst="roundRect">
+            <a:avLst>
+              <a:gd name="adj" fmla="val 8000"/>
+            </a:avLst>
+          </a:prstGeom>
+          <a:solidFill>
+            <a:srgbClr val="374151"/>
+          </a:solidFill>
+          <a:ln w="9525">
+            <a:solidFill>
+              <a:srgbClr val="374151"/>
+            </a:solidFill>
+          </a:ln>
+          <a:effectLst/>
+        </p:spPr>
+        <p:style>
+          <a:lnRef idx="1">
+            <a:schemeClr val="accent1"/>
+          </a:lnRef>
+          <a:fillRef idx="3">
+            <a:schemeClr val="accent1"/>
+          </a:fillRef>
+          <a:effectRef idx="2">
+            <a:schemeClr val="accent1"/>
+          </a:effectRef>
+          <a:fontRef idx="minor">
+            <a:schemeClr val="lt1"/>
+          </a:fontRef>
+        </p:style>
+        <p:txBody>
+          <a:bodyPr rtlCol="0" anchor="ctr" lIns="27432" rIns="27432" tIns="0" bIns="0"/>
+          <a:lstStyle/>
+          <a:p>
+            <a:pPr algn="ctr"/>
+            <a:r>
+              <a:rPr sz="850" b="1">
+                <a:solidFill>
+                  <a:srgbClr val="FFFFFF"/>
+                </a:solidFill>
+                <a:latin typeface="Arial"/>
+              </a:rPr>
+              <a:t>CONFIG</a:t>
+            </a:r>
+          </a:p>
+        </p:txBody>
+      </p:sp>
+      <p:sp>
+        <p:nvSpPr>
+          <p:cNvPr id="14" name="Down Arrow 13"/>
+          <p:cNvSpPr/>
+          <p:nvPr/>
+        </p:nvSpPr>
+        <p:spPr>
+          <a:xfrm>
+            <a:off x="9171432" y="3090672"/>
+            <a:ext cx="128016" cy="292608"/>
+          </a:xfrm>
+          <a:prstGeom prst="downArrow">
+            <a:avLst/>
+          </a:prstGeom>
+          <a:solidFill>
+            <a:srgbClr val="111111"/>
+          </a:solidFill>
+          <a:ln>
+            <a:noFill/>
+          </a:ln>
+          <a:effectLst/>
+        </p:spPr>
+        <p:style>
+          <a:lnRef idx="1">
+            <a:schemeClr val="accent1"/>
+          </a:lnRef>
+          <a:fillRef idx="3">
+            <a:schemeClr val="accent1"/>
+          </a:fillRef>
+          <a:effectRef idx="2">
+            <a:schemeClr val="accent1"/>
+          </a:effectRef>
+          <a:fontRef idx="minor">
+            <a:schemeClr val="lt1"/>
+          </a:fontRef>
+        </p:style>
+        <p:txBody>
+          <a:bodyPr rtlCol="0" anchor="ctr"/>
+          <a:lstStyle/>
+          <a:p>
+            <a:pPr algn="ctr"/>
+          </a:p>
+        </p:txBody>
+      </p:sp>
+      <p:sp>
+        <p:nvSpPr>
+          <p:cNvPr id="15" name="TextBox 14"/>
+          <p:cNvSpPr txBox="1"/>
+          <p:nvPr/>
+        </p:nvSpPr>
+        <p:spPr>
+          <a:xfrm>
+            <a:off x="4206240" y="3401568"/>
+            <a:ext cx="10058400" cy="274320"/>
+          </a:xfrm>
+          <a:prstGeom prst="rect">
+            <a:avLst/>
+          </a:prstGeom>
+          <a:noFill/>
+        </p:spPr>
+        <p:txBody>
+          <a:bodyPr wrap="square" lIns="0" rIns="0" tIns="0" bIns="0">
+            <a:spAutoFit/>
+          </a:bodyPr>
+          <a:lstStyle/>
+          <a:p>
+            <a:pPr algn="l"/>
+            <a:r>
+              <a:rPr sz="950" b="1" i="0">
+                <a:solidFill>
+                  <a:srgbClr val="595959"/>
+                </a:solidFill>
+                <a:latin typeface="Arial"/>
+              </a:rPr>
+              <a:t>STEP 3–4 · READ AND WRAP</a:t>
+            </a:r>
+          </a:p>
+        </p:txBody>
+      </p:sp>
+      <p:sp>
+        <p:nvSpPr>
+          <p:cNvPr id="16" name="Rounded Rectangle 15"/>
+          <p:cNvSpPr/>
+          <p:nvPr/>
+        </p:nvSpPr>
+        <p:spPr>
+          <a:xfrm>
+            <a:off x="6309360" y="3703320"/>
+            <a:ext cx="5852160" cy="914400"/>
+          </a:xfrm>
+          <a:prstGeom prst="roundRect">
+            <a:avLst>
+              <a:gd name="adj" fmla="val 8000"/>
+            </a:avLst>
+          </a:prstGeom>
+          <a:solidFill>
+            <a:srgbClr val="F4F6F9"/>
+          </a:solidFill>
+          <a:ln w="12700">
+            <a:solidFill>
+              <a:srgbClr val="111111"/>
+            </a:solidFill>
+          </a:ln>
+          <a:effectLst/>
+        </p:spPr>
+        <p:style>
+          <a:lnRef idx="1">
+            <a:schemeClr val="accent1"/>
+          </a:lnRef>
+          <a:fillRef idx="3">
+            <a:schemeClr val="accent1"/>
+          </a:fillRef>
+          <a:effectRef idx="2">
+            <a:schemeClr val="accent1"/>
+          </a:effectRef>
+          <a:fontRef idx="minor">
+            <a:schemeClr val="lt1"/>
+          </a:fontRef>
+        </p:style>
+        <p:txBody>
+          <a:bodyPr rtlCol="0" anchor="ctr" wrap="square" lIns="73152" rIns="73152" tIns="36576" bIns="27432"/>
+          <a:lstStyle/>
+          <a:p>
+            <a:pPr algn="ctr"/>
+            <a:r>
+              <a:rPr sz="1150" b="1">
+                <a:solidFill>
+                  <a:srgbClr val="111111"/>
+                </a:solidFill>
+                <a:latin typeface="Arial"/>
+              </a:rPr>
+              <a:t>Message builder</a:t>
+            </a:r>
+          </a:p>
+          <a:p>
+            <a:pPr algn="ctr"/>
+            <a:r>
+              <a:rPr sz="900">
+                <a:solidFill>
+                  <a:srgbClr val="595959"/>
+                </a:solidFill>
+                <a:latin typeface="Arial"/>
+              </a:rPr>
+              <a:t>reads the full record fresh from S/4 · wraps it in the one standard message with its tracking reference</a:t>
+            </a:r>
+          </a:p>
+        </p:txBody>
+      </p:sp>
+      <p:sp>
+        <p:nvSpPr>
+          <p:cNvPr id="17" name="Rounded Rectangle 16"/>
+          <p:cNvSpPr/>
+          <p:nvPr/>
+        </p:nvSpPr>
+        <p:spPr>
+          <a:xfrm>
+            <a:off x="11553444" y="3584448"/>
+            <a:ext cx="534924" cy="237744"/>
+          </a:xfrm>
+          <a:prstGeom prst="roundRect">
+            <a:avLst>
+              <a:gd name="adj" fmla="val 8000"/>
+            </a:avLst>
+          </a:prstGeom>
+          <a:solidFill>
+            <a:srgbClr val="1E56A0"/>
+          </a:solidFill>
+          <a:ln w="9525">
+            <a:solidFill>
+              <a:srgbClr val="1E56A0"/>
+            </a:solidFill>
+          </a:ln>
+          <a:effectLst/>
+        </p:spPr>
+        <p:style>
+          <a:lnRef idx="1">
+            <a:schemeClr val="accent1"/>
+          </a:lnRef>
+          <a:fillRef idx="3">
+            <a:schemeClr val="accent1"/>
+          </a:fillRef>
+          <a:effectRef idx="2">
+            <a:schemeClr val="accent1"/>
+          </a:effectRef>
+          <a:fontRef idx="minor">
+            <a:schemeClr val="lt1"/>
+          </a:fontRef>
+        </p:style>
+        <p:txBody>
+          <a:bodyPr rtlCol="0" anchor="ctr" lIns="27432" rIns="27432" tIns="0" bIns="0"/>
+          <a:lstStyle/>
+          <a:p>
+            <a:pPr algn="ctr"/>
+            <a:r>
+              <a:rPr sz="850" b="1">
+                <a:solidFill>
+                  <a:srgbClr val="FFFFFF"/>
+                </a:solidFill>
+                <a:latin typeface="Arial"/>
+              </a:rPr>
+              <a:t>BUILD</a:t>
+            </a:r>
+          </a:p>
+        </p:txBody>
+      </p:sp>
+      <p:sp>
+        <p:nvSpPr>
+          <p:cNvPr id="18" name="Down Arrow 17"/>
+          <p:cNvSpPr/>
+          <p:nvPr/>
+        </p:nvSpPr>
+        <p:spPr>
+          <a:xfrm>
+            <a:off x="9171432" y="4736592"/>
+            <a:ext cx="128016" cy="292608"/>
+          </a:xfrm>
+          <a:prstGeom prst="downArrow">
+            <a:avLst/>
+          </a:prstGeom>
+          <a:solidFill>
+            <a:srgbClr val="111111"/>
+          </a:solidFill>
+          <a:ln>
+            <a:noFill/>
+          </a:ln>
+          <a:effectLst/>
+        </p:spPr>
+        <p:style>
+          <a:lnRef idx="1">
+            <a:schemeClr val="accent1"/>
+          </a:lnRef>
+          <a:fillRef idx="3">
+            <a:schemeClr val="accent1"/>
+          </a:fillRef>
+          <a:effectRef idx="2">
+            <a:schemeClr val="accent1"/>
+          </a:effectRef>
+          <a:fontRef idx="minor">
+            <a:schemeClr val="lt1"/>
+          </a:fontRef>
+        </p:style>
+        <p:txBody>
+          <a:bodyPr rtlCol="0" anchor="ctr"/>
+          <a:lstStyle/>
+          <a:p>
+            <a:pPr algn="ctr"/>
+          </a:p>
+        </p:txBody>
+      </p:sp>
+      <p:sp>
+        <p:nvSpPr>
+          <p:cNvPr id="19" name="TextBox 18"/>
+          <p:cNvSpPr txBox="1"/>
+          <p:nvPr/>
+        </p:nvSpPr>
+        <p:spPr>
+          <a:xfrm>
+            <a:off x="4206240" y="5047488"/>
+            <a:ext cx="10058400" cy="274320"/>
+          </a:xfrm>
+          <a:prstGeom prst="rect">
+            <a:avLst/>
+          </a:prstGeom>
+          <a:noFill/>
+        </p:spPr>
+        <p:txBody>
+          <a:bodyPr wrap="square" lIns="0" rIns="0" tIns="0" bIns="0">
+            <a:spAutoFit/>
+          </a:bodyPr>
+          <a:lstStyle/>
+          <a:p>
+            <a:pPr algn="l"/>
+            <a:r>
+              <a:rPr sz="950" b="1" i="0">
+                <a:solidFill>
+                  <a:srgbClr val="595959"/>
+                </a:solidFill>
+                <a:latin typeface="Arial"/>
+              </a:rPr>
+              <a:t>STEP 5 · DECIDE WHO GETS IT</a:t>
+            </a:r>
+          </a:p>
+        </p:txBody>
+      </p:sp>
+      <p:sp>
+        <p:nvSpPr>
+          <p:cNvPr id="20" name="Rounded Rectangle 19"/>
+          <p:cNvSpPr/>
+          <p:nvPr/>
+        </p:nvSpPr>
+        <p:spPr>
+          <a:xfrm>
+            <a:off x="4343400" y="5349240"/>
+            <a:ext cx="4846320" cy="960120"/>
+          </a:xfrm>
+          <a:prstGeom prst="roundRect">
+            <a:avLst>
+              <a:gd name="adj" fmla="val 8000"/>
+            </a:avLst>
+          </a:prstGeom>
+          <a:solidFill>
+            <a:srgbClr val="F4F6F9"/>
+          </a:solidFill>
+          <a:ln w="12700">
+            <a:solidFill>
+              <a:srgbClr val="111111"/>
+            </a:solidFill>
+          </a:ln>
+          <a:effectLst/>
+        </p:spPr>
+        <p:style>
+          <a:lnRef idx="1">
+            <a:schemeClr val="accent1"/>
+          </a:lnRef>
+          <a:fillRef idx="3">
+            <a:schemeClr val="accent1"/>
+          </a:fillRef>
+          <a:effectRef idx="2">
+            <a:schemeClr val="accent1"/>
+          </a:effectRef>
+          <a:fontRef idx="minor">
+            <a:schemeClr val="lt1"/>
+          </a:fontRef>
+        </p:style>
+        <p:txBody>
+          <a:bodyPr rtlCol="0" anchor="ctr" wrap="square" lIns="73152" rIns="73152" tIns="36576" bIns="27432"/>
+          <a:lstStyle/>
+          <a:p>
+            <a:pPr algn="ctr"/>
+            <a:r>
+              <a:rPr sz="1150" b="1">
+                <a:solidFill>
+                  <a:srgbClr val="111111"/>
+                </a:solidFill>
+                <a:latin typeface="Arial"/>
+              </a:rPr>
+              <a:t>Subscription list</a:t>
+            </a:r>
+          </a:p>
+          <a:p>
+            <a:pPr algn="ctr"/>
+            <a:r>
+              <a:rPr sz="900">
+                <a:solidFill>
+                  <a:srgbClr val="595959"/>
+                </a:solidFill>
+                <a:latin typeface="Arial"/>
+              </a:rPr>
+              <a:t>who gets what, for which contracts · plain configuration under change control</a:t>
+            </a:r>
+          </a:p>
+        </p:txBody>
+      </p:sp>
+      <p:sp>
+        <p:nvSpPr>
+          <p:cNvPr id="21" name="Rounded Rectangle 20"/>
+          <p:cNvSpPr/>
+          <p:nvPr/>
+        </p:nvSpPr>
+        <p:spPr>
+          <a:xfrm>
+            <a:off x="8503920" y="5230368"/>
+            <a:ext cx="612648" cy="237744"/>
+          </a:xfrm>
+          <a:prstGeom prst="roundRect">
+            <a:avLst>
+              <a:gd name="adj" fmla="val 8000"/>
+            </a:avLst>
+          </a:prstGeom>
+          <a:solidFill>
+            <a:srgbClr val="374151"/>
+          </a:solidFill>
+          <a:ln w="9525">
+            <a:solidFill>
+              <a:srgbClr val="374151"/>
+            </a:solidFill>
+          </a:ln>
+          <a:effectLst/>
+        </p:spPr>
+        <p:style>
+          <a:lnRef idx="1">
+            <a:schemeClr val="accent1"/>
+          </a:lnRef>
+          <a:fillRef idx="3">
+            <a:schemeClr val="accent1"/>
+          </a:fillRef>
+          <a:effectRef idx="2">
+            <a:schemeClr val="accent1"/>
+          </a:effectRef>
+          <a:fontRef idx="minor">
+            <a:schemeClr val="lt1"/>
+          </a:fontRef>
+        </p:style>
+        <p:txBody>
+          <a:bodyPr rtlCol="0" anchor="ctr" lIns="27432" rIns="27432" tIns="0" bIns="0"/>
+          <a:lstStyle/>
+          <a:p>
+            <a:pPr algn="ctr"/>
+            <a:r>
+              <a:rPr sz="850" b="1">
+                <a:solidFill>
+                  <a:srgbClr val="FFFFFF"/>
+                </a:solidFill>
+                <a:latin typeface="Arial"/>
+              </a:rPr>
+              <a:t>CONFIG</a:t>
+            </a:r>
+          </a:p>
+        </p:txBody>
+      </p:sp>
+      <p:sp>
+        <p:nvSpPr>
+          <p:cNvPr id="22" name="Rounded Rectangle 21"/>
+          <p:cNvSpPr/>
+          <p:nvPr/>
+        </p:nvSpPr>
+        <p:spPr>
+          <a:xfrm>
+            <a:off x="9372600" y="5349240"/>
+            <a:ext cx="4846320" cy="960120"/>
+          </a:xfrm>
+          <a:prstGeom prst="roundRect">
+            <a:avLst>
+              <a:gd name="adj" fmla="val 8000"/>
+            </a:avLst>
+          </a:prstGeom>
+          <a:solidFill>
+            <a:srgbClr val="F4F6F9"/>
+          </a:solidFill>
+          <a:ln w="12700">
+            <a:solidFill>
+              <a:srgbClr val="111111"/>
+            </a:solidFill>
+          </a:ln>
+          <a:effectLst/>
+        </p:spPr>
+        <p:style>
+          <a:lnRef idx="1">
+            <a:schemeClr val="accent1"/>
+          </a:lnRef>
+          <a:fillRef idx="3">
+            <a:schemeClr val="accent1"/>
+          </a:fillRef>
+          <a:effectRef idx="2">
+            <a:schemeClr val="accent1"/>
+          </a:effectRef>
+          <a:fontRef idx="minor">
+            <a:schemeClr val="lt1"/>
+          </a:fontRef>
+        </p:style>
+        <p:txBody>
+          <a:bodyPr rtlCol="0" anchor="ctr" wrap="square" lIns="73152" rIns="73152" tIns="36576" bIns="27432"/>
+          <a:lstStyle/>
+          <a:p>
+            <a:pPr algn="ctr"/>
+            <a:r>
+              <a:rPr sz="1150" b="1">
+                <a:solidFill>
+                  <a:srgbClr val="111111"/>
+                </a:solidFill>
+                <a:latin typeface="Arial"/>
+              </a:rPr>
+              <a:t>Router</a:t>
+            </a:r>
+          </a:p>
+          <a:p>
+            <a:pPr algn="ctr"/>
+            <a:r>
+              <a:rPr sz="900">
+                <a:solidFill>
+                  <a:srgbClr val="595959"/>
+                </a:solidFill>
+                <a:latin typeface="Arial"/>
+              </a:rPr>
+              <a:t>one copy per matching system, placed on that system’s queue — no other path exists</a:t>
+            </a:r>
+          </a:p>
+        </p:txBody>
+      </p:sp>
+      <p:sp>
+        <p:nvSpPr>
+          <p:cNvPr id="23" name="Rounded Rectangle 22"/>
+          <p:cNvSpPr/>
+          <p:nvPr/>
+        </p:nvSpPr>
+        <p:spPr>
+          <a:xfrm>
+            <a:off x="13610844" y="5230368"/>
+            <a:ext cx="534924" cy="237744"/>
+          </a:xfrm>
+          <a:prstGeom prst="roundRect">
+            <a:avLst>
+              <a:gd name="adj" fmla="val 8000"/>
+            </a:avLst>
+          </a:prstGeom>
+          <a:solidFill>
+            <a:srgbClr val="1E56A0"/>
+          </a:solidFill>
+          <a:ln w="9525">
+            <a:solidFill>
+              <a:srgbClr val="1E56A0"/>
+            </a:solidFill>
+          </a:ln>
+          <a:effectLst/>
+        </p:spPr>
+        <p:style>
+          <a:lnRef idx="1">
+            <a:schemeClr val="accent1"/>
+          </a:lnRef>
+          <a:fillRef idx="3">
+            <a:schemeClr val="accent1"/>
+          </a:fillRef>
+          <a:effectRef idx="2">
+            <a:schemeClr val="accent1"/>
+          </a:effectRef>
+          <a:fontRef idx="minor">
+            <a:schemeClr val="lt1"/>
+          </a:fontRef>
+        </p:style>
+        <p:txBody>
+          <a:bodyPr rtlCol="0" anchor="ctr" lIns="27432" rIns="27432" tIns="0" bIns="0"/>
+          <a:lstStyle/>
+          <a:p>
+            <a:pPr algn="ctr"/>
+            <a:r>
+              <a:rPr sz="850" b="1">
+                <a:solidFill>
+                  <a:srgbClr val="FFFFFF"/>
+                </a:solidFill>
+                <a:latin typeface="Arial"/>
+              </a:rPr>
+              <a:t>BUILD</a:t>
+            </a:r>
+          </a:p>
+        </p:txBody>
+      </p:sp>
+      <p:sp>
+        <p:nvSpPr>
+          <p:cNvPr id="24" name="Down Arrow 23"/>
+          <p:cNvSpPr/>
+          <p:nvPr/>
+        </p:nvSpPr>
+        <p:spPr>
+          <a:xfrm>
+            <a:off x="9171432" y="6428232"/>
+            <a:ext cx="128016" cy="292608"/>
+          </a:xfrm>
+          <a:prstGeom prst="downArrow">
+            <a:avLst/>
+          </a:prstGeom>
+          <a:solidFill>
+            <a:srgbClr val="111111"/>
+          </a:solidFill>
+          <a:ln>
+            <a:noFill/>
+          </a:ln>
+          <a:effectLst/>
+        </p:spPr>
+        <p:style>
+          <a:lnRef idx="1">
+            <a:schemeClr val="accent1"/>
+          </a:lnRef>
+          <a:fillRef idx="3">
+            <a:schemeClr val="accent1"/>
+          </a:fillRef>
+          <a:effectRef idx="2">
+            <a:schemeClr val="accent1"/>
+          </a:effectRef>
+          <a:fontRef idx="minor">
+            <a:schemeClr val="lt1"/>
+          </a:fontRef>
+        </p:style>
+        <p:txBody>
+          <a:bodyPr rtlCol="0" anchor="ctr"/>
+          <a:lstStyle/>
+          <a:p>
+            <a:pPr algn="ctr"/>
+          </a:p>
+        </p:txBody>
+      </p:sp>
+      <p:sp>
+        <p:nvSpPr>
+          <p:cNvPr id="25" name="TextBox 24"/>
+          <p:cNvSpPr txBox="1"/>
+          <p:nvPr/>
+        </p:nvSpPr>
+        <p:spPr>
+          <a:xfrm>
+            <a:off x="4206240" y="6739128"/>
+            <a:ext cx="10058400" cy="274320"/>
+          </a:xfrm>
+          <a:prstGeom prst="rect">
+            <a:avLst/>
+          </a:prstGeom>
+          <a:noFill/>
+        </p:spPr>
+        <p:txBody>
+          <a:bodyPr wrap="square" lIns="0" rIns="0" tIns="0" bIns="0">
+            <a:spAutoFit/>
+          </a:bodyPr>
+          <a:lstStyle/>
+          <a:p>
+            <a:pPr algn="l"/>
+            <a:r>
+              <a:rPr sz="950" b="1" i="0">
+                <a:solidFill>
+                  <a:srgbClr val="595959"/>
+                </a:solidFill>
+                <a:latin typeface="Arial"/>
+              </a:rPr>
+              <a:t>STEP 6 · DELIVER</a:t>
+            </a:r>
+          </a:p>
+        </p:txBody>
+      </p:sp>
+      <p:sp>
+        <p:nvSpPr>
+          <p:cNvPr id="26" name="Rounded Rectangle 25"/>
+          <p:cNvSpPr/>
+          <p:nvPr/>
+        </p:nvSpPr>
+        <p:spPr>
+          <a:xfrm>
+            <a:off x="4343400" y="7040880"/>
+            <a:ext cx="4846320" cy="960120"/>
+          </a:xfrm>
+          <a:prstGeom prst="roundRect">
+            <a:avLst>
+              <a:gd name="adj" fmla="val 8000"/>
+            </a:avLst>
+          </a:prstGeom>
+          <a:solidFill>
+            <a:srgbClr val="F4F6F9"/>
+          </a:solidFill>
+          <a:ln w="12700">
+            <a:solidFill>
+              <a:srgbClr val="111111"/>
+            </a:solidFill>
+          </a:ln>
+          <a:effectLst/>
+        </p:spPr>
+        <p:style>
+          <a:lnRef idx="1">
+            <a:schemeClr val="accent1"/>
+          </a:lnRef>
+          <a:fillRef idx="3">
+            <a:schemeClr val="accent1"/>
+          </a:fillRef>
+          <a:effectRef idx="2">
+            <a:schemeClr val="accent1"/>
+          </a:effectRef>
+          <a:fontRef idx="minor">
+            <a:schemeClr val="lt1"/>
+          </a:fontRef>
+        </p:style>
+        <p:txBody>
+          <a:bodyPr rtlCol="0" anchor="ctr" wrap="square" lIns="73152" rIns="73152" tIns="36576" bIns="27432"/>
+          <a:lstStyle/>
+          <a:p>
+            <a:pPr algn="ctr"/>
+            <a:r>
+              <a:rPr sz="1150" b="1">
+                <a:solidFill>
+                  <a:srgbClr val="111111"/>
+                </a:solidFill>
+                <a:latin typeface="Arial"/>
+              </a:rPr>
+              <a:t>Queue per system</a:t>
+            </a:r>
+          </a:p>
+          <a:p>
+            <a:pPr algn="ctr"/>
+            <a:r>
+              <a:rPr sz="900">
+                <a:solidFill>
+                  <a:srgbClr val="595959"/>
+                </a:solidFill>
+                <a:latin typeface="Arial"/>
+              </a:rPr>
+              <a:t>retries automatically · failures park on an error queue and alert a named owner</a:t>
+            </a:r>
+          </a:p>
+        </p:txBody>
+      </p:sp>
+      <p:sp>
+        <p:nvSpPr>
+          <p:cNvPr id="27" name="Rounded Rectangle 26"/>
+          <p:cNvSpPr/>
+          <p:nvPr/>
+        </p:nvSpPr>
+        <p:spPr>
+          <a:xfrm>
+            <a:off x="8503920" y="6922008"/>
+            <a:ext cx="612648" cy="237744"/>
+          </a:xfrm>
+          <a:prstGeom prst="roundRect">
+            <a:avLst>
+              <a:gd name="adj" fmla="val 8000"/>
+            </a:avLst>
+          </a:prstGeom>
+          <a:solidFill>
+            <a:srgbClr val="374151"/>
+          </a:solidFill>
+          <a:ln w="9525">
+            <a:solidFill>
+              <a:srgbClr val="374151"/>
+            </a:solidFill>
+          </a:ln>
+          <a:effectLst/>
+        </p:spPr>
+        <p:style>
+          <a:lnRef idx="1">
+            <a:schemeClr val="accent1"/>
+          </a:lnRef>
+          <a:fillRef idx="3">
+            <a:schemeClr val="accent1"/>
+          </a:fillRef>
+          <a:effectRef idx="2">
+            <a:schemeClr val="accent1"/>
+          </a:effectRef>
+          <a:fontRef idx="minor">
+            <a:schemeClr val="lt1"/>
+          </a:fontRef>
+        </p:style>
+        <p:txBody>
+          <a:bodyPr rtlCol="0" anchor="ctr" lIns="27432" rIns="27432" tIns="0" bIns="0"/>
+          <a:lstStyle/>
+          <a:p>
+            <a:pPr algn="ctr"/>
+            <a:r>
+              <a:rPr sz="850" b="1">
+                <a:solidFill>
+                  <a:srgbClr val="FFFFFF"/>
+                </a:solidFill>
+                <a:latin typeface="Arial"/>
+              </a:rPr>
+              <a:t>CONFIG</a:t>
+            </a:r>
+          </a:p>
+        </p:txBody>
+      </p:sp>
+      <p:sp>
+        <p:nvSpPr>
+          <p:cNvPr id="28" name="Rounded Rectangle 27"/>
+          <p:cNvSpPr/>
+          <p:nvPr/>
+        </p:nvSpPr>
+        <p:spPr>
+          <a:xfrm>
+            <a:off x="9372600" y="7040880"/>
+            <a:ext cx="4846320" cy="960120"/>
+          </a:xfrm>
+          <a:prstGeom prst="roundRect">
+            <a:avLst>
+              <a:gd name="adj" fmla="val 8000"/>
+            </a:avLst>
+          </a:prstGeom>
+          <a:solidFill>
+            <a:srgbClr val="F4F6F9"/>
+          </a:solidFill>
+          <a:ln w="12700">
+            <a:solidFill>
+              <a:srgbClr val="111111"/>
+            </a:solidFill>
+          </a:ln>
+          <a:effectLst/>
+        </p:spPr>
+        <p:style>
+          <a:lnRef idx="1">
+            <a:schemeClr val="accent1"/>
+          </a:lnRef>
+          <a:fillRef idx="3">
+            <a:schemeClr val="accent1"/>
+          </a:fillRef>
+          <a:effectRef idx="2">
+            <a:schemeClr val="accent1"/>
+          </a:effectRef>
+          <a:fontRef idx="minor">
+            <a:schemeClr val="lt1"/>
+          </a:fontRef>
+        </p:style>
+        <p:txBody>
+          <a:bodyPr rtlCol="0" anchor="ctr" wrap="square" lIns="73152" rIns="73152" tIns="36576" bIns="27432"/>
+          <a:lstStyle/>
+          <a:p>
+            <a:pPr algn="ctr"/>
+            <a:r>
+              <a:rPr sz="1150" b="1">
+                <a:solidFill>
+                  <a:srgbClr val="111111"/>
+                </a:solidFill>
+                <a:latin typeface="Arial"/>
+              </a:rPr>
+              <a:t>Delivery senders</a:t>
+            </a:r>
+          </a:p>
+          <a:p>
+            <a:pPr algn="ctr"/>
+            <a:r>
+              <a:rPr sz="900">
+                <a:solidFill>
+                  <a:srgbClr val="595959"/>
+                </a:solidFill>
+                <a:latin typeface="Arial"/>
+              </a:rPr>
+              <a:t>one per system: JAMS · SN ITSM · SN Defence · Sitetracker · file</a:t>
+            </a:r>
+          </a:p>
+        </p:txBody>
+      </p:sp>
+      <p:sp>
+        <p:nvSpPr>
+          <p:cNvPr id="29" name="Rounded Rectangle 28"/>
+          <p:cNvSpPr/>
+          <p:nvPr/>
+        </p:nvSpPr>
+        <p:spPr>
+          <a:xfrm>
+            <a:off x="13610844" y="6922008"/>
+            <a:ext cx="534924" cy="237744"/>
+          </a:xfrm>
+          <a:prstGeom prst="roundRect">
+            <a:avLst>
+              <a:gd name="adj" fmla="val 8000"/>
+            </a:avLst>
+          </a:prstGeom>
+          <a:solidFill>
+            <a:srgbClr val="1E56A0"/>
+          </a:solidFill>
+          <a:ln w="9525">
+            <a:solidFill>
+              <a:srgbClr val="1E56A0"/>
+            </a:solidFill>
+          </a:ln>
+          <a:effectLst/>
+        </p:spPr>
+        <p:style>
+          <a:lnRef idx="1">
+            <a:schemeClr val="accent1"/>
+          </a:lnRef>
+          <a:fillRef idx="3">
+            <a:schemeClr val="accent1"/>
+          </a:fillRef>
+          <a:effectRef idx="2">
+            <a:schemeClr val="accent1"/>
+          </a:effectRef>
+          <a:fontRef idx="minor">
+            <a:schemeClr val="lt1"/>
+          </a:fontRef>
+        </p:style>
+        <p:txBody>
+          <a:bodyPr rtlCol="0" anchor="ctr" lIns="27432" rIns="27432" tIns="0" bIns="0"/>
+          <a:lstStyle/>
+          <a:p>
+            <a:pPr algn="ctr"/>
+            <a:r>
+              <a:rPr sz="850" b="1">
+                <a:solidFill>
+                  <a:srgbClr val="FFFFFF"/>
+                </a:solidFill>
+                <a:latin typeface="Arial"/>
+              </a:rPr>
+              <a:t>BUILD</a:t>
+            </a:r>
+          </a:p>
+        </p:txBody>
+      </p:sp>
+      <p:sp>
+        <p:nvSpPr>
+          <p:cNvPr id="30" name="Rounded Rectangle 29"/>
+          <p:cNvSpPr/>
+          <p:nvPr/>
+        </p:nvSpPr>
+        <p:spPr>
+          <a:xfrm>
+            <a:off x="4343400" y="9189720"/>
+            <a:ext cx="4846320" cy="822960"/>
+          </a:xfrm>
+          <a:prstGeom prst="roundRect">
+            <a:avLst>
+              <a:gd name="adj" fmla="val 8000"/>
+            </a:avLst>
+          </a:prstGeom>
+          <a:solidFill>
+            <a:srgbClr val="F4F6F9"/>
+          </a:solidFill>
+          <a:ln w="12700">
+            <a:solidFill>
+              <a:srgbClr val="111111"/>
+            </a:solidFill>
+          </a:ln>
+          <a:effectLst/>
+        </p:spPr>
+        <p:style>
+          <a:lnRef idx="1">
+            <a:schemeClr val="accent1"/>
+          </a:lnRef>
+          <a:fillRef idx="3">
+            <a:schemeClr val="accent1"/>
+          </a:fillRef>
+          <a:effectRef idx="2">
+            <a:schemeClr val="accent1"/>
+          </a:effectRef>
+          <a:fontRef idx="minor">
+            <a:schemeClr val="lt1"/>
+          </a:fontRef>
+        </p:style>
+        <p:txBody>
+          <a:bodyPr rtlCol="0" anchor="ctr" wrap="square" lIns="73152" rIns="73152" tIns="36576" bIns="27432"/>
+          <a:lstStyle/>
+          <a:p>
+            <a:pPr algn="ctr"/>
+            <a:r>
+              <a:rPr sz="1150" b="1">
+                <a:solidFill>
+                  <a:srgbClr val="111111"/>
+                </a:solidFill>
+                <a:latin typeface="Arial"/>
+              </a:rPr>
+              <a:t>Error logging</a:t>
+            </a:r>
+          </a:p>
+          <a:p>
+            <a:pPr algn="ctr"/>
+            <a:r>
+              <a:rPr sz="900">
+                <a:solidFill>
+                  <a:srgbClr val="595959"/>
+                </a:solidFill>
+                <a:latin typeface="Arial"/>
+              </a:rPr>
+              <a:t>extends the existing log — one view for both directions of integration</a:t>
+            </a:r>
+          </a:p>
+        </p:txBody>
+      </p:sp>
+      <p:sp>
+        <p:nvSpPr>
+          <p:cNvPr id="31" name="Rounded Rectangle 30"/>
+          <p:cNvSpPr/>
+          <p:nvPr/>
+        </p:nvSpPr>
+        <p:spPr>
+          <a:xfrm>
+            <a:off x="8503920" y="9070848"/>
+            <a:ext cx="612648" cy="237744"/>
+          </a:xfrm>
+          <a:prstGeom prst="roundRect">
+            <a:avLst>
+              <a:gd name="adj" fmla="val 8000"/>
+            </a:avLst>
+          </a:prstGeom>
+          <a:solidFill>
+            <a:srgbClr val="0F7A3D"/>
+          </a:solidFill>
+          <a:ln w="9525">
+            <a:solidFill>
+              <a:srgbClr val="0F7A3D"/>
+            </a:solidFill>
+          </a:ln>
+          <a:effectLst/>
+        </p:spPr>
+        <p:style>
+          <a:lnRef idx="1">
+            <a:schemeClr val="accent1"/>
+          </a:lnRef>
+          <a:fillRef idx="3">
+            <a:schemeClr val="accent1"/>
+          </a:fillRef>
+          <a:effectRef idx="2">
+            <a:schemeClr val="accent1"/>
+          </a:effectRef>
+          <a:fontRef idx="minor">
+            <a:schemeClr val="lt1"/>
+          </a:fontRef>
+        </p:style>
+        <p:txBody>
+          <a:bodyPr rtlCol="0" anchor="ctr" lIns="27432" rIns="27432" tIns="0" bIns="0"/>
+          <a:lstStyle/>
+          <a:p>
+            <a:pPr algn="ctr"/>
+            <a:r>
+              <a:rPr sz="850" b="1">
+                <a:solidFill>
+                  <a:srgbClr val="FFFFFF"/>
+                </a:solidFill>
+                <a:latin typeface="Arial"/>
+              </a:rPr>
+              <a:t>EXTEND</a:t>
+            </a:r>
+          </a:p>
+        </p:txBody>
+      </p:sp>
+      <p:sp>
+        <p:nvSpPr>
+          <p:cNvPr id="32" name="Rounded Rectangle 31"/>
+          <p:cNvSpPr/>
+          <p:nvPr/>
+        </p:nvSpPr>
+        <p:spPr>
+          <a:xfrm>
+            <a:off x="9372600" y="9189720"/>
+            <a:ext cx="4846320" cy="822960"/>
+          </a:xfrm>
+          <a:prstGeom prst="roundRect">
+            <a:avLst>
+              <a:gd name="adj" fmla="val 8000"/>
+            </a:avLst>
+          </a:prstGeom>
+          <a:solidFill>
+            <a:srgbClr val="F4F6F9"/>
+          </a:solidFill>
+          <a:ln w="12700">
+            <a:solidFill>
+              <a:srgbClr val="111111"/>
+            </a:solidFill>
+          </a:ln>
+          <a:effectLst/>
+        </p:spPr>
+        <p:style>
+          <a:lnRef idx="1">
+            <a:schemeClr val="accent1"/>
+          </a:lnRef>
+          <a:fillRef idx="3">
+            <a:schemeClr val="accent1"/>
+          </a:fillRef>
+          <a:effectRef idx="2">
+            <a:schemeClr val="accent1"/>
+          </a:effectRef>
+          <a:fontRef idx="minor">
+            <a:schemeClr val="lt1"/>
+          </a:fontRef>
+        </p:style>
+        <p:txBody>
+          <a:bodyPr rtlCol="0" anchor="ctr" wrap="square" lIns="73152" rIns="73152" tIns="36576" bIns="27432"/>
+          <a:lstStyle/>
+          <a:p>
+            <a:pPr algn="ctr"/>
+            <a:r>
+              <a:rPr sz="1150" b="1">
+                <a:solidFill>
+                  <a:srgbClr val="111111"/>
+                </a:solidFill>
+                <a:latin typeface="Arial"/>
+              </a:rPr>
+              <a:t>Re-send tool</a:t>
+            </a:r>
+          </a:p>
+          <a:p>
+            <a:pPr algn="ctr"/>
+            <a:r>
+              <a:rPr sz="900">
+                <a:solidFill>
+                  <a:srgbClr val="595959"/>
+                </a:solidFill>
+                <a:latin typeface="Arial"/>
+              </a:rPr>
+              <a:t>re-send an error queue after recovery, or a whole date range — also does first loads</a:t>
+            </a:r>
+          </a:p>
+        </p:txBody>
+      </p:sp>
+      <p:sp>
+        <p:nvSpPr>
+          <p:cNvPr id="33" name="Rounded Rectangle 32"/>
+          <p:cNvSpPr/>
+          <p:nvPr/>
+        </p:nvSpPr>
+        <p:spPr>
+          <a:xfrm>
+            <a:off x="13610844" y="9070848"/>
+            <a:ext cx="534924" cy="237744"/>
+          </a:xfrm>
+          <a:prstGeom prst="roundRect">
+            <a:avLst>
+              <a:gd name="adj" fmla="val 8000"/>
+            </a:avLst>
+          </a:prstGeom>
+          <a:solidFill>
+            <a:srgbClr val="1E56A0"/>
+          </a:solidFill>
+          <a:ln w="9525">
+            <a:solidFill>
+              <a:srgbClr val="1E56A0"/>
+            </a:solidFill>
+          </a:ln>
+          <a:effectLst/>
+        </p:spPr>
+        <p:style>
+          <a:lnRef idx="1">
+            <a:schemeClr val="accent1"/>
+          </a:lnRef>
+          <a:fillRef idx="3">
+            <a:schemeClr val="accent1"/>
+          </a:fillRef>
+          <a:effectRef idx="2">
+            <a:schemeClr val="accent1"/>
+          </a:effectRef>
+          <a:fontRef idx="minor">
+            <a:schemeClr val="lt1"/>
+          </a:fontRef>
+        </p:style>
+        <p:txBody>
+          <a:bodyPr rtlCol="0" anchor="ctr" lIns="27432" rIns="27432" tIns="0" bIns="0"/>
+          <a:lstStyle/>
+          <a:p>
+            <a:pPr algn="ctr"/>
+            <a:r>
+              <a:rPr sz="850" b="1">
+                <a:solidFill>
+                  <a:srgbClr val="FFFFFF"/>
+                </a:solidFill>
+                <a:latin typeface="Arial"/>
+              </a:rPr>
+              <a:t>BUILD</a:t>
+            </a:r>
+          </a:p>
+        </p:txBody>
+      </p:sp>
+      <p:sp>
+        <p:nvSpPr>
+          <p:cNvPr id="34" name="Rounded Rectangle 33"/>
+          <p:cNvSpPr/>
+          <p:nvPr/>
+        </p:nvSpPr>
+        <p:spPr>
+          <a:xfrm>
+            <a:off x="640080" y="3840480"/>
+            <a:ext cx="2651760" cy="1371600"/>
+          </a:xfrm>
+          <a:prstGeom prst="roundRect">
+            <a:avLst>
+              <a:gd name="adj" fmla="val 8000"/>
+            </a:avLst>
+          </a:prstGeom>
+          <a:solidFill>
+            <a:srgbClr val="FFFFFF"/>
+          </a:solidFill>
+          <a:ln w="19050">
+            <a:solidFill>
+              <a:srgbClr val="111111"/>
+            </a:solidFill>
+          </a:ln>
+          <a:effectLst/>
+        </p:spPr>
+        <p:style>
+          <a:lnRef idx="1">
+            <a:schemeClr val="accent1"/>
+          </a:lnRef>
+          <a:fillRef idx="3">
+            <a:schemeClr val="accent1"/>
+          </a:fillRef>
+          <a:effectRef idx="2">
+            <a:schemeClr val="accent1"/>
+          </a:effectRef>
+          <a:fontRef idx="minor">
+            <a:schemeClr val="lt1"/>
+          </a:fontRef>
+        </p:style>
+        <p:txBody>
+          <a:bodyPr rtlCol="0" anchor="ctr" wrap="square" lIns="73152" rIns="73152"/>
+          <a:lstStyle/>
+          <a:p>
+            <a:pPr algn="ctr"/>
+            <a:r>
+              <a:rPr sz="1300" b="1">
+                <a:solidFill>
+                  <a:srgbClr val="111111"/>
+                </a:solidFill>
+                <a:latin typeface="Arial"/>
+              </a:rPr>
+              <a:t>S/4HANA</a:t>
+            </a:r>
+          </a:p>
+          <a:p>
+            <a:pPr algn="ctr"/>
+            <a:r>
+              <a:rPr sz="900">
+                <a:solidFill>
+                  <a:srgbClr val="595959"/>
+                </a:solidFill>
+                <a:latin typeface="Arial"/>
+              </a:rPr>
+              <a:t>configuration only —
+no development possible or needed</a:t>
+            </a:r>
+          </a:p>
+        </p:txBody>
+      </p:sp>
+      <p:sp>
+        <p:nvSpPr>
+          <p:cNvPr id="35" name="Rounded Rectangle 34"/>
+          <p:cNvSpPr/>
+          <p:nvPr/>
+        </p:nvSpPr>
+        <p:spPr>
+          <a:xfrm>
+            <a:off x="777240" y="3712463"/>
+            <a:ext cx="1005840" cy="237744"/>
+          </a:xfrm>
+          <a:prstGeom prst="roundRect">
+            <a:avLst>
+              <a:gd name="adj" fmla="val 8000"/>
+            </a:avLst>
+          </a:prstGeom>
+          <a:solidFill>
+            <a:srgbClr val="111111"/>
+          </a:solidFill>
+          <a:ln w="9525">
+            <a:solidFill>
+              <a:srgbClr val="111111"/>
+            </a:solidFill>
+          </a:ln>
+          <a:effectLst/>
+        </p:spPr>
+        <p:style>
+          <a:lnRef idx="1">
+            <a:schemeClr val="accent1"/>
+          </a:lnRef>
+          <a:fillRef idx="3">
+            <a:schemeClr val="accent1"/>
+          </a:fillRef>
+          <a:effectRef idx="2">
+            <a:schemeClr val="accent1"/>
+          </a:effectRef>
+          <a:fontRef idx="minor">
+            <a:schemeClr val="lt1"/>
+          </a:fontRef>
+        </p:style>
+        <p:txBody>
+          <a:bodyPr rtlCol="0" anchor="ctr" lIns="27432" rIns="27432" tIns="0" bIns="0"/>
+          <a:lstStyle/>
+          <a:p>
+            <a:pPr algn="ctr"/>
+            <a:r>
+              <a:rPr sz="850" b="1">
+                <a:solidFill>
+                  <a:srgbClr val="FFFFFF"/>
+                </a:solidFill>
+                <a:latin typeface="Arial"/>
+              </a:rPr>
+              <a:t>SAP CLOUD</a:t>
+            </a:r>
+          </a:p>
+        </p:txBody>
+      </p:sp>
+      <p:sp>
+        <p:nvSpPr>
+          <p:cNvPr id="36" name="Right Arrow 35"/>
+          <p:cNvSpPr/>
+          <p:nvPr/>
+        </p:nvSpPr>
+        <p:spPr>
+          <a:xfrm>
+            <a:off x="3337560" y="4434840"/>
+            <a:ext cx="594360" cy="109728"/>
+          </a:xfrm>
+          <a:prstGeom prst="rightArrow">
+            <a:avLst/>
+          </a:prstGeom>
+          <a:solidFill>
+            <a:srgbClr val="111111"/>
+          </a:solidFill>
+          <a:ln>
+            <a:noFill/>
+          </a:ln>
+          <a:effectLst/>
+        </p:spPr>
+        <p:style>
+          <a:lnRef idx="1">
+            <a:schemeClr val="accent1"/>
+          </a:lnRef>
+          <a:fillRef idx="3">
+            <a:schemeClr val="accent1"/>
+          </a:fillRef>
+          <a:effectRef idx="2">
+            <a:schemeClr val="accent1"/>
+          </a:effectRef>
+          <a:fontRef idx="minor">
+            <a:schemeClr val="lt1"/>
+          </a:fontRef>
+        </p:style>
+        <p:txBody>
+          <a:bodyPr rtlCol="0" anchor="ctr"/>
+          <a:lstStyle/>
+          <a:p>
+            <a:pPr algn="ctr"/>
+          </a:p>
+        </p:txBody>
+      </p:sp>
+      <p:sp>
+        <p:nvSpPr>
+          <p:cNvPr id="37" name="TextBox 36"/>
+          <p:cNvSpPr txBox="1"/>
+          <p:nvPr/>
+        </p:nvSpPr>
+        <p:spPr>
+          <a:xfrm>
+            <a:off x="2880360" y="3931920"/>
+            <a:ext cx="1554480" cy="457200"/>
+          </a:xfrm>
+          <a:prstGeom prst="rect">
+            <a:avLst/>
+          </a:prstGeom>
+          <a:noFill/>
+        </p:spPr>
+        <p:txBody>
+          <a:bodyPr wrap="square" lIns="0" rIns="0" tIns="0" bIns="0">
+            <a:spAutoFit/>
+          </a:bodyPr>
+          <a:lstStyle/>
+          <a:p>
+            <a:pPr algn="ctr"/>
+            <a:r>
+              <a:rPr sz="850" b="1" i="0">
+                <a:solidFill>
+                  <a:srgbClr val="0F7A3D"/>
+                </a:solidFill>
+                <a:latin typeface="Arial"/>
+              </a:rPr>
+              <a:t>notices +</a:t>
+            </a:r>
+          </a:p>
+          <a:p>
+            <a:pPr algn="ctr"/>
+            <a:r>
+              <a:rPr sz="850" b="1" i="0">
+                <a:solidFill>
+                  <a:srgbClr val="0F7A3D"/>
+                </a:solidFill>
+                <a:latin typeface="Arial"/>
+              </a:rPr>
+              <a:t>record reads</a:t>
+            </a:r>
+          </a:p>
+        </p:txBody>
+      </p:sp>
+      <p:sp>
+        <p:nvSpPr>
+          <p:cNvPr id="38" name="Rounded Rectangle 37"/>
+          <p:cNvSpPr/>
+          <p:nvPr/>
+        </p:nvSpPr>
+        <p:spPr>
+          <a:xfrm>
+            <a:off x="14950440" y="3840480"/>
+            <a:ext cx="2743200" cy="1737360"/>
+          </a:xfrm>
+          <a:prstGeom prst="roundRect">
+            <a:avLst>
+              <a:gd name="adj" fmla="val 8000"/>
+            </a:avLst>
+          </a:prstGeom>
+          <a:solidFill>
+            <a:srgbClr val="FFFFFF"/>
+          </a:solidFill>
+          <a:ln w="19050">
+            <a:solidFill>
+              <a:srgbClr val="111111"/>
+            </a:solidFill>
+          </a:ln>
+          <a:effectLst/>
+        </p:spPr>
+        <p:style>
+          <a:lnRef idx="1">
+            <a:schemeClr val="accent1"/>
+          </a:lnRef>
+          <a:fillRef idx="3">
+            <a:schemeClr val="accent1"/>
+          </a:fillRef>
+          <a:effectRef idx="2">
+            <a:schemeClr val="accent1"/>
+          </a:effectRef>
+          <a:fontRef idx="minor">
+            <a:schemeClr val="lt1"/>
+          </a:fontRef>
+        </p:style>
+        <p:txBody>
+          <a:bodyPr rtlCol="0" anchor="ctr" wrap="square" lIns="73152" rIns="73152"/>
+          <a:lstStyle/>
+          <a:p>
+            <a:pPr algn="ctr"/>
+            <a:r>
+              <a:rPr sz="1300" b="1">
+                <a:solidFill>
+                  <a:srgbClr val="111111"/>
+                </a:solidFill>
+                <a:latin typeface="Arial"/>
+              </a:rPr>
+              <a:t>Field systems</a:t>
+            </a:r>
+          </a:p>
+          <a:p>
+            <a:pPr algn="ctr"/>
+            <a:r>
+              <a:rPr sz="900">
+                <a:solidFill>
+                  <a:srgbClr val="595959"/>
+                </a:solidFill>
+                <a:latin typeface="Arial"/>
+              </a:rPr>
+              <a:t>configuration only,
+except JAMS’s six small
+receiving services</a:t>
+            </a:r>
+          </a:p>
+        </p:txBody>
+      </p:sp>
+      <p:sp>
+        <p:nvSpPr>
+          <p:cNvPr id="39" name="Rounded Rectangle 38"/>
+          <p:cNvSpPr/>
+          <p:nvPr/>
+        </p:nvSpPr>
+        <p:spPr>
+          <a:xfrm>
+            <a:off x="15087600" y="3712463"/>
+            <a:ext cx="1234440" cy="237744"/>
+          </a:xfrm>
+          <a:prstGeom prst="roundRect">
+            <a:avLst>
+              <a:gd name="adj" fmla="val 8000"/>
+            </a:avLst>
+          </a:prstGeom>
+          <a:solidFill>
+            <a:srgbClr val="6B7280"/>
+          </a:solidFill>
+          <a:ln w="9525">
+            <a:solidFill>
+              <a:srgbClr val="6B7280"/>
+            </a:solidFill>
+          </a:ln>
+          <a:effectLst/>
+        </p:spPr>
+        <p:style>
+          <a:lnRef idx="1">
+            <a:schemeClr val="accent1"/>
+          </a:lnRef>
+          <a:fillRef idx="3">
+            <a:schemeClr val="accent1"/>
+          </a:fillRef>
+          <a:effectRef idx="2">
+            <a:schemeClr val="accent1"/>
+          </a:effectRef>
+          <a:fontRef idx="minor">
+            <a:schemeClr val="lt1"/>
+          </a:fontRef>
+        </p:style>
+        <p:txBody>
+          <a:bodyPr rtlCol="0" anchor="ctr" lIns="27432" rIns="27432" tIns="0" bIns="0"/>
+          <a:lstStyle/>
+          <a:p>
+            <a:pPr algn="ctr"/>
+            <a:r>
+              <a:rPr sz="800" b="1">
+                <a:solidFill>
+                  <a:srgbClr val="FFFFFF"/>
+                </a:solidFill>
+                <a:latin typeface="Arial"/>
+              </a:rPr>
+              <a:t>FIELD SYSTEMS</a:t>
+            </a:r>
+          </a:p>
+        </p:txBody>
+      </p:sp>
+      <p:sp>
+        <p:nvSpPr>
+          <p:cNvPr id="40" name="Right Arrow 39"/>
+          <p:cNvSpPr/>
+          <p:nvPr/>
+        </p:nvSpPr>
+        <p:spPr>
+          <a:xfrm>
+            <a:off x="14538960" y="4434840"/>
+            <a:ext cx="384048" cy="109728"/>
+          </a:xfrm>
+          <a:prstGeom prst="rightArrow">
+            <a:avLst/>
+          </a:prstGeom>
+          <a:solidFill>
+            <a:srgbClr val="111111"/>
+          </a:solidFill>
+          <a:ln>
+            <a:noFill/>
+          </a:ln>
+          <a:effectLst/>
+        </p:spPr>
+        <p:style>
+          <a:lnRef idx="1">
+            <a:schemeClr val="accent1"/>
+          </a:lnRef>
+          <a:fillRef idx="3">
+            <a:schemeClr val="accent1"/>
+          </a:fillRef>
+          <a:effectRef idx="2">
+            <a:schemeClr val="accent1"/>
+          </a:effectRef>
+          <a:fontRef idx="minor">
+            <a:schemeClr val="lt1"/>
+          </a:fontRef>
+        </p:style>
+        <p:txBody>
+          <a:bodyPr rtlCol="0" anchor="ctr"/>
+          <a:lstStyle/>
+          <a:p>
+            <a:pPr algn="ctr"/>
+          </a:p>
+        </p:txBody>
+      </p:sp>
+      <p:sp>
+        <p:nvSpPr>
+          <p:cNvPr id="41" name="TextBox 40"/>
+          <p:cNvSpPr txBox="1"/>
+          <p:nvPr/>
+        </p:nvSpPr>
+        <p:spPr>
+          <a:xfrm>
+            <a:off x="640080" y="9189720"/>
+            <a:ext cx="3566160" cy="914400"/>
+          </a:xfrm>
+          <a:prstGeom prst="rect">
+            <a:avLst/>
+          </a:prstGeom>
+          <a:noFill/>
+        </p:spPr>
+        <p:txBody>
+          <a:bodyPr wrap="square" lIns="0" rIns="0" tIns="0" bIns="0">
+            <a:spAutoFit/>
+          </a:bodyPr>
+          <a:lstStyle/>
+          <a:p>
+            <a:pPr algn="l"/>
+            <a:r>
+              <a:rPr sz="950" b="0" i="0">
+                <a:solidFill>
+                  <a:srgbClr val="595959"/>
+                </a:solidFill>
+                <a:latin typeface="Arial"/>
+              </a:rPr>
+              <a:t>BUILD = development in CPI, assembled from standard delivered pieces</a:t>
+            </a:r>
+          </a:p>
+          <a:p>
+            <a:pPr algn="l"/>
+            <a:r>
+              <a:rPr sz="950" b="0" i="0">
+                <a:solidFill>
+                  <a:srgbClr val="595959"/>
+                </a:solidFill>
+                <a:latin typeface="Arial"/>
+              </a:rPr>
+              <a:t>CONFIG = configuration only</a:t>
+            </a:r>
+          </a:p>
+          <a:p>
+            <a:pPr algn="l"/>
+            <a:r>
+              <a:rPr sz="950" b="0" i="0">
+                <a:solidFill>
+                  <a:srgbClr val="595959"/>
+                </a:solidFill>
+                <a:latin typeface="Arial"/>
+              </a:rPr>
+              <a:t>EXTEND = existing part extended</a:t>
+            </a:r>
+          </a:p>
+        </p:txBody>
+      </p:sp>
+      <p:sp>
+        <p:nvSpPr>
+          <p:cNvPr id="42" name="TextBox 41"/>
+          <p:cNvSpPr txBox="1"/>
+          <p:nvPr/>
+        </p:nvSpPr>
+        <p:spPr>
+          <a:xfrm>
+            <a:off x="640080" y="10076688"/>
+            <a:ext cx="17190720" cy="0"/>
+          </a:xfrm>
+          <a:prstGeom prst="rect">
+            <a:avLst/>
+          </a:prstGeom>
+          <a:noFill/>
+        </p:spPr>
+        <p:txBody>
+          <a:bodyPr wrap="square" lIns="0" rIns="0" tIns="0" bIns="0">
+            <a:spAutoFit/>
+          </a:bodyPr>
+          <a:lstStyle/>
+          <a:p>
+            <a:pPr algn="l"/>
+            <a:r>
+              <a:rPr sz="100" b="0" i="0">
+                <a:solidFill>
+                  <a:srgbClr val="111111"/>
+                </a:solidFill>
+                <a:latin typeface="Arial"/>
+              </a:rPr>
+              <a:t/>
+            </a:r>
           </a:p>
         </p:txBody>
       </p:sp>

</xml_diff>

<commit_message>
ARB deck: complete A/B/C/D options table inserted after the original options slide
New slide 5 in the same green-header style: the original three options
abridged faithfully (A red/JDW, B decided-kept-as-fallback, C noted)
plus Option D as the proposed recommendation, with the updated
recommendation box: Option D as the rule, built on Option B.

Co-Authored-By: Claude Fable 5 <noreply@anthropic.com>
Claude-Session: https://claude.ai/code/session_01J9sMjqcGkRLhakCptK95KF
</commit_message>
<xml_diff>
--- a/docs/JAMS-WriteBack-Callback-S4-Key-Design-Decision-2.pptx
+++ b/docs/JAMS-WriteBack-Callback-S4-Key-Design-Decision-2.pptx
@@ -12,6 +12,7 @@
     <p:sldId id="257" r:id="rId6"/>
     <p:sldId id="258" r:id="rId7"/>
     <p:sldId id="275" r:id="rId8"/>
+    <p:sldId id="284" r:id="rId34"/>
     <p:sldId id="260" r:id="rId9"/>
     <p:sldId id="261" r:id="rId10"/>
     <p:sldId id="273" r:id="rId11"/>
@@ -19344,1968 +19345,6 @@
         <p:spPr>
           <a:xfrm>
             <a:off x="640080" y="320040"/>
-            <a:ext cx="13716000" cy="548640"/>
-          </a:xfrm>
-          <a:prstGeom prst="rect">
-            <a:avLst/>
-          </a:prstGeom>
-          <a:noFill/>
-        </p:spPr>
-        <p:txBody>
-          <a:bodyPr wrap="square" lIns="0" rIns="0" tIns="0" bIns="0" anchor="t">
-            <a:spAutoFit/>
-          </a:bodyPr>
-          <a:lstStyle/>
-          <a:p>
-            <a:pPr algn="l"/>
-            <a:r>
-              <a:rPr sz="2200" b="1" i="0">
-                <a:solidFill>
-                  <a:srgbClr val="1F3864"/>
-                </a:solidFill>
-                <a:latin typeface="Arial"/>
-              </a:rPr>
-              <a:t>Option D – What It Takes to Build</a:t>
-            </a:r>
-          </a:p>
-        </p:txBody>
-      </p:sp>
-      <p:sp>
-        <p:nvSpPr>
-          <p:cNvPr id="4" name="TextBox 3"/>
-          <p:cNvSpPr txBox="1"/>
-          <p:nvPr/>
-        </p:nvSpPr>
-        <p:spPr>
-          <a:xfrm>
-            <a:off x="640080" y="868680"/>
-            <a:ext cx="16002000" cy="365760"/>
-          </a:xfrm>
-          <a:prstGeom prst="rect">
-            <a:avLst/>
-          </a:prstGeom>
-          <a:noFill/>
-        </p:spPr>
-        <p:txBody>
-          <a:bodyPr wrap="square" lIns="0" rIns="0" tIns="0" bIns="0" anchor="t">
-            <a:spAutoFit/>
-          </a:bodyPr>
-          <a:lstStyle/>
-          <a:p>
-            <a:pPr algn="l"/>
-            <a:r>
-              <a:rPr sz="1200" b="0" i="0">
-                <a:solidFill>
-                  <a:srgbClr val="595959"/>
-                </a:solidFill>
-                <a:latin typeface="Arial"/>
-              </a:rPr>
-              <a:t>S/4: configuration only. CPI: the only development. Licences: nothing new to buy.</a:t>
-            </a:r>
-          </a:p>
-        </p:txBody>
-      </p:sp>
-      <p:graphicFrame>
-        <p:nvGraphicFramePr>
-          <p:cNvPr id="5" name="Table 4"/>
-          <p:cNvGraphicFramePr>
-            <a:graphicFrameLocks noGrp="1"/>
-          </p:cNvGraphicFramePr>
-          <p:nvPr/>
-        </p:nvGraphicFramePr>
-        <p:xfrm>
-          <a:off x="640080" y="1600200"/>
-          <a:ext cx="17007840" cy="4937760"/>
-        </p:xfrm>
-        <a:graphic>
-          <a:graphicData uri="http://schemas.openxmlformats.org/drawingml/2006/table">
-            <a:tbl>
-              <a:tblPr firstRow="1" bandRow="1">
-                <a:tableStyleId>{5C22544A-7EE6-4342-B048-85BDC9FD1C3A}</a:tableStyleId>
-              </a:tblPr>
-              <a:tblGrid>
-                <a:gridCol w="2377440"/>
-                <a:gridCol w="8229600"/>
-                <a:gridCol w="6400800"/>
-              </a:tblGrid>
-              <a:tr h="987552">
-                <a:tc>
-                  <a:txBody>
-                    <a:bodyPr wrap="square"/>
-                    <a:lstStyle/>
-                    <a:p>
-                      <a:r>
-                        <a:rPr sz="1050" b="1">
-                          <a:solidFill>
-                            <a:srgbClr val="1F3864"/>
-                          </a:solidFill>
-                          <a:latin typeface="Arial"/>
-                        </a:rPr>
-                        <a:t>Where</a:t>
-                      </a:r>
-                    </a:p>
-                  </a:txBody>
-                  <a:tcPr marL="73152" marR="73152" marT="36576" marB="36576">
-                    <a:solidFill>
-                      <a:srgbClr val="F4F6F9"/>
-                    </a:solidFill>
-                  </a:tcPr>
-                </a:tc>
-                <a:tc>
-                  <a:txBody>
-                    <a:bodyPr wrap="square"/>
-                    <a:lstStyle/>
-                    <a:p>
-                      <a:r>
-                        <a:rPr sz="1050" b="1">
-                          <a:solidFill>
-                            <a:srgbClr val="1F3864"/>
-                          </a:solidFill>
-                          <a:latin typeface="Arial"/>
-                        </a:rPr>
-                        <a:t>What is needed</a:t>
-                      </a:r>
-                    </a:p>
-                  </a:txBody>
-                  <a:tcPr marL="73152" marR="73152" marT="36576" marB="36576">
-                    <a:solidFill>
-                      <a:srgbClr val="F4F6F9"/>
-                    </a:solidFill>
-                  </a:tcPr>
-                </a:tc>
-                <a:tc>
-                  <a:txBody>
-                    <a:bodyPr wrap="square"/>
-                    <a:lstStyle/>
-                    <a:p>
-                      <a:r>
-                        <a:rPr sz="1050" b="1">
-                          <a:solidFill>
-                            <a:srgbClr val="1F3864"/>
-                          </a:solidFill>
-                          <a:latin typeface="Arial"/>
-                        </a:rPr>
-                        <a:t>Proof / status</a:t>
-                      </a:r>
-                    </a:p>
-                  </a:txBody>
-                  <a:tcPr marL="73152" marR="73152" marT="36576" marB="36576">
-                    <a:solidFill>
-                      <a:srgbClr val="F4F6F9"/>
-                    </a:solidFill>
-                  </a:tcPr>
-                </a:tc>
-              </a:tr>
-              <a:tr h="987552">
-                <a:tc>
-                  <a:txBody>
-                    <a:bodyPr wrap="square"/>
-                    <a:lstStyle/>
-                    <a:p>
-                      <a:r>
-                        <a:rPr b="0" sz="1050">
-                          <a:solidFill>
-                            <a:srgbClr val="111111"/>
-                          </a:solidFill>
-                          <a:latin typeface="Arial"/>
-                        </a:rPr>
-                        <a:t>S/4HANA</a:t>
-                      </a:r>
-                    </a:p>
-                  </a:txBody>
-                  <a:tcPr marL="73152" marR="73152" marT="36576" marB="36576">
-                    <a:solidFill>
-                      <a:srgbClr val="FFFFFF"/>
-                    </a:solidFill>
-                  </a:tcPr>
-                </a:tc>
-                <a:tc>
-                  <a:txBody>
-                    <a:bodyPr wrap="square"/>
-                    <a:lstStyle/>
-                    <a:p>
-                      <a:r>
-                        <a:rPr sz="1050" b="0">
-                          <a:solidFill>
-                            <a:srgbClr val="111111"/>
-                          </a:solidFill>
-                          <a:latin typeface="Arial"/>
-                        </a:rPr>
-                        <a:t>Configuration in standard apps only: switch on the change notice per kind of data (a two-minute step each). No development — none is even possible in our cloud edition.</a:t>
-                      </a:r>
-                    </a:p>
-                  </a:txBody>
-                  <a:tcPr marL="73152" marR="73152" marT="36576" marB="36576">
-                    <a:solidFill>
-                      <a:srgbClr val="FFFFFF"/>
-                    </a:solidFill>
-                  </a:tcPr>
-                </a:tc>
-                <a:tc>
-                  <a:txBody>
-                    <a:bodyPr wrap="square"/>
-                    <a:lstStyle/>
-                    <a:p>
-                      <a:r>
-                        <a:rPr sz="1050" b="0">
-                          <a:solidFill>
-                            <a:srgbClr val="111111"/>
-                          </a:solidFill>
-                          <a:latin typeface="Arial"/>
-                        </a:rPr>
-                        <a:t>The notice channel is already active in our tenant, with one notice (service entry sheet) switched on and working today.</a:t>
-                      </a:r>
-                    </a:p>
-                  </a:txBody>
-                  <a:tcPr marL="73152" marR="73152" marT="36576" marB="36576">
-                    <a:solidFill>
-                      <a:srgbClr val="FFFFFF"/>
-                    </a:solidFill>
-                  </a:tcPr>
-                </a:tc>
-              </a:tr>
-              <a:tr h="987552">
-                <a:tc>
-                  <a:txBody>
-                    <a:bodyPr wrap="square"/>
-                    <a:lstStyle/>
-                    <a:p>
-                      <a:r>
-                        <a:rPr b="0" sz="1050">
-                          <a:solidFill>
-                            <a:srgbClr val="111111"/>
-                          </a:solidFill>
-                          <a:latin typeface="Arial"/>
-                        </a:rPr>
-                        <a:t>SAP CPI</a:t>
-                      </a:r>
-                    </a:p>
-                  </a:txBody>
-                  <a:tcPr marL="73152" marR="73152" marT="36576" marB="36576">
-                    <a:solidFill>
-                      <a:srgbClr val="FFFFFF"/>
-                    </a:solidFill>
-                  </a:tcPr>
-                </a:tc>
-                <a:tc>
-                  <a:txBody>
-                    <a:bodyPr wrap="square"/>
-                    <a:lstStyle/>
-                    <a:p>
-                      <a:r>
-                        <a:rPr sz="1050" b="0">
-                          <a:solidFill>
-                            <a:srgbClr val="111111"/>
-                          </a:solidFill>
-                          <a:latin typeface="Arial"/>
-                        </a:rPr>
-                        <a:t>The distribution layer — detect, read, wrap, route, deliver, retry, re-send. Assembled from standard delivered parts; no custom platform components.</a:t>
-                      </a:r>
-                    </a:p>
-                  </a:txBody>
-                  <a:tcPr marL="73152" marR="73152" marT="36576" marB="36576">
-                    <a:solidFill>
-                      <a:srgbClr val="FFFFFF"/>
-                    </a:solidFill>
-                  </a:tcPr>
-                </a:tc>
-                <a:tc>
-                  <a:txBody>
-                    <a:bodyPr wrap="square"/>
-                    <a:lstStyle/>
-                    <a:p>
-                      <a:r>
-                        <a:rPr sz="1050" b="0">
-                          <a:solidFill>
-                            <a:srgbClr val="111111"/>
-                          </a:solidFill>
-                          <a:latin typeface="Arial"/>
-                        </a:rPr>
-                        <a:t>Fully specified for the build partner: numbered requirements, tests and a definition of done (build specification document).</a:t>
-                      </a:r>
-                    </a:p>
-                  </a:txBody>
-                  <a:tcPr marL="73152" marR="73152" marT="36576" marB="36576">
-                    <a:solidFill>
-                      <a:srgbClr val="FFFFFF"/>
-                    </a:solidFill>
-                  </a:tcPr>
-                </a:tc>
-              </a:tr>
-              <a:tr h="987552">
-                <a:tc>
-                  <a:txBody>
-                    <a:bodyPr wrap="square"/>
-                    <a:lstStyle/>
-                    <a:p>
-                      <a:r>
-                        <a:rPr b="0" sz="1050">
-                          <a:solidFill>
-                            <a:srgbClr val="111111"/>
-                          </a:solidFill>
-                          <a:latin typeface="Arial"/>
-                        </a:rPr>
-                        <a:t>Field systems</a:t>
-                      </a:r>
-                    </a:p>
-                  </a:txBody>
-                  <a:tcPr marL="73152" marR="73152" marT="36576" marB="36576">
-                    <a:solidFill>
-                      <a:srgbClr val="FFFFFF"/>
-                    </a:solidFill>
-                  </a:tcPr>
-                </a:tc>
-                <a:tc>
-                  <a:txBody>
-                    <a:bodyPr wrap="square"/>
-                    <a:lstStyle/>
-                    <a:p>
-                      <a:r>
-                        <a:rPr sz="1050" b="0">
-                          <a:solidFill>
-                            <a:srgbClr val="111111"/>
-                          </a:solidFill>
-                          <a:latin typeface="Arial"/>
-                        </a:rPr>
-                        <a:t>Configuration, plus JAMS’s six receiving services.</a:t>
-                      </a:r>
-                    </a:p>
-                  </a:txBody>
-                  <a:tcPr marL="73152" marR="73152" marT="36576" marB="36576">
-                    <a:solidFill>
-                      <a:srgbClr val="FFFFFF"/>
-                    </a:solidFill>
-                  </a:tcPr>
-                </a:tc>
-                <a:tc>
-                  <a:txBody>
-                    <a:bodyPr wrap="square"/>
-                    <a:lstStyle/>
-                    <a:p>
-                      <a:r>
-                        <a:rPr sz="1050" b="0">
-                          <a:solidFill>
-                            <a:srgbClr val="111111"/>
-                          </a:solidFill>
-                          <a:latin typeface="Arial"/>
-                        </a:rPr>
-                        <a:t>Previous slide.</a:t>
-                      </a:r>
-                    </a:p>
-                  </a:txBody>
-                  <a:tcPr marL="73152" marR="73152" marT="36576" marB="36576">
-                    <a:solidFill>
-                      <a:srgbClr val="FFFFFF"/>
-                    </a:solidFill>
-                  </a:tcPr>
-                </a:tc>
-              </a:tr>
-              <a:tr h="987552">
-                <a:tc>
-                  <a:txBody>
-                    <a:bodyPr wrap="square"/>
-                    <a:lstStyle/>
-                    <a:p>
-                      <a:r>
-                        <a:rPr b="0" sz="1050">
-                          <a:solidFill>
-                            <a:srgbClr val="111111"/>
-                          </a:solidFill>
-                          <a:latin typeface="Arial"/>
-                        </a:rPr>
-                        <a:t>Licences</a:t>
-                      </a:r>
-                    </a:p>
-                  </a:txBody>
-                  <a:tcPr marL="73152" marR="73152" marT="36576" marB="36576">
-                    <a:solidFill>
-                      <a:srgbClr val="FFFFFF"/>
-                    </a:solidFill>
-                  </a:tcPr>
-                </a:tc>
-                <a:tc>
-                  <a:txBody>
-                    <a:bodyPr wrap="square"/>
-                    <a:lstStyle/>
-                    <a:p>
-                      <a:r>
-                        <a:rPr sz="1050" b="0">
-                          <a:solidFill>
-                            <a:srgbClr val="111111"/>
-                          </a:solidFill>
-                          <a:latin typeface="Arial"/>
-                        </a:rPr>
-                        <a:t>Everything used is inside licences already held. The event capability is included in our Integration Suite edition; the S/4 extensibility plans show ‘commercial type: none’ in our own account. No AI is used anywhere.</a:t>
-                      </a:r>
-                    </a:p>
-                  </a:txBody>
-                  <a:tcPr marL="73152" marR="73152" marT="36576" marB="36576">
-                    <a:solidFill>
-                      <a:srgbClr val="FFFFFF"/>
-                    </a:solidFill>
-                  </a:tcPr>
-                </a:tc>
-                <a:tc>
-                  <a:txBody>
-                    <a:bodyPr wrap="square"/>
-                    <a:lstStyle/>
-                    <a:p>
-                      <a:r>
-                        <a:rPr sz="1050" b="0">
-                          <a:solidFill>
-                            <a:srgbClr val="111111"/>
-                          </a:solidFill>
-                          <a:latin typeface="Arial"/>
-                        </a:rPr>
-                        <a:t>Checked in our own SAP accounts. One open commercial check: message volumes against existing Integration Suite metering.</a:t>
-                      </a:r>
-                    </a:p>
-                  </a:txBody>
-                  <a:tcPr marL="73152" marR="73152" marT="36576" marB="36576">
-                    <a:solidFill>
-                      <a:srgbClr val="FFFFFF"/>
-                    </a:solidFill>
-                  </a:tcPr>
-                </a:tc>
-              </a:tr>
-            </a:tbl>
-          </a:graphicData>
-        </a:graphic>
-      </p:graphicFrame>
-      <p:sp>
-        <p:nvSpPr>
-          <p:cNvPr id="6" name="TextBox 5"/>
-          <p:cNvSpPr txBox="1"/>
-          <p:nvPr/>
-        </p:nvSpPr>
-        <p:spPr>
-          <a:xfrm>
-            <a:off x="640080" y="7178040"/>
-            <a:ext cx="16916400" cy="457200"/>
-          </a:xfrm>
-          <a:prstGeom prst="rect">
-            <a:avLst/>
-          </a:prstGeom>
-          <a:noFill/>
-        </p:spPr>
-        <p:txBody>
-          <a:bodyPr wrap="square" lIns="0" rIns="0" tIns="0" bIns="0" anchor="t">
-            <a:spAutoFit/>
-          </a:bodyPr>
-          <a:lstStyle/>
-          <a:p>
-            <a:pPr algn="l"/>
-            <a:r>
-              <a:rPr sz="1200" b="1" i="0">
-                <a:solidFill>
-                  <a:srgbClr val="0F7A3D"/>
-                </a:solidFill>
-                <a:latin typeface="Arial"/>
-              </a:rPr>
-              <a:t>Sequencing: the JAMS day-one scope works with the timer alone — the change-notice part improves speed later and blocks nothing.</a:t>
-            </a:r>
-          </a:p>
-        </p:txBody>
-      </p:sp>
-      <p:sp>
-        <p:nvSpPr>
-          <p:cNvPr id="7" name="TextBox 6"/>
-          <p:cNvSpPr txBox="1"/>
-          <p:nvPr/>
-        </p:nvSpPr>
-        <p:spPr>
-          <a:xfrm>
-            <a:off x="640080" y="7635240"/>
-            <a:ext cx="16916400" cy="731520"/>
-          </a:xfrm>
-          <a:prstGeom prst="rect">
-            <a:avLst/>
-          </a:prstGeom>
-          <a:noFill/>
-        </p:spPr>
-        <p:txBody>
-          <a:bodyPr wrap="square" lIns="0" rIns="0" tIns="0" bIns="0" anchor="t">
-            <a:spAutoFit/>
-          </a:bodyPr>
-          <a:lstStyle/>
-          <a:p>
-            <a:pPr algn="l"/>
-            <a:r>
-              <a:rPr sz="1100" b="0" i="0">
-                <a:solidFill>
-                  <a:srgbClr val="595959"/>
-                </a:solidFill>
-                <a:latin typeface="Arial"/>
-              </a:rPr>
-              <a:t>Open before build (with owners): exact change-notice names per data set (Rajesh) · timer frequency per data set (Trajce) · JAMS service addresses, login and six field lists (Trajce + CPI team) · ServiceNow import approach under Defence security rules and ITSM need (Chamila) · Sitetracker need and owner (TBC) · message-volume estimate (Rajesh).</a:t>
-            </a:r>
-          </a:p>
-        </p:txBody>
-      </p:sp>
-    </p:spTree>
-  </p:cSld>
-  <p:clrMapOvr>
-    <a:masterClrMapping/>
-  </p:clrMapOvr>
-</p:sld>
-</file>
-
-<file path=ppt/slides/slide2.xml><?xml version="1.0" encoding="utf-8"?>
-<p:sld xmlns:a="http://schemas.openxmlformats.org/drawingml/2006/main" xmlns:r="http://schemas.openxmlformats.org/officeDocument/2006/relationships" xmlns:p="http://schemas.openxmlformats.org/presentationml/2006/main">
-  <p:cSld name="Slide 2">
-    <p:bg>
-      <p:bgPr>
-        <a:solidFill>
-          <a:srgbClr val="0E2233"/>
-        </a:solidFill>
-        <a:effectLst/>
-      </p:bgPr>
-    </p:bg>
-    <p:spTree>
-      <p:nvGrpSpPr>
-        <p:cNvPr id="1" name=""/>
-        <p:cNvGrpSpPr/>
-        <p:nvPr/>
-      </p:nvGrpSpPr>
-      <p:grpSpPr>
-        <a:xfrm>
-          <a:off x="0" y="0"/>
-          <a:ext cx="0" cy="0"/>
-          <a:chOff x="0" y="0"/>
-          <a:chExt cx="0" cy="0"/>
-        </a:xfrm>
-      </p:grpSpPr>
-      <p:pic>
-        <p:nvPicPr>
-          <p:cNvPr id="2" name="Image 0" descr="preencoded.png"/>
-          <p:cNvPicPr>
-            <a:picLocks noChangeAspect="1"/>
-          </p:cNvPicPr>
-          <p:nvPr/>
-        </p:nvPicPr>
-        <p:blipFill>
-          <a:blip r:embed="rId3"/>
-          <a:srcRect/>
-          <a:stretch/>
-        </p:blipFill>
-        <p:spPr>
-          <a:xfrm>
-            <a:off x="0" y="0"/>
-            <a:ext cx="18288000" cy="10287000"/>
-          </a:xfrm>
-          <a:prstGeom prst="rect">
-            <a:avLst/>
-          </a:prstGeom>
-        </p:spPr>
-      </p:pic>
-      <p:sp>
-        <p:nvSpPr>
-          <p:cNvPr id="3" name="Text 0"/>
-          <p:cNvSpPr/>
-          <p:nvPr/>
-        </p:nvSpPr>
-        <p:spPr>
-          <a:xfrm>
-            <a:off x="1143000" y="3905250"/>
-            <a:ext cx="1515145" cy="2514600"/>
-          </a:xfrm>
-          <a:prstGeom prst="rect">
-            <a:avLst/>
-          </a:prstGeom>
-          <a:noFill/>
-          <a:ln/>
-        </p:spPr>
-        <p:txBody>
-          <a:bodyPr wrap="square" lIns="25400" tIns="25400" rIns="25400" bIns="25400" rtlCol="0" anchor="t">
-            <a:normAutofit lnSpcReduction="10000"/>
-          </a:bodyPr>
-          <a:lstStyle/>
-          <a:p>
-            <a:pPr marL="0" indent="0" algn="l">
-              <a:lnSpc>
-                <a:spcPct val="87151"/>
-              </a:lnSpc>
-              <a:buNone/>
-            </a:pPr>
-            <a:r>
-              <a:rPr lang="en-US" sz="19500" b="1">
-                <a:solidFill>
-                  <a:srgbClr val="FFFFFF"/>
-                </a:solidFill>
-                <a:latin typeface="Arial" pitchFamily="34" charset="0"/>
-                <a:ea typeface="Arial" pitchFamily="34" charset="-122"/>
-                <a:cs typeface="Arial" pitchFamily="34" charset="-120"/>
-              </a:rPr>
-              <a:t>1</a:t>
-            </a:r>
-            <a:endParaRPr lang="en-US" sz="19500"/>
-          </a:p>
-        </p:txBody>
-      </p:sp>
-      <p:sp>
-        <p:nvSpPr>
-          <p:cNvPr id="4" name="Shape 1"/>
-          <p:cNvSpPr/>
-          <p:nvPr/>
-        </p:nvSpPr>
-        <p:spPr>
-          <a:xfrm>
-            <a:off x="3187154" y="3905250"/>
-            <a:ext cx="57051" cy="2476500"/>
-          </a:xfrm>
-          <a:prstGeom prst="rect">
-            <a:avLst/>
-          </a:prstGeom>
-          <a:solidFill>
-            <a:srgbClr val="FFFFFF">
-              <a:alpha val="60000"/>
-            </a:srgbClr>
-          </a:solidFill>
-          <a:ln/>
-        </p:spPr>
-        <p:txBody>
-          <a:bodyPr/>
-          <a:lstStyle/>
-          <a:p>
-            <a:endParaRPr lang="en-AU"/>
-          </a:p>
-        </p:txBody>
-      </p:sp>
-      <p:sp>
-        <p:nvSpPr>
-          <p:cNvPr id="5" name="Text 2"/>
-          <p:cNvSpPr/>
-          <p:nvPr/>
-        </p:nvSpPr>
-        <p:spPr>
-          <a:xfrm>
-            <a:off x="3910955" y="4262438"/>
-            <a:ext cx="7831522" cy="871538"/>
-          </a:xfrm>
-          <a:prstGeom prst="rect">
-            <a:avLst/>
-          </a:prstGeom>
-          <a:noFill/>
-          <a:ln/>
-        </p:spPr>
-        <p:txBody>
-          <a:bodyPr wrap="square" lIns="25400" tIns="25400" rIns="25400" bIns="25400" rtlCol="0" anchor="t">
-            <a:normAutofit lnSpcReduction="10000"/>
-          </a:bodyPr>
-          <a:lstStyle/>
-          <a:p>
-            <a:pPr marL="0" indent="0" algn="l">
-              <a:buNone/>
-            </a:pPr>
-            <a:r>
-              <a:rPr lang="en-US" sz="5700" b="1">
-                <a:solidFill>
-                  <a:srgbClr val="FFFFFF"/>
-                </a:solidFill>
-                <a:latin typeface="Arial" pitchFamily="34" charset="0"/>
-                <a:ea typeface="Arial" pitchFamily="34" charset="-122"/>
-                <a:cs typeface="Arial" pitchFamily="34" charset="-120"/>
-              </a:rPr>
-              <a:t>Architecture Council</a:t>
-            </a:r>
-            <a:endParaRPr lang="en-US" sz="5700"/>
-          </a:p>
-        </p:txBody>
-      </p:sp>
-      <p:sp>
-        <p:nvSpPr>
-          <p:cNvPr id="6" name="Text 3"/>
-          <p:cNvSpPr/>
-          <p:nvPr/>
-        </p:nvSpPr>
-        <p:spPr>
-          <a:xfrm>
-            <a:off x="3910955" y="5191125"/>
-            <a:ext cx="7831522" cy="871538"/>
-          </a:xfrm>
-          <a:prstGeom prst="rect">
-            <a:avLst/>
-          </a:prstGeom>
-          <a:noFill/>
-          <a:ln/>
-        </p:spPr>
-        <p:txBody>
-          <a:bodyPr wrap="square" lIns="25400" tIns="25400" rIns="25400" bIns="25400" rtlCol="0" anchor="t">
-            <a:normAutofit lnSpcReduction="10000"/>
-          </a:bodyPr>
-          <a:lstStyle/>
-          <a:p>
-            <a:pPr marL="0" indent="0" algn="l">
-              <a:buNone/>
-            </a:pPr>
-            <a:r>
-              <a:rPr lang="en-US" sz="5700" b="1">
-                <a:solidFill>
-                  <a:srgbClr val="FFFFFF"/>
-                </a:solidFill>
-                <a:latin typeface="Arial" pitchFamily="34" charset="0"/>
-                <a:ea typeface="Arial" pitchFamily="34" charset="-122"/>
-                <a:cs typeface="Arial" pitchFamily="34" charset="-120"/>
-              </a:rPr>
-              <a:t>Overview</a:t>
-            </a:r>
-            <a:endParaRPr lang="en-US" sz="5700"/>
-          </a:p>
-        </p:txBody>
-      </p:sp>
-    </p:spTree>
-  </p:cSld>
-  <p:clrMapOvr>
-    <a:masterClrMapping/>
-  </p:clrMapOvr>
-</p:sld>
-</file>
-
-<file path=ppt/slides/slide20.xml><?xml version="1.0" encoding="utf-8"?>
-<p:sld xmlns:a="http://schemas.openxmlformats.org/drawingml/2006/main" xmlns:p="http://schemas.openxmlformats.org/presentationml/2006/main" xmlns:r="http://schemas.openxmlformats.org/officeDocument/2006/relationships">
-  <p:cSld>
-    <p:spTree>
-      <p:nvGrpSpPr>
-        <p:cNvPr id="1" name=""/>
-        <p:cNvGrpSpPr/>
-        <p:nvPr/>
-      </p:nvGrpSpPr>
-      <p:grpSpPr/>
-      <p:pic>
-        <p:nvPicPr>
-          <p:cNvPr id="2" name="Picture 1" descr="image.png"/>
-          <p:cNvPicPr>
-            <a:picLocks noChangeAspect="1"/>
-          </p:cNvPicPr>
-          <p:nvPr/>
-        </p:nvPicPr>
-        <p:blipFill>
-          <a:blip r:embed="rId2"/>
-          <a:stretch>
-            <a:fillRect/>
-          </a:stretch>
-        </p:blipFill>
-        <p:spPr>
-          <a:xfrm>
-            <a:off x="16188779" y="476250"/>
-            <a:ext cx="1337221" cy="419075"/>
-          </a:xfrm>
-          <a:prstGeom prst="rect">
-            <a:avLst/>
-          </a:prstGeom>
-        </p:spPr>
-      </p:pic>
-      <p:sp>
-        <p:nvSpPr>
-          <p:cNvPr id="3" name="TextBox 2"/>
-          <p:cNvSpPr txBox="1"/>
-          <p:nvPr/>
-        </p:nvSpPr>
-        <p:spPr>
-          <a:xfrm>
-            <a:off x="640080" y="320040"/>
-            <a:ext cx="13716000" cy="548640"/>
-          </a:xfrm>
-          <a:prstGeom prst="rect">
-            <a:avLst/>
-          </a:prstGeom>
-          <a:noFill/>
-        </p:spPr>
-        <p:txBody>
-          <a:bodyPr wrap="square" lIns="0" rIns="0" tIns="0" bIns="0" anchor="t">
-            <a:spAutoFit/>
-          </a:bodyPr>
-          <a:lstStyle/>
-          <a:p>
-            <a:pPr algn="l"/>
-            <a:r>
-              <a:rPr sz="2200" b="1" i="0">
-                <a:solidFill>
-                  <a:srgbClr val="1F3864"/>
-                </a:solidFill>
-                <a:latin typeface="Arial"/>
-              </a:rPr>
-              <a:t>Option E Considered – Fully Event-Driven Delivery (a Variant, Not the Rule)</a:t>
-            </a:r>
-          </a:p>
-        </p:txBody>
-      </p:sp>
-      <p:sp>
-        <p:nvSpPr>
-          <p:cNvPr id="4" name="TextBox 3"/>
-          <p:cNvSpPr txBox="1"/>
-          <p:nvPr/>
-        </p:nvSpPr>
-        <p:spPr>
-          <a:xfrm>
-            <a:off x="640080" y="868680"/>
-            <a:ext cx="16002000" cy="365760"/>
-          </a:xfrm>
-          <a:prstGeom prst="rect">
-            <a:avLst/>
-          </a:prstGeom>
-          <a:noFill/>
-        </p:spPr>
-        <p:txBody>
-          <a:bodyPr wrap="square" lIns="0" rIns="0" tIns="0" bIns="0" anchor="t">
-            <a:spAutoFit/>
-          </a:bodyPr>
-          <a:lstStyle/>
-          <a:p>
-            <a:pPr algn="l"/>
-            <a:r>
-              <a:rPr sz="1200" b="0" i="0">
-                <a:solidFill>
-                  <a:srgbClr val="595959"/>
-                </a:solidFill>
-                <a:latin typeface="Arial"/>
-              </a:rPr>
-              <a:t>Fair question: SAP sells an event service built for one-publisher-to-many-subscribers. Researched against SAP’s own documentation — three facts decide where it fits.</a:t>
-            </a:r>
-          </a:p>
-        </p:txBody>
-      </p:sp>
-      <p:sp>
-        <p:nvSpPr>
-          <p:cNvPr id="5" name="Rectangle 4"/>
-          <p:cNvSpPr/>
-          <p:nvPr/>
-        </p:nvSpPr>
-        <p:spPr>
-          <a:xfrm>
-            <a:off x="640080" y="1691640"/>
-            <a:ext cx="17007840" cy="1170432"/>
-          </a:xfrm>
-          <a:prstGeom prst="rect">
-            <a:avLst/>
-          </a:prstGeom>
-          <a:solidFill>
-            <a:srgbClr val="F4F6F9"/>
-          </a:solidFill>
-          <a:ln w="12700">
-            <a:solidFill>
-              <a:srgbClr val="C9CFD8"/>
-            </a:solidFill>
-          </a:ln>
-          <a:effectLst/>
-        </p:spPr>
-        <p:style>
-          <a:lnRef idx="1">
-            <a:schemeClr val="accent1"/>
-          </a:lnRef>
-          <a:fillRef idx="3">
-            <a:schemeClr val="accent1"/>
-          </a:fillRef>
-          <a:effectRef idx="2">
-            <a:schemeClr val="accent1"/>
-          </a:effectRef>
-          <a:fontRef idx="minor">
-            <a:schemeClr val="lt1"/>
-          </a:fontRef>
-        </p:style>
-        <p:txBody>
-          <a:bodyPr rtlCol="0" anchor="ctr" wrap="square" lIns="137160" rIns="137160" tIns="73152" bIns="54864"/>
-          <a:lstStyle/>
-          <a:p>
-            <a:pPr algn="ctr"/>
-            <a:r>
-              <a:rPr sz="1250" b="1">
-                <a:solidFill>
-                  <a:srgbClr val="1F3864"/>
-                </a:solidFill>
-                <a:latin typeface="Arial"/>
-              </a:rPr>
-              <a:t>1 — Change notices carry almost no data, by design.</a:t>
-            </a:r>
-          </a:p>
-          <a:p>
-            <a:r>
-              <a:rPr sz="1150">
-                <a:solidFill>
-                  <a:srgbClr val="111111"/>
-                </a:solidFill>
-                <a:latin typeface="Arial"/>
-              </a:rPr>
-              <a:t>They contain the record’s ID and little else; SAP’s documented pattern is that the receiver calls back to S/4 for the full data. If field systems subscribed directly, every one of them would have to build fetch-and-convert logic — the exact burden this design removes.</a:t>
-            </a:r>
-          </a:p>
-        </p:txBody>
-      </p:sp>
-      <p:sp>
-        <p:nvSpPr>
-          <p:cNvPr id="6" name="Rectangle 5"/>
-          <p:cNvSpPr/>
-          <p:nvPr/>
-        </p:nvSpPr>
-        <p:spPr>
-          <a:xfrm>
-            <a:off x="640080" y="3044952"/>
-            <a:ext cx="17007840" cy="1170432"/>
-          </a:xfrm>
-          <a:prstGeom prst="rect">
-            <a:avLst/>
-          </a:prstGeom>
-          <a:solidFill>
-            <a:srgbClr val="F4F6F9"/>
-          </a:solidFill>
-          <a:ln w="12700">
-            <a:solidFill>
-              <a:srgbClr val="C9CFD8"/>
-            </a:solidFill>
-          </a:ln>
-          <a:effectLst/>
-        </p:spPr>
-        <p:style>
-          <a:lnRef idx="1">
-            <a:schemeClr val="accent1"/>
-          </a:lnRef>
-          <a:fillRef idx="3">
-            <a:schemeClr val="accent1"/>
-          </a:fillRef>
-          <a:effectRef idx="2">
-            <a:schemeClr val="accent1"/>
-          </a:effectRef>
-          <a:fontRef idx="minor">
-            <a:schemeClr val="lt1"/>
-          </a:fontRef>
-        </p:style>
-        <p:txBody>
-          <a:bodyPr rtlCol="0" anchor="ctr" wrap="square" lIns="137160" rIns="137160" tIns="73152" bIns="54864"/>
-          <a:lstStyle/>
-          <a:p>
-            <a:pPr algn="ctr"/>
-            <a:r>
-              <a:rPr sz="1250" b="1">
-                <a:solidFill>
-                  <a:srgbClr val="1F3864"/>
-                </a:solidFill>
-                <a:latin typeface="Arial"/>
-              </a:rPr>
-              <a:t>2 — Filtering by content is not supported.</a:t>
-            </a:r>
-          </a:p>
-          <a:p>
-            <a:r>
-              <a:rPr sz="1150">
-                <a:solidFill>
-                  <a:srgbClr val="111111"/>
-                </a:solidFill>
-                <a:latin typeface="Arial"/>
-              </a:rPr>
-              <a:t>The event service filters by topic name only; SAP documents content filtering (e.g. “only Defence contracts”) as an anti-pattern. Standard notices name the kind of data, never the contract — so Defence separation could not be enforced.</a:t>
-            </a:r>
-          </a:p>
-        </p:txBody>
-      </p:sp>
-      <p:sp>
-        <p:nvSpPr>
-          <p:cNvPr id="7" name="Rectangle 6"/>
-          <p:cNvSpPr/>
-          <p:nvPr/>
-        </p:nvSpPr>
-        <p:spPr>
-          <a:xfrm>
-            <a:off x="640080" y="4398264"/>
-            <a:ext cx="17007840" cy="1170432"/>
-          </a:xfrm>
-          <a:prstGeom prst="rect">
-            <a:avLst/>
-          </a:prstGeom>
-          <a:solidFill>
-            <a:srgbClr val="F4F6F9"/>
-          </a:solidFill>
-          <a:ln w="12700">
-            <a:solidFill>
-              <a:srgbClr val="C9CFD8"/>
-            </a:solidFill>
-          </a:ln>
-          <a:effectLst/>
-        </p:spPr>
-        <p:style>
-          <a:lnRef idx="1">
-            <a:schemeClr val="accent1"/>
-          </a:lnRef>
-          <a:fillRef idx="3">
-            <a:schemeClr val="accent1"/>
-          </a:fillRef>
-          <a:effectRef idx="2">
-            <a:schemeClr val="accent1"/>
-          </a:effectRef>
-          <a:fontRef idx="minor">
-            <a:schemeClr val="lt1"/>
-          </a:fontRef>
-        </p:style>
-        <p:txBody>
-          <a:bodyPr rtlCol="0" anchor="ctr" wrap="square" lIns="137160" rIns="137160" tIns="73152" bIns="54864"/>
-          <a:lstStyle/>
-          <a:p>
-            <a:pPr algn="ctr"/>
-            <a:r>
-              <a:rPr sz="1250" b="1">
-                <a:solidFill>
-                  <a:srgbClr val="1F3864"/>
-                </a:solidFill>
-                <a:latin typeface="Arial"/>
-              </a:rPr>
-              <a:t>3 — It does not convert formats.</a:t>
-            </a:r>
-          </a:p>
-          <a:p>
-            <a:r>
-              <a:rPr sz="1150">
-                <a:solidFill>
-                  <a:srgbClr val="111111"/>
-                </a:solidFill>
-                <a:latin typeface="Arial"/>
-              </a:rPr>
-              <a:t>It is a delivery service, not a mapper. Nothing in it can turn the standard message into ServiceNow’s import format or Salesforce’s save call — that conversion has to live somewhere, and if not in CPI, then in every field system.</a:t>
-            </a:r>
-          </a:p>
-        </p:txBody>
-      </p:sp>
-      <p:sp>
-        <p:nvSpPr>
-          <p:cNvPr id="8" name="TextBox 7"/>
-          <p:cNvSpPr txBox="1"/>
-          <p:nvPr/>
-        </p:nvSpPr>
-        <p:spPr>
-          <a:xfrm>
-            <a:off x="640080" y="5843016"/>
-            <a:ext cx="17007840" cy="822960"/>
-          </a:xfrm>
-          <a:prstGeom prst="rect">
-            <a:avLst/>
-          </a:prstGeom>
-          <a:noFill/>
-        </p:spPr>
-        <p:txBody>
-          <a:bodyPr wrap="square" lIns="0" rIns="0" tIns="0" bIns="0" anchor="t">
-            <a:spAutoFit/>
-          </a:bodyPr>
-          <a:lstStyle/>
-          <a:p>
-            <a:pPr algn="l"/>
-            <a:r>
-              <a:rPr sz="1200" b="0" i="0">
-                <a:solidFill>
-                  <a:srgbClr val="111111"/>
-                </a:solidFill>
-                <a:latin typeface="Arial"/>
-              </a:rPr>
-              <a:t>So a workable middle form exists — CPI still detects, reads, filters and wraps, then publishes the finished message to event topics and lets the event service deliver it by web call — but it only suits systems willing to accept the standard message directly. ServiceNow and Sitetracker cannot without a converter in front, which is CPI again.</a:t>
-            </a:r>
-          </a:p>
-        </p:txBody>
-      </p:sp>
-      <p:sp>
-        <p:nvSpPr>
-          <p:cNvPr id="9" name="TextBox 8"/>
-          <p:cNvSpPr txBox="1"/>
-          <p:nvPr/>
-        </p:nvSpPr>
-        <p:spPr>
-          <a:xfrm>
-            <a:off x="640080" y="6711696"/>
-            <a:ext cx="17007840" cy="822960"/>
-          </a:xfrm>
-          <a:prstGeom prst="rect">
-            <a:avLst/>
-          </a:prstGeom>
-          <a:noFill/>
-        </p:spPr>
-        <p:txBody>
-          <a:bodyPr wrap="square" lIns="0" rIns="0" tIns="0" bIns="0" anchor="t">
-            <a:spAutoFit/>
-          </a:bodyPr>
-          <a:lstStyle/>
-          <a:p>
-            <a:pPr algn="l"/>
-            <a:r>
-              <a:rPr sz="1200" b="1" i="0">
-                <a:solidFill>
-                  <a:srgbClr val="0F7A3D"/>
-                </a:solidFill>
-                <a:latin typeface="Arial"/>
-              </a:rPr>
-              <a:t>Position: SAP’s event-driven architecture is already inside Option D — it carries the change notice from S/4 into CPI, and that is its only job. As a delivery mechanism it stays a per-system variant the design can adopt later by swapping only the delivery plumbing. It is not the primary pattern, because it moves format conversion into the field systems — the one cost this programme set out to avoid.</a:t>
-            </a:r>
-          </a:p>
-        </p:txBody>
-      </p:sp>
-    </p:spTree>
-  </p:cSld>
-  <p:clrMapOvr>
-    <a:masterClrMapping/>
-  </p:clrMapOvr>
-</p:sld>
-</file>
-
-<file path=ppt/slides/slide21.xml><?xml version="1.0" encoding="utf-8"?>
-<p:sld xmlns:a="http://schemas.openxmlformats.org/drawingml/2006/main" xmlns:p="http://schemas.openxmlformats.org/presentationml/2006/main" xmlns:r="http://schemas.openxmlformats.org/officeDocument/2006/relationships">
-  <p:cSld>
-    <p:spTree>
-      <p:nvGrpSpPr>
-        <p:cNvPr id="1" name=""/>
-        <p:cNvGrpSpPr/>
-        <p:nvPr/>
-      </p:nvGrpSpPr>
-      <p:grpSpPr/>
-      <p:pic>
-        <p:nvPicPr>
-          <p:cNvPr id="2" name="Picture 1" descr="image.png"/>
-          <p:cNvPicPr>
-            <a:picLocks noChangeAspect="1"/>
-          </p:cNvPicPr>
-          <p:nvPr/>
-        </p:nvPicPr>
-        <p:blipFill>
-          <a:blip r:embed="rId2"/>
-          <a:stretch>
-            <a:fillRect/>
-          </a:stretch>
-        </p:blipFill>
-        <p:spPr>
-          <a:xfrm>
-            <a:off x="16188779" y="476250"/>
-            <a:ext cx="1337221" cy="419075"/>
-          </a:xfrm>
-          <a:prstGeom prst="rect">
-            <a:avLst/>
-          </a:prstGeom>
-        </p:spPr>
-      </p:pic>
-      <p:sp>
-        <p:nvSpPr>
-          <p:cNvPr id="3" name="TextBox 2"/>
-          <p:cNvSpPr txBox="1"/>
-          <p:nvPr/>
-        </p:nvSpPr>
-        <p:spPr>
-          <a:xfrm>
-            <a:off x="640080" y="320040"/>
-            <a:ext cx="13716000" cy="548640"/>
-          </a:xfrm>
-          <a:prstGeom prst="rect">
-            <a:avLst/>
-          </a:prstGeom>
-          <a:noFill/>
-        </p:spPr>
-        <p:txBody>
-          <a:bodyPr wrap="square" lIns="0" rIns="0" tIns="0" bIns="0">
-            <a:spAutoFit/>
-          </a:bodyPr>
-          <a:lstStyle/>
-          <a:p>
-            <a:r>
-              <a:rPr sz="2200" b="1">
-                <a:solidFill>
-                  <a:srgbClr val="1F3864"/>
-                </a:solidFill>
-                <a:latin typeface="Arial"/>
-              </a:rPr>
-              <a:t>Options (Updated) – Where the Work of Returning S/4 Data Lives</a:t>
-            </a:r>
-          </a:p>
-        </p:txBody>
-      </p:sp>
-      <p:sp>
-        <p:nvSpPr>
-          <p:cNvPr id="4" name="TextBox 3"/>
-          <p:cNvSpPr txBox="1"/>
-          <p:nvPr/>
-        </p:nvSpPr>
-        <p:spPr>
-          <a:xfrm>
-            <a:off x="640080" y="868680"/>
-            <a:ext cx="16002000" cy="365760"/>
-          </a:xfrm>
-          <a:prstGeom prst="rect">
-            <a:avLst/>
-          </a:prstGeom>
-          <a:noFill/>
-        </p:spPr>
-        <p:txBody>
-          <a:bodyPr wrap="square" lIns="0" rIns="0" tIns="0" bIns="0">
-            <a:spAutoFit/>
-          </a:bodyPr>
-          <a:lstStyle/>
-          <a:p>
-            <a:r>
-              <a:rPr sz="1200">
-                <a:solidFill>
-                  <a:srgbClr val="595959"/>
-                </a:solidFill>
-                <a:latin typeface="Arial"/>
-              </a:rPr>
-              <a:t>All three deliver the same data. They differ in who does the fetching, filtering and converting — each field system, or CPI once for everyone.</a:t>
-            </a:r>
-          </a:p>
-        </p:txBody>
-      </p:sp>
-      <p:graphicFrame>
-        <p:nvGraphicFramePr>
-          <p:cNvPr id="5" name="Table 4"/>
-          <p:cNvGraphicFramePr>
-            <a:graphicFrameLocks noGrp="1"/>
-          </p:cNvGraphicFramePr>
-          <p:nvPr/>
-        </p:nvGraphicFramePr>
-        <p:xfrm>
-          <a:off x="502920" y="1417320"/>
-          <a:ext cx="17556480" cy="4892040"/>
-        </p:xfrm>
-        <a:graphic>
-          <a:graphicData uri="http://schemas.openxmlformats.org/drawingml/2006/table">
-            <a:tbl>
-              <a:tblPr firstRow="1" bandRow="1">
-                <a:tableStyleId>{5C22544A-7EE6-4342-B048-85BDC9FD1C3A}</a:tableStyleId>
-              </a:tblPr>
-              <a:tblGrid>
-                <a:gridCol w="2834640"/>
-                <a:gridCol w="3291840"/>
-                <a:gridCol w="3017520"/>
-                <a:gridCol w="2468880"/>
-                <a:gridCol w="2743200"/>
-                <a:gridCol w="3200400"/>
-              </a:tblGrid>
-              <a:tr h="365760">
-                <a:tc>
-                  <a:txBody>
-                    <a:bodyPr wrap="square"/>
-                    <a:lstStyle/>
-                    <a:p>
-                      <a:r>
-                        <a:rPr sz="1200" b="1">
-                          <a:solidFill>
-                            <a:srgbClr val="111111"/>
-                          </a:solidFill>
-                          <a:latin typeface="Arial"/>
-                        </a:rPr>
-                        <a:t>Option</a:t>
-                      </a:r>
-                    </a:p>
-                  </a:txBody>
-                  <a:tcPr marL="73152" marR="73152" marT="45720" marB="45720">
-                    <a:solidFill>
-                      <a:srgbClr val="92D050"/>
-                    </a:solidFill>
-                  </a:tcPr>
-                </a:tc>
-                <a:tc>
-                  <a:txBody>
-                    <a:bodyPr wrap="square"/>
-                    <a:lstStyle/>
-                    <a:p>
-                      <a:r>
-                        <a:rPr sz="1200" b="1">
-                          <a:solidFill>
-                            <a:srgbClr val="111111"/>
-                          </a:solidFill>
-                          <a:latin typeface="Arial"/>
-                        </a:rPr>
-                        <a:t>Approach</a:t>
-                      </a:r>
-                    </a:p>
-                  </a:txBody>
-                  <a:tcPr marL="73152" marR="73152" marT="45720" marB="45720">
-                    <a:solidFill>
-                      <a:srgbClr val="92D050"/>
-                    </a:solidFill>
-                  </a:tcPr>
-                </a:tc>
-                <a:tc>
-                  <a:txBody>
-                    <a:bodyPr wrap="square"/>
-                    <a:lstStyle/>
-                    <a:p>
-                      <a:r>
-                        <a:rPr sz="1200" b="1">
-                          <a:solidFill>
-                            <a:srgbClr val="111111"/>
-                          </a:solidFill>
-                          <a:latin typeface="Arial"/>
-                        </a:rPr>
-                        <a:t>Build Cost &amp; Duration</a:t>
-                      </a:r>
-                    </a:p>
-                  </a:txBody>
-                  <a:tcPr marL="73152" marR="73152" marT="45720" marB="45720">
-                    <a:solidFill>
-                      <a:srgbClr val="92D050"/>
-                    </a:solidFill>
-                  </a:tcPr>
-                </a:tc>
-                <a:tc>
-                  <a:txBody>
-                    <a:bodyPr wrap="square"/>
-                    <a:lstStyle/>
-                    <a:p>
-                      <a:r>
-                        <a:rPr sz="1200" b="1">
-                          <a:solidFill>
-                            <a:srgbClr val="111111"/>
-                          </a:solidFill>
-                          <a:latin typeface="Arial"/>
-                        </a:rPr>
-                        <a:t>Ongoing Cost</a:t>
-                      </a:r>
-                    </a:p>
-                  </a:txBody>
-                  <a:tcPr marL="73152" marR="73152" marT="45720" marB="45720">
-                    <a:solidFill>
-                      <a:srgbClr val="92D050"/>
-                    </a:solidFill>
-                  </a:tcPr>
-                </a:tc>
-                <a:tc>
-                  <a:txBody>
-                    <a:bodyPr wrap="square"/>
-                    <a:lstStyle/>
-                    <a:p>
-                      <a:r>
-                        <a:rPr sz="1200" b="1">
-                          <a:solidFill>
-                            <a:srgbClr val="111111"/>
-                          </a:solidFill>
-                          <a:latin typeface="Arial"/>
-                        </a:rPr>
-                        <a:t>Ongoing Benefit</a:t>
-                      </a:r>
-                    </a:p>
-                  </a:txBody>
-                  <a:tcPr marL="73152" marR="73152" marT="45720" marB="45720">
-                    <a:solidFill>
-                      <a:srgbClr val="92D050"/>
-                    </a:solidFill>
-                  </a:tcPr>
-                </a:tc>
-                <a:tc>
-                  <a:txBody>
-                    <a:bodyPr wrap="square"/>
-                    <a:lstStyle/>
-                    <a:p>
-                      <a:r>
-                        <a:rPr sz="1200" b="1">
-                          <a:solidFill>
-                            <a:srgbClr val="111111"/>
-                          </a:solidFill>
-                          <a:latin typeface="Arial"/>
-                        </a:rPr>
-                        <a:t>Key Risks</a:t>
-                      </a:r>
-                    </a:p>
-                  </a:txBody>
-                  <a:tcPr marL="73152" marR="73152" marT="45720" marB="45720">
-                    <a:solidFill>
-                      <a:srgbClr val="92D050"/>
-                    </a:solidFill>
-                  </a:tcPr>
-                </a:tc>
-              </a:tr>
-              <a:tr h="1508760">
-                <a:tc>
-                  <a:txBody>
-                    <a:bodyPr wrap="square"/>
-                    <a:lstStyle/>
-                    <a:p>
-                      <a:r>
-                        <a:rPr sz="1150" b="1">
-                          <a:solidFill>
-                            <a:srgbClr val="111111"/>
-                          </a:solidFill>
-                          <a:latin typeface="Arial"/>
-                        </a:rPr>
-                        <a:t>B – Each system fetches from a published query on CPI</a:t>
-                      </a:r>
-                    </a:p>
-                    <a:p>
-                      <a:r>
-                        <a:rPr sz="1150" b="1" i="1">
-                          <a:solidFill>
-                            <a:srgbClr val="1F3864"/>
-                          </a:solidFill>
-                          <a:latin typeface="Arial"/>
-                        </a:rPr>
-                        <a:t>(Decided baseline — kept)</a:t>
-                      </a:r>
-                    </a:p>
-                  </a:txBody>
-                  <a:tcPr marL="73152" marR="73152" marT="45720" marB="45720">
-                    <a:solidFill>
-                      <a:srgbClr val="FFFFFF"/>
-                    </a:solidFill>
-                  </a:tcPr>
-                </a:tc>
-                <a:tc>
-                  <a:txBody>
-                    <a:bodyPr wrap="square"/>
-                    <a:lstStyle/>
-                    <a:p>
-                      <a:r>
-                        <a:rPr sz="1000">
-                          <a:solidFill>
-                            <a:srgbClr val="111111"/>
-                          </a:solidFill>
-                          <a:latin typeface="Arial"/>
-                        </a:rPr>
-                        <a:t>CPI publishes one query per system; each field system fetches on its own schedule with its own filters.</a:t>
-                      </a:r>
-                    </a:p>
-                  </a:txBody>
-                  <a:tcPr marL="73152" marR="73152" marT="45720" marB="45720">
-                    <a:solidFill>
-                      <a:srgbClr val="FFFFFF"/>
-                    </a:solidFill>
-                  </a:tcPr>
-                </a:tc>
-                <a:tc>
-                  <a:txBody>
-                    <a:bodyPr wrap="square"/>
-                    <a:lstStyle/>
-                    <a:p>
-                      <a:r>
-                        <a:rPr sz="1000" b="1">
-                          <a:solidFill>
-                            <a:srgbClr val="111111"/>
-                          </a:solidFill>
-                          <a:latin typeface="Arial"/>
-                        </a:rPr>
-                        <a:t>Medium.</a:t>
-                      </a:r>
-                      <a:r>
-                        <a:rPr sz="1000">
-                          <a:solidFill>
-                            <a:srgbClr val="111111"/>
-                          </a:solidFill>
-                          <a:latin typeface="Arial"/>
-                        </a:rPr>
-                        <a:t> Build mostly in CPI. But every field system also builds scheduling, data fetching and filtering — ten times, in ten toolsets.</a:t>
-                      </a:r>
-                    </a:p>
-                  </a:txBody>
-                  <a:tcPr marL="73152" marR="73152" marT="45720" marB="45720">
-                    <a:solidFill>
-                      <a:srgbClr val="FFFFFF"/>
-                    </a:solidFill>
-                  </a:tcPr>
-                </a:tc>
-                <a:tc>
-                  <a:txBody>
-                    <a:bodyPr wrap="square"/>
-                    <a:lstStyle/>
-                    <a:p>
-                      <a:r>
-                        <a:rPr sz="1000" b="1">
-                          <a:solidFill>
-                            <a:srgbClr val="111111"/>
-                          </a:solidFill>
-                          <a:latin typeface="Arial"/>
-                        </a:rPr>
-                        <a:t>Medium.</a:t>
-                      </a:r>
-                      <a:r>
-                        <a:rPr sz="1000">
-                          <a:solidFill>
-                            <a:srgbClr val="111111"/>
-                          </a:solidFill>
-                          <a:latin typeface="Arial"/>
-                        </a:rPr>
-                        <a:t> Each system runs and supports its own fetching; skills spread across every vendor.</a:t>
-                      </a:r>
-                    </a:p>
-                  </a:txBody>
-                  <a:tcPr marL="73152" marR="73152" marT="45720" marB="45720">
-                    <a:solidFill>
-                      <a:srgbClr val="FFFFFF"/>
-                    </a:solidFill>
-                  </a:tcPr>
-                </a:tc>
-                <a:tc>
-                  <a:txBody>
-                    <a:bodyPr wrap="square"/>
-                    <a:lstStyle/>
-                    <a:p>
-                      <a:r>
-                        <a:rPr sz="1000">
-                          <a:solidFill>
-                            <a:srgbClr val="111111"/>
-                          </a:solidFill>
-                          <a:latin typeface="Arial"/>
-                        </a:rPr>
-                        <a:t>Simple CPI. Each system controls its own timing.</a:t>
-                      </a:r>
-                    </a:p>
-                  </a:txBody>
-                  <a:tcPr marL="73152" marR="73152" marT="45720" marB="45720">
-                    <a:solidFill>
-                      <a:srgbClr val="FFFFFF"/>
-                    </a:solidFill>
-                  </a:tcPr>
-                </a:tc>
-                <a:tc>
-                  <a:txBody>
-                    <a:bodyPr wrap="square"/>
-                    <a:lstStyle/>
-                    <a:p>
-                      <a:r>
-                        <a:rPr sz="1000">
-                          <a:solidFill>
-                            <a:srgbClr val="111111"/>
-                          </a:solidFill>
-                          <a:latin typeface="Arial"/>
-                        </a:rPr>
-                        <a:t>Orchestration is duplicated in every system. An acquired company's system must be modified before it can see its own data. Filtering correctness must be trusted and audited ten times — including Defence.</a:t>
-                      </a:r>
-                    </a:p>
-                  </a:txBody>
-                  <a:tcPr marL="73152" marR="73152" marT="45720" marB="45720">
-                    <a:solidFill>
-                      <a:srgbClr val="FFFFFF"/>
-                    </a:solidFill>
-                  </a:tcPr>
-                </a:tc>
-              </a:tr>
-              <a:tr h="1508760">
-                <a:tc>
-                  <a:txBody>
-                    <a:bodyPr wrap="square"/>
-                    <a:lstStyle/>
-                    <a:p>
-                      <a:r>
-                        <a:rPr sz="1150" b="1">
-                          <a:solidFill>
-                            <a:srgbClr val="111111"/>
-                          </a:solidFill>
-                          <a:latin typeface="Arial"/>
-                        </a:rPr>
-                        <a:t>D – CPI delivers each system's data to it</a:t>
-                      </a:r>
-                    </a:p>
-                    <a:p>
-                      <a:r>
-                        <a:rPr sz="1150" b="1" i="1">
-                          <a:solidFill>
-                            <a:srgbClr val="008A3E"/>
-                          </a:solidFill>
-                          <a:latin typeface="Arial"/>
-                        </a:rPr>
-                        <a:t>(Proposed – Recommended)</a:t>
-                      </a:r>
-                    </a:p>
-                  </a:txBody>
-                  <a:tcPr marL="73152" marR="73152" marT="45720" marB="45720">
-                    <a:solidFill>
-                      <a:srgbClr val="FFFFFF"/>
-                    </a:solidFill>
-                  </a:tcPr>
-                </a:tc>
-                <a:tc>
-                  <a:txBody>
-                    <a:bodyPr wrap="square"/>
-                    <a:lstStyle/>
-                    <a:p>
-                      <a:r>
-                        <a:rPr sz="1000">
-                          <a:solidFill>
-                            <a:srgbClr val="111111"/>
-                          </a:solidFill>
-                          <a:latin typeface="Arial"/>
-                        </a:rPr>
-                        <a:t>CPI detects each change once, reads the full record, filters by a central subscription list, and delivers it the way each system accepts (web service call or file). The Option B query stays as the fallback.</a:t>
-                      </a:r>
-                    </a:p>
-                  </a:txBody>
-                  <a:tcPr marL="73152" marR="73152" marT="45720" marB="45720">
-                    <a:solidFill>
-                      <a:srgbClr val="FFFFFF"/>
-                    </a:solidFill>
-                  </a:tcPr>
-                </a:tc>
-                <a:tc>
-                  <a:txBody>
-                    <a:bodyPr wrap="square"/>
-                    <a:lstStyle/>
-                    <a:p>
-                      <a:r>
-                        <a:rPr sz="1000" b="1">
-                          <a:solidFill>
-                            <a:srgbClr val="111111"/>
-                          </a:solidFill>
-                          <a:latin typeface="Arial"/>
-                        </a:rPr>
-                        <a:t>Medium.</a:t>
-                      </a:r>
-                      <a:r>
-                        <a:rPr sz="1000">
-                          <a:solidFill>
-                            <a:srgbClr val="111111"/>
-                          </a:solidFill>
-                          <a:latin typeface="Arial"/>
-                        </a:rPr>
-                        <a:t> All development in CPI, from standard delivered parts. S/4: configuration only. Field systems: configuration only, except six small JAMS receiving services.</a:t>
-                      </a:r>
-                    </a:p>
-                  </a:txBody>
-                  <a:tcPr marL="73152" marR="73152" marT="45720" marB="45720">
-                    <a:solidFill>
-                      <a:srgbClr val="FFFFFF"/>
-                    </a:solidFill>
-                  </a:tcPr>
-                </a:tc>
-                <a:tc>
-                  <a:txBody>
-                    <a:bodyPr wrap="square"/>
-                    <a:lstStyle/>
-                    <a:p>
-                      <a:r>
-                        <a:rPr sz="1000" b="1">
-                          <a:solidFill>
-                            <a:srgbClr val="111111"/>
-                          </a:solidFill>
-                          <a:latin typeface="Arial"/>
-                        </a:rPr>
-                        <a:t>Medium.</a:t>
-                      </a:r>
-                      <a:r>
-                        <a:rPr sz="1000">
-                          <a:solidFill>
-                            <a:srgbClr val="111111"/>
-                          </a:solidFill>
-                          <a:latin typeface="Arial"/>
-                        </a:rPr>
-                        <a:t> One team, one toolset, one monitoring view for everything. Nothing new to buy — all inside licences already held.</a:t>
-                      </a:r>
-                    </a:p>
-                  </a:txBody>
-                  <a:tcPr marL="73152" marR="73152" marT="45720" marB="45720">
-                    <a:solidFill>
-                      <a:srgbClr val="FFFFFF"/>
-                    </a:solidFill>
-                  </a:tcPr>
-                </a:tc>
-                <a:tc>
-                  <a:txBody>
-                    <a:bodyPr wrap="square"/>
-                    <a:lstStyle/>
-                    <a:p>
-                      <a:r>
-                        <a:rPr sz="1000">
-                          <a:solidFill>
-                            <a:srgbClr val="111111"/>
-                          </a:solidFill>
-                          <a:latin typeface="Arial"/>
-                        </a:rPr>
-                        <a:t>Field systems stop building orchestration. Defence separation enforced centrally and auditably. A new or acquired system = configuration rows plus one converter. Data arrives as it changes.</a:t>
-                      </a:r>
-                    </a:p>
-                  </a:txBody>
-                  <a:tcPr marL="73152" marR="73152" marT="45720" marB="45720">
-                    <a:solidFill>
-                      <a:srgbClr val="FFFFFF"/>
-                    </a:solidFill>
-                  </a:tcPr>
-                </a:tc>
-                <a:tc>
-                  <a:txBody>
-                    <a:bodyPr wrap="square"/>
-                    <a:lstStyle/>
-                    <a:p>
-                      <a:r>
-                        <a:rPr sz="1000">
-                          <a:solidFill>
-                            <a:srgbClr val="111111"/>
-                          </a:solidFill>
-                          <a:latin typeface="Arial"/>
-                        </a:rPr>
-                        <a:t>CPI becomes an operational platform — queues, alerts and a run book to own. Message volumes are metered under the existing licence (sizing in progress). Standard-message format needs version discipline.</a:t>
-                      </a:r>
-                    </a:p>
-                  </a:txBody>
-                  <a:tcPr marL="73152" marR="73152" marT="45720" marB="45720">
-                    <a:solidFill>
-                      <a:srgbClr val="FFFFFF"/>
-                    </a:solidFill>
-                  </a:tcPr>
-                </a:tc>
-              </a:tr>
-              <a:tr h="1508760">
-                <a:tc>
-                  <a:txBody>
-                    <a:bodyPr wrap="square"/>
-                    <a:lstStyle/>
-                    <a:p>
-                      <a:r>
-                        <a:rPr sz="1150" b="1">
-                          <a:solidFill>
-                            <a:srgbClr val="111111"/>
-                          </a:solidFill>
-                          <a:latin typeface="Arial"/>
-                        </a:rPr>
-                        <a:t>E – Fully event-driven delivery</a:t>
-                      </a:r>
-                    </a:p>
-                    <a:p>
-                      <a:r>
-                        <a:rPr sz="1150" b="1" i="1">
-                          <a:solidFill>
-                            <a:srgbClr val="595959"/>
-                          </a:solidFill>
-                          <a:latin typeface="Arial"/>
-                        </a:rPr>
-                        <a:t>(Noted — a per-system variant, not the rule)</a:t>
-                      </a:r>
-                    </a:p>
-                  </a:txBody>
-                  <a:tcPr marL="73152" marR="73152" marT="45720" marB="45720">
-                    <a:solidFill>
-                      <a:srgbClr val="FFFFFF"/>
-                    </a:solidFill>
-                  </a:tcPr>
-                </a:tc>
-                <a:tc>
-                  <a:txBody>
-                    <a:bodyPr wrap="square"/>
-                    <a:lstStyle/>
-                    <a:p>
-                      <a:r>
-                        <a:rPr sz="1000">
-                          <a:solidFill>
-                            <a:srgbClr val="111111"/>
-                          </a:solidFill>
-                          <a:latin typeface="Arial"/>
-                        </a:rPr>
-                        <a:t>CPI still detects, reads, filters and wraps — then publishes finished messages to event topics; SAP's event service delivers them by web call to each subscribed system.</a:t>
-                      </a:r>
-                    </a:p>
-                  </a:txBody>
-                  <a:tcPr marL="73152" marR="73152" marT="45720" marB="45720">
-                    <a:solidFill>
-                      <a:srgbClr val="FFFFFF"/>
-                    </a:solidFill>
-                  </a:tcPr>
-                </a:tc>
-                <a:tc>
-                  <a:txBody>
-                    <a:bodyPr wrap="square"/>
-                    <a:lstStyle/>
-                    <a:p>
-                      <a:r>
-                        <a:rPr sz="1000">
-                          <a:solidFill>
-                            <a:srgbClr val="111111"/>
-                          </a:solidFill>
-                          <a:latin typeface="Arial"/>
-                        </a:rPr>
-                        <a:t>Lower in CPI (no delivery plumbing) but higher in each field system: every receiver must accept the standard message itself.</a:t>
-                      </a:r>
-                    </a:p>
-                  </a:txBody>
-                  <a:tcPr marL="73152" marR="73152" marT="45720" marB="45720">
-                    <a:solidFill>
-                      <a:srgbClr val="FFFFFF"/>
-                    </a:solidFill>
-                  </a:tcPr>
-                </a:tc>
-                <a:tc>
-                  <a:txBody>
-                    <a:bodyPr wrap="square"/>
-                    <a:lstStyle/>
-                    <a:p>
-                      <a:r>
-                        <a:rPr sz="1000" b="1">
-                          <a:solidFill>
-                            <a:srgbClr val="111111"/>
-                          </a:solidFill>
-                          <a:latin typeface="Arial"/>
-                        </a:rPr>
-                        <a:t>Split operations across CPI and the event service consoles.</a:t>
-                      </a:r>
-                      <a:r>
-                        <a:rPr sz="1000">
-                          <a:solidFill>
-                            <a:srgbClr val="111111"/>
-                          </a:solidFill>
-                          <a:latin typeface="Arial"/>
-                        </a:rPr>
-                        <a:t/>
-                      </a:r>
-                    </a:p>
-                  </a:txBody>
-                  <a:tcPr marL="73152" marR="73152" marT="45720" marB="45720">
-                    <a:solidFill>
-                      <a:srgbClr val="FFFFFF"/>
-                    </a:solidFill>
-                  </a:tcPr>
-                </a:tc>
-                <a:tc>
-                  <a:txBody>
-                    <a:bodyPr wrap="square"/>
-                    <a:lstStyle/>
-                    <a:p>
-                      <a:r>
-                        <a:rPr sz="1000">
-                          <a:solidFill>
-                            <a:srgbClr val="111111"/>
-                          </a:solidFill>
-                          <a:latin typeface="Arial"/>
-                        </a:rPr>
-                        <a:t>Native one-to-many delivery with built-in retry. Suits systems willing to accept the standard message directly (JAMS could).</a:t>
-                      </a:r>
-                    </a:p>
-                  </a:txBody>
-                  <a:tcPr marL="73152" marR="73152" marT="45720" marB="45720">
-                    <a:solidFill>
-                      <a:srgbClr val="FFFFFF"/>
-                    </a:solidFill>
-                  </a:tcPr>
-                </a:tc>
-                <a:tc>
-                  <a:txBody>
-                    <a:bodyPr wrap="square"/>
-                    <a:lstStyle/>
-                    <a:p>
-                      <a:r>
-                        <a:rPr sz="1000">
-                          <a:solidFill>
-                            <a:srgbClr val="111111"/>
-                          </a:solidFill>
-                          <a:latin typeface="Arial"/>
-                        </a:rPr>
-                        <a:t>Change notices carry the record ID only. No filtering by contract (SAP documents content filtering as an anti-pattern) — Defence separation cannot be enforced this way. No format conversion — ServiceNow and Sitetracker still need a converter in front, which is CPI again.</a:t>
-                      </a:r>
-                    </a:p>
-                  </a:txBody>
-                  <a:tcPr marL="73152" marR="73152" marT="45720" marB="45720">
-                    <a:solidFill>
-                      <a:srgbClr val="FFFFFF"/>
-                    </a:solidFill>
-                  </a:tcPr>
-                </a:tc>
-              </a:tr>
-            </a:tbl>
-          </a:graphicData>
-        </a:graphic>
-      </p:graphicFrame>
-      <p:sp>
-        <p:nvSpPr>
-          <p:cNvPr id="6" name="Rounded Rectangle 5"/>
-          <p:cNvSpPr/>
-          <p:nvPr/>
-        </p:nvSpPr>
-        <p:spPr>
-          <a:xfrm>
-            <a:off x="502920" y="7726679"/>
-            <a:ext cx="17556480" cy="1828800"/>
-          </a:xfrm>
-          <a:prstGeom prst="roundRect">
-            <a:avLst>
-              <a:gd name="adj" fmla="val 8000"/>
-            </a:avLst>
-          </a:prstGeom>
-          <a:solidFill>
-            <a:srgbClr val="E2F0D9"/>
-          </a:solidFill>
-          <a:ln w="22225">
-            <a:solidFill>
-              <a:srgbClr val="00B050"/>
-            </a:solidFill>
-          </a:ln>
-          <a:effectLst/>
-        </p:spPr>
-        <p:style>
-          <a:lnRef idx="1">
-            <a:schemeClr val="accent1"/>
-          </a:lnRef>
-          <a:fillRef idx="3">
-            <a:schemeClr val="accent1"/>
-          </a:fillRef>
-          <a:effectRef idx="2">
-            <a:schemeClr val="accent1"/>
-          </a:effectRef>
-          <a:fontRef idx="minor">
-            <a:schemeClr val="lt1"/>
-          </a:fontRef>
-        </p:style>
-        <p:txBody>
-          <a:bodyPr rtlCol="0" anchor="ctr" wrap="square" lIns="228600" rIns="228600" tIns="109728" bIns="91440"/>
-          <a:lstStyle/>
-          <a:p>
-            <a:pPr algn="ctr"/>
-            <a:r>
-              <a:rPr sz="1500" b="1">
-                <a:solidFill>
-                  <a:srgbClr val="008A3E"/>
-                </a:solidFill>
-                <a:latin typeface="Arial"/>
-              </a:rPr>
-              <a:t>Recommendation: Option D as the rule, Option B kept as the fallback</a:t>
-            </a:r>
-          </a:p>
-          <a:p>
-            <a:r>
-              <a:rPr sz="1150">
-                <a:solidFill>
-                  <a:srgbClr val="111111"/>
-                </a:solidFill>
-                <a:latin typeface="Arial"/>
-              </a:rPr>
-              <a:t>CPI does the work once — detect, read, filter, deliver — and every field system just receives its own data through an interface it already has. Where a system cannot receive, it falls back to Option B's query, and Option E remains a per-system variant that can be adopted later by swapping only the delivery plumbing. Effort is roughly the same overall as Option B, but it lands in one team and one toolset instead of inside every field system — and an acquired company's system can be connected without modifying it.</a:t>
-            </a:r>
-          </a:p>
-        </p:txBody>
-      </p:sp>
-    </p:spTree>
-  </p:cSld>
-  <p:clrMapOvr>
-    <a:masterClrMapping/>
-  </p:clrMapOvr>
-</p:sld>
-</file>
-
-<file path=ppt/slides/slide22.xml><?xml version="1.0" encoding="utf-8"?>
-<p:sld xmlns:a="http://schemas.openxmlformats.org/drawingml/2006/main" xmlns:p="http://schemas.openxmlformats.org/presentationml/2006/main" xmlns:r="http://schemas.openxmlformats.org/officeDocument/2006/relationships">
-  <p:cSld>
-    <p:spTree>
-      <p:nvGrpSpPr>
-        <p:cNvPr id="1" name=""/>
-        <p:cNvGrpSpPr/>
-        <p:nvPr/>
-      </p:nvGrpSpPr>
-      <p:grpSpPr/>
-      <p:pic>
-        <p:nvPicPr>
-          <p:cNvPr id="2" name="Picture 1" descr="image.png"/>
-          <p:cNvPicPr>
-            <a:picLocks noChangeAspect="1"/>
-          </p:cNvPicPr>
-          <p:nvPr/>
-        </p:nvPicPr>
-        <p:blipFill>
-          <a:blip r:embed="rId2"/>
-          <a:stretch>
-            <a:fillRect/>
-          </a:stretch>
-        </p:blipFill>
-        <p:spPr>
-          <a:xfrm>
-            <a:off x="16188779" y="476250"/>
-            <a:ext cx="1337221" cy="419075"/>
-          </a:xfrm>
-          <a:prstGeom prst="rect">
-            <a:avLst/>
-          </a:prstGeom>
-        </p:spPr>
-      </p:pic>
-      <p:sp>
-        <p:nvSpPr>
-          <p:cNvPr id="3" name="TextBox 2"/>
-          <p:cNvSpPr txBox="1"/>
-          <p:nvPr/>
-        </p:nvSpPr>
-        <p:spPr>
-          <a:xfrm>
-            <a:off x="640080" y="320040"/>
             <a:ext cx="15544800" cy="548640"/>
           </a:xfrm>
           <a:prstGeom prst="rect">
@@ -22297,6 +20336,2890 @@
                 <a:latin typeface="Arial"/>
               </a:rPr>
               <a:t>Agreed before build:  the six field lists (one per kind of data), the six paths, and the login method — written down and signed off by the JAMS team and the CPI team. These become appendices of the build specification.</a:t>
+            </a:r>
+          </a:p>
+        </p:txBody>
+      </p:sp>
+    </p:spTree>
+  </p:cSld>
+  <p:clrMapOvr>
+    <a:masterClrMapping/>
+  </p:clrMapOvr>
+</p:sld>
+</file>
+
+<file path=ppt/slides/slide2.xml><?xml version="1.0" encoding="utf-8"?>
+<p:sld xmlns:a="http://schemas.openxmlformats.org/drawingml/2006/main" xmlns:r="http://schemas.openxmlformats.org/officeDocument/2006/relationships" xmlns:p="http://schemas.openxmlformats.org/presentationml/2006/main">
+  <p:cSld name="Slide 2">
+    <p:bg>
+      <p:bgPr>
+        <a:solidFill>
+          <a:srgbClr val="0E2233"/>
+        </a:solidFill>
+        <a:effectLst/>
+      </p:bgPr>
+    </p:bg>
+    <p:spTree>
+      <p:nvGrpSpPr>
+        <p:cNvPr id="1" name=""/>
+        <p:cNvGrpSpPr/>
+        <p:nvPr/>
+      </p:nvGrpSpPr>
+      <p:grpSpPr>
+        <a:xfrm>
+          <a:off x="0" y="0"/>
+          <a:ext cx="0" cy="0"/>
+          <a:chOff x="0" y="0"/>
+          <a:chExt cx="0" cy="0"/>
+        </a:xfrm>
+      </p:grpSpPr>
+      <p:pic>
+        <p:nvPicPr>
+          <p:cNvPr id="2" name="Image 0" descr="preencoded.png"/>
+          <p:cNvPicPr>
+            <a:picLocks noChangeAspect="1"/>
+          </p:cNvPicPr>
+          <p:nvPr/>
+        </p:nvPicPr>
+        <p:blipFill>
+          <a:blip r:embed="rId3"/>
+          <a:srcRect/>
+          <a:stretch/>
+        </p:blipFill>
+        <p:spPr>
+          <a:xfrm>
+            <a:off x="0" y="0"/>
+            <a:ext cx="18288000" cy="10287000"/>
+          </a:xfrm>
+          <a:prstGeom prst="rect">
+            <a:avLst/>
+          </a:prstGeom>
+        </p:spPr>
+      </p:pic>
+      <p:sp>
+        <p:nvSpPr>
+          <p:cNvPr id="3" name="Text 0"/>
+          <p:cNvSpPr/>
+          <p:nvPr/>
+        </p:nvSpPr>
+        <p:spPr>
+          <a:xfrm>
+            <a:off x="1143000" y="3905250"/>
+            <a:ext cx="1515145" cy="2514600"/>
+          </a:xfrm>
+          <a:prstGeom prst="rect">
+            <a:avLst/>
+          </a:prstGeom>
+          <a:noFill/>
+          <a:ln/>
+        </p:spPr>
+        <p:txBody>
+          <a:bodyPr wrap="square" lIns="25400" tIns="25400" rIns="25400" bIns="25400" rtlCol="0" anchor="t">
+            <a:normAutofit lnSpcReduction="10000"/>
+          </a:bodyPr>
+          <a:lstStyle/>
+          <a:p>
+            <a:pPr marL="0" indent="0" algn="l">
+              <a:lnSpc>
+                <a:spcPct val="87151"/>
+              </a:lnSpc>
+              <a:buNone/>
+            </a:pPr>
+            <a:r>
+              <a:rPr lang="en-US" sz="19500" b="1">
+                <a:solidFill>
+                  <a:srgbClr val="FFFFFF"/>
+                </a:solidFill>
+                <a:latin typeface="Arial" pitchFamily="34" charset="0"/>
+                <a:ea typeface="Arial" pitchFamily="34" charset="-122"/>
+                <a:cs typeface="Arial" pitchFamily="34" charset="-120"/>
+              </a:rPr>
+              <a:t>1</a:t>
+            </a:r>
+            <a:endParaRPr lang="en-US" sz="19500"/>
+          </a:p>
+        </p:txBody>
+      </p:sp>
+      <p:sp>
+        <p:nvSpPr>
+          <p:cNvPr id="4" name="Shape 1"/>
+          <p:cNvSpPr/>
+          <p:nvPr/>
+        </p:nvSpPr>
+        <p:spPr>
+          <a:xfrm>
+            <a:off x="3187154" y="3905250"/>
+            <a:ext cx="57051" cy="2476500"/>
+          </a:xfrm>
+          <a:prstGeom prst="rect">
+            <a:avLst/>
+          </a:prstGeom>
+          <a:solidFill>
+            <a:srgbClr val="FFFFFF">
+              <a:alpha val="60000"/>
+            </a:srgbClr>
+          </a:solidFill>
+          <a:ln/>
+        </p:spPr>
+        <p:txBody>
+          <a:bodyPr/>
+          <a:lstStyle/>
+          <a:p>
+            <a:endParaRPr lang="en-AU"/>
+          </a:p>
+        </p:txBody>
+      </p:sp>
+      <p:sp>
+        <p:nvSpPr>
+          <p:cNvPr id="5" name="Text 2"/>
+          <p:cNvSpPr/>
+          <p:nvPr/>
+        </p:nvSpPr>
+        <p:spPr>
+          <a:xfrm>
+            <a:off x="3910955" y="4262438"/>
+            <a:ext cx="7831522" cy="871538"/>
+          </a:xfrm>
+          <a:prstGeom prst="rect">
+            <a:avLst/>
+          </a:prstGeom>
+          <a:noFill/>
+          <a:ln/>
+        </p:spPr>
+        <p:txBody>
+          <a:bodyPr wrap="square" lIns="25400" tIns="25400" rIns="25400" bIns="25400" rtlCol="0" anchor="t">
+            <a:normAutofit lnSpcReduction="10000"/>
+          </a:bodyPr>
+          <a:lstStyle/>
+          <a:p>
+            <a:pPr marL="0" indent="0" algn="l">
+              <a:buNone/>
+            </a:pPr>
+            <a:r>
+              <a:rPr lang="en-US" sz="5700" b="1">
+                <a:solidFill>
+                  <a:srgbClr val="FFFFFF"/>
+                </a:solidFill>
+                <a:latin typeface="Arial" pitchFamily="34" charset="0"/>
+                <a:ea typeface="Arial" pitchFamily="34" charset="-122"/>
+                <a:cs typeface="Arial" pitchFamily="34" charset="-120"/>
+              </a:rPr>
+              <a:t>Architecture Council</a:t>
+            </a:r>
+            <a:endParaRPr lang="en-US" sz="5700"/>
+          </a:p>
+        </p:txBody>
+      </p:sp>
+      <p:sp>
+        <p:nvSpPr>
+          <p:cNvPr id="6" name="Text 3"/>
+          <p:cNvSpPr/>
+          <p:nvPr/>
+        </p:nvSpPr>
+        <p:spPr>
+          <a:xfrm>
+            <a:off x="3910955" y="5191125"/>
+            <a:ext cx="7831522" cy="871538"/>
+          </a:xfrm>
+          <a:prstGeom prst="rect">
+            <a:avLst/>
+          </a:prstGeom>
+          <a:noFill/>
+          <a:ln/>
+        </p:spPr>
+        <p:txBody>
+          <a:bodyPr wrap="square" lIns="25400" tIns="25400" rIns="25400" bIns="25400" rtlCol="0" anchor="t">
+            <a:normAutofit lnSpcReduction="10000"/>
+          </a:bodyPr>
+          <a:lstStyle/>
+          <a:p>
+            <a:pPr marL="0" indent="0" algn="l">
+              <a:buNone/>
+            </a:pPr>
+            <a:r>
+              <a:rPr lang="en-US" sz="5700" b="1">
+                <a:solidFill>
+                  <a:srgbClr val="FFFFFF"/>
+                </a:solidFill>
+                <a:latin typeface="Arial" pitchFamily="34" charset="0"/>
+                <a:ea typeface="Arial" pitchFamily="34" charset="-122"/>
+                <a:cs typeface="Arial" pitchFamily="34" charset="-120"/>
+              </a:rPr>
+              <a:t>Overview</a:t>
+            </a:r>
+            <a:endParaRPr lang="en-US" sz="5700"/>
+          </a:p>
+        </p:txBody>
+      </p:sp>
+    </p:spTree>
+  </p:cSld>
+  <p:clrMapOvr>
+    <a:masterClrMapping/>
+  </p:clrMapOvr>
+</p:sld>
+</file>
+
+<file path=ppt/slides/slide20.xml><?xml version="1.0" encoding="utf-8"?>
+<p:sld xmlns:a="http://schemas.openxmlformats.org/drawingml/2006/main" xmlns:p="http://schemas.openxmlformats.org/presentationml/2006/main" xmlns:r="http://schemas.openxmlformats.org/officeDocument/2006/relationships">
+  <p:cSld>
+    <p:spTree>
+      <p:nvGrpSpPr>
+        <p:cNvPr id="1" name=""/>
+        <p:cNvGrpSpPr/>
+        <p:nvPr/>
+      </p:nvGrpSpPr>
+      <p:grpSpPr/>
+      <p:pic>
+        <p:nvPicPr>
+          <p:cNvPr id="2" name="Picture 1" descr="image.png"/>
+          <p:cNvPicPr>
+            <a:picLocks noChangeAspect="1"/>
+          </p:cNvPicPr>
+          <p:nvPr/>
+        </p:nvPicPr>
+        <p:blipFill>
+          <a:blip r:embed="rId2"/>
+          <a:stretch>
+            <a:fillRect/>
+          </a:stretch>
+        </p:blipFill>
+        <p:spPr>
+          <a:xfrm>
+            <a:off x="16188779" y="476250"/>
+            <a:ext cx="1337221" cy="419075"/>
+          </a:xfrm>
+          <a:prstGeom prst="rect">
+            <a:avLst/>
+          </a:prstGeom>
+        </p:spPr>
+      </p:pic>
+      <p:sp>
+        <p:nvSpPr>
+          <p:cNvPr id="3" name="TextBox 2"/>
+          <p:cNvSpPr txBox="1"/>
+          <p:nvPr/>
+        </p:nvSpPr>
+        <p:spPr>
+          <a:xfrm>
+            <a:off x="640080" y="320040"/>
+            <a:ext cx="13716000" cy="548640"/>
+          </a:xfrm>
+          <a:prstGeom prst="rect">
+            <a:avLst/>
+          </a:prstGeom>
+          <a:noFill/>
+        </p:spPr>
+        <p:txBody>
+          <a:bodyPr wrap="square" lIns="0" rIns="0" tIns="0" bIns="0" anchor="t">
+            <a:spAutoFit/>
+          </a:bodyPr>
+          <a:lstStyle/>
+          <a:p>
+            <a:pPr algn="l"/>
+            <a:r>
+              <a:rPr sz="2200" b="1" i="0">
+                <a:solidFill>
+                  <a:srgbClr val="1F3864"/>
+                </a:solidFill>
+                <a:latin typeface="Arial"/>
+              </a:rPr>
+              <a:t>Option D – What It Takes to Build</a:t>
+            </a:r>
+          </a:p>
+        </p:txBody>
+      </p:sp>
+      <p:sp>
+        <p:nvSpPr>
+          <p:cNvPr id="4" name="TextBox 3"/>
+          <p:cNvSpPr txBox="1"/>
+          <p:nvPr/>
+        </p:nvSpPr>
+        <p:spPr>
+          <a:xfrm>
+            <a:off x="640080" y="868680"/>
+            <a:ext cx="16002000" cy="365760"/>
+          </a:xfrm>
+          <a:prstGeom prst="rect">
+            <a:avLst/>
+          </a:prstGeom>
+          <a:noFill/>
+        </p:spPr>
+        <p:txBody>
+          <a:bodyPr wrap="square" lIns="0" rIns="0" tIns="0" bIns="0" anchor="t">
+            <a:spAutoFit/>
+          </a:bodyPr>
+          <a:lstStyle/>
+          <a:p>
+            <a:pPr algn="l"/>
+            <a:r>
+              <a:rPr sz="1200" b="0" i="0">
+                <a:solidFill>
+                  <a:srgbClr val="595959"/>
+                </a:solidFill>
+                <a:latin typeface="Arial"/>
+              </a:rPr>
+              <a:t>S/4: configuration only. CPI: the only development. Licences: nothing new to buy.</a:t>
+            </a:r>
+          </a:p>
+        </p:txBody>
+      </p:sp>
+      <p:graphicFrame>
+        <p:nvGraphicFramePr>
+          <p:cNvPr id="5" name="Table 4"/>
+          <p:cNvGraphicFramePr>
+            <a:graphicFrameLocks noGrp="1"/>
+          </p:cNvGraphicFramePr>
+          <p:nvPr/>
+        </p:nvGraphicFramePr>
+        <p:xfrm>
+          <a:off x="640080" y="1600200"/>
+          <a:ext cx="17007840" cy="4937760"/>
+        </p:xfrm>
+        <a:graphic>
+          <a:graphicData uri="http://schemas.openxmlformats.org/drawingml/2006/table">
+            <a:tbl>
+              <a:tblPr firstRow="1" bandRow="1">
+                <a:tableStyleId>{5C22544A-7EE6-4342-B048-85BDC9FD1C3A}</a:tableStyleId>
+              </a:tblPr>
+              <a:tblGrid>
+                <a:gridCol w="2377440"/>
+                <a:gridCol w="8229600"/>
+                <a:gridCol w="6400800"/>
+              </a:tblGrid>
+              <a:tr h="987552">
+                <a:tc>
+                  <a:txBody>
+                    <a:bodyPr wrap="square"/>
+                    <a:lstStyle/>
+                    <a:p>
+                      <a:r>
+                        <a:rPr sz="1050" b="1">
+                          <a:solidFill>
+                            <a:srgbClr val="1F3864"/>
+                          </a:solidFill>
+                          <a:latin typeface="Arial"/>
+                        </a:rPr>
+                        <a:t>Where</a:t>
+                      </a:r>
+                    </a:p>
+                  </a:txBody>
+                  <a:tcPr marL="73152" marR="73152" marT="36576" marB="36576">
+                    <a:solidFill>
+                      <a:srgbClr val="F4F6F9"/>
+                    </a:solidFill>
+                  </a:tcPr>
+                </a:tc>
+                <a:tc>
+                  <a:txBody>
+                    <a:bodyPr wrap="square"/>
+                    <a:lstStyle/>
+                    <a:p>
+                      <a:r>
+                        <a:rPr sz="1050" b="1">
+                          <a:solidFill>
+                            <a:srgbClr val="1F3864"/>
+                          </a:solidFill>
+                          <a:latin typeface="Arial"/>
+                        </a:rPr>
+                        <a:t>What is needed</a:t>
+                      </a:r>
+                    </a:p>
+                  </a:txBody>
+                  <a:tcPr marL="73152" marR="73152" marT="36576" marB="36576">
+                    <a:solidFill>
+                      <a:srgbClr val="F4F6F9"/>
+                    </a:solidFill>
+                  </a:tcPr>
+                </a:tc>
+                <a:tc>
+                  <a:txBody>
+                    <a:bodyPr wrap="square"/>
+                    <a:lstStyle/>
+                    <a:p>
+                      <a:r>
+                        <a:rPr sz="1050" b="1">
+                          <a:solidFill>
+                            <a:srgbClr val="1F3864"/>
+                          </a:solidFill>
+                          <a:latin typeface="Arial"/>
+                        </a:rPr>
+                        <a:t>Proof / status</a:t>
+                      </a:r>
+                    </a:p>
+                  </a:txBody>
+                  <a:tcPr marL="73152" marR="73152" marT="36576" marB="36576">
+                    <a:solidFill>
+                      <a:srgbClr val="F4F6F9"/>
+                    </a:solidFill>
+                  </a:tcPr>
+                </a:tc>
+              </a:tr>
+              <a:tr h="987552">
+                <a:tc>
+                  <a:txBody>
+                    <a:bodyPr wrap="square"/>
+                    <a:lstStyle/>
+                    <a:p>
+                      <a:r>
+                        <a:rPr b="0" sz="1050">
+                          <a:solidFill>
+                            <a:srgbClr val="111111"/>
+                          </a:solidFill>
+                          <a:latin typeface="Arial"/>
+                        </a:rPr>
+                        <a:t>S/4HANA</a:t>
+                      </a:r>
+                    </a:p>
+                  </a:txBody>
+                  <a:tcPr marL="73152" marR="73152" marT="36576" marB="36576">
+                    <a:solidFill>
+                      <a:srgbClr val="FFFFFF"/>
+                    </a:solidFill>
+                  </a:tcPr>
+                </a:tc>
+                <a:tc>
+                  <a:txBody>
+                    <a:bodyPr wrap="square"/>
+                    <a:lstStyle/>
+                    <a:p>
+                      <a:r>
+                        <a:rPr sz="1050" b="0">
+                          <a:solidFill>
+                            <a:srgbClr val="111111"/>
+                          </a:solidFill>
+                          <a:latin typeface="Arial"/>
+                        </a:rPr>
+                        <a:t>Configuration in standard apps only: switch on the change notice per kind of data (a two-minute step each). No development — none is even possible in our cloud edition.</a:t>
+                      </a:r>
+                    </a:p>
+                  </a:txBody>
+                  <a:tcPr marL="73152" marR="73152" marT="36576" marB="36576">
+                    <a:solidFill>
+                      <a:srgbClr val="FFFFFF"/>
+                    </a:solidFill>
+                  </a:tcPr>
+                </a:tc>
+                <a:tc>
+                  <a:txBody>
+                    <a:bodyPr wrap="square"/>
+                    <a:lstStyle/>
+                    <a:p>
+                      <a:r>
+                        <a:rPr sz="1050" b="0">
+                          <a:solidFill>
+                            <a:srgbClr val="111111"/>
+                          </a:solidFill>
+                          <a:latin typeface="Arial"/>
+                        </a:rPr>
+                        <a:t>The notice channel is already active in our tenant, with one notice (service entry sheet) switched on and working today.</a:t>
+                      </a:r>
+                    </a:p>
+                  </a:txBody>
+                  <a:tcPr marL="73152" marR="73152" marT="36576" marB="36576">
+                    <a:solidFill>
+                      <a:srgbClr val="FFFFFF"/>
+                    </a:solidFill>
+                  </a:tcPr>
+                </a:tc>
+              </a:tr>
+              <a:tr h="987552">
+                <a:tc>
+                  <a:txBody>
+                    <a:bodyPr wrap="square"/>
+                    <a:lstStyle/>
+                    <a:p>
+                      <a:r>
+                        <a:rPr b="0" sz="1050">
+                          <a:solidFill>
+                            <a:srgbClr val="111111"/>
+                          </a:solidFill>
+                          <a:latin typeface="Arial"/>
+                        </a:rPr>
+                        <a:t>SAP CPI</a:t>
+                      </a:r>
+                    </a:p>
+                  </a:txBody>
+                  <a:tcPr marL="73152" marR="73152" marT="36576" marB="36576">
+                    <a:solidFill>
+                      <a:srgbClr val="FFFFFF"/>
+                    </a:solidFill>
+                  </a:tcPr>
+                </a:tc>
+                <a:tc>
+                  <a:txBody>
+                    <a:bodyPr wrap="square"/>
+                    <a:lstStyle/>
+                    <a:p>
+                      <a:r>
+                        <a:rPr sz="1050" b="0">
+                          <a:solidFill>
+                            <a:srgbClr val="111111"/>
+                          </a:solidFill>
+                          <a:latin typeface="Arial"/>
+                        </a:rPr>
+                        <a:t>The distribution layer — detect, read, wrap, route, deliver, retry, re-send. Assembled from standard delivered parts; no custom platform components.</a:t>
+                      </a:r>
+                    </a:p>
+                  </a:txBody>
+                  <a:tcPr marL="73152" marR="73152" marT="36576" marB="36576">
+                    <a:solidFill>
+                      <a:srgbClr val="FFFFFF"/>
+                    </a:solidFill>
+                  </a:tcPr>
+                </a:tc>
+                <a:tc>
+                  <a:txBody>
+                    <a:bodyPr wrap="square"/>
+                    <a:lstStyle/>
+                    <a:p>
+                      <a:r>
+                        <a:rPr sz="1050" b="0">
+                          <a:solidFill>
+                            <a:srgbClr val="111111"/>
+                          </a:solidFill>
+                          <a:latin typeface="Arial"/>
+                        </a:rPr>
+                        <a:t>Fully specified for the build partner: numbered requirements, tests and a definition of done (build specification document).</a:t>
+                      </a:r>
+                    </a:p>
+                  </a:txBody>
+                  <a:tcPr marL="73152" marR="73152" marT="36576" marB="36576">
+                    <a:solidFill>
+                      <a:srgbClr val="FFFFFF"/>
+                    </a:solidFill>
+                  </a:tcPr>
+                </a:tc>
+              </a:tr>
+              <a:tr h="987552">
+                <a:tc>
+                  <a:txBody>
+                    <a:bodyPr wrap="square"/>
+                    <a:lstStyle/>
+                    <a:p>
+                      <a:r>
+                        <a:rPr b="0" sz="1050">
+                          <a:solidFill>
+                            <a:srgbClr val="111111"/>
+                          </a:solidFill>
+                          <a:latin typeface="Arial"/>
+                        </a:rPr>
+                        <a:t>Field systems</a:t>
+                      </a:r>
+                    </a:p>
+                  </a:txBody>
+                  <a:tcPr marL="73152" marR="73152" marT="36576" marB="36576">
+                    <a:solidFill>
+                      <a:srgbClr val="FFFFFF"/>
+                    </a:solidFill>
+                  </a:tcPr>
+                </a:tc>
+                <a:tc>
+                  <a:txBody>
+                    <a:bodyPr wrap="square"/>
+                    <a:lstStyle/>
+                    <a:p>
+                      <a:r>
+                        <a:rPr sz="1050" b="0">
+                          <a:solidFill>
+                            <a:srgbClr val="111111"/>
+                          </a:solidFill>
+                          <a:latin typeface="Arial"/>
+                        </a:rPr>
+                        <a:t>Configuration, plus JAMS’s six receiving services.</a:t>
+                      </a:r>
+                    </a:p>
+                  </a:txBody>
+                  <a:tcPr marL="73152" marR="73152" marT="36576" marB="36576">
+                    <a:solidFill>
+                      <a:srgbClr val="FFFFFF"/>
+                    </a:solidFill>
+                  </a:tcPr>
+                </a:tc>
+                <a:tc>
+                  <a:txBody>
+                    <a:bodyPr wrap="square"/>
+                    <a:lstStyle/>
+                    <a:p>
+                      <a:r>
+                        <a:rPr sz="1050" b="0">
+                          <a:solidFill>
+                            <a:srgbClr val="111111"/>
+                          </a:solidFill>
+                          <a:latin typeface="Arial"/>
+                        </a:rPr>
+                        <a:t>Previous slide.</a:t>
+                      </a:r>
+                    </a:p>
+                  </a:txBody>
+                  <a:tcPr marL="73152" marR="73152" marT="36576" marB="36576">
+                    <a:solidFill>
+                      <a:srgbClr val="FFFFFF"/>
+                    </a:solidFill>
+                  </a:tcPr>
+                </a:tc>
+              </a:tr>
+              <a:tr h="987552">
+                <a:tc>
+                  <a:txBody>
+                    <a:bodyPr wrap="square"/>
+                    <a:lstStyle/>
+                    <a:p>
+                      <a:r>
+                        <a:rPr b="0" sz="1050">
+                          <a:solidFill>
+                            <a:srgbClr val="111111"/>
+                          </a:solidFill>
+                          <a:latin typeface="Arial"/>
+                        </a:rPr>
+                        <a:t>Licences</a:t>
+                      </a:r>
+                    </a:p>
+                  </a:txBody>
+                  <a:tcPr marL="73152" marR="73152" marT="36576" marB="36576">
+                    <a:solidFill>
+                      <a:srgbClr val="FFFFFF"/>
+                    </a:solidFill>
+                  </a:tcPr>
+                </a:tc>
+                <a:tc>
+                  <a:txBody>
+                    <a:bodyPr wrap="square"/>
+                    <a:lstStyle/>
+                    <a:p>
+                      <a:r>
+                        <a:rPr sz="1050" b="0">
+                          <a:solidFill>
+                            <a:srgbClr val="111111"/>
+                          </a:solidFill>
+                          <a:latin typeface="Arial"/>
+                        </a:rPr>
+                        <a:t>Everything used is inside licences already held. The event capability is included in our Integration Suite edition; the S/4 extensibility plans show ‘commercial type: none’ in our own account. No AI is used anywhere.</a:t>
+                      </a:r>
+                    </a:p>
+                  </a:txBody>
+                  <a:tcPr marL="73152" marR="73152" marT="36576" marB="36576">
+                    <a:solidFill>
+                      <a:srgbClr val="FFFFFF"/>
+                    </a:solidFill>
+                  </a:tcPr>
+                </a:tc>
+                <a:tc>
+                  <a:txBody>
+                    <a:bodyPr wrap="square"/>
+                    <a:lstStyle/>
+                    <a:p>
+                      <a:r>
+                        <a:rPr sz="1050" b="0">
+                          <a:solidFill>
+                            <a:srgbClr val="111111"/>
+                          </a:solidFill>
+                          <a:latin typeface="Arial"/>
+                        </a:rPr>
+                        <a:t>Checked in our own SAP accounts. One open commercial check: message volumes against existing Integration Suite metering.</a:t>
+                      </a:r>
+                    </a:p>
+                  </a:txBody>
+                  <a:tcPr marL="73152" marR="73152" marT="36576" marB="36576">
+                    <a:solidFill>
+                      <a:srgbClr val="FFFFFF"/>
+                    </a:solidFill>
+                  </a:tcPr>
+                </a:tc>
+              </a:tr>
+            </a:tbl>
+          </a:graphicData>
+        </a:graphic>
+      </p:graphicFrame>
+      <p:sp>
+        <p:nvSpPr>
+          <p:cNvPr id="6" name="TextBox 5"/>
+          <p:cNvSpPr txBox="1"/>
+          <p:nvPr/>
+        </p:nvSpPr>
+        <p:spPr>
+          <a:xfrm>
+            <a:off x="640080" y="7178040"/>
+            <a:ext cx="16916400" cy="457200"/>
+          </a:xfrm>
+          <a:prstGeom prst="rect">
+            <a:avLst/>
+          </a:prstGeom>
+          <a:noFill/>
+        </p:spPr>
+        <p:txBody>
+          <a:bodyPr wrap="square" lIns="0" rIns="0" tIns="0" bIns="0" anchor="t">
+            <a:spAutoFit/>
+          </a:bodyPr>
+          <a:lstStyle/>
+          <a:p>
+            <a:pPr algn="l"/>
+            <a:r>
+              <a:rPr sz="1200" b="1" i="0">
+                <a:solidFill>
+                  <a:srgbClr val="0F7A3D"/>
+                </a:solidFill>
+                <a:latin typeface="Arial"/>
+              </a:rPr>
+              <a:t>Sequencing: the JAMS day-one scope works with the timer alone — the change-notice part improves speed later and blocks nothing.</a:t>
+            </a:r>
+          </a:p>
+        </p:txBody>
+      </p:sp>
+      <p:sp>
+        <p:nvSpPr>
+          <p:cNvPr id="7" name="TextBox 6"/>
+          <p:cNvSpPr txBox="1"/>
+          <p:nvPr/>
+        </p:nvSpPr>
+        <p:spPr>
+          <a:xfrm>
+            <a:off x="640080" y="7635240"/>
+            <a:ext cx="16916400" cy="731520"/>
+          </a:xfrm>
+          <a:prstGeom prst="rect">
+            <a:avLst/>
+          </a:prstGeom>
+          <a:noFill/>
+        </p:spPr>
+        <p:txBody>
+          <a:bodyPr wrap="square" lIns="0" rIns="0" tIns="0" bIns="0" anchor="t">
+            <a:spAutoFit/>
+          </a:bodyPr>
+          <a:lstStyle/>
+          <a:p>
+            <a:pPr algn="l"/>
+            <a:r>
+              <a:rPr sz="1100" b="0" i="0">
+                <a:solidFill>
+                  <a:srgbClr val="595959"/>
+                </a:solidFill>
+                <a:latin typeface="Arial"/>
+              </a:rPr>
+              <a:t>Open before build (with owners): exact change-notice names per data set (Rajesh) · timer frequency per data set (Trajce) · JAMS service addresses, login and six field lists (Trajce + CPI team) · ServiceNow import approach under Defence security rules and ITSM need (Chamila) · Sitetracker need and owner (TBC) · message-volume estimate (Rajesh).</a:t>
+            </a:r>
+          </a:p>
+        </p:txBody>
+      </p:sp>
+    </p:spTree>
+  </p:cSld>
+  <p:clrMapOvr>
+    <a:masterClrMapping/>
+  </p:clrMapOvr>
+</p:sld>
+</file>
+
+<file path=ppt/slides/slide21.xml><?xml version="1.0" encoding="utf-8"?>
+<p:sld xmlns:a="http://schemas.openxmlformats.org/drawingml/2006/main" xmlns:p="http://schemas.openxmlformats.org/presentationml/2006/main" xmlns:r="http://schemas.openxmlformats.org/officeDocument/2006/relationships">
+  <p:cSld>
+    <p:spTree>
+      <p:nvGrpSpPr>
+        <p:cNvPr id="1" name=""/>
+        <p:cNvGrpSpPr/>
+        <p:nvPr/>
+      </p:nvGrpSpPr>
+      <p:grpSpPr/>
+      <p:pic>
+        <p:nvPicPr>
+          <p:cNvPr id="2" name="Picture 1" descr="image.png"/>
+          <p:cNvPicPr>
+            <a:picLocks noChangeAspect="1"/>
+          </p:cNvPicPr>
+          <p:nvPr/>
+        </p:nvPicPr>
+        <p:blipFill>
+          <a:blip r:embed="rId2"/>
+          <a:stretch>
+            <a:fillRect/>
+          </a:stretch>
+        </p:blipFill>
+        <p:spPr>
+          <a:xfrm>
+            <a:off x="16188779" y="476250"/>
+            <a:ext cx="1337221" cy="419075"/>
+          </a:xfrm>
+          <a:prstGeom prst="rect">
+            <a:avLst/>
+          </a:prstGeom>
+        </p:spPr>
+      </p:pic>
+      <p:sp>
+        <p:nvSpPr>
+          <p:cNvPr id="3" name="TextBox 2"/>
+          <p:cNvSpPr txBox="1"/>
+          <p:nvPr/>
+        </p:nvSpPr>
+        <p:spPr>
+          <a:xfrm>
+            <a:off x="640080" y="320040"/>
+            <a:ext cx="13716000" cy="548640"/>
+          </a:xfrm>
+          <a:prstGeom prst="rect">
+            <a:avLst/>
+          </a:prstGeom>
+          <a:noFill/>
+        </p:spPr>
+        <p:txBody>
+          <a:bodyPr wrap="square" lIns="0" rIns="0" tIns="0" bIns="0" anchor="t">
+            <a:spAutoFit/>
+          </a:bodyPr>
+          <a:lstStyle/>
+          <a:p>
+            <a:pPr algn="l"/>
+            <a:r>
+              <a:rPr sz="2200" b="1" i="0">
+                <a:solidFill>
+                  <a:srgbClr val="1F3864"/>
+                </a:solidFill>
+                <a:latin typeface="Arial"/>
+              </a:rPr>
+              <a:t>Option E Considered – Fully Event-Driven Delivery (a Variant, Not the Rule)</a:t>
+            </a:r>
+          </a:p>
+        </p:txBody>
+      </p:sp>
+      <p:sp>
+        <p:nvSpPr>
+          <p:cNvPr id="4" name="TextBox 3"/>
+          <p:cNvSpPr txBox="1"/>
+          <p:nvPr/>
+        </p:nvSpPr>
+        <p:spPr>
+          <a:xfrm>
+            <a:off x="640080" y="868680"/>
+            <a:ext cx="16002000" cy="365760"/>
+          </a:xfrm>
+          <a:prstGeom prst="rect">
+            <a:avLst/>
+          </a:prstGeom>
+          <a:noFill/>
+        </p:spPr>
+        <p:txBody>
+          <a:bodyPr wrap="square" lIns="0" rIns="0" tIns="0" bIns="0" anchor="t">
+            <a:spAutoFit/>
+          </a:bodyPr>
+          <a:lstStyle/>
+          <a:p>
+            <a:pPr algn="l"/>
+            <a:r>
+              <a:rPr sz="1200" b="0" i="0">
+                <a:solidFill>
+                  <a:srgbClr val="595959"/>
+                </a:solidFill>
+                <a:latin typeface="Arial"/>
+              </a:rPr>
+              <a:t>Fair question: SAP sells an event service built for one-publisher-to-many-subscribers. Researched against SAP’s own documentation — three facts decide where it fits.</a:t>
+            </a:r>
+          </a:p>
+        </p:txBody>
+      </p:sp>
+      <p:sp>
+        <p:nvSpPr>
+          <p:cNvPr id="5" name="Rectangle 4"/>
+          <p:cNvSpPr/>
+          <p:nvPr/>
+        </p:nvSpPr>
+        <p:spPr>
+          <a:xfrm>
+            <a:off x="640080" y="1691640"/>
+            <a:ext cx="17007840" cy="1170432"/>
+          </a:xfrm>
+          <a:prstGeom prst="rect">
+            <a:avLst/>
+          </a:prstGeom>
+          <a:solidFill>
+            <a:srgbClr val="F4F6F9"/>
+          </a:solidFill>
+          <a:ln w="12700">
+            <a:solidFill>
+              <a:srgbClr val="C9CFD8"/>
+            </a:solidFill>
+          </a:ln>
+          <a:effectLst/>
+        </p:spPr>
+        <p:style>
+          <a:lnRef idx="1">
+            <a:schemeClr val="accent1"/>
+          </a:lnRef>
+          <a:fillRef idx="3">
+            <a:schemeClr val="accent1"/>
+          </a:fillRef>
+          <a:effectRef idx="2">
+            <a:schemeClr val="accent1"/>
+          </a:effectRef>
+          <a:fontRef idx="minor">
+            <a:schemeClr val="lt1"/>
+          </a:fontRef>
+        </p:style>
+        <p:txBody>
+          <a:bodyPr rtlCol="0" anchor="ctr" wrap="square" lIns="137160" rIns="137160" tIns="73152" bIns="54864"/>
+          <a:lstStyle/>
+          <a:p>
+            <a:pPr algn="ctr"/>
+            <a:r>
+              <a:rPr sz="1250" b="1">
+                <a:solidFill>
+                  <a:srgbClr val="1F3864"/>
+                </a:solidFill>
+                <a:latin typeface="Arial"/>
+              </a:rPr>
+              <a:t>1 — Change notices carry almost no data, by design.</a:t>
+            </a:r>
+          </a:p>
+          <a:p>
+            <a:r>
+              <a:rPr sz="1150">
+                <a:solidFill>
+                  <a:srgbClr val="111111"/>
+                </a:solidFill>
+                <a:latin typeface="Arial"/>
+              </a:rPr>
+              <a:t>They contain the record’s ID and little else; SAP’s documented pattern is that the receiver calls back to S/4 for the full data. If field systems subscribed directly, every one of them would have to build fetch-and-convert logic — the exact burden this design removes.</a:t>
+            </a:r>
+          </a:p>
+        </p:txBody>
+      </p:sp>
+      <p:sp>
+        <p:nvSpPr>
+          <p:cNvPr id="6" name="Rectangle 5"/>
+          <p:cNvSpPr/>
+          <p:nvPr/>
+        </p:nvSpPr>
+        <p:spPr>
+          <a:xfrm>
+            <a:off x="640080" y="3044952"/>
+            <a:ext cx="17007840" cy="1170432"/>
+          </a:xfrm>
+          <a:prstGeom prst="rect">
+            <a:avLst/>
+          </a:prstGeom>
+          <a:solidFill>
+            <a:srgbClr val="F4F6F9"/>
+          </a:solidFill>
+          <a:ln w="12700">
+            <a:solidFill>
+              <a:srgbClr val="C9CFD8"/>
+            </a:solidFill>
+          </a:ln>
+          <a:effectLst/>
+        </p:spPr>
+        <p:style>
+          <a:lnRef idx="1">
+            <a:schemeClr val="accent1"/>
+          </a:lnRef>
+          <a:fillRef idx="3">
+            <a:schemeClr val="accent1"/>
+          </a:fillRef>
+          <a:effectRef idx="2">
+            <a:schemeClr val="accent1"/>
+          </a:effectRef>
+          <a:fontRef idx="minor">
+            <a:schemeClr val="lt1"/>
+          </a:fontRef>
+        </p:style>
+        <p:txBody>
+          <a:bodyPr rtlCol="0" anchor="ctr" wrap="square" lIns="137160" rIns="137160" tIns="73152" bIns="54864"/>
+          <a:lstStyle/>
+          <a:p>
+            <a:pPr algn="ctr"/>
+            <a:r>
+              <a:rPr sz="1250" b="1">
+                <a:solidFill>
+                  <a:srgbClr val="1F3864"/>
+                </a:solidFill>
+                <a:latin typeface="Arial"/>
+              </a:rPr>
+              <a:t>2 — Filtering by content is not supported.</a:t>
+            </a:r>
+          </a:p>
+          <a:p>
+            <a:r>
+              <a:rPr sz="1150">
+                <a:solidFill>
+                  <a:srgbClr val="111111"/>
+                </a:solidFill>
+                <a:latin typeface="Arial"/>
+              </a:rPr>
+              <a:t>The event service filters by topic name only; SAP documents content filtering (e.g. “only Defence contracts”) as an anti-pattern. Standard notices name the kind of data, never the contract — so Defence separation could not be enforced.</a:t>
+            </a:r>
+          </a:p>
+        </p:txBody>
+      </p:sp>
+      <p:sp>
+        <p:nvSpPr>
+          <p:cNvPr id="7" name="Rectangle 6"/>
+          <p:cNvSpPr/>
+          <p:nvPr/>
+        </p:nvSpPr>
+        <p:spPr>
+          <a:xfrm>
+            <a:off x="640080" y="4398264"/>
+            <a:ext cx="17007840" cy="1170432"/>
+          </a:xfrm>
+          <a:prstGeom prst="rect">
+            <a:avLst/>
+          </a:prstGeom>
+          <a:solidFill>
+            <a:srgbClr val="F4F6F9"/>
+          </a:solidFill>
+          <a:ln w="12700">
+            <a:solidFill>
+              <a:srgbClr val="C9CFD8"/>
+            </a:solidFill>
+          </a:ln>
+          <a:effectLst/>
+        </p:spPr>
+        <p:style>
+          <a:lnRef idx="1">
+            <a:schemeClr val="accent1"/>
+          </a:lnRef>
+          <a:fillRef idx="3">
+            <a:schemeClr val="accent1"/>
+          </a:fillRef>
+          <a:effectRef idx="2">
+            <a:schemeClr val="accent1"/>
+          </a:effectRef>
+          <a:fontRef idx="minor">
+            <a:schemeClr val="lt1"/>
+          </a:fontRef>
+        </p:style>
+        <p:txBody>
+          <a:bodyPr rtlCol="0" anchor="ctr" wrap="square" lIns="137160" rIns="137160" tIns="73152" bIns="54864"/>
+          <a:lstStyle/>
+          <a:p>
+            <a:pPr algn="ctr"/>
+            <a:r>
+              <a:rPr sz="1250" b="1">
+                <a:solidFill>
+                  <a:srgbClr val="1F3864"/>
+                </a:solidFill>
+                <a:latin typeface="Arial"/>
+              </a:rPr>
+              <a:t>3 — It does not convert formats.</a:t>
+            </a:r>
+          </a:p>
+          <a:p>
+            <a:r>
+              <a:rPr sz="1150">
+                <a:solidFill>
+                  <a:srgbClr val="111111"/>
+                </a:solidFill>
+                <a:latin typeface="Arial"/>
+              </a:rPr>
+              <a:t>It is a delivery service, not a mapper. Nothing in it can turn the standard message into ServiceNow’s import format or Salesforce’s save call — that conversion has to live somewhere, and if not in CPI, then in every field system.</a:t>
+            </a:r>
+          </a:p>
+        </p:txBody>
+      </p:sp>
+      <p:sp>
+        <p:nvSpPr>
+          <p:cNvPr id="8" name="TextBox 7"/>
+          <p:cNvSpPr txBox="1"/>
+          <p:nvPr/>
+        </p:nvSpPr>
+        <p:spPr>
+          <a:xfrm>
+            <a:off x="640080" y="5843016"/>
+            <a:ext cx="17007840" cy="822960"/>
+          </a:xfrm>
+          <a:prstGeom prst="rect">
+            <a:avLst/>
+          </a:prstGeom>
+          <a:noFill/>
+        </p:spPr>
+        <p:txBody>
+          <a:bodyPr wrap="square" lIns="0" rIns="0" tIns="0" bIns="0" anchor="t">
+            <a:spAutoFit/>
+          </a:bodyPr>
+          <a:lstStyle/>
+          <a:p>
+            <a:pPr algn="l"/>
+            <a:r>
+              <a:rPr sz="1200" b="0" i="0">
+                <a:solidFill>
+                  <a:srgbClr val="111111"/>
+                </a:solidFill>
+                <a:latin typeface="Arial"/>
+              </a:rPr>
+              <a:t>So a workable middle form exists — CPI still detects, reads, filters and wraps, then publishes the finished message to event topics and lets the event service deliver it by web call — but it only suits systems willing to accept the standard message directly. ServiceNow and Sitetracker cannot without a converter in front, which is CPI again.</a:t>
+            </a:r>
+          </a:p>
+        </p:txBody>
+      </p:sp>
+      <p:sp>
+        <p:nvSpPr>
+          <p:cNvPr id="9" name="TextBox 8"/>
+          <p:cNvSpPr txBox="1"/>
+          <p:nvPr/>
+        </p:nvSpPr>
+        <p:spPr>
+          <a:xfrm>
+            <a:off x="640080" y="6711696"/>
+            <a:ext cx="17007840" cy="822960"/>
+          </a:xfrm>
+          <a:prstGeom prst="rect">
+            <a:avLst/>
+          </a:prstGeom>
+          <a:noFill/>
+        </p:spPr>
+        <p:txBody>
+          <a:bodyPr wrap="square" lIns="0" rIns="0" tIns="0" bIns="0" anchor="t">
+            <a:spAutoFit/>
+          </a:bodyPr>
+          <a:lstStyle/>
+          <a:p>
+            <a:pPr algn="l"/>
+            <a:r>
+              <a:rPr sz="1200" b="1" i="0">
+                <a:solidFill>
+                  <a:srgbClr val="0F7A3D"/>
+                </a:solidFill>
+                <a:latin typeface="Arial"/>
+              </a:rPr>
+              <a:t>Position: SAP’s event-driven architecture is already inside Option D — it carries the change notice from S/4 into CPI, and that is its only job. As a delivery mechanism it stays a per-system variant the design can adopt later by swapping only the delivery plumbing. It is not the primary pattern, because it moves format conversion into the field systems — the one cost this programme set out to avoid.</a:t>
+            </a:r>
+          </a:p>
+        </p:txBody>
+      </p:sp>
+    </p:spTree>
+  </p:cSld>
+  <p:clrMapOvr>
+    <a:masterClrMapping/>
+  </p:clrMapOvr>
+</p:sld>
+</file>
+
+<file path=ppt/slides/slide22.xml><?xml version="1.0" encoding="utf-8"?>
+<p:sld xmlns:a="http://schemas.openxmlformats.org/drawingml/2006/main" xmlns:p="http://schemas.openxmlformats.org/presentationml/2006/main" xmlns:r="http://schemas.openxmlformats.org/officeDocument/2006/relationships">
+  <p:cSld>
+    <p:spTree>
+      <p:nvGrpSpPr>
+        <p:cNvPr id="1" name=""/>
+        <p:cNvGrpSpPr/>
+        <p:nvPr/>
+      </p:nvGrpSpPr>
+      <p:grpSpPr/>
+      <p:pic>
+        <p:nvPicPr>
+          <p:cNvPr id="2" name="Picture 1" descr="image.png"/>
+          <p:cNvPicPr>
+            <a:picLocks noChangeAspect="1"/>
+          </p:cNvPicPr>
+          <p:nvPr/>
+        </p:nvPicPr>
+        <p:blipFill>
+          <a:blip r:embed="rId2"/>
+          <a:stretch>
+            <a:fillRect/>
+          </a:stretch>
+        </p:blipFill>
+        <p:spPr>
+          <a:xfrm>
+            <a:off x="16188779" y="476250"/>
+            <a:ext cx="1337221" cy="419075"/>
+          </a:xfrm>
+          <a:prstGeom prst="rect">
+            <a:avLst/>
+          </a:prstGeom>
+        </p:spPr>
+      </p:pic>
+      <p:sp>
+        <p:nvSpPr>
+          <p:cNvPr id="3" name="TextBox 2"/>
+          <p:cNvSpPr txBox="1"/>
+          <p:nvPr/>
+        </p:nvSpPr>
+        <p:spPr>
+          <a:xfrm>
+            <a:off x="640080" y="320040"/>
+            <a:ext cx="13716000" cy="548640"/>
+          </a:xfrm>
+          <a:prstGeom prst="rect">
+            <a:avLst/>
+          </a:prstGeom>
+          <a:noFill/>
+        </p:spPr>
+        <p:txBody>
+          <a:bodyPr wrap="square" lIns="0" rIns="0" tIns="0" bIns="0">
+            <a:spAutoFit/>
+          </a:bodyPr>
+          <a:lstStyle/>
+          <a:p>
+            <a:r>
+              <a:rPr sz="2200" b="1">
+                <a:solidFill>
+                  <a:srgbClr val="1F3864"/>
+                </a:solidFill>
+                <a:latin typeface="Arial"/>
+              </a:rPr>
+              <a:t>Options (Updated) – Where the Work of Returning S/4 Data Lives</a:t>
+            </a:r>
+          </a:p>
+        </p:txBody>
+      </p:sp>
+      <p:sp>
+        <p:nvSpPr>
+          <p:cNvPr id="4" name="TextBox 3"/>
+          <p:cNvSpPr txBox="1"/>
+          <p:nvPr/>
+        </p:nvSpPr>
+        <p:spPr>
+          <a:xfrm>
+            <a:off x="640080" y="868680"/>
+            <a:ext cx="16002000" cy="365760"/>
+          </a:xfrm>
+          <a:prstGeom prst="rect">
+            <a:avLst/>
+          </a:prstGeom>
+          <a:noFill/>
+        </p:spPr>
+        <p:txBody>
+          <a:bodyPr wrap="square" lIns="0" rIns="0" tIns="0" bIns="0">
+            <a:spAutoFit/>
+          </a:bodyPr>
+          <a:lstStyle/>
+          <a:p>
+            <a:r>
+              <a:rPr sz="1200">
+                <a:solidFill>
+                  <a:srgbClr val="595959"/>
+                </a:solidFill>
+                <a:latin typeface="Arial"/>
+              </a:rPr>
+              <a:t>All three deliver the same data. They differ in who does the fetching, filtering and converting — each field system, or CPI once for everyone.</a:t>
+            </a:r>
+          </a:p>
+        </p:txBody>
+      </p:sp>
+      <p:graphicFrame>
+        <p:nvGraphicFramePr>
+          <p:cNvPr id="5" name="Table 4"/>
+          <p:cNvGraphicFramePr>
+            <a:graphicFrameLocks noGrp="1"/>
+          </p:cNvGraphicFramePr>
+          <p:nvPr/>
+        </p:nvGraphicFramePr>
+        <p:xfrm>
+          <a:off x="502920" y="1417320"/>
+          <a:ext cx="17556480" cy="4892040"/>
+        </p:xfrm>
+        <a:graphic>
+          <a:graphicData uri="http://schemas.openxmlformats.org/drawingml/2006/table">
+            <a:tbl>
+              <a:tblPr firstRow="1" bandRow="1">
+                <a:tableStyleId>{5C22544A-7EE6-4342-B048-85BDC9FD1C3A}</a:tableStyleId>
+              </a:tblPr>
+              <a:tblGrid>
+                <a:gridCol w="2834640"/>
+                <a:gridCol w="3291840"/>
+                <a:gridCol w="3017520"/>
+                <a:gridCol w="2468880"/>
+                <a:gridCol w="2743200"/>
+                <a:gridCol w="3200400"/>
+              </a:tblGrid>
+              <a:tr h="365760">
+                <a:tc>
+                  <a:txBody>
+                    <a:bodyPr wrap="square"/>
+                    <a:lstStyle/>
+                    <a:p>
+                      <a:r>
+                        <a:rPr sz="1200" b="1">
+                          <a:solidFill>
+                            <a:srgbClr val="111111"/>
+                          </a:solidFill>
+                          <a:latin typeface="Arial"/>
+                        </a:rPr>
+                        <a:t>Option</a:t>
+                      </a:r>
+                    </a:p>
+                  </a:txBody>
+                  <a:tcPr marL="73152" marR="73152" marT="45720" marB="45720">
+                    <a:solidFill>
+                      <a:srgbClr val="92D050"/>
+                    </a:solidFill>
+                  </a:tcPr>
+                </a:tc>
+                <a:tc>
+                  <a:txBody>
+                    <a:bodyPr wrap="square"/>
+                    <a:lstStyle/>
+                    <a:p>
+                      <a:r>
+                        <a:rPr sz="1200" b="1">
+                          <a:solidFill>
+                            <a:srgbClr val="111111"/>
+                          </a:solidFill>
+                          <a:latin typeface="Arial"/>
+                        </a:rPr>
+                        <a:t>Approach</a:t>
+                      </a:r>
+                    </a:p>
+                  </a:txBody>
+                  <a:tcPr marL="73152" marR="73152" marT="45720" marB="45720">
+                    <a:solidFill>
+                      <a:srgbClr val="92D050"/>
+                    </a:solidFill>
+                  </a:tcPr>
+                </a:tc>
+                <a:tc>
+                  <a:txBody>
+                    <a:bodyPr wrap="square"/>
+                    <a:lstStyle/>
+                    <a:p>
+                      <a:r>
+                        <a:rPr sz="1200" b="1">
+                          <a:solidFill>
+                            <a:srgbClr val="111111"/>
+                          </a:solidFill>
+                          <a:latin typeface="Arial"/>
+                        </a:rPr>
+                        <a:t>Build Cost &amp; Duration</a:t>
+                      </a:r>
+                    </a:p>
+                  </a:txBody>
+                  <a:tcPr marL="73152" marR="73152" marT="45720" marB="45720">
+                    <a:solidFill>
+                      <a:srgbClr val="92D050"/>
+                    </a:solidFill>
+                  </a:tcPr>
+                </a:tc>
+                <a:tc>
+                  <a:txBody>
+                    <a:bodyPr wrap="square"/>
+                    <a:lstStyle/>
+                    <a:p>
+                      <a:r>
+                        <a:rPr sz="1200" b="1">
+                          <a:solidFill>
+                            <a:srgbClr val="111111"/>
+                          </a:solidFill>
+                          <a:latin typeface="Arial"/>
+                        </a:rPr>
+                        <a:t>Ongoing Cost</a:t>
+                      </a:r>
+                    </a:p>
+                  </a:txBody>
+                  <a:tcPr marL="73152" marR="73152" marT="45720" marB="45720">
+                    <a:solidFill>
+                      <a:srgbClr val="92D050"/>
+                    </a:solidFill>
+                  </a:tcPr>
+                </a:tc>
+                <a:tc>
+                  <a:txBody>
+                    <a:bodyPr wrap="square"/>
+                    <a:lstStyle/>
+                    <a:p>
+                      <a:r>
+                        <a:rPr sz="1200" b="1">
+                          <a:solidFill>
+                            <a:srgbClr val="111111"/>
+                          </a:solidFill>
+                          <a:latin typeface="Arial"/>
+                        </a:rPr>
+                        <a:t>Ongoing Benefit</a:t>
+                      </a:r>
+                    </a:p>
+                  </a:txBody>
+                  <a:tcPr marL="73152" marR="73152" marT="45720" marB="45720">
+                    <a:solidFill>
+                      <a:srgbClr val="92D050"/>
+                    </a:solidFill>
+                  </a:tcPr>
+                </a:tc>
+                <a:tc>
+                  <a:txBody>
+                    <a:bodyPr wrap="square"/>
+                    <a:lstStyle/>
+                    <a:p>
+                      <a:r>
+                        <a:rPr sz="1200" b="1">
+                          <a:solidFill>
+                            <a:srgbClr val="111111"/>
+                          </a:solidFill>
+                          <a:latin typeface="Arial"/>
+                        </a:rPr>
+                        <a:t>Key Risks</a:t>
+                      </a:r>
+                    </a:p>
+                  </a:txBody>
+                  <a:tcPr marL="73152" marR="73152" marT="45720" marB="45720">
+                    <a:solidFill>
+                      <a:srgbClr val="92D050"/>
+                    </a:solidFill>
+                  </a:tcPr>
+                </a:tc>
+              </a:tr>
+              <a:tr h="1508760">
+                <a:tc>
+                  <a:txBody>
+                    <a:bodyPr wrap="square"/>
+                    <a:lstStyle/>
+                    <a:p>
+                      <a:r>
+                        <a:rPr sz="1150" b="1">
+                          <a:solidFill>
+                            <a:srgbClr val="111111"/>
+                          </a:solidFill>
+                          <a:latin typeface="Arial"/>
+                        </a:rPr>
+                        <a:t>B – Each system fetches from a published query on CPI</a:t>
+                      </a:r>
+                    </a:p>
+                    <a:p>
+                      <a:r>
+                        <a:rPr sz="1150" b="1" i="1">
+                          <a:solidFill>
+                            <a:srgbClr val="1F3864"/>
+                          </a:solidFill>
+                          <a:latin typeface="Arial"/>
+                        </a:rPr>
+                        <a:t>(Decided baseline — kept)</a:t>
+                      </a:r>
+                    </a:p>
+                  </a:txBody>
+                  <a:tcPr marL="73152" marR="73152" marT="45720" marB="45720">
+                    <a:solidFill>
+                      <a:srgbClr val="FFFFFF"/>
+                    </a:solidFill>
+                  </a:tcPr>
+                </a:tc>
+                <a:tc>
+                  <a:txBody>
+                    <a:bodyPr wrap="square"/>
+                    <a:lstStyle/>
+                    <a:p>
+                      <a:r>
+                        <a:rPr sz="1000">
+                          <a:solidFill>
+                            <a:srgbClr val="111111"/>
+                          </a:solidFill>
+                          <a:latin typeface="Arial"/>
+                        </a:rPr>
+                        <a:t>CPI publishes one query per system; each field system fetches on its own schedule with its own filters.</a:t>
+                      </a:r>
+                    </a:p>
+                  </a:txBody>
+                  <a:tcPr marL="73152" marR="73152" marT="45720" marB="45720">
+                    <a:solidFill>
+                      <a:srgbClr val="FFFFFF"/>
+                    </a:solidFill>
+                  </a:tcPr>
+                </a:tc>
+                <a:tc>
+                  <a:txBody>
+                    <a:bodyPr wrap="square"/>
+                    <a:lstStyle/>
+                    <a:p>
+                      <a:r>
+                        <a:rPr sz="1000" b="1">
+                          <a:solidFill>
+                            <a:srgbClr val="111111"/>
+                          </a:solidFill>
+                          <a:latin typeface="Arial"/>
+                        </a:rPr>
+                        <a:t>Medium.</a:t>
+                      </a:r>
+                      <a:r>
+                        <a:rPr sz="1000">
+                          <a:solidFill>
+                            <a:srgbClr val="111111"/>
+                          </a:solidFill>
+                          <a:latin typeface="Arial"/>
+                        </a:rPr>
+                        <a:t> Build mostly in CPI. But every field system also builds scheduling, data fetching and filtering — ten times, in ten toolsets.</a:t>
+                      </a:r>
+                    </a:p>
+                  </a:txBody>
+                  <a:tcPr marL="73152" marR="73152" marT="45720" marB="45720">
+                    <a:solidFill>
+                      <a:srgbClr val="FFFFFF"/>
+                    </a:solidFill>
+                  </a:tcPr>
+                </a:tc>
+                <a:tc>
+                  <a:txBody>
+                    <a:bodyPr wrap="square"/>
+                    <a:lstStyle/>
+                    <a:p>
+                      <a:r>
+                        <a:rPr sz="1000" b="1">
+                          <a:solidFill>
+                            <a:srgbClr val="111111"/>
+                          </a:solidFill>
+                          <a:latin typeface="Arial"/>
+                        </a:rPr>
+                        <a:t>Medium.</a:t>
+                      </a:r>
+                      <a:r>
+                        <a:rPr sz="1000">
+                          <a:solidFill>
+                            <a:srgbClr val="111111"/>
+                          </a:solidFill>
+                          <a:latin typeface="Arial"/>
+                        </a:rPr>
+                        <a:t> Each system runs and supports its own fetching; skills spread across every vendor.</a:t>
+                      </a:r>
+                    </a:p>
+                  </a:txBody>
+                  <a:tcPr marL="73152" marR="73152" marT="45720" marB="45720">
+                    <a:solidFill>
+                      <a:srgbClr val="FFFFFF"/>
+                    </a:solidFill>
+                  </a:tcPr>
+                </a:tc>
+                <a:tc>
+                  <a:txBody>
+                    <a:bodyPr wrap="square"/>
+                    <a:lstStyle/>
+                    <a:p>
+                      <a:r>
+                        <a:rPr sz="1000">
+                          <a:solidFill>
+                            <a:srgbClr val="111111"/>
+                          </a:solidFill>
+                          <a:latin typeface="Arial"/>
+                        </a:rPr>
+                        <a:t>Simple CPI. Each system controls its own timing.</a:t>
+                      </a:r>
+                    </a:p>
+                  </a:txBody>
+                  <a:tcPr marL="73152" marR="73152" marT="45720" marB="45720">
+                    <a:solidFill>
+                      <a:srgbClr val="FFFFFF"/>
+                    </a:solidFill>
+                  </a:tcPr>
+                </a:tc>
+                <a:tc>
+                  <a:txBody>
+                    <a:bodyPr wrap="square"/>
+                    <a:lstStyle/>
+                    <a:p>
+                      <a:r>
+                        <a:rPr sz="1000">
+                          <a:solidFill>
+                            <a:srgbClr val="111111"/>
+                          </a:solidFill>
+                          <a:latin typeface="Arial"/>
+                        </a:rPr>
+                        <a:t>Orchestration is duplicated in every system. An acquired company's system must be modified before it can see its own data. Filtering correctness must be trusted and audited ten times — including Defence.</a:t>
+                      </a:r>
+                    </a:p>
+                  </a:txBody>
+                  <a:tcPr marL="73152" marR="73152" marT="45720" marB="45720">
+                    <a:solidFill>
+                      <a:srgbClr val="FFFFFF"/>
+                    </a:solidFill>
+                  </a:tcPr>
+                </a:tc>
+              </a:tr>
+              <a:tr h="1508760">
+                <a:tc>
+                  <a:txBody>
+                    <a:bodyPr wrap="square"/>
+                    <a:lstStyle/>
+                    <a:p>
+                      <a:r>
+                        <a:rPr sz="1150" b="1">
+                          <a:solidFill>
+                            <a:srgbClr val="111111"/>
+                          </a:solidFill>
+                          <a:latin typeface="Arial"/>
+                        </a:rPr>
+                        <a:t>D – CPI delivers each system's data to it</a:t>
+                      </a:r>
+                    </a:p>
+                    <a:p>
+                      <a:r>
+                        <a:rPr sz="1150" b="1" i="1">
+                          <a:solidFill>
+                            <a:srgbClr val="008A3E"/>
+                          </a:solidFill>
+                          <a:latin typeface="Arial"/>
+                        </a:rPr>
+                        <a:t>(Proposed – Recommended)</a:t>
+                      </a:r>
+                    </a:p>
+                  </a:txBody>
+                  <a:tcPr marL="73152" marR="73152" marT="45720" marB="45720">
+                    <a:solidFill>
+                      <a:srgbClr val="FFFFFF"/>
+                    </a:solidFill>
+                  </a:tcPr>
+                </a:tc>
+                <a:tc>
+                  <a:txBody>
+                    <a:bodyPr wrap="square"/>
+                    <a:lstStyle/>
+                    <a:p>
+                      <a:r>
+                        <a:rPr sz="1000">
+                          <a:solidFill>
+                            <a:srgbClr val="111111"/>
+                          </a:solidFill>
+                          <a:latin typeface="Arial"/>
+                        </a:rPr>
+                        <a:t>CPI detects each change once, reads the full record, filters by a central subscription list, and delivers it the way each system accepts (web service call or file). The Option B query stays as the fallback.</a:t>
+                      </a:r>
+                    </a:p>
+                  </a:txBody>
+                  <a:tcPr marL="73152" marR="73152" marT="45720" marB="45720">
+                    <a:solidFill>
+                      <a:srgbClr val="FFFFFF"/>
+                    </a:solidFill>
+                  </a:tcPr>
+                </a:tc>
+                <a:tc>
+                  <a:txBody>
+                    <a:bodyPr wrap="square"/>
+                    <a:lstStyle/>
+                    <a:p>
+                      <a:r>
+                        <a:rPr sz="1000" b="1">
+                          <a:solidFill>
+                            <a:srgbClr val="111111"/>
+                          </a:solidFill>
+                          <a:latin typeface="Arial"/>
+                        </a:rPr>
+                        <a:t>Medium.</a:t>
+                      </a:r>
+                      <a:r>
+                        <a:rPr sz="1000">
+                          <a:solidFill>
+                            <a:srgbClr val="111111"/>
+                          </a:solidFill>
+                          <a:latin typeface="Arial"/>
+                        </a:rPr>
+                        <a:t> All development in CPI, from standard delivered parts. S/4: configuration only. Field systems: configuration only, except six small JAMS receiving services.</a:t>
+                      </a:r>
+                    </a:p>
+                  </a:txBody>
+                  <a:tcPr marL="73152" marR="73152" marT="45720" marB="45720">
+                    <a:solidFill>
+                      <a:srgbClr val="FFFFFF"/>
+                    </a:solidFill>
+                  </a:tcPr>
+                </a:tc>
+                <a:tc>
+                  <a:txBody>
+                    <a:bodyPr wrap="square"/>
+                    <a:lstStyle/>
+                    <a:p>
+                      <a:r>
+                        <a:rPr sz="1000" b="1">
+                          <a:solidFill>
+                            <a:srgbClr val="111111"/>
+                          </a:solidFill>
+                          <a:latin typeface="Arial"/>
+                        </a:rPr>
+                        <a:t>Medium.</a:t>
+                      </a:r>
+                      <a:r>
+                        <a:rPr sz="1000">
+                          <a:solidFill>
+                            <a:srgbClr val="111111"/>
+                          </a:solidFill>
+                          <a:latin typeface="Arial"/>
+                        </a:rPr>
+                        <a:t> One team, one toolset, one monitoring view for everything. Nothing new to buy — all inside licences already held.</a:t>
+                      </a:r>
+                    </a:p>
+                  </a:txBody>
+                  <a:tcPr marL="73152" marR="73152" marT="45720" marB="45720">
+                    <a:solidFill>
+                      <a:srgbClr val="FFFFFF"/>
+                    </a:solidFill>
+                  </a:tcPr>
+                </a:tc>
+                <a:tc>
+                  <a:txBody>
+                    <a:bodyPr wrap="square"/>
+                    <a:lstStyle/>
+                    <a:p>
+                      <a:r>
+                        <a:rPr sz="1000">
+                          <a:solidFill>
+                            <a:srgbClr val="111111"/>
+                          </a:solidFill>
+                          <a:latin typeface="Arial"/>
+                        </a:rPr>
+                        <a:t>Field systems stop building orchestration. Defence separation enforced centrally and auditably. A new or acquired system = configuration rows plus one converter. Data arrives as it changes.</a:t>
+                      </a:r>
+                    </a:p>
+                  </a:txBody>
+                  <a:tcPr marL="73152" marR="73152" marT="45720" marB="45720">
+                    <a:solidFill>
+                      <a:srgbClr val="FFFFFF"/>
+                    </a:solidFill>
+                  </a:tcPr>
+                </a:tc>
+                <a:tc>
+                  <a:txBody>
+                    <a:bodyPr wrap="square"/>
+                    <a:lstStyle/>
+                    <a:p>
+                      <a:r>
+                        <a:rPr sz="1000">
+                          <a:solidFill>
+                            <a:srgbClr val="111111"/>
+                          </a:solidFill>
+                          <a:latin typeface="Arial"/>
+                        </a:rPr>
+                        <a:t>CPI becomes an operational platform — queues, alerts and a run book to own. Message volumes are metered under the existing licence (sizing in progress). Standard-message format needs version discipline.</a:t>
+                      </a:r>
+                    </a:p>
+                  </a:txBody>
+                  <a:tcPr marL="73152" marR="73152" marT="45720" marB="45720">
+                    <a:solidFill>
+                      <a:srgbClr val="FFFFFF"/>
+                    </a:solidFill>
+                  </a:tcPr>
+                </a:tc>
+              </a:tr>
+              <a:tr h="1508760">
+                <a:tc>
+                  <a:txBody>
+                    <a:bodyPr wrap="square"/>
+                    <a:lstStyle/>
+                    <a:p>
+                      <a:r>
+                        <a:rPr sz="1150" b="1">
+                          <a:solidFill>
+                            <a:srgbClr val="111111"/>
+                          </a:solidFill>
+                          <a:latin typeface="Arial"/>
+                        </a:rPr>
+                        <a:t>E – Fully event-driven delivery</a:t>
+                      </a:r>
+                    </a:p>
+                    <a:p>
+                      <a:r>
+                        <a:rPr sz="1150" b="1" i="1">
+                          <a:solidFill>
+                            <a:srgbClr val="595959"/>
+                          </a:solidFill>
+                          <a:latin typeface="Arial"/>
+                        </a:rPr>
+                        <a:t>(Noted — a per-system variant, not the rule)</a:t>
+                      </a:r>
+                    </a:p>
+                  </a:txBody>
+                  <a:tcPr marL="73152" marR="73152" marT="45720" marB="45720">
+                    <a:solidFill>
+                      <a:srgbClr val="FFFFFF"/>
+                    </a:solidFill>
+                  </a:tcPr>
+                </a:tc>
+                <a:tc>
+                  <a:txBody>
+                    <a:bodyPr wrap="square"/>
+                    <a:lstStyle/>
+                    <a:p>
+                      <a:r>
+                        <a:rPr sz="1000">
+                          <a:solidFill>
+                            <a:srgbClr val="111111"/>
+                          </a:solidFill>
+                          <a:latin typeface="Arial"/>
+                        </a:rPr>
+                        <a:t>CPI still detects, reads, filters and wraps — then publishes finished messages to event topics; SAP's event service delivers them by web call to each subscribed system.</a:t>
+                      </a:r>
+                    </a:p>
+                  </a:txBody>
+                  <a:tcPr marL="73152" marR="73152" marT="45720" marB="45720">
+                    <a:solidFill>
+                      <a:srgbClr val="FFFFFF"/>
+                    </a:solidFill>
+                  </a:tcPr>
+                </a:tc>
+                <a:tc>
+                  <a:txBody>
+                    <a:bodyPr wrap="square"/>
+                    <a:lstStyle/>
+                    <a:p>
+                      <a:r>
+                        <a:rPr sz="1000">
+                          <a:solidFill>
+                            <a:srgbClr val="111111"/>
+                          </a:solidFill>
+                          <a:latin typeface="Arial"/>
+                        </a:rPr>
+                        <a:t>Lower in CPI (no delivery plumbing) but higher in each field system: every receiver must accept the standard message itself.</a:t>
+                      </a:r>
+                    </a:p>
+                  </a:txBody>
+                  <a:tcPr marL="73152" marR="73152" marT="45720" marB="45720">
+                    <a:solidFill>
+                      <a:srgbClr val="FFFFFF"/>
+                    </a:solidFill>
+                  </a:tcPr>
+                </a:tc>
+                <a:tc>
+                  <a:txBody>
+                    <a:bodyPr wrap="square"/>
+                    <a:lstStyle/>
+                    <a:p>
+                      <a:r>
+                        <a:rPr sz="1000" b="1">
+                          <a:solidFill>
+                            <a:srgbClr val="111111"/>
+                          </a:solidFill>
+                          <a:latin typeface="Arial"/>
+                        </a:rPr>
+                        <a:t>Split operations across CPI and the event service consoles.</a:t>
+                      </a:r>
+                      <a:r>
+                        <a:rPr sz="1000">
+                          <a:solidFill>
+                            <a:srgbClr val="111111"/>
+                          </a:solidFill>
+                          <a:latin typeface="Arial"/>
+                        </a:rPr>
+                        <a:t/>
+                      </a:r>
+                    </a:p>
+                  </a:txBody>
+                  <a:tcPr marL="73152" marR="73152" marT="45720" marB="45720">
+                    <a:solidFill>
+                      <a:srgbClr val="FFFFFF"/>
+                    </a:solidFill>
+                  </a:tcPr>
+                </a:tc>
+                <a:tc>
+                  <a:txBody>
+                    <a:bodyPr wrap="square"/>
+                    <a:lstStyle/>
+                    <a:p>
+                      <a:r>
+                        <a:rPr sz="1000">
+                          <a:solidFill>
+                            <a:srgbClr val="111111"/>
+                          </a:solidFill>
+                          <a:latin typeface="Arial"/>
+                        </a:rPr>
+                        <a:t>Native one-to-many delivery with built-in retry. Suits systems willing to accept the standard message directly (JAMS could).</a:t>
+                      </a:r>
+                    </a:p>
+                  </a:txBody>
+                  <a:tcPr marL="73152" marR="73152" marT="45720" marB="45720">
+                    <a:solidFill>
+                      <a:srgbClr val="FFFFFF"/>
+                    </a:solidFill>
+                  </a:tcPr>
+                </a:tc>
+                <a:tc>
+                  <a:txBody>
+                    <a:bodyPr wrap="square"/>
+                    <a:lstStyle/>
+                    <a:p>
+                      <a:r>
+                        <a:rPr sz="1000">
+                          <a:solidFill>
+                            <a:srgbClr val="111111"/>
+                          </a:solidFill>
+                          <a:latin typeface="Arial"/>
+                        </a:rPr>
+                        <a:t>Change notices carry the record ID only. No filtering by contract (SAP documents content filtering as an anti-pattern) — Defence separation cannot be enforced this way. No format conversion — ServiceNow and Sitetracker still need a converter in front, which is CPI again.</a:t>
+                      </a:r>
+                    </a:p>
+                  </a:txBody>
+                  <a:tcPr marL="73152" marR="73152" marT="45720" marB="45720">
+                    <a:solidFill>
+                      <a:srgbClr val="FFFFFF"/>
+                    </a:solidFill>
+                  </a:tcPr>
+                </a:tc>
+              </a:tr>
+            </a:tbl>
+          </a:graphicData>
+        </a:graphic>
+      </p:graphicFrame>
+      <p:sp>
+        <p:nvSpPr>
+          <p:cNvPr id="6" name="Rounded Rectangle 5"/>
+          <p:cNvSpPr/>
+          <p:nvPr/>
+        </p:nvSpPr>
+        <p:spPr>
+          <a:xfrm>
+            <a:off x="502920" y="7726679"/>
+            <a:ext cx="17556480" cy="1828800"/>
+          </a:xfrm>
+          <a:prstGeom prst="roundRect">
+            <a:avLst>
+              <a:gd name="adj" fmla="val 8000"/>
+            </a:avLst>
+          </a:prstGeom>
+          <a:solidFill>
+            <a:srgbClr val="E2F0D9"/>
+          </a:solidFill>
+          <a:ln w="22225">
+            <a:solidFill>
+              <a:srgbClr val="00B050"/>
+            </a:solidFill>
+          </a:ln>
+          <a:effectLst/>
+        </p:spPr>
+        <p:style>
+          <a:lnRef idx="1">
+            <a:schemeClr val="accent1"/>
+          </a:lnRef>
+          <a:fillRef idx="3">
+            <a:schemeClr val="accent1"/>
+          </a:fillRef>
+          <a:effectRef idx="2">
+            <a:schemeClr val="accent1"/>
+          </a:effectRef>
+          <a:fontRef idx="minor">
+            <a:schemeClr val="lt1"/>
+          </a:fontRef>
+        </p:style>
+        <p:txBody>
+          <a:bodyPr rtlCol="0" anchor="ctr" wrap="square" lIns="228600" rIns="228600" tIns="109728" bIns="91440"/>
+          <a:lstStyle/>
+          <a:p>
+            <a:pPr algn="ctr"/>
+            <a:r>
+              <a:rPr sz="1500" b="1">
+                <a:solidFill>
+                  <a:srgbClr val="008A3E"/>
+                </a:solidFill>
+                <a:latin typeface="Arial"/>
+              </a:rPr>
+              <a:t>Recommendation: Option D as the rule, Option B kept as the fallback</a:t>
+            </a:r>
+          </a:p>
+          <a:p>
+            <a:r>
+              <a:rPr sz="1150">
+                <a:solidFill>
+                  <a:srgbClr val="111111"/>
+                </a:solidFill>
+                <a:latin typeface="Arial"/>
+              </a:rPr>
+              <a:t>CPI does the work once — detect, read, filter, deliver — and every field system just receives its own data through an interface it already has. Where a system cannot receive, it falls back to Option B's query, and Option E remains a per-system variant that can be adopted later by swapping only the delivery plumbing. Effort is roughly the same overall as Option B, but it lands in one team and one toolset instead of inside every field system — and an acquired company's system can be connected without modifying it.</a:t>
+            </a:r>
+          </a:p>
+        </p:txBody>
+      </p:sp>
+    </p:spTree>
+  </p:cSld>
+  <p:clrMapOvr>
+    <a:masterClrMapping/>
+  </p:clrMapOvr>
+</p:sld>
+</file>
+
+<file path=ppt/slides/slide23.xml><?xml version="1.0" encoding="utf-8"?>
+<p:sld xmlns:a="http://schemas.openxmlformats.org/drawingml/2006/main" xmlns:p="http://schemas.openxmlformats.org/presentationml/2006/main" xmlns:r="http://schemas.openxmlformats.org/officeDocument/2006/relationships">
+  <p:cSld>
+    <p:spTree>
+      <p:nvGrpSpPr>
+        <p:cNvPr id="1" name=""/>
+        <p:cNvGrpSpPr/>
+        <p:nvPr/>
+      </p:nvGrpSpPr>
+      <p:grpSpPr/>
+      <p:pic>
+        <p:nvPicPr>
+          <p:cNvPr id="2" name="Picture 1" descr="image.png"/>
+          <p:cNvPicPr>
+            <a:picLocks noChangeAspect="1"/>
+          </p:cNvPicPr>
+          <p:nvPr/>
+        </p:nvPicPr>
+        <p:blipFill>
+          <a:blip r:embed="rId2"/>
+          <a:stretch>
+            <a:fillRect/>
+          </a:stretch>
+        </p:blipFill>
+        <p:spPr>
+          <a:xfrm>
+            <a:off x="16188779" y="476250"/>
+            <a:ext cx="1337221" cy="419075"/>
+          </a:xfrm>
+          <a:prstGeom prst="rect">
+            <a:avLst/>
+          </a:prstGeom>
+        </p:spPr>
+      </p:pic>
+      <p:sp>
+        <p:nvSpPr>
+          <p:cNvPr id="3" name="TextBox 2"/>
+          <p:cNvSpPr txBox="1"/>
+          <p:nvPr/>
+        </p:nvSpPr>
+        <p:spPr>
+          <a:xfrm>
+            <a:off x="640080" y="320040"/>
+            <a:ext cx="16459200" cy="548640"/>
+          </a:xfrm>
+          <a:prstGeom prst="rect">
+            <a:avLst/>
+          </a:prstGeom>
+          <a:noFill/>
+        </p:spPr>
+        <p:txBody>
+          <a:bodyPr wrap="square" lIns="0" rIns="0" tIns="0" bIns="0">
+            <a:spAutoFit/>
+          </a:bodyPr>
+          <a:lstStyle/>
+          <a:p>
+            <a:r>
+              <a:rPr sz="2200" b="1">
+                <a:solidFill>
+                  <a:srgbClr val="1F3864"/>
+                </a:solidFill>
+                <a:latin typeface="Arial"/>
+              </a:rPr>
+              <a:t>Options (Complete) – New Database, CPI Pull Interface, Business Data Cloud, or CPI Delivery</a:t>
+            </a:r>
+          </a:p>
+        </p:txBody>
+      </p:sp>
+      <p:sp>
+        <p:nvSpPr>
+          <p:cNvPr id="4" name="TextBox 3"/>
+          <p:cNvSpPr txBox="1"/>
+          <p:nvPr/>
+        </p:nvSpPr>
+        <p:spPr>
+          <a:xfrm>
+            <a:off x="640080" y="868680"/>
+            <a:ext cx="16642080" cy="365760"/>
+          </a:xfrm>
+          <a:prstGeom prst="rect">
+            <a:avLst/>
+          </a:prstGeom>
+          <a:noFill/>
+        </p:spPr>
+        <p:txBody>
+          <a:bodyPr wrap="square" lIns="0" rIns="0" tIns="0" bIns="0">
+            <a:spAutoFit/>
+          </a:bodyPr>
+          <a:lstStyle/>
+          <a:p>
+            <a:r>
+              <a:rPr sz="1150">
+                <a:solidFill>
+                  <a:srgbClr val="595959"/>
+                </a:solidFill>
+                <a:latin typeface="Arial"/>
+              </a:rPr>
+              <a:t>The same three options as before, plus Option D: keeping everything decided for Option B and adding delivery on top, so field systems receive their data instead of each building its own fetching.</a:t>
+            </a:r>
+          </a:p>
+        </p:txBody>
+      </p:sp>
+      <p:graphicFrame>
+        <p:nvGraphicFramePr>
+          <p:cNvPr id="5" name="Table 4"/>
+          <p:cNvGraphicFramePr>
+            <a:graphicFrameLocks noGrp="1"/>
+          </p:cNvGraphicFramePr>
+          <p:nvPr/>
+        </p:nvGraphicFramePr>
+        <p:xfrm>
+          <a:off x="502920" y="1371600"/>
+          <a:ext cx="17556480" cy="5394960"/>
+        </p:xfrm>
+        <a:graphic>
+          <a:graphicData uri="http://schemas.openxmlformats.org/drawingml/2006/table">
+            <a:tbl>
+              <a:tblPr firstRow="1" bandRow="1">
+                <a:tableStyleId>{5C22544A-7EE6-4342-B048-85BDC9FD1C3A}</a:tableStyleId>
+              </a:tblPr>
+              <a:tblGrid>
+                <a:gridCol w="2926080"/>
+                <a:gridCol w="3383280"/>
+                <a:gridCol w="3017520"/>
+                <a:gridCol w="2560320"/>
+                <a:gridCol w="2743200"/>
+                <a:gridCol w="2926080"/>
+              </a:tblGrid>
+              <a:tr h="347472">
+                <a:tc>
+                  <a:txBody>
+                    <a:bodyPr wrap="square"/>
+                    <a:lstStyle/>
+                    <a:p>
+                      <a:r>
+                        <a:rPr sz="1200" b="1">
+                          <a:solidFill>
+                            <a:srgbClr val="111111"/>
+                          </a:solidFill>
+                          <a:latin typeface="Arial"/>
+                        </a:rPr>
+                        <a:t>Option</a:t>
+                      </a:r>
+                    </a:p>
+                  </a:txBody>
+                  <a:tcPr marL="73152" marR="73152" marT="45720" marB="45720">
+                    <a:solidFill>
+                      <a:srgbClr val="92D050"/>
+                    </a:solidFill>
+                  </a:tcPr>
+                </a:tc>
+                <a:tc>
+                  <a:txBody>
+                    <a:bodyPr wrap="square"/>
+                    <a:lstStyle/>
+                    <a:p>
+                      <a:r>
+                        <a:rPr sz="1200" b="1">
+                          <a:solidFill>
+                            <a:srgbClr val="111111"/>
+                          </a:solidFill>
+                          <a:latin typeface="Arial"/>
+                        </a:rPr>
+                        <a:t>Approach</a:t>
+                      </a:r>
+                    </a:p>
+                  </a:txBody>
+                  <a:tcPr marL="73152" marR="73152" marT="45720" marB="45720">
+                    <a:solidFill>
+                      <a:srgbClr val="92D050"/>
+                    </a:solidFill>
+                  </a:tcPr>
+                </a:tc>
+                <a:tc>
+                  <a:txBody>
+                    <a:bodyPr wrap="square"/>
+                    <a:lstStyle/>
+                    <a:p>
+                      <a:r>
+                        <a:rPr sz="1200" b="1">
+                          <a:solidFill>
+                            <a:srgbClr val="111111"/>
+                          </a:solidFill>
+                          <a:latin typeface="Arial"/>
+                        </a:rPr>
+                        <a:t>Build Cost &amp; Duration</a:t>
+                      </a:r>
+                    </a:p>
+                  </a:txBody>
+                  <a:tcPr marL="73152" marR="73152" marT="45720" marB="45720">
+                    <a:solidFill>
+                      <a:srgbClr val="92D050"/>
+                    </a:solidFill>
+                  </a:tcPr>
+                </a:tc>
+                <a:tc>
+                  <a:txBody>
+                    <a:bodyPr wrap="square"/>
+                    <a:lstStyle/>
+                    <a:p>
+                      <a:r>
+                        <a:rPr sz="1200" b="1">
+                          <a:solidFill>
+                            <a:srgbClr val="111111"/>
+                          </a:solidFill>
+                          <a:latin typeface="Arial"/>
+                        </a:rPr>
+                        <a:t>Ongoing Cost</a:t>
+                      </a:r>
+                    </a:p>
+                  </a:txBody>
+                  <a:tcPr marL="73152" marR="73152" marT="45720" marB="45720">
+                    <a:solidFill>
+                      <a:srgbClr val="92D050"/>
+                    </a:solidFill>
+                  </a:tcPr>
+                </a:tc>
+                <a:tc>
+                  <a:txBody>
+                    <a:bodyPr wrap="square"/>
+                    <a:lstStyle/>
+                    <a:p>
+                      <a:r>
+                        <a:rPr sz="1200" b="1">
+                          <a:solidFill>
+                            <a:srgbClr val="111111"/>
+                          </a:solidFill>
+                          <a:latin typeface="Arial"/>
+                        </a:rPr>
+                        <a:t>Ongoing Benefit</a:t>
+                      </a:r>
+                    </a:p>
+                  </a:txBody>
+                  <a:tcPr marL="73152" marR="73152" marT="45720" marB="45720">
+                    <a:solidFill>
+                      <a:srgbClr val="92D050"/>
+                    </a:solidFill>
+                  </a:tcPr>
+                </a:tc>
+                <a:tc>
+                  <a:txBody>
+                    <a:bodyPr wrap="square"/>
+                    <a:lstStyle/>
+                    <a:p>
+                      <a:r>
+                        <a:rPr sz="1200" b="1">
+                          <a:solidFill>
+                            <a:srgbClr val="111111"/>
+                          </a:solidFill>
+                          <a:latin typeface="Arial"/>
+                        </a:rPr>
+                        <a:t>Key Risks</a:t>
+                      </a:r>
+                    </a:p>
+                  </a:txBody>
+                  <a:tcPr marL="73152" marR="73152" marT="45720" marB="45720">
+                    <a:solidFill>
+                      <a:srgbClr val="92D050"/>
+                    </a:solidFill>
+                  </a:tcPr>
+                </a:tc>
+              </a:tr>
+              <a:tr h="1261872">
+                <a:tc>
+                  <a:txBody>
+                    <a:bodyPr wrap="square"/>
+                    <a:lstStyle/>
+                    <a:p>
+                      <a:r>
+                        <a:rPr sz="1100" b="1">
+                          <a:solidFill>
+                            <a:srgbClr val="111111"/>
+                          </a:solidFill>
+                          <a:latin typeface="Arial"/>
+                        </a:rPr>
+                        <a:t>A – New database that JAMS queries</a:t>
+                      </a:r>
+                    </a:p>
+                    <a:p>
+                      <a:r>
+                        <a:rPr sz="1050" b="1" i="1">
+                          <a:solidFill>
+                            <a:srgbClr val="C00000"/>
+                          </a:solidFill>
+                          <a:latin typeface="Arial"/>
+                        </a:rPr>
+                        <a:t>(JDW Replacement)</a:t>
+                      </a:r>
+                    </a:p>
+                  </a:txBody>
+                  <a:tcPr marL="73152" marR="73152" marT="45720" marB="45720">
+                    <a:solidFill>
+                      <a:srgbClr val="FFFFFF"/>
+                    </a:solidFill>
+                  </a:tcPr>
+                </a:tc>
+                <a:tc>
+                  <a:txBody>
+                    <a:bodyPr wrap="square"/>
+                    <a:lstStyle/>
+                    <a:p>
+                      <a:r>
+                        <a:rPr sz="950">
+                          <a:solidFill>
+                            <a:srgbClr val="111111"/>
+                          </a:solidFill>
+                          <a:latin typeface="Arial"/>
+                        </a:rPr>
+                        <a:t>S/4 replicates data into a separate database mirroring the Jobpac data warehouse; JAMS keeps its SQL queries.</a:t>
+                      </a:r>
+                    </a:p>
+                  </a:txBody>
+                  <a:tcPr marL="73152" marR="73152" marT="45720" marB="45720">
+                    <a:solidFill>
+                      <a:srgbClr val="FFFFFF"/>
+                    </a:solidFill>
+                  </a:tcPr>
+                </a:tc>
+                <a:tc>
+                  <a:txBody>
+                    <a:bodyPr wrap="square"/>
+                    <a:lstStyle/>
+                    <a:p>
+                      <a:r>
+                        <a:rPr sz="950">
+                          <a:solidFill>
+                            <a:srgbClr val="111111"/>
+                          </a:solidFill>
+                          <a:latin typeface="Arial"/>
+                        </a:rPr>
+                        <a:t>Lower impact on JAMS, higher effort for Apollo: new database, replication, monitoring, deployment across DEV/TEST/PROD.</a:t>
+                      </a:r>
+                    </a:p>
+                  </a:txBody>
+                  <a:tcPr marL="73152" marR="73152" marT="45720" marB="45720">
+                    <a:solidFill>
+                      <a:srgbClr val="FFFFFF"/>
+                    </a:solidFill>
+                  </a:tcPr>
+                </a:tc>
+                <a:tc>
+                  <a:txBody>
+                    <a:bodyPr wrap="square"/>
+                    <a:lstStyle/>
+                    <a:p>
+                      <a:r>
+                        <a:rPr sz="950">
+                          <a:solidFill>
+                            <a:srgbClr val="111111"/>
+                          </a:solidFill>
+                          <a:latin typeface="Arial"/>
+                        </a:rPr>
+                        <a:t>High. Infrastructure, database licensing, security, backups, operational support.</a:t>
+                      </a:r>
+                    </a:p>
+                  </a:txBody>
+                  <a:tcPr marL="73152" marR="73152" marT="45720" marB="45720">
+                    <a:solidFill>
+                      <a:srgbClr val="FFFFFF"/>
+                    </a:solidFill>
+                  </a:tcPr>
+                </a:tc>
+                <a:tc>
+                  <a:txBody>
+                    <a:bodyPr wrap="square"/>
+                    <a:lstStyle/>
+                    <a:p>
+                      <a:r>
+                        <a:rPr sz="950">
+                          <a:solidFill>
+                            <a:srgbClr val="111111"/>
+                          </a:solidFill>
+                          <a:latin typeface="Arial"/>
+                        </a:rPr>
+                        <a:t>Familiar to the JAMS team; no new skill needed.</a:t>
+                      </a:r>
+                    </a:p>
+                  </a:txBody>
+                  <a:tcPr marL="73152" marR="73152" marT="45720" marB="45720">
+                    <a:solidFill>
+                      <a:srgbClr val="FFFFFF"/>
+                    </a:solidFill>
+                  </a:tcPr>
+                </a:tc>
+                <a:tc>
+                  <a:txBody>
+                    <a:bodyPr wrap="square"/>
+                    <a:lstStyle/>
+                    <a:p>
+                      <a:r>
+                        <a:rPr sz="950">
+                          <a:solidFill>
+                            <a:srgbClr val="111111"/>
+                          </a:solidFill>
+                          <a:latin typeface="Arial"/>
+                        </a:rPr>
+                        <a:t>Recreates the store being decommissioned. Apollo owns a second copy of ERP data permanently.</a:t>
+                      </a:r>
+                    </a:p>
+                  </a:txBody>
+                  <a:tcPr marL="73152" marR="73152" marT="45720" marB="45720">
+                    <a:solidFill>
+                      <a:srgbClr val="FFFFFF"/>
+                    </a:solidFill>
+                  </a:tcPr>
+                </a:tc>
+              </a:tr>
+              <a:tr h="1261872">
+                <a:tc>
+                  <a:txBody>
+                    <a:bodyPr wrap="square"/>
+                    <a:lstStyle/>
+                    <a:p>
+                      <a:r>
+                        <a:rPr sz="1100" b="1">
+                          <a:solidFill>
+                            <a:srgbClr val="111111"/>
+                          </a:solidFill>
+                          <a:latin typeface="Arial"/>
+                        </a:rPr>
+                        <a:t>B – JAMS calls a published query on CPI</a:t>
+                      </a:r>
+                    </a:p>
+                    <a:p>
+                      <a:r>
+                        <a:rPr sz="1050" b="1" i="1">
+                          <a:solidFill>
+                            <a:srgbClr val="1F3864"/>
+                          </a:solidFill>
+                          <a:latin typeface="Arial"/>
+                        </a:rPr>
+                        <a:t>(Decided – kept as the fallback)</a:t>
+                      </a:r>
+                    </a:p>
+                  </a:txBody>
+                  <a:tcPr marL="73152" marR="73152" marT="45720" marB="45720">
+                    <a:solidFill>
+                      <a:srgbClr val="FFFFFF"/>
+                    </a:solidFill>
+                  </a:tcPr>
+                </a:tc>
+                <a:tc>
+                  <a:txBody>
+                    <a:bodyPr wrap="square"/>
+                    <a:lstStyle/>
+                    <a:p>
+                      <a:r>
+                        <a:rPr sz="950">
+                          <a:solidFill>
+                            <a:srgbClr val="111111"/>
+                          </a:solidFill>
+                          <a:latin typeface="Arial"/>
+                        </a:rPr>
+                        <a:t>CPI publishes one query per system; each field system fetches on its own schedule with its own filters.</a:t>
+                      </a:r>
+                    </a:p>
+                  </a:txBody>
+                  <a:tcPr marL="73152" marR="73152" marT="45720" marB="45720">
+                    <a:solidFill>
+                      <a:srgbClr val="FFFFFF"/>
+                    </a:solidFill>
+                  </a:tcPr>
+                </a:tc>
+                <a:tc>
+                  <a:txBody>
+                    <a:bodyPr wrap="square"/>
+                    <a:lstStyle/>
+                    <a:p>
+                      <a:r>
+                        <a:rPr sz="950">
+                          <a:solidFill>
+                            <a:srgbClr val="111111"/>
+                          </a:solidFill>
+                          <a:latin typeface="Arial"/>
+                        </a:rPr>
+                        <a:t>Medium. Build mostly in CPI — but every field system also builds scheduling, fetching and filtering, in its own toolset.</a:t>
+                      </a:r>
+                    </a:p>
+                  </a:txBody>
+                  <a:tcPr marL="73152" marR="73152" marT="45720" marB="45720">
+                    <a:solidFill>
+                      <a:srgbClr val="FFFFFF"/>
+                    </a:solidFill>
+                  </a:tcPr>
+                </a:tc>
+                <a:tc>
+                  <a:txBody>
+                    <a:bodyPr wrap="square"/>
+                    <a:lstStyle/>
+                    <a:p>
+                      <a:r>
+                        <a:rPr sz="950">
+                          <a:solidFill>
+                            <a:srgbClr val="111111"/>
+                          </a:solidFill>
+                          <a:latin typeface="Arial"/>
+                        </a:rPr>
+                        <a:t>Medium. Each system runs and supports its own fetching; skills spread across every vendor.</a:t>
+                      </a:r>
+                    </a:p>
+                  </a:txBody>
+                  <a:tcPr marL="73152" marR="73152" marT="45720" marB="45720">
+                    <a:solidFill>
+                      <a:srgbClr val="FFFFFF"/>
+                    </a:solidFill>
+                  </a:tcPr>
+                </a:tc>
+                <a:tc>
+                  <a:txBody>
+                    <a:bodyPr wrap="square"/>
+                    <a:lstStyle/>
+                    <a:p>
+                      <a:r>
+                        <a:rPr sz="950">
+                          <a:solidFill>
+                            <a:srgbClr val="111111"/>
+                          </a:solidFill>
+                          <a:latin typeface="Arial"/>
+                        </a:rPr>
+                        <a:t>Single source of truth in S/4. No replicated database. Reusable APIs for all field systems.</a:t>
+                      </a:r>
+                    </a:p>
+                  </a:txBody>
+                  <a:tcPr marL="73152" marR="73152" marT="45720" marB="45720">
+                    <a:solidFill>
+                      <a:srgbClr val="FFFFFF"/>
+                    </a:solidFill>
+                  </a:tcPr>
+                </a:tc>
+                <a:tc>
+                  <a:txBody>
+                    <a:bodyPr wrap="square"/>
+                    <a:lstStyle/>
+                    <a:p>
+                      <a:r>
+                        <a:rPr sz="950">
+                          <a:solidFill>
+                            <a:srgbClr val="111111"/>
+                          </a:solidFill>
+                          <a:latin typeface="Arial"/>
+                        </a:rPr>
+                        <a:t>Orchestration duplicated in every system. An acquired company’s system must be modified before it can see its own data. Filtering must be trusted and audited per system — including Defence.</a:t>
+                      </a:r>
+                    </a:p>
+                  </a:txBody>
+                  <a:tcPr marL="73152" marR="73152" marT="45720" marB="45720">
+                    <a:solidFill>
+                      <a:srgbClr val="FFFFFF"/>
+                    </a:solidFill>
+                  </a:tcPr>
+                </a:tc>
+              </a:tr>
+              <a:tr h="1261872">
+                <a:tc>
+                  <a:txBody>
+                    <a:bodyPr wrap="square"/>
+                    <a:lstStyle/>
+                    <a:p>
+                      <a:r>
+                        <a:rPr sz="1100" b="1">
+                          <a:solidFill>
+                            <a:srgbClr val="111111"/>
+                          </a:solidFill>
+                          <a:latin typeface="Arial"/>
+                        </a:rPr>
+                        <a:t>C – SAP Business Data Cloud feeds a new database</a:t>
+                      </a:r>
+                    </a:p>
+                    <a:p>
+                      <a:r>
+                        <a:rPr sz="1050" b="1" i="1">
+                          <a:solidFill>
+                            <a:srgbClr val="595959"/>
+                          </a:solidFill>
+                          <a:latin typeface="Arial"/>
+                        </a:rPr>
+                        <a:t>(Noted, not in scope)</a:t>
+                      </a:r>
+                    </a:p>
+                  </a:txBody>
+                  <a:tcPr marL="73152" marR="73152" marT="45720" marB="45720">
+                    <a:solidFill>
+                      <a:srgbClr val="FFFFFF"/>
+                    </a:solidFill>
+                  </a:tcPr>
+                </a:tc>
+                <a:tc>
+                  <a:txBody>
+                    <a:bodyPr wrap="square"/>
+                    <a:lstStyle/>
+                    <a:p>
+                      <a:r>
+                        <a:rPr sz="950">
+                          <a:solidFill>
+                            <a:srgbClr val="111111"/>
+                          </a:solidFill>
+                          <a:latin typeface="Arial"/>
+                        </a:rPr>
+                        <a:t>S/4 data published as SAP data products via Business Data Cloud and Datasphere, landed in a store JAMS queries.</a:t>
+                      </a:r>
+                    </a:p>
+                  </a:txBody>
+                  <a:tcPr marL="73152" marR="73152" marT="45720" marB="45720">
+                    <a:solidFill>
+                      <a:srgbClr val="FFFFFF"/>
+                    </a:solidFill>
+                  </a:tcPr>
+                </a:tc>
+                <a:tc>
+                  <a:txBody>
+                    <a:bodyPr wrap="square"/>
+                    <a:lstStyle/>
+                    <a:p>
+                      <a:r>
+                        <a:rPr sz="950">
+                          <a:solidFill>
+                            <a:srgbClr val="111111"/>
+                          </a:solidFill>
+                          <a:latin typeface="Arial"/>
+                        </a:rPr>
+                        <a:t>Low for JAMS, high for Service Stream: separately licensed product outside Apollo scope, needing its own funding and delivery.</a:t>
+                      </a:r>
+                    </a:p>
+                  </a:txBody>
+                  <a:tcPr marL="73152" marR="73152" marT="45720" marB="45720">
+                    <a:solidFill>
+                      <a:srgbClr val="FFFFFF"/>
+                    </a:solidFill>
+                  </a:tcPr>
+                </a:tc>
+                <a:tc>
+                  <a:txBody>
+                    <a:bodyPr wrap="square"/>
+                    <a:lstStyle/>
+                    <a:p>
+                      <a:r>
+                        <a:rPr sz="950">
+                          <a:solidFill>
+                            <a:srgbClr val="111111"/>
+                          </a:solidFill>
+                          <a:latin typeface="Arial"/>
+                        </a:rPr>
+                        <a:t>High. Product subscription plus a data store and its content to run and reconcile.</a:t>
+                      </a:r>
+                    </a:p>
+                  </a:txBody>
+                  <a:tcPr marL="73152" marR="73152" marT="45720" marB="45720">
+                    <a:solidFill>
+                      <a:srgbClr val="FFFFFF"/>
+                    </a:solidFill>
+                  </a:tcPr>
+                </a:tc>
+                <a:tc>
+                  <a:txBody>
+                    <a:bodyPr wrap="square"/>
+                    <a:lstStyle/>
+                    <a:p>
+                      <a:r>
+                        <a:rPr sz="950">
+                          <a:solidFill>
+                            <a:srgbClr val="111111"/>
+                          </a:solidFill>
+                          <a:latin typeface="Arial"/>
+                        </a:rPr>
+                        <a:t>Standard SAP tooling; the same data products could support future reporting.</a:t>
+                      </a:r>
+                    </a:p>
+                  </a:txBody>
+                  <a:tcPr marL="73152" marR="73152" marT="45720" marB="45720">
+                    <a:solidFill>
+                      <a:srgbClr val="FFFFFF"/>
+                    </a:solidFill>
+                  </a:tcPr>
+                </a:tc>
+                <a:tc>
+                  <a:txBody>
+                    <a:bodyPr wrap="square"/>
+                    <a:lstStyle/>
+                    <a:p>
+                      <a:r>
+                        <a:rPr sz="950">
+                          <a:solidFill>
+                            <a:srgbClr val="111111"/>
+                          </a:solidFill>
+                          <a:latin typeface="Arial"/>
+                        </a:rPr>
+                        <a:t>Scheduled refresh, not live — may not suit operational checks. Out of scope: delivery and go-live risk.</a:t>
+                      </a:r>
+                    </a:p>
+                  </a:txBody>
+                  <a:tcPr marL="73152" marR="73152" marT="45720" marB="45720">
+                    <a:solidFill>
+                      <a:srgbClr val="FFFFFF"/>
+                    </a:solidFill>
+                  </a:tcPr>
+                </a:tc>
+              </a:tr>
+              <a:tr h="1261872">
+                <a:tc>
+                  <a:txBody>
+                    <a:bodyPr wrap="square"/>
+                    <a:lstStyle/>
+                    <a:p>
+                      <a:r>
+                        <a:rPr sz="1100" b="1">
+                          <a:solidFill>
+                            <a:srgbClr val="111111"/>
+                          </a:solidFill>
+                          <a:latin typeface="Arial"/>
+                        </a:rPr>
+                        <a:t>D – CPI delivers each system’s data to it</a:t>
+                      </a:r>
+                    </a:p>
+                    <a:p>
+                      <a:r>
+                        <a:rPr sz="1050" b="1" i="1">
+                          <a:solidFill>
+                            <a:srgbClr val="008A3E"/>
+                          </a:solidFill>
+                          <a:latin typeface="Arial"/>
+                        </a:rPr>
+                        <a:t>(Proposed – Recommended)</a:t>
+                      </a:r>
+                    </a:p>
+                  </a:txBody>
+                  <a:tcPr marL="73152" marR="73152" marT="45720" marB="45720">
+                    <a:solidFill>
+                      <a:srgbClr val="FFFFFF"/>
+                    </a:solidFill>
+                  </a:tcPr>
+                </a:tc>
+                <a:tc>
+                  <a:txBody>
+                    <a:bodyPr wrap="square"/>
+                    <a:lstStyle/>
+                    <a:p>
+                      <a:r>
+                        <a:rPr sz="950">
+                          <a:solidFill>
+                            <a:srgbClr val="111111"/>
+                          </a:solidFill>
+                          <a:latin typeface="Arial"/>
+                        </a:rPr>
+                        <a:t>CPI detects each change once, reads the full record, filters via a central subscription list, and delivers it the way each system accepts (web service call or file). Option B’s query stays as the fallback.</a:t>
+                      </a:r>
+                    </a:p>
+                  </a:txBody>
+                  <a:tcPr marL="73152" marR="73152" marT="45720" marB="45720">
+                    <a:solidFill>
+                      <a:srgbClr val="FFFFFF"/>
+                    </a:solidFill>
+                  </a:tcPr>
+                </a:tc>
+                <a:tc>
+                  <a:txBody>
+                    <a:bodyPr wrap="square"/>
+                    <a:lstStyle/>
+                    <a:p>
+                      <a:r>
+                        <a:rPr sz="950">
+                          <a:solidFill>
+                            <a:srgbClr val="111111"/>
+                          </a:solidFill>
+                          <a:latin typeface="Arial"/>
+                        </a:rPr>
+                        <a:t>Medium. All development in CPI from standard delivered parts. S/4: configuration only. Field systems: configuration only, except six small JAMS receiving services.</a:t>
+                      </a:r>
+                    </a:p>
+                  </a:txBody>
+                  <a:tcPr marL="73152" marR="73152" marT="45720" marB="45720">
+                    <a:solidFill>
+                      <a:srgbClr val="FFFFFF"/>
+                    </a:solidFill>
+                  </a:tcPr>
+                </a:tc>
+                <a:tc>
+                  <a:txBody>
+                    <a:bodyPr wrap="square"/>
+                    <a:lstStyle/>
+                    <a:p>
+                      <a:r>
+                        <a:rPr sz="950">
+                          <a:solidFill>
+                            <a:srgbClr val="111111"/>
+                          </a:solidFill>
+                          <a:latin typeface="Arial"/>
+                        </a:rPr>
+                        <a:t>Medium. One team, one toolset, one monitoring view. Nothing new to buy — all inside licences already held.</a:t>
+                      </a:r>
+                    </a:p>
+                  </a:txBody>
+                  <a:tcPr marL="73152" marR="73152" marT="45720" marB="45720">
+                    <a:solidFill>
+                      <a:srgbClr val="FFFFFF"/>
+                    </a:solidFill>
+                  </a:tcPr>
+                </a:tc>
+                <a:tc>
+                  <a:txBody>
+                    <a:bodyPr wrap="square"/>
+                    <a:lstStyle/>
+                    <a:p>
+                      <a:r>
+                        <a:rPr sz="950">
+                          <a:solidFill>
+                            <a:srgbClr val="111111"/>
+                          </a:solidFill>
+                          <a:latin typeface="Arial"/>
+                        </a:rPr>
+                        <a:t>Field systems stop building orchestration. Defence separation enforced centrally, auditably. New or acquired system = configuration + one converter. Data arrives as it changes.</a:t>
+                      </a:r>
+                    </a:p>
+                  </a:txBody>
+                  <a:tcPr marL="73152" marR="73152" marT="45720" marB="45720">
+                    <a:solidFill>
+                      <a:srgbClr val="FFFFFF"/>
+                    </a:solidFill>
+                  </a:tcPr>
+                </a:tc>
+                <a:tc>
+                  <a:txBody>
+                    <a:bodyPr wrap="square"/>
+                    <a:lstStyle/>
+                    <a:p>
+                      <a:r>
+                        <a:rPr sz="950">
+                          <a:solidFill>
+                            <a:srgbClr val="111111"/>
+                          </a:solidFill>
+                          <a:latin typeface="Arial"/>
+                        </a:rPr>
+                        <a:t>CPI becomes an operational platform — queues, alerts, run book. Message volumes metered under the existing licence. Message-format version discipline needed.</a:t>
+                      </a:r>
+                    </a:p>
+                  </a:txBody>
+                  <a:tcPr marL="73152" marR="73152" marT="45720" marB="45720">
+                    <a:solidFill>
+                      <a:srgbClr val="FFFFFF"/>
+                    </a:solidFill>
+                  </a:tcPr>
+                </a:tc>
+              </a:tr>
+            </a:tbl>
+          </a:graphicData>
+        </a:graphic>
+      </p:graphicFrame>
+      <p:sp>
+        <p:nvSpPr>
+          <p:cNvPr id="6" name="Rounded Rectangle 5"/>
+          <p:cNvSpPr/>
+          <p:nvPr/>
+        </p:nvSpPr>
+        <p:spPr>
+          <a:xfrm>
+            <a:off x="502920" y="7909560"/>
+            <a:ext cx="17556480" cy="1691640"/>
+          </a:xfrm>
+          <a:prstGeom prst="roundRect">
+            <a:avLst>
+              <a:gd name="adj" fmla="val 8000"/>
+            </a:avLst>
+          </a:prstGeom>
+          <a:solidFill>
+            <a:srgbClr val="E2F0D9"/>
+          </a:solidFill>
+          <a:ln w="22225">
+            <a:solidFill>
+              <a:srgbClr val="00B050"/>
+            </a:solidFill>
+          </a:ln>
+          <a:effectLst/>
+        </p:spPr>
+        <p:style>
+          <a:lnRef idx="1">
+            <a:schemeClr val="accent1"/>
+          </a:lnRef>
+          <a:fillRef idx="3">
+            <a:schemeClr val="accent1"/>
+          </a:fillRef>
+          <a:effectRef idx="2">
+            <a:schemeClr val="accent1"/>
+          </a:effectRef>
+          <a:fontRef idx="minor">
+            <a:schemeClr val="lt1"/>
+          </a:fontRef>
+        </p:style>
+        <p:txBody>
+          <a:bodyPr rtlCol="0" anchor="ctr" wrap="square" lIns="228600" rIns="228600" tIns="109728" bIns="91440"/>
+          <a:lstStyle/>
+          <a:p>
+            <a:pPr algn="ctr"/>
+            <a:r>
+              <a:rPr sz="1500" b="1">
+                <a:solidFill>
+                  <a:srgbClr val="008A3E"/>
+                </a:solidFill>
+                <a:latin typeface="Arial"/>
+              </a:rPr>
+              <a:t>Recommendation: Option D as the rule, built on Option B</a:t>
+            </a:r>
+          </a:p>
+          <a:p>
+            <a:r>
+              <a:rPr sz="1150">
+                <a:solidFill>
+                  <a:srgbClr val="111111"/>
+                </a:solidFill>
+                <a:latin typeface="Arial"/>
+              </a:rPr>
+              <a:t>CPI does the work once — detect, read, filter, deliver — and every field system receives its own data through an interface it already has. Option B’s published query remains the fallback for any system that cannot receive. No new database anywhere; S/4 stays the single source of truth. Overall effort is roughly the same as Option B alone, but it lands in one team and one toolset instead of inside every field system.</a:t>
             </a:r>
           </a:p>
         </p:txBody>

</xml_diff>

<commit_message>
ARB deck: technically complete S/4HANA block on proposal and components slides
The S/4 box now shows its two actual interfaces on both slides:
Business events (Enterprise Event Enablement, active channel
EMIS_COM_0092, listing the event objects) and Released OData APIs
(the existing passthrough set CPI reads full records from). Also
cleans the licences line on the proposal slide and tightens arrow
labels to match (event, or timed check on the APIs).

Co-Authored-By: Claude Fable 5 <noreply@anthropic.com>
Claude-Session: https://claude.ai/code/session_01J9sMjqcGkRLhakCptK95KF
</commit_message>
<xml_diff>
--- a/docs/JAMS-WriteBack-Callback-S4-Key-Design-Decision-2.pptx
+++ b/docs/JAMS-WriteBack-Callback-S4-Key-Design-Decision-2.pptx
@@ -12190,7 +12190,7 @@
         <p:spPr>
           <a:xfrm>
             <a:off x="640080" y="320040"/>
-            <a:ext cx="13716000" cy="548640"/>
+            <a:ext cx="15087600" cy="548640"/>
           </a:xfrm>
           <a:prstGeom prst="rect">
             <a:avLst/>
@@ -12225,7 +12225,7 @@
         <p:spPr>
           <a:xfrm>
             <a:off x="640080" y="868680"/>
-            <a:ext cx="16002000" cy="365760"/>
+            <a:ext cx="16276320" cy="365760"/>
           </a:xfrm>
           <a:prstGeom prst="rect">
             <a:avLst/>
@@ -12259,8 +12259,8 @@
         </p:nvSpPr>
         <p:spPr>
           <a:xfrm>
-            <a:off x="640080" y="3520439"/>
-            <a:ext cx="2468880" cy="1371600"/>
+            <a:off x="502920" y="2606039"/>
+            <a:ext cx="3154680" cy="3063240"/>
           </a:xfrm>
           <a:prstGeom prst="roundRect">
             <a:avLst>
@@ -12292,7 +12292,7 @@
           </a:fontRef>
         </p:style>
         <p:txBody>
-          <a:bodyPr rtlCol="0" anchor="ctr" wrap="square" lIns="73152" rIns="73152" bIns="36576"/>
+          <a:bodyPr rtlCol="0" anchor="t" wrap="square" lIns="73152" rIns="73152" tIns="91440"/>
           <a:lstStyle/>
           <a:p>
             <a:pPr algn="ctr"/>
@@ -12309,13 +12309,13 @@
           <a:p>
             <a:pPr algn="ctr"/>
             <a:r>
-              <a:rPr sz="950" b="0">
+              <a:rPr sz="850">
                 <a:solidFill>
                   <a:srgbClr val="595959"/>
                 </a:solidFill>
                 <a:latin typeface="Arial"/>
               </a:rPr>
-              <a:t>the single source of truth</a:t>
+              <a:t>the single source of truth · configuration only</a:t>
             </a:r>
           </a:p>
         </p:txBody>
@@ -12328,7 +12328,7 @@
         </p:nvSpPr>
         <p:spPr>
           <a:xfrm>
-            <a:off x="777240" y="3392424"/>
+            <a:off x="640080" y="2478023"/>
             <a:ext cx="888796" cy="256032"/>
           </a:xfrm>
           <a:prstGeom prst="roundRect">
@@ -12379,23 +12379,27 @@
       </p:sp>
       <p:sp>
         <p:nvSpPr>
-          <p:cNvPr id="7" name="Right Arrow 6"/>
-          <p:cNvSpPr/>
-          <p:nvPr/>
-        </p:nvSpPr>
-        <p:spPr>
-          <a:xfrm>
-            <a:off x="3291840" y="4151376"/>
-            <a:ext cx="1371600" cy="109728"/>
-          </a:xfrm>
-          <a:prstGeom prst="rightArrow">
-            <a:avLst/>
+          <p:cNvPr id="7" name="Rounded Rectangle 6"/>
+          <p:cNvSpPr/>
+          <p:nvPr/>
+        </p:nvSpPr>
+        <p:spPr>
+          <a:xfrm>
+            <a:off x="667512" y="3383279"/>
+            <a:ext cx="2825496" cy="1115568"/>
+          </a:xfrm>
+          <a:prstGeom prst="roundRect">
+            <a:avLst>
+              <a:gd name="adj" fmla="val 8000"/>
+            </a:avLst>
           </a:prstGeom>
           <a:solidFill>
-            <a:srgbClr val="111111"/>
+            <a:srgbClr val="F4F6F9"/>
           </a:solidFill>
-          <a:ln>
-            <a:noFill/>
+          <a:ln w="12700">
+            <a:solidFill>
+              <a:srgbClr val="111111"/>
+            </a:solidFill>
           </a:ln>
           <a:effectLst/>
         </p:spPr>
@@ -12414,80 +12418,54 @@
           </a:fontRef>
         </p:style>
         <p:txBody>
-          <a:bodyPr rtlCol="0" anchor="ctr"/>
+          <a:bodyPr rtlCol="0" anchor="ctr" wrap="square" lIns="54864" rIns="54864" tIns="36576" bIns="27432"/>
           <a:lstStyle/>
           <a:p>
             <a:pPr algn="ctr"/>
-          </a:p>
-        </p:txBody>
-      </p:sp>
-      <p:sp>
-        <p:nvSpPr>
-          <p:cNvPr id="8" name="TextBox 7"/>
-          <p:cNvSpPr txBox="1"/>
-          <p:nvPr/>
-        </p:nvSpPr>
-        <p:spPr>
-          <a:xfrm>
-            <a:off x="2971800" y="3584448"/>
-            <a:ext cx="2011680" cy="530352"/>
-          </a:xfrm>
-          <a:prstGeom prst="rect">
-            <a:avLst/>
-          </a:prstGeom>
-          <a:noFill/>
-        </p:spPr>
-        <p:txBody>
-          <a:bodyPr wrap="square" lIns="0" rIns="0" tIns="0" bIns="0" anchor="b">
-            <a:spAutoFit/>
-          </a:bodyPr>
-          <a:lstStyle/>
+            <a:r>
+              <a:rPr sz="1050" b="1">
+                <a:solidFill>
+                  <a:srgbClr val="111111"/>
+                </a:solidFill>
+                <a:latin typeface="Arial"/>
+              </a:rPr>
+              <a:t>Business events</a:t>
+            </a:r>
+          </a:p>
           <a:p>
             <a:pPr algn="ctr"/>
             <a:r>
-              <a:rPr sz="950" b="1" i="0">
-                <a:solidFill>
-                  <a:srgbClr val="0F7A3D"/>
+              <a:rPr sz="850">
+                <a:solidFill>
+                  <a:srgbClr val="595959"/>
                 </a:solidFill>
                 <a:latin typeface="Arial"/>
               </a:rPr>
-              <a:t>1 · change detected</a:t>
-            </a:r>
-          </a:p>
-          <a:p>
-            <a:pPr algn="ctr"/>
-            <a:r>
-              <a:rPr sz="950" b="1" i="0">
-                <a:solidFill>
-                  <a:srgbClr val="0F7A3D"/>
-                </a:solidFill>
-                <a:latin typeface="Arial"/>
-              </a:rPr>
-              <a:t>(notice from S/4, or timer)</a:t>
-            </a:r>
-          </a:p>
-        </p:txBody>
-      </p:sp>
-      <p:sp>
-        <p:nvSpPr>
-          <p:cNvPr id="9" name="Rounded Rectangle 8"/>
-          <p:cNvSpPr/>
-          <p:nvPr/>
-        </p:nvSpPr>
-        <p:spPr>
-          <a:xfrm>
-            <a:off x="4846320" y="2103120"/>
-            <a:ext cx="4480560" cy="4297680"/>
+              <a:t>Enterprise Event Enablement · channel EMIS_COM_0092 active · service orders · projects · invoices · POs · goods movements</a:t>
+            </a:r>
+          </a:p>
+        </p:txBody>
+      </p:sp>
+      <p:sp>
+        <p:nvSpPr>
+          <p:cNvPr id="8" name="Rounded Rectangle 7"/>
+          <p:cNvSpPr/>
+          <p:nvPr/>
+        </p:nvSpPr>
+        <p:spPr>
+          <a:xfrm>
+            <a:off x="667512" y="4636008"/>
+            <a:ext cx="2825496" cy="868680"/>
           </a:xfrm>
           <a:prstGeom prst="roundRect">
             <a:avLst>
-              <a:gd name="adj" fmla="val 6000"/>
+              <a:gd name="adj" fmla="val 8000"/>
             </a:avLst>
           </a:prstGeom>
           <a:solidFill>
-            <a:srgbClr val="FFFFFF"/>
+            <a:srgbClr val="F4F6F9"/>
           </a:solidFill>
-          <a:ln w="22225">
+          <a:ln w="12700">
             <a:solidFill>
               <a:srgbClr val="111111"/>
             </a:solidFill>
@@ -12509,36 +12487,53 @@
           </a:fontRef>
         </p:style>
         <p:txBody>
-          <a:bodyPr rtlCol="0" anchor="ctr" wrap="square"/>
+          <a:bodyPr rtlCol="0" anchor="ctr" wrap="square" lIns="54864" rIns="54864" tIns="36576" bIns="27432"/>
           <a:lstStyle/>
           <a:p>
             <a:pPr algn="ctr"/>
-          </a:p>
-        </p:txBody>
-      </p:sp>
-      <p:sp>
-        <p:nvSpPr>
-          <p:cNvPr id="10" name="Rounded Rectangle 9"/>
-          <p:cNvSpPr/>
-          <p:nvPr/>
-        </p:nvSpPr>
-        <p:spPr>
-          <a:xfrm>
-            <a:off x="4983480" y="1975103"/>
-            <a:ext cx="1532534" cy="256032"/>
-          </a:xfrm>
-          <a:prstGeom prst="roundRect">
-            <a:avLst>
-              <a:gd name="adj" fmla="val 6000"/>
-            </a:avLst>
+            <a:r>
+              <a:rPr sz="1050" b="1">
+                <a:solidFill>
+                  <a:srgbClr val="111111"/>
+                </a:solidFill>
+                <a:latin typeface="Arial"/>
+              </a:rPr>
+              <a:t>Released OData APIs</a:t>
+            </a:r>
+          </a:p>
+          <a:p>
+            <a:pPr algn="ctr"/>
+            <a:r>
+              <a:rPr sz="850">
+                <a:solidFill>
+                  <a:srgbClr val="595959"/>
+                </a:solidFill>
+                <a:latin typeface="Arial"/>
+              </a:rPr>
+              <a:t>the existing passthrough set — CPI reads the full record here</a:t>
+            </a:r>
+          </a:p>
+        </p:txBody>
+      </p:sp>
+      <p:sp>
+        <p:nvSpPr>
+          <p:cNvPr id="9" name="Right Arrow 8"/>
+          <p:cNvSpPr/>
+          <p:nvPr/>
+        </p:nvSpPr>
+        <p:spPr>
+          <a:xfrm>
+            <a:off x="3749039" y="4151376"/>
+            <a:ext cx="1005840" cy="109728"/>
+          </a:xfrm>
+          <a:prstGeom prst="rightArrow">
+            <a:avLst/>
           </a:prstGeom>
           <a:solidFill>
             <a:srgbClr val="111111"/>
           </a:solidFill>
-          <a:ln w="9525">
-            <a:solidFill>
-              <a:srgbClr val="111111"/>
-            </a:solidFill>
+          <a:ln>
+            <a:noFill/>
           </a:ln>
           <a:effectLst/>
         </p:spPr>
@@ -12557,32 +12552,23 @@
           </a:fontRef>
         </p:style>
         <p:txBody>
-          <a:bodyPr rtlCol="0" anchor="ctr" wrap="square" lIns="36576" rIns="36576" tIns="0" bIns="0"/>
+          <a:bodyPr rtlCol="0" anchor="ctr"/>
           <a:lstStyle/>
           <a:p>
             <a:pPr algn="ctr"/>
-            <a:r>
-              <a:rPr sz="900" b="1">
-                <a:solidFill>
-                  <a:srgbClr val="FFFFFF"/>
-                </a:solidFill>
-                <a:latin typeface="Arial"/>
-              </a:rPr>
-              <a:t>SAP BTP · SAP CPI</a:t>
-            </a:r>
-          </a:p>
-        </p:txBody>
-      </p:sp>
-      <p:sp>
-        <p:nvSpPr>
-          <p:cNvPr id="11" name="TextBox 10"/>
+          </a:p>
+        </p:txBody>
+      </p:sp>
+      <p:sp>
+        <p:nvSpPr>
+          <p:cNvPr id="10" name="TextBox 9"/>
           <p:cNvSpPr txBox="1"/>
           <p:nvPr/>
         </p:nvSpPr>
         <p:spPr>
           <a:xfrm>
-            <a:off x="4846320" y="2231136"/>
-            <a:ext cx="4480560" cy="365760"/>
+            <a:off x="3429000" y="3584448"/>
+            <a:ext cx="1645920" cy="530352"/>
           </a:xfrm>
           <a:prstGeom prst="rect">
             <a:avLst/>
@@ -12590,34 +12576,58 @@
           <a:noFill/>
         </p:spPr>
         <p:txBody>
-          <a:bodyPr wrap="square" lIns="0" rIns="0" tIns="0" bIns="0" anchor="t">
+          <a:bodyPr wrap="square" lIns="0" rIns="0" tIns="0" bIns="0" anchor="b">
             <a:spAutoFit/>
           </a:bodyPr>
           <a:lstStyle/>
           <a:p>
             <a:pPr algn="ctr"/>
             <a:r>
-              <a:rPr sz="1400" b="1" i="0">
-                <a:solidFill>
-                  <a:srgbClr val="111111"/>
+              <a:rPr sz="900" b="1" i="0">
+                <a:solidFill>
+                  <a:srgbClr val="0F7A3D"/>
                 </a:solidFill>
                 <a:latin typeface="Arial"/>
               </a:rPr>
-              <a:t>Distribution layer</a:t>
-            </a:r>
-          </a:p>
-        </p:txBody>
-      </p:sp>
-      <p:sp>
-        <p:nvSpPr>
-          <p:cNvPr id="12" name="Rounded Rectangle 11"/>
-          <p:cNvSpPr/>
-          <p:nvPr/>
-        </p:nvSpPr>
-        <p:spPr>
-          <a:xfrm>
-            <a:off x="5074920" y="2670048"/>
-            <a:ext cx="4023360" cy="566928"/>
+              <a:t>1 · change detected</a:t>
+            </a:r>
+          </a:p>
+          <a:p>
+            <a:pPr algn="ctr"/>
+            <a:r>
+              <a:rPr sz="900" b="1" i="0">
+                <a:solidFill>
+                  <a:srgbClr val="0F7A3D"/>
+                </a:solidFill>
+                <a:latin typeface="Arial"/>
+              </a:rPr>
+              <a:t>(event, or timed check</a:t>
+            </a:r>
+          </a:p>
+          <a:p>
+            <a:pPr algn="ctr"/>
+            <a:r>
+              <a:rPr sz="900" b="1" i="0">
+                <a:solidFill>
+                  <a:srgbClr val="0F7A3D"/>
+                </a:solidFill>
+                <a:latin typeface="Arial"/>
+              </a:rPr>
+              <a:t>on the APIs)</a:t>
+            </a:r>
+          </a:p>
+        </p:txBody>
+      </p:sp>
+      <p:sp>
+        <p:nvSpPr>
+          <p:cNvPr id="11" name="Rounded Rectangle 10"/>
+          <p:cNvSpPr/>
+          <p:nvPr/>
+        </p:nvSpPr>
+        <p:spPr>
+          <a:xfrm>
+            <a:off x="4846320" y="2103120"/>
+            <a:ext cx="4480560" cy="4297680"/>
           </a:xfrm>
           <a:prstGeom prst="roundRect">
             <a:avLst>
@@ -12625,9 +12635,9 @@
             </a:avLst>
           </a:prstGeom>
           <a:solidFill>
-            <a:srgbClr val="F4F6F9"/>
+            <a:srgbClr val="FFFFFF"/>
           </a:solidFill>
-          <a:ln w="12700">
+          <a:ln w="22225">
             <a:solidFill>
               <a:srgbClr val="111111"/>
             </a:solidFill>
@@ -12649,32 +12659,23 @@
           </a:fontRef>
         </p:style>
         <p:txBody>
-          <a:bodyPr rtlCol="0" anchor="ctr" wrap="square" lIns="54864" rIns="54864" tIns="18288" bIns="18288"/>
+          <a:bodyPr rtlCol="0" anchor="ctr" wrap="square"/>
           <a:lstStyle/>
           <a:p>
             <a:pPr algn="ctr"/>
-            <a:r>
-              <a:rPr sz="1050" b="1">
-                <a:solidFill>
-                  <a:srgbClr val="111111"/>
-                </a:solidFill>
-                <a:latin typeface="Arial"/>
-              </a:rPr>
-              <a:t>Detect the change</a:t>
-            </a:r>
-          </a:p>
-        </p:txBody>
-      </p:sp>
-      <p:sp>
-        <p:nvSpPr>
-          <p:cNvPr id="13" name="Rounded Rectangle 12"/>
-          <p:cNvSpPr/>
-          <p:nvPr/>
-        </p:nvSpPr>
-        <p:spPr>
-          <a:xfrm>
-            <a:off x="5074920" y="3364991"/>
-            <a:ext cx="4023360" cy="566928"/>
+          </a:p>
+        </p:txBody>
+      </p:sp>
+      <p:sp>
+        <p:nvSpPr>
+          <p:cNvPr id="12" name="Rounded Rectangle 11"/>
+          <p:cNvSpPr/>
+          <p:nvPr/>
+        </p:nvSpPr>
+        <p:spPr>
+          <a:xfrm>
+            <a:off x="4983480" y="1975103"/>
+            <a:ext cx="1532534" cy="256032"/>
           </a:xfrm>
           <a:prstGeom prst="roundRect">
             <a:avLst>
@@ -12682,9 +12683,9 @@
             </a:avLst>
           </a:prstGeom>
           <a:solidFill>
-            <a:srgbClr val="F4F6F9"/>
+            <a:srgbClr val="111111"/>
           </a:solidFill>
-          <a:ln w="12700">
+          <a:ln w="9525">
             <a:solidFill>
               <a:srgbClr val="111111"/>
             </a:solidFill>
@@ -12706,18 +12707,53 @@
           </a:fontRef>
         </p:style>
         <p:txBody>
-          <a:bodyPr rtlCol="0" anchor="ctr" wrap="square" lIns="54864" rIns="54864" tIns="18288" bIns="18288"/>
+          <a:bodyPr rtlCol="0" anchor="ctr" wrap="square" lIns="36576" rIns="36576" tIns="0" bIns="0"/>
           <a:lstStyle/>
           <a:p>
             <a:pPr algn="ctr"/>
             <a:r>
-              <a:rPr sz="1050" b="1">
+              <a:rPr sz="900" b="1">
+                <a:solidFill>
+                  <a:srgbClr val="FFFFFF"/>
+                </a:solidFill>
+                <a:latin typeface="Arial"/>
+              </a:rPr>
+              <a:t>SAP BTP · SAP CPI</a:t>
+            </a:r>
+          </a:p>
+        </p:txBody>
+      </p:sp>
+      <p:sp>
+        <p:nvSpPr>
+          <p:cNvPr id="13" name="TextBox 12"/>
+          <p:cNvSpPr txBox="1"/>
+          <p:nvPr/>
+        </p:nvSpPr>
+        <p:spPr>
+          <a:xfrm>
+            <a:off x="4846320" y="2231136"/>
+            <a:ext cx="4480560" cy="365760"/>
+          </a:xfrm>
+          <a:prstGeom prst="rect">
+            <a:avLst/>
+          </a:prstGeom>
+          <a:noFill/>
+        </p:spPr>
+        <p:txBody>
+          <a:bodyPr wrap="square" lIns="0" rIns="0" tIns="0" bIns="0" anchor="t">
+            <a:spAutoFit/>
+          </a:bodyPr>
+          <a:lstStyle/>
+          <a:p>
+            <a:pPr algn="ctr"/>
+            <a:r>
+              <a:rPr sz="1400" b="1" i="0">
                 <a:solidFill>
                   <a:srgbClr val="111111"/>
                 </a:solidFill>
                 <a:latin typeface="Arial"/>
               </a:rPr>
-              <a:t>Read the full record from S/4</a:t>
+              <a:t>Distribution layer</a:t>
             </a:r>
           </a:p>
         </p:txBody>
@@ -12730,12 +12766,12 @@
         </p:nvSpPr>
         <p:spPr>
           <a:xfrm>
-            <a:off x="5074920" y="4059935"/>
-            <a:ext cx="4023360" cy="713232"/>
+            <a:off x="5074920" y="2670048"/>
+            <a:ext cx="4023360" cy="566928"/>
           </a:xfrm>
           <a:prstGeom prst="roundRect">
             <a:avLst>
-              <a:gd name="adj" fmla="val 6000"/>
+              <a:gd name="adj" fmla="val 8000"/>
             </a:avLst>
           </a:prstGeom>
           <a:solidFill>
@@ -12774,19 +12810,7 @@
                 </a:solidFill>
                 <a:latin typeface="Arial"/>
               </a:rPr>
-              <a:t>Check the subscription list –</a:t>
-            </a:r>
-          </a:p>
-          <a:p>
-            <a:pPr algn="ctr"/>
-            <a:r>
-              <a:rPr sz="900" b="0">
-                <a:solidFill>
-                  <a:srgbClr val="595959"/>
-                </a:solidFill>
-                <a:latin typeface="Arial"/>
-              </a:rPr>
-              <a:t>who gets this data, for which contracts</a:t>
+              <a:t>Detect the change</a:t>
             </a:r>
           </a:p>
         </p:txBody>
@@ -12799,12 +12823,12 @@
         </p:nvSpPr>
         <p:spPr>
           <a:xfrm>
-            <a:off x="5074920" y="4901183"/>
+            <a:off x="5074920" y="3364991"/>
             <a:ext cx="4023360" cy="566928"/>
           </a:xfrm>
           <a:prstGeom prst="roundRect">
             <a:avLst>
-              <a:gd name="adj" fmla="val 6000"/>
+              <a:gd name="adj" fmla="val 8000"/>
             </a:avLst>
           </a:prstGeom>
           <a:solidFill>
@@ -12843,65 +12867,34 @@
                 </a:solidFill>
                 <a:latin typeface="Arial"/>
               </a:rPr>
-              <a:t>Deliver, with automatic retries</a:t>
-            </a:r>
-          </a:p>
-        </p:txBody>
-      </p:sp>
-      <p:sp>
-        <p:nvSpPr>
-          <p:cNvPr id="16" name="TextBox 15"/>
-          <p:cNvSpPr txBox="1"/>
-          <p:nvPr/>
-        </p:nvSpPr>
-        <p:spPr>
-          <a:xfrm>
-            <a:off x="4846320" y="5614415"/>
-            <a:ext cx="4480560" cy="274320"/>
-          </a:xfrm>
-          <a:prstGeom prst="rect">
-            <a:avLst/>
-          </a:prstGeom>
-          <a:noFill/>
-        </p:spPr>
-        <p:txBody>
-          <a:bodyPr wrap="square" lIns="0" rIns="0" tIns="0" bIns="0" anchor="t">
-            <a:spAutoFit/>
-          </a:bodyPr>
-          <a:lstStyle/>
-          <a:p>
-            <a:pPr algn="ctr"/>
-            <a:r>
-              <a:rPr sz="950" b="0" i="1">
-                <a:solidFill>
-                  <a:srgbClr val="595959"/>
-                </a:solidFill>
-                <a:latin typeface="Arial"/>
-              </a:rPr>
-              <a:t>holds no business data — ever</a:t>
-            </a:r>
-          </a:p>
-        </p:txBody>
-      </p:sp>
-      <p:sp>
-        <p:nvSpPr>
-          <p:cNvPr id="17" name="Right Arrow 16"/>
-          <p:cNvSpPr/>
-          <p:nvPr/>
-        </p:nvSpPr>
-        <p:spPr>
-          <a:xfrm>
-            <a:off x="9509760" y="4151376"/>
-            <a:ext cx="1371600" cy="109728"/>
-          </a:xfrm>
-          <a:prstGeom prst="rightArrow">
-            <a:avLst/>
+              <a:t>Read the full record from S/4</a:t>
+            </a:r>
+          </a:p>
+        </p:txBody>
+      </p:sp>
+      <p:sp>
+        <p:nvSpPr>
+          <p:cNvPr id="16" name="Rounded Rectangle 15"/>
+          <p:cNvSpPr/>
+          <p:nvPr/>
+        </p:nvSpPr>
+        <p:spPr>
+          <a:xfrm>
+            <a:off x="5074920" y="4059935"/>
+            <a:ext cx="4023360" cy="713232"/>
+          </a:xfrm>
+          <a:prstGeom prst="roundRect">
+            <a:avLst>
+              <a:gd name="adj" fmla="val 8000"/>
+            </a:avLst>
           </a:prstGeom>
           <a:solidFill>
-            <a:srgbClr val="111111"/>
+            <a:srgbClr val="F4F6F9"/>
           </a:solidFill>
-          <a:ln>
-            <a:noFill/>
+          <a:ln w="12700">
+            <a:solidFill>
+              <a:srgbClr val="111111"/>
+            </a:solidFill>
           </a:ln>
           <a:effectLst/>
         </p:spPr>
@@ -12920,80 +12913,54 @@
           </a:fontRef>
         </p:style>
         <p:txBody>
-          <a:bodyPr rtlCol="0" anchor="ctr"/>
+          <a:bodyPr rtlCol="0" anchor="ctr" wrap="square" lIns="54864" rIns="54864" tIns="18288" bIns="18288"/>
           <a:lstStyle/>
           <a:p>
             <a:pPr algn="ctr"/>
-          </a:p>
-        </p:txBody>
-      </p:sp>
-      <p:sp>
-        <p:nvSpPr>
-          <p:cNvPr id="18" name="TextBox 17"/>
-          <p:cNvSpPr txBox="1"/>
-          <p:nvPr/>
-        </p:nvSpPr>
-        <p:spPr>
-          <a:xfrm>
-            <a:off x="9189720" y="3584448"/>
-            <a:ext cx="2011680" cy="530352"/>
-          </a:xfrm>
-          <a:prstGeom prst="rect">
-            <a:avLst/>
-          </a:prstGeom>
-          <a:noFill/>
-        </p:spPr>
-        <p:txBody>
-          <a:bodyPr wrap="square" lIns="0" rIns="0" tIns="0" bIns="0" anchor="b">
-            <a:spAutoFit/>
-          </a:bodyPr>
-          <a:lstStyle/>
+            <a:r>
+              <a:rPr sz="1050" b="1">
+                <a:solidFill>
+                  <a:srgbClr val="111111"/>
+                </a:solidFill>
+                <a:latin typeface="Arial"/>
+              </a:rPr>
+              <a:t>Check the subscription list –</a:t>
+            </a:r>
+          </a:p>
           <a:p>
             <a:pPr algn="ctr"/>
             <a:r>
-              <a:rPr sz="950" b="1" i="0">
-                <a:solidFill>
-                  <a:srgbClr val="0F7A3D"/>
+              <a:rPr sz="900" b="0">
+                <a:solidFill>
+                  <a:srgbClr val="595959"/>
                 </a:solidFill>
                 <a:latin typeface="Arial"/>
               </a:rPr>
-              <a:t>2 · each system gets</a:t>
-            </a:r>
-          </a:p>
-          <a:p>
-            <a:pPr algn="ctr"/>
-            <a:r>
-              <a:rPr sz="950" b="1" i="0">
-                <a:solidFill>
-                  <a:srgbClr val="0F7A3D"/>
-                </a:solidFill>
-                <a:latin typeface="Arial"/>
-              </a:rPr>
-              <a:t>only its own data</a:t>
-            </a:r>
-          </a:p>
-        </p:txBody>
-      </p:sp>
-      <p:sp>
-        <p:nvSpPr>
-          <p:cNvPr id="19" name="Rounded Rectangle 18"/>
-          <p:cNvSpPr/>
-          <p:nvPr/>
-        </p:nvSpPr>
-        <p:spPr>
-          <a:xfrm>
-            <a:off x="11064240" y="2057400"/>
-            <a:ext cx="6492240" cy="932688"/>
+              <a:t>who gets this data, for which contracts</a:t>
+            </a:r>
+          </a:p>
+        </p:txBody>
+      </p:sp>
+      <p:sp>
+        <p:nvSpPr>
+          <p:cNvPr id="17" name="Rounded Rectangle 16"/>
+          <p:cNvSpPr/>
+          <p:nvPr/>
+        </p:nvSpPr>
+        <p:spPr>
+          <a:xfrm>
+            <a:off x="5074920" y="4901183"/>
+            <a:ext cx="4023360" cy="566928"/>
           </a:xfrm>
           <a:prstGeom prst="roundRect">
             <a:avLst>
-              <a:gd name="adj" fmla="val 6000"/>
+              <a:gd name="adj" fmla="val 8000"/>
             </a:avLst>
           </a:prstGeom>
           <a:solidFill>
-            <a:srgbClr val="FFFFFF"/>
+            <a:srgbClr val="F4F6F9"/>
           </a:solidFill>
-          <a:ln w="22225">
+          <a:ln w="12700">
             <a:solidFill>
               <a:srgbClr val="111111"/>
             </a:solidFill>
@@ -13015,57 +12982,76 @@
           </a:fontRef>
         </p:style>
         <p:txBody>
-          <a:bodyPr rtlCol="0" anchor="ctr" wrap="square" lIns="73152" rIns="73152" bIns="36576"/>
+          <a:bodyPr rtlCol="0" anchor="ctr" wrap="square" lIns="54864" rIns="54864" tIns="18288" bIns="18288"/>
           <a:lstStyle/>
           <a:p>
             <a:pPr algn="ctr"/>
             <a:r>
-              <a:rPr sz="1200" b="1">
+              <a:rPr sz="1050" b="1">
                 <a:solidFill>
                   <a:srgbClr val="111111"/>
                 </a:solidFill>
                 <a:latin typeface="Arial"/>
               </a:rPr>
-              <a:t>JAMS</a:t>
-            </a:r>
-          </a:p>
+              <a:t>Deliver, with automatic retries</a:t>
+            </a:r>
+          </a:p>
+        </p:txBody>
+      </p:sp>
+      <p:sp>
+        <p:nvSpPr>
+          <p:cNvPr id="18" name="TextBox 17"/>
+          <p:cNvSpPr txBox="1"/>
+          <p:nvPr/>
+        </p:nvSpPr>
+        <p:spPr>
+          <a:xfrm>
+            <a:off x="4846320" y="5614415"/>
+            <a:ext cx="4480560" cy="274320"/>
+          </a:xfrm>
+          <a:prstGeom prst="rect">
+            <a:avLst/>
+          </a:prstGeom>
+          <a:noFill/>
+        </p:spPr>
+        <p:txBody>
+          <a:bodyPr wrap="square" lIns="0" rIns="0" tIns="0" bIns="0" anchor="t">
+            <a:spAutoFit/>
+          </a:bodyPr>
+          <a:lstStyle/>
           <a:p>
             <a:pPr algn="ctr"/>
             <a:r>
-              <a:rPr sz="950" b="0">
+              <a:rPr sz="950" b="0" i="1">
                 <a:solidFill>
                   <a:srgbClr val="595959"/>
                 </a:solidFill>
                 <a:latin typeface="Arial"/>
               </a:rPr>
-              <a:t>receives a web service call</a:t>
-            </a:r>
-          </a:p>
-        </p:txBody>
-      </p:sp>
-      <p:sp>
-        <p:nvSpPr>
-          <p:cNvPr id="20" name="Rounded Rectangle 19"/>
-          <p:cNvSpPr/>
-          <p:nvPr/>
-        </p:nvSpPr>
-        <p:spPr>
-          <a:xfrm>
-            <a:off x="11201400" y="1929384"/>
-            <a:ext cx="1130198" cy="256032"/>
-          </a:xfrm>
-          <a:prstGeom prst="roundRect">
-            <a:avLst>
-              <a:gd name="adj" fmla="val 6000"/>
-            </a:avLst>
+              <a:t>holds no business data — ever</a:t>
+            </a:r>
+          </a:p>
+        </p:txBody>
+      </p:sp>
+      <p:sp>
+        <p:nvSpPr>
+          <p:cNvPr id="19" name="Right Arrow 18"/>
+          <p:cNvSpPr/>
+          <p:nvPr/>
+        </p:nvSpPr>
+        <p:spPr>
+          <a:xfrm>
+            <a:off x="9509760" y="4151376"/>
+            <a:ext cx="1371600" cy="109728"/>
+          </a:xfrm>
+          <a:prstGeom prst="rightArrow">
+            <a:avLst/>
           </a:prstGeom>
           <a:solidFill>
-            <a:srgbClr val="6B7280"/>
+            <a:srgbClr val="111111"/>
           </a:solidFill>
-          <a:ln w="9525">
-            <a:solidFill>
-              <a:srgbClr val="6B7280"/>
-            </a:solidFill>
+          <a:ln>
+            <a:noFill/>
           </a:ln>
           <a:effectLst/>
         </p:spPr>
@@ -13084,18 +13070,56 @@
           </a:fontRef>
         </p:style>
         <p:txBody>
-          <a:bodyPr rtlCol="0" anchor="ctr" wrap="square" lIns="36576" rIns="36576" tIns="0" bIns="0"/>
+          <a:bodyPr rtlCol="0" anchor="ctr"/>
           <a:lstStyle/>
           <a:p>
             <a:pPr algn="ctr"/>
-            <a:r>
-              <a:rPr sz="900" b="1">
-                <a:solidFill>
-                  <a:srgbClr val="FFFFFF"/>
+          </a:p>
+        </p:txBody>
+      </p:sp>
+      <p:sp>
+        <p:nvSpPr>
+          <p:cNvPr id="20" name="TextBox 19"/>
+          <p:cNvSpPr txBox="1"/>
+          <p:nvPr/>
+        </p:nvSpPr>
+        <p:spPr>
+          <a:xfrm>
+            <a:off x="9189720" y="3584448"/>
+            <a:ext cx="2011680" cy="530352"/>
+          </a:xfrm>
+          <a:prstGeom prst="rect">
+            <a:avLst/>
+          </a:prstGeom>
+          <a:noFill/>
+        </p:spPr>
+        <p:txBody>
+          <a:bodyPr wrap="square" lIns="0" rIns="0" tIns="0" bIns="0" anchor="b">
+            <a:spAutoFit/>
+          </a:bodyPr>
+          <a:lstStyle/>
+          <a:p>
+            <a:pPr algn="ctr"/>
+            <a:r>
+              <a:rPr sz="950" b="1" i="0">
+                <a:solidFill>
+                  <a:srgbClr val="0F7A3D"/>
                 </a:solidFill>
                 <a:latin typeface="Arial"/>
               </a:rPr>
-              <a:t>FIELD SYSTEM</a:t>
+              <a:t>2 · each system gets</a:t>
+            </a:r>
+          </a:p>
+          <a:p>
+            <a:pPr algn="ctr"/>
+            <a:r>
+              <a:rPr sz="950" b="1" i="0">
+                <a:solidFill>
+                  <a:srgbClr val="0F7A3D"/>
+                </a:solidFill>
+                <a:latin typeface="Arial"/>
+              </a:rPr>
+              <a:t>only its own data</a:t>
             </a:r>
           </a:p>
         </p:txBody>
@@ -13108,7 +13132,7 @@
         </p:nvSpPr>
         <p:spPr>
           <a:xfrm>
-            <a:off x="11064240" y="3218688"/>
+            <a:off x="11064240" y="2057400"/>
             <a:ext cx="6492240" cy="932688"/>
           </a:xfrm>
           <a:prstGeom prst="roundRect">
@@ -13141,7 +13165,7 @@
           </a:fontRef>
         </p:style>
         <p:txBody>
-          <a:bodyPr rtlCol="0" anchor="ctr" wrap="square" lIns="73152" rIns="73152" bIns="36576"/>
+          <a:bodyPr rtlCol="0" anchor="ctr" wrap="square" lIns="73152" rIns="73152"/>
           <a:lstStyle/>
           <a:p>
             <a:pPr algn="ctr"/>
@@ -13152,19 +13176,19 @@
                 </a:solidFill>
                 <a:latin typeface="Arial"/>
               </a:rPr>
-              <a:t>ServiceNow ITSM / Defence</a:t>
+              <a:t>JAMS</a:t>
             </a:r>
           </a:p>
           <a:p>
             <a:pPr algn="ctr"/>
             <a:r>
-              <a:rPr sz="950" b="0">
+              <a:rPr sz="950">
                 <a:solidFill>
                   <a:srgbClr val="595959"/>
                 </a:solidFill>
                 <a:latin typeface="Arial"/>
               </a:rPr>
-              <a:t>receives via its built-in import interface</a:t>
+              <a:t>receives a web service call</a:t>
             </a:r>
           </a:p>
         </p:txBody>
@@ -13177,7 +13201,7 @@
         </p:nvSpPr>
         <p:spPr>
           <a:xfrm>
-            <a:off x="11201400" y="3090672"/>
+            <a:off x="11201400" y="1929384"/>
             <a:ext cx="1130198" cy="256032"/>
           </a:xfrm>
           <a:prstGeom prst="roundRect">
@@ -13234,7 +13258,7 @@
         </p:nvSpPr>
         <p:spPr>
           <a:xfrm>
-            <a:off x="11064240" y="4379976"/>
+            <a:off x="11064240" y="3218688"/>
             <a:ext cx="6492240" cy="932688"/>
           </a:xfrm>
           <a:prstGeom prst="roundRect">
@@ -13267,7 +13291,7 @@
           </a:fontRef>
         </p:style>
         <p:txBody>
-          <a:bodyPr rtlCol="0" anchor="ctr" wrap="square" lIns="73152" rIns="73152" bIns="36576"/>
+          <a:bodyPr rtlCol="0" anchor="ctr" wrap="square" lIns="73152" rIns="73152"/>
           <a:lstStyle/>
           <a:p>
             <a:pPr algn="ctr"/>
@@ -13278,19 +13302,19 @@
                 </a:solidFill>
                 <a:latin typeface="Arial"/>
               </a:rPr>
-              <a:t>Sitetracker</a:t>
+              <a:t>ServiceNow ITSM / Defence</a:t>
             </a:r>
           </a:p>
           <a:p>
             <a:pPr algn="ctr"/>
             <a:r>
-              <a:rPr sz="950" b="0">
+              <a:rPr sz="950">
                 <a:solidFill>
                   <a:srgbClr val="595959"/>
                 </a:solidFill>
                 <a:latin typeface="Arial"/>
               </a:rPr>
-              <a:t>receives via its standard Salesforce interface</a:t>
+              <a:t>receives via its built-in import interface</a:t>
             </a:r>
           </a:p>
         </p:txBody>
@@ -13303,7 +13327,7 @@
         </p:nvSpPr>
         <p:spPr>
           <a:xfrm>
-            <a:off x="11201400" y="4251960"/>
+            <a:off x="11201400" y="3090672"/>
             <a:ext cx="1130198" cy="256032"/>
           </a:xfrm>
           <a:prstGeom prst="roundRect">
@@ -13360,7 +13384,7 @@
         </p:nvSpPr>
         <p:spPr>
           <a:xfrm>
-            <a:off x="11064240" y="5541264"/>
+            <a:off x="11064240" y="4379976"/>
             <a:ext cx="6492240" cy="932688"/>
           </a:xfrm>
           <a:prstGeom prst="roundRect">
@@ -13393,7 +13417,7 @@
           </a:fontRef>
         </p:style>
         <p:txBody>
-          <a:bodyPr rtlCol="0" anchor="ctr" wrap="square" lIns="73152" rIns="73152" bIns="36576"/>
+          <a:bodyPr rtlCol="0" anchor="ctr" wrap="square" lIns="73152" rIns="73152"/>
           <a:lstStyle/>
           <a:p>
             <a:pPr algn="ctr"/>
@@ -13404,19 +13428,19 @@
                 </a:solidFill>
                 <a:latin typeface="Arial"/>
               </a:rPr>
-              <a:t>System with no interface</a:t>
+              <a:t>Sitetracker</a:t>
             </a:r>
           </a:p>
           <a:p>
             <a:pPr algn="ctr"/>
             <a:r>
-              <a:rPr sz="950" b="0">
+              <a:rPr sz="950">
                 <a:solidFill>
                   <a:srgbClr val="595959"/>
                 </a:solidFill>
                 <a:latin typeface="Arial"/>
               </a:rPr>
-              <a:t>file drop — or it fetches from the existing pull endpoint</a:t>
+              <a:t>receives via its standard Salesforce interface</a:t>
             </a:r>
           </a:p>
         </p:txBody>
@@ -13429,7 +13453,7 @@
         </p:nvSpPr>
         <p:spPr>
           <a:xfrm>
-            <a:off x="11201400" y="5413248"/>
+            <a:off x="11201400" y="4251960"/>
             <a:ext cx="1130198" cy="256032"/>
           </a:xfrm>
           <a:prstGeom prst="roundRect">
@@ -13480,7 +13504,133 @@
       </p:sp>
       <p:sp>
         <p:nvSpPr>
-          <p:cNvPr id="27" name="TextBox 26"/>
+          <p:cNvPr id="27" name="Rounded Rectangle 26"/>
+          <p:cNvSpPr/>
+          <p:nvPr/>
+        </p:nvSpPr>
+        <p:spPr>
+          <a:xfrm>
+            <a:off x="11064240" y="5541264"/>
+            <a:ext cx="6492240" cy="932688"/>
+          </a:xfrm>
+          <a:prstGeom prst="roundRect">
+            <a:avLst>
+              <a:gd name="adj" fmla="val 6000"/>
+            </a:avLst>
+          </a:prstGeom>
+          <a:solidFill>
+            <a:srgbClr val="FFFFFF"/>
+          </a:solidFill>
+          <a:ln w="22225">
+            <a:solidFill>
+              <a:srgbClr val="111111"/>
+            </a:solidFill>
+          </a:ln>
+          <a:effectLst/>
+        </p:spPr>
+        <p:style>
+          <a:lnRef idx="1">
+            <a:schemeClr val="accent1"/>
+          </a:lnRef>
+          <a:fillRef idx="3">
+            <a:schemeClr val="accent1"/>
+          </a:fillRef>
+          <a:effectRef idx="2">
+            <a:schemeClr val="accent1"/>
+          </a:effectRef>
+          <a:fontRef idx="minor">
+            <a:schemeClr val="lt1"/>
+          </a:fontRef>
+        </p:style>
+        <p:txBody>
+          <a:bodyPr rtlCol="0" anchor="ctr" wrap="square" lIns="73152" rIns="73152"/>
+          <a:lstStyle/>
+          <a:p>
+            <a:pPr algn="ctr"/>
+            <a:r>
+              <a:rPr sz="1200" b="1">
+                <a:solidFill>
+                  <a:srgbClr val="111111"/>
+                </a:solidFill>
+                <a:latin typeface="Arial"/>
+              </a:rPr>
+              <a:t>System with no interface</a:t>
+            </a:r>
+          </a:p>
+          <a:p>
+            <a:pPr algn="ctr"/>
+            <a:r>
+              <a:rPr sz="950">
+                <a:solidFill>
+                  <a:srgbClr val="595959"/>
+                </a:solidFill>
+                <a:latin typeface="Arial"/>
+              </a:rPr>
+              <a:t>file drop — or it fetches from the existing pull endpoint</a:t>
+            </a:r>
+          </a:p>
+        </p:txBody>
+      </p:sp>
+      <p:sp>
+        <p:nvSpPr>
+          <p:cNvPr id="28" name="Rounded Rectangle 27"/>
+          <p:cNvSpPr/>
+          <p:nvPr/>
+        </p:nvSpPr>
+        <p:spPr>
+          <a:xfrm>
+            <a:off x="11201400" y="5413248"/>
+            <a:ext cx="1130198" cy="256032"/>
+          </a:xfrm>
+          <a:prstGeom prst="roundRect">
+            <a:avLst>
+              <a:gd name="adj" fmla="val 6000"/>
+            </a:avLst>
+          </a:prstGeom>
+          <a:solidFill>
+            <a:srgbClr val="6B7280"/>
+          </a:solidFill>
+          <a:ln w="9525">
+            <a:solidFill>
+              <a:srgbClr val="6B7280"/>
+            </a:solidFill>
+          </a:ln>
+          <a:effectLst/>
+        </p:spPr>
+        <p:style>
+          <a:lnRef idx="1">
+            <a:schemeClr val="accent1"/>
+          </a:lnRef>
+          <a:fillRef idx="3">
+            <a:schemeClr val="accent1"/>
+          </a:fillRef>
+          <a:effectRef idx="2">
+            <a:schemeClr val="accent1"/>
+          </a:effectRef>
+          <a:fontRef idx="minor">
+            <a:schemeClr val="lt1"/>
+          </a:fontRef>
+        </p:style>
+        <p:txBody>
+          <a:bodyPr rtlCol="0" anchor="ctr" wrap="square" lIns="36576" rIns="36576" tIns="0" bIns="0"/>
+          <a:lstStyle/>
+          <a:p>
+            <a:pPr algn="ctr"/>
+            <a:r>
+              <a:rPr sz="900" b="1">
+                <a:solidFill>
+                  <a:srgbClr val="FFFFFF"/>
+                </a:solidFill>
+                <a:latin typeface="Arial"/>
+              </a:rPr>
+              <a:t>FIELD SYSTEM</a:t>
+            </a:r>
+          </a:p>
+        </p:txBody>
+      </p:sp>
+      <p:sp>
+        <p:nvSpPr>
+          <p:cNvPr id="29" name="TextBox 28"/>
           <p:cNvSpPr txBox="1"/>
           <p:nvPr/>
         </p:nvSpPr>
@@ -13515,7 +13665,7 @@
       </p:sp>
       <p:sp>
         <p:nvSpPr>
-          <p:cNvPr id="28" name="TextBox 27"/>
+          <p:cNvPr id="30" name="TextBox 29"/>
           <p:cNvSpPr txBox="1"/>
           <p:nvPr/>
         </p:nvSpPr>
@@ -13550,7 +13700,7 @@
       </p:sp>
       <p:sp>
         <p:nvSpPr>
-          <p:cNvPr id="29" name="TextBox 28"/>
+          <p:cNvPr id="31" name="TextBox 30"/>
           <p:cNvSpPr txBox="1"/>
           <p:nvPr/>
         </p:nvSpPr>
@@ -13578,7 +13728,7 @@
                 </a:solidFill>
                 <a:latin typeface="Arial"/>
               </a:rPr>
-              <a:t>S/4’s change-notice service has exactly one job: telling CPI something changed. CPI does everything else. No field system ever connects to it — and a timer can do the same job where no notice exists.</a:t>
+              <a:t>S/4’s event service has exactly one job: telling CPI something changed. CPI does everything else. No field system ever connects to it — and the timed check covers any data set without an event.</a:t>
             </a:r>
           </a:p>
         </p:txBody>
@@ -16740,27 +16890,23 @@
       </p:sp>
       <p:sp>
         <p:nvSpPr>
-          <p:cNvPr id="34" name="Rounded Rectangle 33"/>
-          <p:cNvSpPr/>
-          <p:nvPr/>
-        </p:nvSpPr>
-        <p:spPr>
-          <a:xfrm>
-            <a:off x="640080" y="3840480"/>
-            <a:ext cx="2651760" cy="1371600"/>
-          </a:xfrm>
-          <a:prstGeom prst="roundRect">
-            <a:avLst>
-              <a:gd name="adj" fmla="val 8000"/>
-            </a:avLst>
+          <p:cNvPr id="36" name="Right Arrow 35"/>
+          <p:cNvSpPr/>
+          <p:nvPr/>
+        </p:nvSpPr>
+        <p:spPr>
+          <a:xfrm>
+            <a:off x="3337560" y="4434840"/>
+            <a:ext cx="594360" cy="109728"/>
+          </a:xfrm>
+          <a:prstGeom prst="rightArrow">
+            <a:avLst/>
           </a:prstGeom>
           <a:solidFill>
-            <a:srgbClr val="FFFFFF"/>
+            <a:srgbClr val="111111"/>
           </a:solidFill>
-          <a:ln w="19050">
-            <a:solidFill>
-              <a:srgbClr val="111111"/>
-            </a:solidFill>
+          <a:ln>
+            <a:noFill/>
           </a:ln>
           <a:effectLst/>
         </p:spPr>
@@ -16779,45 +16925,23 @@
           </a:fontRef>
         </p:style>
         <p:txBody>
-          <a:bodyPr rtlCol="0" anchor="ctr" wrap="square" lIns="73152" rIns="73152"/>
+          <a:bodyPr rtlCol="0" anchor="ctr"/>
           <a:lstStyle/>
           <a:p>
             <a:pPr algn="ctr"/>
-            <a:r>
-              <a:rPr sz="1300" b="1">
-                <a:solidFill>
-                  <a:srgbClr val="111111"/>
-                </a:solidFill>
-                <a:latin typeface="Arial"/>
-              </a:rPr>
-              <a:t>S/4HANA</a:t>
-            </a:r>
-          </a:p>
-          <a:p>
-            <a:pPr algn="ctr"/>
-            <a:r>
-              <a:rPr sz="900">
-                <a:solidFill>
-                  <a:srgbClr val="595959"/>
-                </a:solidFill>
-                <a:latin typeface="Arial"/>
-              </a:rPr>
-              <a:t>configuration only —
-no development possible or needed</a:t>
-            </a:r>
-          </a:p>
-        </p:txBody>
-      </p:sp>
-      <p:sp>
-        <p:nvSpPr>
-          <p:cNvPr id="35" name="Rounded Rectangle 34"/>
-          <p:cNvSpPr/>
-          <p:nvPr/>
-        </p:nvSpPr>
-        <p:spPr>
-          <a:xfrm>
-            <a:off x="777240" y="3712463"/>
-            <a:ext cx="1005840" cy="237744"/>
+          </a:p>
+        </p:txBody>
+      </p:sp>
+      <p:sp>
+        <p:nvSpPr>
+          <p:cNvPr id="38" name="Rounded Rectangle 37"/>
+          <p:cNvSpPr/>
+          <p:nvPr/>
+        </p:nvSpPr>
+        <p:spPr>
+          <a:xfrm>
+            <a:off x="14950440" y="3840480"/>
+            <a:ext cx="2743200" cy="1737360"/>
           </a:xfrm>
           <a:prstGeom prst="roundRect">
             <a:avLst>
@@ -16825,9 +16949,9 @@
             </a:avLst>
           </a:prstGeom>
           <a:solidFill>
-            <a:srgbClr val="111111"/>
+            <a:srgbClr val="FFFFFF"/>
           </a:solidFill>
-          <a:ln w="9525">
+          <a:ln w="19050">
             <a:solidFill>
               <a:srgbClr val="111111"/>
             </a:solidFill>
@@ -16849,41 +16973,59 @@
           </a:fontRef>
         </p:style>
         <p:txBody>
-          <a:bodyPr rtlCol="0" anchor="ctr" lIns="27432" rIns="27432" tIns="0" bIns="0"/>
+          <a:bodyPr rtlCol="0" anchor="ctr" wrap="square" lIns="73152" rIns="73152"/>
           <a:lstStyle/>
           <a:p>
             <a:pPr algn="ctr"/>
             <a:r>
-              <a:rPr sz="850" b="1">
-                <a:solidFill>
-                  <a:srgbClr val="FFFFFF"/>
+              <a:rPr sz="1300" b="1">
+                <a:solidFill>
+                  <a:srgbClr val="111111"/>
                 </a:solidFill>
                 <a:latin typeface="Arial"/>
               </a:rPr>
-              <a:t>SAP CLOUD</a:t>
-            </a:r>
-          </a:p>
-        </p:txBody>
-      </p:sp>
-      <p:sp>
-        <p:nvSpPr>
-          <p:cNvPr id="36" name="Right Arrow 35"/>
-          <p:cNvSpPr/>
-          <p:nvPr/>
-        </p:nvSpPr>
-        <p:spPr>
-          <a:xfrm>
-            <a:off x="3337560" y="4434840"/>
-            <a:ext cx="594360" cy="109728"/>
-          </a:xfrm>
-          <a:prstGeom prst="rightArrow">
-            <a:avLst/>
+              <a:t>Field systems</a:t>
+            </a:r>
+          </a:p>
+          <a:p>
+            <a:pPr algn="ctr"/>
+            <a:r>
+              <a:rPr sz="900">
+                <a:solidFill>
+                  <a:srgbClr val="595959"/>
+                </a:solidFill>
+                <a:latin typeface="Arial"/>
+              </a:rPr>
+              <a:t>configuration only,
+except JAMS’s six small
+receiving services</a:t>
+            </a:r>
+          </a:p>
+        </p:txBody>
+      </p:sp>
+      <p:sp>
+        <p:nvSpPr>
+          <p:cNvPr id="39" name="Rounded Rectangle 38"/>
+          <p:cNvSpPr/>
+          <p:nvPr/>
+        </p:nvSpPr>
+        <p:spPr>
+          <a:xfrm>
+            <a:off x="15087600" y="3712463"/>
+            <a:ext cx="1234440" cy="237744"/>
+          </a:xfrm>
+          <a:prstGeom prst="roundRect">
+            <a:avLst>
+              <a:gd name="adj" fmla="val 8000"/>
+            </a:avLst>
           </a:prstGeom>
           <a:solidFill>
-            <a:srgbClr val="111111"/>
+            <a:srgbClr val="6B7280"/>
           </a:solidFill>
-          <a:ln>
-            <a:noFill/>
+          <a:ln w="9525">
+            <a:solidFill>
+              <a:srgbClr val="6B7280"/>
+            </a:solidFill>
           </a:ln>
           <a:effectLst/>
         </p:spPr>
@@ -16902,83 +17044,41 @@
           </a:fontRef>
         </p:style>
         <p:txBody>
-          <a:bodyPr rtlCol="0" anchor="ctr"/>
+          <a:bodyPr rtlCol="0" anchor="ctr" lIns="27432" rIns="27432" tIns="0" bIns="0"/>
           <a:lstStyle/>
           <a:p>
             <a:pPr algn="ctr"/>
-          </a:p>
-        </p:txBody>
-      </p:sp>
-      <p:sp>
-        <p:nvSpPr>
-          <p:cNvPr id="37" name="TextBox 36"/>
-          <p:cNvSpPr txBox="1"/>
-          <p:nvPr/>
-        </p:nvSpPr>
-        <p:spPr>
-          <a:xfrm>
-            <a:off x="2880360" y="3931920"/>
-            <a:ext cx="1554480" cy="457200"/>
-          </a:xfrm>
-          <a:prstGeom prst="rect">
-            <a:avLst/>
-          </a:prstGeom>
-          <a:noFill/>
-        </p:spPr>
-        <p:txBody>
-          <a:bodyPr wrap="square" lIns="0" rIns="0" tIns="0" bIns="0">
-            <a:spAutoFit/>
-          </a:bodyPr>
-          <a:lstStyle/>
-          <a:p>
-            <a:pPr algn="ctr"/>
-            <a:r>
-              <a:rPr sz="850" b="1" i="0">
-                <a:solidFill>
-                  <a:srgbClr val="0F7A3D"/>
+            <a:r>
+              <a:rPr sz="800" b="1">
+                <a:solidFill>
+                  <a:srgbClr val="FFFFFF"/>
                 </a:solidFill>
                 <a:latin typeface="Arial"/>
               </a:rPr>
-              <a:t>notices +</a:t>
-            </a:r>
-          </a:p>
-          <a:p>
-            <a:pPr algn="ctr"/>
-            <a:r>
-              <a:rPr sz="850" b="1" i="0">
-                <a:solidFill>
-                  <a:srgbClr val="0F7A3D"/>
-                </a:solidFill>
-                <a:latin typeface="Arial"/>
-              </a:rPr>
-              <a:t>record reads</a:t>
-            </a:r>
-          </a:p>
-        </p:txBody>
-      </p:sp>
-      <p:sp>
-        <p:nvSpPr>
-          <p:cNvPr id="38" name="Rounded Rectangle 37"/>
-          <p:cNvSpPr/>
-          <p:nvPr/>
-        </p:nvSpPr>
-        <p:spPr>
-          <a:xfrm>
-            <a:off x="14950440" y="3840480"/>
-            <a:ext cx="2743200" cy="1737360"/>
-          </a:xfrm>
-          <a:prstGeom prst="roundRect">
-            <a:avLst>
-              <a:gd name="adj" fmla="val 8000"/>
-            </a:avLst>
+              <a:t>FIELD SYSTEMS</a:t>
+            </a:r>
+          </a:p>
+        </p:txBody>
+      </p:sp>
+      <p:sp>
+        <p:nvSpPr>
+          <p:cNvPr id="40" name="Right Arrow 39"/>
+          <p:cNvSpPr/>
+          <p:nvPr/>
+        </p:nvSpPr>
+        <p:spPr>
+          <a:xfrm>
+            <a:off x="14538960" y="4434840"/>
+            <a:ext cx="384048" cy="109728"/>
+          </a:xfrm>
+          <a:prstGeom prst="rightArrow">
+            <a:avLst/>
           </a:prstGeom>
           <a:solidFill>
-            <a:srgbClr val="FFFFFF"/>
+            <a:srgbClr val="111111"/>
           </a:solidFill>
-          <a:ln w="19050">
-            <a:solidFill>
-              <a:srgbClr val="111111"/>
-            </a:solidFill>
+          <a:ln>
+            <a:noFill/>
           </a:ln>
           <a:effectLst/>
         </p:spPr>
@@ -16997,58 +17097,129 @@
           </a:fontRef>
         </p:style>
         <p:txBody>
-          <a:bodyPr rtlCol="0" anchor="ctr" wrap="square" lIns="73152" rIns="73152"/>
+          <a:bodyPr rtlCol="0" anchor="ctr"/>
           <a:lstStyle/>
           <a:p>
             <a:pPr algn="ctr"/>
-            <a:r>
-              <a:rPr sz="1300" b="1">
+          </a:p>
+        </p:txBody>
+      </p:sp>
+      <p:sp>
+        <p:nvSpPr>
+          <p:cNvPr id="41" name="TextBox 40"/>
+          <p:cNvSpPr txBox="1"/>
+          <p:nvPr/>
+        </p:nvSpPr>
+        <p:spPr>
+          <a:xfrm>
+            <a:off x="640080" y="9189720"/>
+            <a:ext cx="3566160" cy="914400"/>
+          </a:xfrm>
+          <a:prstGeom prst="rect">
+            <a:avLst/>
+          </a:prstGeom>
+          <a:noFill/>
+        </p:spPr>
+        <p:txBody>
+          <a:bodyPr wrap="square" lIns="0" rIns="0" tIns="0" bIns="0">
+            <a:spAutoFit/>
+          </a:bodyPr>
+          <a:lstStyle/>
+          <a:p>
+            <a:pPr algn="l"/>
+            <a:r>
+              <a:rPr sz="950" b="0" i="0">
+                <a:solidFill>
+                  <a:srgbClr val="595959"/>
+                </a:solidFill>
+                <a:latin typeface="Arial"/>
+              </a:rPr>
+              <a:t>BUILD = development in CPI, assembled from standard delivered pieces</a:t>
+            </a:r>
+          </a:p>
+          <a:p>
+            <a:pPr algn="l"/>
+            <a:r>
+              <a:rPr sz="950" b="0" i="0">
+                <a:solidFill>
+                  <a:srgbClr val="595959"/>
+                </a:solidFill>
+                <a:latin typeface="Arial"/>
+              </a:rPr>
+              <a:t>CONFIG = configuration only</a:t>
+            </a:r>
+          </a:p>
+          <a:p>
+            <a:pPr algn="l"/>
+            <a:r>
+              <a:rPr sz="950" b="0" i="0">
+                <a:solidFill>
+                  <a:srgbClr val="595959"/>
+                </a:solidFill>
+                <a:latin typeface="Arial"/>
+              </a:rPr>
+              <a:t>EXTEND = existing part extended</a:t>
+            </a:r>
+          </a:p>
+        </p:txBody>
+      </p:sp>
+      <p:sp>
+        <p:nvSpPr>
+          <p:cNvPr id="42" name="TextBox 41"/>
+          <p:cNvSpPr txBox="1"/>
+          <p:nvPr/>
+        </p:nvSpPr>
+        <p:spPr>
+          <a:xfrm>
+            <a:off x="640080" y="10076688"/>
+            <a:ext cx="17190720" cy="0"/>
+          </a:xfrm>
+          <a:prstGeom prst="rect">
+            <a:avLst/>
+          </a:prstGeom>
+          <a:noFill/>
+        </p:spPr>
+        <p:txBody>
+          <a:bodyPr wrap="square" lIns="0" rIns="0" tIns="0" bIns="0">
+            <a:spAutoFit/>
+          </a:bodyPr>
+          <a:lstStyle/>
+          <a:p>
+            <a:pPr algn="l"/>
+            <a:r>
+              <a:rPr sz="100" b="0" i="0">
                 <a:solidFill>
                   <a:srgbClr val="111111"/>
                 </a:solidFill>
                 <a:latin typeface="Arial"/>
               </a:rPr>
-              <a:t>Field systems</a:t>
-            </a:r>
-          </a:p>
-          <a:p>
-            <a:pPr algn="ctr"/>
-            <a:r>
-              <a:rPr sz="900">
-                <a:solidFill>
-                  <a:srgbClr val="595959"/>
-                </a:solidFill>
-                <a:latin typeface="Arial"/>
-              </a:rPr>
-              <a:t>configuration only,
-except JAMS’s six small
-receiving services</a:t>
-            </a:r>
-          </a:p>
-        </p:txBody>
-      </p:sp>
-      <p:sp>
-        <p:nvSpPr>
-          <p:cNvPr id="39" name="Rounded Rectangle 38"/>
-          <p:cNvSpPr/>
-          <p:nvPr/>
-        </p:nvSpPr>
-        <p:spPr>
-          <a:xfrm>
-            <a:off x="15087600" y="3712463"/>
-            <a:ext cx="1234440" cy="237744"/>
+              <a:t/>
+            </a:r>
+          </a:p>
+        </p:txBody>
+      </p:sp>
+      <p:sp>
+        <p:nvSpPr>
+          <p:cNvPr id="43" name="Rounded Rectangle 42"/>
+          <p:cNvSpPr/>
+          <p:nvPr/>
+        </p:nvSpPr>
+        <p:spPr>
+          <a:xfrm>
+            <a:off x="502920" y="3063240"/>
+            <a:ext cx="3154680" cy="3063240"/>
           </a:xfrm>
           <a:prstGeom prst="roundRect">
             <a:avLst>
-              <a:gd name="adj" fmla="val 8000"/>
+              <a:gd name="adj" fmla="val 6000"/>
             </a:avLst>
           </a:prstGeom>
           <a:solidFill>
-            <a:srgbClr val="6B7280"/>
+            <a:srgbClr val="FFFFFF"/>
           </a:solidFill>
-          <a:ln w="9525">
+          <a:ln w="22225">
             <a:solidFill>
-              <a:srgbClr val="6B7280"/>
+              <a:srgbClr val="111111"/>
             </a:solidFill>
           </a:ln>
           <a:effectLst/>
@@ -17068,41 +17239,57 @@
           </a:fontRef>
         </p:style>
         <p:txBody>
-          <a:bodyPr rtlCol="0" anchor="ctr" lIns="27432" rIns="27432" tIns="0" bIns="0"/>
+          <a:bodyPr rtlCol="0" anchor="t" wrap="square" lIns="73152" rIns="73152" tIns="91440"/>
           <a:lstStyle/>
           <a:p>
             <a:pPr algn="ctr"/>
             <a:r>
-              <a:rPr sz="800" b="1">
-                <a:solidFill>
-                  <a:srgbClr val="FFFFFF"/>
+              <a:rPr sz="1300" b="1">
+                <a:solidFill>
+                  <a:srgbClr val="111111"/>
                 </a:solidFill>
                 <a:latin typeface="Arial"/>
               </a:rPr>
-              <a:t>FIELD SYSTEMS</a:t>
-            </a:r>
-          </a:p>
-        </p:txBody>
-      </p:sp>
-      <p:sp>
-        <p:nvSpPr>
-          <p:cNvPr id="40" name="Right Arrow 39"/>
-          <p:cNvSpPr/>
-          <p:nvPr/>
-        </p:nvSpPr>
-        <p:spPr>
-          <a:xfrm>
-            <a:off x="14538960" y="4434840"/>
-            <a:ext cx="384048" cy="109728"/>
-          </a:xfrm>
-          <a:prstGeom prst="rightArrow">
-            <a:avLst/>
+              <a:t>S/4HANA</a:t>
+            </a:r>
+          </a:p>
+          <a:p>
+            <a:pPr algn="ctr"/>
+            <a:r>
+              <a:rPr sz="850">
+                <a:solidFill>
+                  <a:srgbClr val="595959"/>
+                </a:solidFill>
+                <a:latin typeface="Arial"/>
+              </a:rPr>
+              <a:t>the single source of truth · configuration only</a:t>
+            </a:r>
+          </a:p>
+        </p:txBody>
+      </p:sp>
+      <p:sp>
+        <p:nvSpPr>
+          <p:cNvPr id="44" name="Rounded Rectangle 43"/>
+          <p:cNvSpPr/>
+          <p:nvPr/>
+        </p:nvSpPr>
+        <p:spPr>
+          <a:xfrm>
+            <a:off x="640080" y="2935224"/>
+            <a:ext cx="888796" cy="256032"/>
+          </a:xfrm>
+          <a:prstGeom prst="roundRect">
+            <a:avLst>
+              <a:gd name="adj" fmla="val 6000"/>
+            </a:avLst>
           </a:prstGeom>
           <a:solidFill>
             <a:srgbClr val="111111"/>
           </a:solidFill>
-          <a:ln>
-            <a:noFill/>
+          <a:ln w="9525">
+            <a:solidFill>
+              <a:srgbClr val="111111"/>
+            </a:solidFill>
           </a:ln>
           <a:effectLst/>
         </p:spPr>
@@ -17121,103 +17308,156 @@
           </a:fontRef>
         </p:style>
         <p:txBody>
-          <a:bodyPr rtlCol="0" anchor="ctr"/>
+          <a:bodyPr rtlCol="0" anchor="ctr" wrap="square" lIns="36576" rIns="36576" tIns="0" bIns="0"/>
           <a:lstStyle/>
           <a:p>
             <a:pPr algn="ctr"/>
-          </a:p>
-        </p:txBody>
-      </p:sp>
-      <p:sp>
-        <p:nvSpPr>
-          <p:cNvPr id="41" name="TextBox 40"/>
-          <p:cNvSpPr txBox="1"/>
-          <p:nvPr/>
-        </p:nvSpPr>
-        <p:spPr>
-          <a:xfrm>
-            <a:off x="640080" y="9189720"/>
-            <a:ext cx="3566160" cy="914400"/>
-          </a:xfrm>
-          <a:prstGeom prst="rect">
-            <a:avLst/>
-          </a:prstGeom>
-          <a:noFill/>
-        </p:spPr>
-        <p:txBody>
-          <a:bodyPr wrap="square" lIns="0" rIns="0" tIns="0" bIns="0">
-            <a:spAutoFit/>
-          </a:bodyPr>
-          <a:lstStyle/>
-          <a:p>
-            <a:pPr algn="l"/>
-            <a:r>
-              <a:rPr sz="950" b="0" i="0">
+            <a:r>
+              <a:rPr sz="900" b="1">
+                <a:solidFill>
+                  <a:srgbClr val="FFFFFF"/>
+                </a:solidFill>
+                <a:latin typeface="Arial"/>
+              </a:rPr>
+              <a:t>SAP CLOUD</a:t>
+            </a:r>
+          </a:p>
+        </p:txBody>
+      </p:sp>
+      <p:sp>
+        <p:nvSpPr>
+          <p:cNvPr id="45" name="Rounded Rectangle 44"/>
+          <p:cNvSpPr/>
+          <p:nvPr/>
+        </p:nvSpPr>
+        <p:spPr>
+          <a:xfrm>
+            <a:off x="667512" y="3840480"/>
+            <a:ext cx="2825496" cy="1115568"/>
+          </a:xfrm>
+          <a:prstGeom prst="roundRect">
+            <a:avLst>
+              <a:gd name="adj" fmla="val 8000"/>
+            </a:avLst>
+          </a:prstGeom>
+          <a:solidFill>
+            <a:srgbClr val="F4F6F9"/>
+          </a:solidFill>
+          <a:ln w="12700">
+            <a:solidFill>
+              <a:srgbClr val="111111"/>
+            </a:solidFill>
+          </a:ln>
+          <a:effectLst/>
+        </p:spPr>
+        <p:style>
+          <a:lnRef idx="1">
+            <a:schemeClr val="accent1"/>
+          </a:lnRef>
+          <a:fillRef idx="3">
+            <a:schemeClr val="accent1"/>
+          </a:fillRef>
+          <a:effectRef idx="2">
+            <a:schemeClr val="accent1"/>
+          </a:effectRef>
+          <a:fontRef idx="minor">
+            <a:schemeClr val="lt1"/>
+          </a:fontRef>
+        </p:style>
+        <p:txBody>
+          <a:bodyPr rtlCol="0" anchor="ctr" wrap="square" lIns="54864" rIns="54864" tIns="36576" bIns="27432"/>
+          <a:lstStyle/>
+          <a:p>
+            <a:pPr algn="ctr"/>
+            <a:r>
+              <a:rPr sz="1050" b="1">
+                <a:solidFill>
+                  <a:srgbClr val="111111"/>
+                </a:solidFill>
+                <a:latin typeface="Arial"/>
+              </a:rPr>
+              <a:t>Business events</a:t>
+            </a:r>
+          </a:p>
+          <a:p>
+            <a:pPr algn="ctr"/>
+            <a:r>
+              <a:rPr sz="850">
                 <a:solidFill>
                   <a:srgbClr val="595959"/>
                 </a:solidFill>
                 <a:latin typeface="Arial"/>
               </a:rPr>
-              <a:t>BUILD = development in CPI, assembled from standard delivered pieces</a:t>
-            </a:r>
-          </a:p>
-          <a:p>
-            <a:pPr algn="l"/>
-            <a:r>
-              <a:rPr sz="950" b="0" i="0">
+              <a:t>Enterprise Event Enablement · channel EMIS_COM_0092 active · service orders · projects · invoices · POs · goods movements</a:t>
+            </a:r>
+          </a:p>
+        </p:txBody>
+      </p:sp>
+      <p:sp>
+        <p:nvSpPr>
+          <p:cNvPr id="46" name="Rounded Rectangle 45"/>
+          <p:cNvSpPr/>
+          <p:nvPr/>
+        </p:nvSpPr>
+        <p:spPr>
+          <a:xfrm>
+            <a:off x="667512" y="5093208"/>
+            <a:ext cx="2825496" cy="868680"/>
+          </a:xfrm>
+          <a:prstGeom prst="roundRect">
+            <a:avLst>
+              <a:gd name="adj" fmla="val 8000"/>
+            </a:avLst>
+          </a:prstGeom>
+          <a:solidFill>
+            <a:srgbClr val="F4F6F9"/>
+          </a:solidFill>
+          <a:ln w="12700">
+            <a:solidFill>
+              <a:srgbClr val="111111"/>
+            </a:solidFill>
+          </a:ln>
+          <a:effectLst/>
+        </p:spPr>
+        <p:style>
+          <a:lnRef idx="1">
+            <a:schemeClr val="accent1"/>
+          </a:lnRef>
+          <a:fillRef idx="3">
+            <a:schemeClr val="accent1"/>
+          </a:fillRef>
+          <a:effectRef idx="2">
+            <a:schemeClr val="accent1"/>
+          </a:effectRef>
+          <a:fontRef idx="minor">
+            <a:schemeClr val="lt1"/>
+          </a:fontRef>
+        </p:style>
+        <p:txBody>
+          <a:bodyPr rtlCol="0" anchor="ctr" wrap="square" lIns="54864" rIns="54864" tIns="36576" bIns="27432"/>
+          <a:lstStyle/>
+          <a:p>
+            <a:pPr algn="ctr"/>
+            <a:r>
+              <a:rPr sz="1050" b="1">
+                <a:solidFill>
+                  <a:srgbClr val="111111"/>
+                </a:solidFill>
+                <a:latin typeface="Arial"/>
+              </a:rPr>
+              <a:t>Released OData APIs</a:t>
+            </a:r>
+          </a:p>
+          <a:p>
+            <a:pPr algn="ctr"/>
+            <a:r>
+              <a:rPr sz="850">
                 <a:solidFill>
                   <a:srgbClr val="595959"/>
                 </a:solidFill>
                 <a:latin typeface="Arial"/>
               </a:rPr>
-              <a:t>CONFIG = configuration only</a:t>
-            </a:r>
-          </a:p>
-          <a:p>
-            <a:pPr algn="l"/>
-            <a:r>
-              <a:rPr sz="950" b="0" i="0">
-                <a:solidFill>
-                  <a:srgbClr val="595959"/>
-                </a:solidFill>
-                <a:latin typeface="Arial"/>
-              </a:rPr>
-              <a:t>EXTEND = existing part extended</a:t>
-            </a:r>
-          </a:p>
-        </p:txBody>
-      </p:sp>
-      <p:sp>
-        <p:nvSpPr>
-          <p:cNvPr id="42" name="TextBox 41"/>
-          <p:cNvSpPr txBox="1"/>
-          <p:nvPr/>
-        </p:nvSpPr>
-        <p:spPr>
-          <a:xfrm>
-            <a:off x="640080" y="10076688"/>
-            <a:ext cx="17190720" cy="0"/>
-          </a:xfrm>
-          <a:prstGeom prst="rect">
-            <a:avLst/>
-          </a:prstGeom>
-          <a:noFill/>
-        </p:spPr>
-        <p:txBody>
-          <a:bodyPr wrap="square" lIns="0" rIns="0" tIns="0" bIns="0">
-            <a:spAutoFit/>
-          </a:bodyPr>
-          <a:lstStyle/>
-          <a:p>
-            <a:pPr algn="l"/>
-            <a:r>
-              <a:rPr sz="100" b="0" i="0">
-                <a:solidFill>
-                  <a:srgbClr val="111111"/>
-                </a:solidFill>
-                <a:latin typeface="Arial"/>
-              </a:rPr>
-              <a:t/>
+              <a:t>the existing passthrough set — CPI reads the full record here</a:t>
             </a:r>
           </a:p>
         </p:txBody>

</xml_diff>

<commit_message>
ARB deck: name the layer precisely - Business data distribution
Renames 'Distribution layer' to 'Business data distribution' across
the deck so it is explicit what is distributed: the S/4 business
records after processing, not acknowledgements (Response Type 1 is a
separate, unchanged pathway). Caption reworded to 'passes business
data through - stores none of it' to avoid reading against the name.

Co-Authored-By: Claude Fable 5 <noreply@anthropic.com>
Claude-Session: https://claude.ai/code/session_01J9sMjqcGkRLhakCptK95KF
</commit_message>
<xml_diff>
--- a/docs/JAMS-WriteBack-Callback-S4-Key-Design-Decision-2.pptx
+++ b/docs/JAMS-WriteBack-Callback-S4-Key-Design-Decision-2.pptx
@@ -12753,7 +12753,7 @@
                 </a:solidFill>
                 <a:latin typeface="Arial"/>
               </a:rPr>
-              <a:t>Distribution layer</a:t>
+              <a:t>Business data distribution</a:t>
             </a:r>
           </a:p>
         </p:txBody>
@@ -13028,7 +13028,7 @@
                 </a:solidFill>
                 <a:latin typeface="Arial"/>
               </a:rPr>
-              <a:t>holds no business data — ever</a:t>
+              <a:t>passes business data through — stores none of it</a:t>
             </a:r>
           </a:p>
         </p:txBody>
@@ -15211,7 +15211,7 @@
                 </a:solidFill>
                 <a:latin typeface="Arial"/>
               </a:rPr>
-              <a:t>Option D – The Distribution Layer Expanded: Every Part, and Whether It Is Built or Configured</a:t>
+              <a:t>Option D – The Business Data Distribution Layer Expanded: Every Part, and Whether It Is Built or Configured</a:t>
             </a:r>
           </a:p>
         </p:txBody>

</xml_diff>

<commit_message>
Event intake detail design: tenant evidence, queue design, consumer settings, full-payload read
Build spec section 13.1a extended and a new deck appendix slide added,
both from verified tenant evidence: EMIS entitlement assigned
(message-client plan), broker Ready (2GB/1MB/200/600/600), message
client emis-s4hdev-client on namespace ssm/s4h/dev, working queue
s4h-dev-ses-events, and the EventMesh_POC consumer flow. Target
design: one intake queue per data set with mandatory dead-message
queue (dialog default None rejected as silent-loss risk), 7-day TTL,
5-retry consumer at concurrency 1, and the full-payload read pattern
with its four engineering reasons.

Co-Authored-By: Claude Fable 5 <noreply@anthropic.com>
Claude-Session: https://claude.ai/code/session_01J9sMjqcGkRLhakCptK95KF
</commit_message>
<xml_diff>
--- a/docs/JAMS-WriteBack-Callback-S4-Key-Design-Decision-2.pptx
+++ b/docs/JAMS-WriteBack-Callback-S4-Key-Design-Decision-2.pptx
@@ -31,6 +31,7 @@
     <p:sldId id="268" r:id="rId16"/>
     <p:sldId id="269" r:id="rId17"/>
     <p:sldId id="270" r:id="rId18"/>
+    <p:sldId id="285" r:id="rId35"/>
   </p:sldIdLst>
   <p:sldSz cx="18288000" cy="10287000"/>
   <p:notesSz cx="10287000" cy="18288000"/>
@@ -23461,6 +23462,1590 @@
               <a:t>Response type 1 (acknowledgement, status and correlation ID) and response type 2 (pull of S/4 data) are separate interfaces with separate error handling.</a:t>
             </a:r>
             <a:endParaRPr lang="en-US" sz="1950"/>
+          </a:p>
+        </p:txBody>
+      </p:sp>
+    </p:spTree>
+  </p:cSld>
+  <p:clrMapOvr>
+    <a:masterClrMapping/>
+  </p:clrMapOvr>
+</p:sld>
+</file>
+
+<file path=ppt/slides/slide24.xml><?xml version="1.0" encoding="utf-8"?>
+<p:sld xmlns:a="http://schemas.openxmlformats.org/drawingml/2006/main" xmlns:p="http://schemas.openxmlformats.org/presentationml/2006/main" xmlns:r="http://schemas.openxmlformats.org/officeDocument/2006/relationships">
+  <p:cSld>
+    <p:spTree>
+      <p:nvGrpSpPr>
+        <p:cNvPr id="1" name=""/>
+        <p:cNvGrpSpPr/>
+        <p:nvPr/>
+      </p:nvGrpSpPr>
+      <p:grpSpPr/>
+      <p:pic>
+        <p:nvPicPr>
+          <p:cNvPr id="2" name="Picture 1" descr="image.png"/>
+          <p:cNvPicPr>
+            <a:picLocks noChangeAspect="1"/>
+          </p:cNvPicPr>
+          <p:nvPr/>
+        </p:nvPicPr>
+        <p:blipFill>
+          <a:blip r:embed="rId2"/>
+          <a:stretch>
+            <a:fillRect/>
+          </a:stretch>
+        </p:blipFill>
+        <p:spPr>
+          <a:xfrm>
+            <a:off x="16188779" y="476250"/>
+            <a:ext cx="1337221" cy="419075"/>
+          </a:xfrm>
+          <a:prstGeom prst="rect">
+            <a:avLst/>
+          </a:prstGeom>
+        </p:spPr>
+      </p:pic>
+      <p:sp>
+        <p:nvSpPr>
+          <p:cNvPr id="3" name="TextBox 2"/>
+          <p:cNvSpPr txBox="1"/>
+          <p:nvPr/>
+        </p:nvSpPr>
+        <p:spPr>
+          <a:xfrm>
+            <a:off x="640080" y="320040"/>
+            <a:ext cx="16459200" cy="548640"/>
+          </a:xfrm>
+          <a:prstGeom prst="rect">
+            <a:avLst/>
+          </a:prstGeom>
+          <a:noFill/>
+        </p:spPr>
+        <p:txBody>
+          <a:bodyPr wrap="square" lIns="0" rIns="0" tIns="0" bIns="0">
+            <a:spAutoFit/>
+          </a:bodyPr>
+          <a:lstStyle/>
+          <a:p>
+            <a:pPr algn="l"/>
+            <a:r>
+              <a:rPr sz="2100" b="1">
+                <a:solidFill>
+                  <a:srgbClr val="1F3864"/>
+                </a:solidFill>
+                <a:latin typeface="Arial"/>
+              </a:rPr>
+              <a:t>Appendix – Event Intake: Working Tenant Configuration, Queue Design and the Full-Payload Read</a:t>
+            </a:r>
+          </a:p>
+        </p:txBody>
+      </p:sp>
+      <p:sp>
+        <p:nvSpPr>
+          <p:cNvPr id="4" name="TextBox 3"/>
+          <p:cNvSpPr txBox="1"/>
+          <p:nvPr/>
+        </p:nvSpPr>
+        <p:spPr>
+          <a:xfrm>
+            <a:off x="640080" y="850392"/>
+            <a:ext cx="16824960" cy="365760"/>
+          </a:xfrm>
+          <a:prstGeom prst="rect">
+            <a:avLst/>
+          </a:prstGeom>
+          <a:noFill/>
+        </p:spPr>
+        <p:txBody>
+          <a:bodyPr wrap="square" lIns="0" rIns="0" tIns="0" bIns="0">
+            <a:spAutoFit/>
+          </a:bodyPr>
+          <a:lstStyle/>
+          <a:p>
+            <a:pPr algn="l"/>
+            <a:r>
+              <a:rPr sz="1150" b="0">
+                <a:solidFill>
+                  <a:srgbClr val="595959"/>
+                </a:solidFill>
+                <a:latin typeface="Arial"/>
+              </a:rPr>
+              <a:t>Everything on this slide is verified in our own non-prod tenant. Intake queues carry S/4 change notices INTO CPI — they are separate from CPI’s delivery queues to the field systems.</a:t>
+            </a:r>
+          </a:p>
+        </p:txBody>
+      </p:sp>
+      <p:sp>
+        <p:nvSpPr>
+          <p:cNvPr id="5" name="TextBox 4"/>
+          <p:cNvSpPr txBox="1"/>
+          <p:nvPr/>
+        </p:nvSpPr>
+        <p:spPr>
+          <a:xfrm>
+            <a:off x="640080" y="1371600"/>
+            <a:ext cx="8229600" cy="274320"/>
+          </a:xfrm>
+          <a:prstGeom prst="rect">
+            <a:avLst/>
+          </a:prstGeom>
+          <a:noFill/>
+        </p:spPr>
+        <p:txBody>
+          <a:bodyPr wrap="square" lIns="0" rIns="0" tIns="0" bIns="0">
+            <a:spAutoFit/>
+          </a:bodyPr>
+          <a:lstStyle/>
+          <a:p>
+            <a:pPr algn="l"/>
+            <a:r>
+              <a:rPr sz="1250" b="1">
+                <a:solidFill>
+                  <a:srgbClr val="111111"/>
+                </a:solidFill>
+                <a:latin typeface="Arial"/>
+              </a:rPr>
+              <a:t>Already working (verified)</a:t>
+            </a:r>
+          </a:p>
+        </p:txBody>
+      </p:sp>
+      <p:graphicFrame>
+        <p:nvGraphicFramePr>
+          <p:cNvPr id="6" name="Table 5"/>
+          <p:cNvGraphicFramePr>
+            <a:graphicFrameLocks noGrp="1"/>
+          </p:cNvGraphicFramePr>
+          <p:nvPr/>
+        </p:nvGraphicFramePr>
+        <p:xfrm>
+          <a:off x="640080" y="1691640"/>
+          <a:ext cx="8412480" cy="2565546"/>
+        </p:xfrm>
+        <a:graphic>
+          <a:graphicData uri="http://schemas.openxmlformats.org/drawingml/2006/table">
+            <a:tbl>
+              <a:tblPr firstRow="1" bandRow="1">
+                <a:tableStyleId>{5C22544A-7EE6-4342-B048-85BDC9FD1C3A}</a:tableStyleId>
+              </a:tblPr>
+              <a:tblGrid>
+                <a:gridCol w="2194560"/>
+                <a:gridCol w="6217920"/>
+              </a:tblGrid>
+              <a:tr h="292608">
+                <a:tc>
+                  <a:txBody>
+                    <a:bodyPr wrap="square"/>
+                    <a:lstStyle/>
+                    <a:p>
+                      <a:r>
+                        <a:rPr sz="1050" b="1">
+                          <a:solidFill>
+                            <a:srgbClr val="111111"/>
+                          </a:solidFill>
+                          <a:latin typeface="Arial"/>
+                        </a:rPr>
+                        <a:t>Item</a:t>
+                      </a:r>
+                    </a:p>
+                  </a:txBody>
+                  <a:tcPr marL="64008" marR="64008" marT="27432" marB="27432">
+                    <a:solidFill>
+                      <a:srgbClr val="92D050"/>
+                    </a:solidFill>
+                  </a:tcPr>
+                </a:tc>
+                <a:tc>
+                  <a:txBody>
+                    <a:bodyPr wrap="square"/>
+                    <a:lstStyle/>
+                    <a:p>
+                      <a:r>
+                        <a:rPr sz="1050" b="1">
+                          <a:solidFill>
+                            <a:srgbClr val="111111"/>
+                          </a:solidFill>
+                          <a:latin typeface="Arial"/>
+                        </a:rPr>
+                        <a:t>Evidence in our tenant</a:t>
+                      </a:r>
+                    </a:p>
+                  </a:txBody>
+                  <a:tcPr marL="64008" marR="64008" marT="27432" marB="27432">
+                    <a:solidFill>
+                      <a:srgbClr val="92D050"/>
+                    </a:solidFill>
+                  </a:tcPr>
+                </a:tc>
+              </a:tr>
+              <a:tr h="378822">
+                <a:tc>
+                  <a:txBody>
+                    <a:bodyPr wrap="square"/>
+                    <a:lstStyle/>
+                    <a:p>
+                      <a:r>
+                        <a:rPr sz="950" b="1">
+                          <a:solidFill>
+                            <a:srgbClr val="111111"/>
+                          </a:solidFill>
+                          <a:latin typeface="Arial"/>
+                        </a:rPr>
+                        <a:t>Entitlement</a:t>
+                      </a:r>
+                    </a:p>
+                  </a:txBody>
+                  <a:tcPr marL="64008" marR="64008" marT="27432" marB="27432">
+                    <a:solidFill>
+                      <a:srgbClr val="FFFFFF"/>
+                    </a:solidFill>
+                  </a:tcPr>
+                </a:tc>
+                <a:tc>
+                  <a:txBody>
+                    <a:bodyPr wrap="square"/>
+                    <a:lstStyle/>
+                    <a:p>
+                      <a:r>
+                        <a:rPr sz="950" b="0">
+                          <a:solidFill>
+                            <a:srgbClr val="111111"/>
+                          </a:solidFill>
+                          <a:latin typeface="Arial"/>
+                        </a:rPr>
+                        <a:t>“SAP Integration Suite, Event Mesh” — message-client plan assigned, unlimited quota</a:t>
+                      </a:r>
+                    </a:p>
+                  </a:txBody>
+                  <a:tcPr marL="64008" marR="64008" marT="27432" marB="27432">
+                    <a:solidFill>
+                      <a:srgbClr val="FFFFFF"/>
+                    </a:solidFill>
+                  </a:tcPr>
+                </a:tc>
+              </a:tr>
+              <a:tr h="378822">
+                <a:tc>
+                  <a:txBody>
+                    <a:bodyPr wrap="square"/>
+                    <a:lstStyle/>
+                    <a:p>
+                      <a:r>
+                        <a:rPr sz="950" b="1">
+                          <a:solidFill>
+                            <a:srgbClr val="111111"/>
+                          </a:solidFill>
+                          <a:latin typeface="Arial"/>
+                        </a:rPr>
+                        <a:t>Capability</a:t>
+                      </a:r>
+                    </a:p>
+                  </a:txBody>
+                  <a:tcPr marL="64008" marR="64008" marT="27432" marB="27432">
+                    <a:solidFill>
+                      <a:srgbClr val="FFFFFF"/>
+                    </a:solidFill>
+                  </a:tcPr>
+                </a:tc>
+                <a:tc>
+                  <a:txBody>
+                    <a:bodyPr wrap="square"/>
+                    <a:lstStyle/>
+                    <a:p>
+                      <a:r>
+                        <a:rPr sz="950" b="0">
+                          <a:solidFill>
+                            <a:srgbClr val="111111"/>
+                          </a:solidFill>
+                          <a:latin typeface="Arial"/>
+                        </a:rPr>
+                        <a:t>“Manage Business Events” active in non-prod Integration Suite</a:t>
+                      </a:r>
+                    </a:p>
+                  </a:txBody>
+                  <a:tcPr marL="64008" marR="64008" marT="27432" marB="27432">
+                    <a:solidFill>
+                      <a:srgbClr val="FFFFFF"/>
+                    </a:solidFill>
+                  </a:tcPr>
+                </a:tc>
+              </a:tr>
+              <a:tr h="378822">
+                <a:tc>
+                  <a:txBody>
+                    <a:bodyPr wrap="square"/>
+                    <a:lstStyle/>
+                    <a:p>
+                      <a:r>
+                        <a:rPr sz="950" b="1">
+                          <a:solidFill>
+                            <a:srgbClr val="111111"/>
+                          </a:solidFill>
+                          <a:latin typeface="Arial"/>
+                        </a:rPr>
+                        <a:t>Broker</a:t>
+                      </a:r>
+                    </a:p>
+                  </a:txBody>
+                  <a:tcPr marL="64008" marR="64008" marT="27432" marB="27432">
+                    <a:solidFill>
+                      <a:srgbClr val="FFFFFF"/>
+                    </a:solidFill>
+                  </a:tcPr>
+                </a:tc>
+                <a:tc>
+                  <a:txBody>
+                    <a:bodyPr wrap="square"/>
+                    <a:lstStyle/>
+                    <a:p>
+                      <a:r>
+                        <a:rPr sz="950" b="0">
+                          <a:solidFill>
+                            <a:srgbClr val="111111"/>
+                          </a:solidFill>
+                          <a:latin typeface="Arial"/>
+                        </a:rPr>
+                        <a:t>Status Ready · 2 GB buffer · 1 MB max message · 200 connections · 600 producers · 600 consumers</a:t>
+                      </a:r>
+                    </a:p>
+                  </a:txBody>
+                  <a:tcPr marL="64008" marR="64008" marT="27432" marB="27432">
+                    <a:solidFill>
+                      <a:srgbClr val="FFFFFF"/>
+                    </a:solidFill>
+                  </a:tcPr>
+                </a:tc>
+              </a:tr>
+              <a:tr h="378822">
+                <a:tc>
+                  <a:txBody>
+                    <a:bodyPr wrap="square"/>
+                    <a:lstStyle/>
+                    <a:p>
+                      <a:r>
+                        <a:rPr sz="950" b="1">
+                          <a:solidFill>
+                            <a:srgbClr val="111111"/>
+                          </a:solidFill>
+                          <a:latin typeface="Arial"/>
+                        </a:rPr>
+                        <a:t>Message client</a:t>
+                      </a:r>
+                    </a:p>
+                  </a:txBody>
+                  <a:tcPr marL="64008" marR="64008" marT="27432" marB="27432">
+                    <a:solidFill>
+                      <a:srgbClr val="FFFFFF"/>
+                    </a:solidFill>
+                  </a:tcPr>
+                </a:tc>
+                <a:tc>
+                  <a:txBody>
+                    <a:bodyPr wrap="square"/>
+                    <a:lstStyle/>
+                    <a:p>
+                      <a:r>
+                        <a:rPr sz="950" b="0">
+                          <a:solidFill>
+                            <a:srgbClr val="111111"/>
+                          </a:solidFill>
+                          <a:latin typeface="Arial"/>
+                        </a:rPr>
+                        <a:t>emis-s4hdev-client · namespace ssm/s4h/dev</a:t>
+                      </a:r>
+                    </a:p>
+                  </a:txBody>
+                  <a:tcPr marL="64008" marR="64008" marT="27432" marB="27432">
+                    <a:solidFill>
+                      <a:srgbClr val="FFFFFF"/>
+                    </a:solidFill>
+                  </a:tcPr>
+                </a:tc>
+              </a:tr>
+              <a:tr h="378822">
+                <a:tc>
+                  <a:txBody>
+                    <a:bodyPr wrap="square"/>
+                    <a:lstStyle/>
+                    <a:p>
+                      <a:r>
+                        <a:rPr sz="950" b="1">
+                          <a:solidFill>
+                            <a:srgbClr val="111111"/>
+                          </a:solidFill>
+                          <a:latin typeface="Arial"/>
+                        </a:rPr>
+                        <a:t>Working queue</a:t>
+                      </a:r>
+                    </a:p>
+                  </a:txBody>
+                  <a:tcPr marL="64008" marR="64008" marT="27432" marB="27432">
+                    <a:solidFill>
+                      <a:srgbClr val="FFFFFF"/>
+                    </a:solidFill>
+                  </a:tcPr>
+                </a:tc>
+                <a:tc>
+                  <a:txBody>
+                    <a:bodyPr wrap="square"/>
+                    <a:lstStyle/>
+                    <a:p>
+                      <a:r>
+                        <a:rPr sz="950" b="0">
+                          <a:solidFill>
+                            <a:srgbClr val="111111"/>
+                          </a:solidFill>
+                          <a:latin typeface="Arial"/>
+                        </a:rPr>
+                        <a:t>ssm/s4h/dev/s4h-dev-ses-events (non-exclusive) — service entry sheet events</a:t>
+                      </a:r>
+                    </a:p>
+                  </a:txBody>
+                  <a:tcPr marL="64008" marR="64008" marT="27432" marB="27432">
+                    <a:solidFill>
+                      <a:srgbClr val="FFFFFF"/>
+                    </a:solidFill>
+                  </a:tcPr>
+                </a:tc>
+              </a:tr>
+              <a:tr h="378828">
+                <a:tc>
+                  <a:txBody>
+                    <a:bodyPr wrap="square"/>
+                    <a:lstStyle/>
+                    <a:p>
+                      <a:r>
+                        <a:rPr sz="950" b="1">
+                          <a:solidFill>
+                            <a:srgbClr val="111111"/>
+                          </a:solidFill>
+                          <a:latin typeface="Arial"/>
+                        </a:rPr>
+                        <a:t>Proof-of-concept flow</a:t>
+                      </a:r>
+                    </a:p>
+                  </a:txBody>
+                  <a:tcPr marL="64008" marR="64008" marT="27432" marB="27432">
+                    <a:solidFill>
+                      <a:srgbClr val="FFFFFF"/>
+                    </a:solidFill>
+                  </a:tcPr>
+                </a:tc>
+                <a:tc>
+                  <a:txBody>
+                    <a:bodyPr wrap="square"/>
+                    <a:lstStyle/>
+                    <a:p>
+                      <a:r>
+                        <a:rPr sz="950" b="0">
+                          <a:solidFill>
+                            <a:srgbClr val="111111"/>
+                          </a:solidFill>
+                          <a:latin typeface="Arial"/>
+                        </a:rPr>
+                        <a:t>EventMesh_POC in the Proof of Concepts package — the consumer pattern already tried</a:t>
+                      </a:r>
+                    </a:p>
+                  </a:txBody>
+                  <a:tcPr marL="64008" marR="64008" marT="27432" marB="27432">
+                    <a:solidFill>
+                      <a:srgbClr val="FFFFFF"/>
+                    </a:solidFill>
+                  </a:tcPr>
+                </a:tc>
+              </a:tr>
+            </a:tbl>
+          </a:graphicData>
+        </a:graphic>
+      </p:graphicFrame>
+      <p:sp>
+        <p:nvSpPr>
+          <p:cNvPr id="7" name="TextBox 6"/>
+          <p:cNvSpPr txBox="1"/>
+          <p:nvPr/>
+        </p:nvSpPr>
+        <p:spPr>
+          <a:xfrm>
+            <a:off x="640080" y="4572000"/>
+            <a:ext cx="8229600" cy="274320"/>
+          </a:xfrm>
+          <a:prstGeom prst="rect">
+            <a:avLst/>
+          </a:prstGeom>
+          <a:noFill/>
+        </p:spPr>
+        <p:txBody>
+          <a:bodyPr wrap="square" lIns="0" rIns="0" tIns="0" bIns="0">
+            <a:spAutoFit/>
+          </a:bodyPr>
+          <a:lstStyle/>
+          <a:p>
+            <a:pPr algn="l"/>
+            <a:r>
+              <a:rPr sz="1250" b="1">
+                <a:solidFill>
+                  <a:srgbClr val="111111"/>
+                </a:solidFill>
+                <a:latin typeface="Arial"/>
+              </a:rPr>
+              <a:t>Target intake-queue design (per environment)</a:t>
+            </a:r>
+          </a:p>
+        </p:txBody>
+      </p:sp>
+      <p:graphicFrame>
+        <p:nvGraphicFramePr>
+          <p:cNvPr id="8" name="Table 7"/>
+          <p:cNvGraphicFramePr>
+            <a:graphicFrameLocks noGrp="1"/>
+          </p:cNvGraphicFramePr>
+          <p:nvPr/>
+        </p:nvGraphicFramePr>
+        <p:xfrm>
+          <a:off x="640080" y="4892040"/>
+          <a:ext cx="8412480" cy="2879054"/>
+        </p:xfrm>
+        <a:graphic>
+          <a:graphicData uri="http://schemas.openxmlformats.org/drawingml/2006/table">
+            <a:tbl>
+              <a:tblPr firstRow="1" bandRow="1">
+                <a:tableStyleId>{5C22544A-7EE6-4342-B048-85BDC9FD1C3A}</a:tableStyleId>
+              </a:tblPr>
+              <a:tblGrid>
+                <a:gridCol w="2194560"/>
+                <a:gridCol w="6217920"/>
+              </a:tblGrid>
+              <a:tr h="292608">
+                <a:tc>
+                  <a:txBody>
+                    <a:bodyPr wrap="square"/>
+                    <a:lstStyle/>
+                    <a:p>
+                      <a:r>
+                        <a:rPr sz="1050" b="1">
+                          <a:solidFill>
+                            <a:srgbClr val="111111"/>
+                          </a:solidFill>
+                          <a:latin typeface="Arial"/>
+                        </a:rPr>
+                        <a:t>Setting</a:t>
+                      </a:r>
+                    </a:p>
+                  </a:txBody>
+                  <a:tcPr marL="64008" marR="64008" marT="27432" marB="27432">
+                    <a:solidFill>
+                      <a:srgbClr val="92D050"/>
+                    </a:solidFill>
+                  </a:tcPr>
+                </a:tc>
+                <a:tc>
+                  <a:txBody>
+                    <a:bodyPr wrap="square"/>
+                    <a:lstStyle/>
+                    <a:p>
+                      <a:r>
+                        <a:rPr sz="1050" b="1">
+                          <a:solidFill>
+                            <a:srgbClr val="111111"/>
+                          </a:solidFill>
+                          <a:latin typeface="Arial"/>
+                        </a:rPr>
+                        <a:t>Value and reason</a:t>
+                      </a:r>
+                    </a:p>
+                  </a:txBody>
+                  <a:tcPr marL="64008" marR="64008" marT="27432" marB="27432">
+                    <a:solidFill>
+                      <a:srgbClr val="92D050"/>
+                    </a:solidFill>
+                  </a:tcPr>
+                </a:tc>
+              </a:tr>
+              <a:tr h="431074">
+                <a:tc>
+                  <a:txBody>
+                    <a:bodyPr wrap="square"/>
+                    <a:lstStyle/>
+                    <a:p>
+                      <a:r>
+                        <a:rPr sz="950" b="1">
+                          <a:solidFill>
+                            <a:srgbClr val="111111"/>
+                          </a:solidFill>
+                          <a:latin typeface="Arial"/>
+                        </a:rPr>
+                        <a:t>Name</a:t>
+                      </a:r>
+                    </a:p>
+                  </a:txBody>
+                  <a:tcPr marL="64008" marR="64008" marT="27432" marB="27432">
+                    <a:solidFill>
+                      <a:srgbClr val="FFFFFF"/>
+                    </a:solidFill>
+                  </a:tcPr>
+                </a:tc>
+                <a:tc>
+                  <a:txBody>
+                    <a:bodyPr wrap="square"/>
+                    <a:lstStyle/>
+                    <a:p>
+                      <a:r>
+                        <a:rPr sz="950" b="0">
+                          <a:solidFill>
+                            <a:srgbClr val="111111"/>
+                          </a:solidFill>
+                          <a:latin typeface="Arial"/>
+                        </a:rPr>
+                        <a:t>ssm/s4h/{env}/{data-set}-events — one queue per data set, following the existing convention</a:t>
+                      </a:r>
+                    </a:p>
+                  </a:txBody>
+                  <a:tcPr marL="64008" marR="64008" marT="27432" marB="27432">
+                    <a:solidFill>
+                      <a:srgbClr val="FFFFFF"/>
+                    </a:solidFill>
+                  </a:tcPr>
+                </a:tc>
+              </a:tr>
+              <a:tr h="431074">
+                <a:tc>
+                  <a:txBody>
+                    <a:bodyPr wrap="square"/>
+                    <a:lstStyle/>
+                    <a:p>
+                      <a:r>
+                        <a:rPr sz="950" b="1">
+                          <a:solidFill>
+                            <a:srgbClr val="111111"/>
+                          </a:solidFill>
+                          <a:latin typeface="Arial"/>
+                        </a:rPr>
+                        <a:t>Access type</a:t>
+                      </a:r>
+                    </a:p>
+                  </a:txBody>
+                  <a:tcPr marL="64008" marR="64008" marT="27432" marB="27432">
+                    <a:solidFill>
+                      <a:srgbClr val="FFFFFF"/>
+                    </a:solidFill>
+                  </a:tcPr>
+                </a:tc>
+                <a:tc>
+                  <a:txBody>
+                    <a:bodyPr wrap="square"/>
+                    <a:lstStyle/>
+                    <a:p>
+                      <a:r>
+                        <a:rPr sz="950" b="0">
+                          <a:solidFill>
+                            <a:srgbClr val="111111"/>
+                          </a:solidFill>
+                          <a:latin typeface="Arial"/>
+                        </a:rPr>
+                        <a:t>Non-exclusive — allows parallel consumers later</a:t>
+                      </a:r>
+                    </a:p>
+                  </a:txBody>
+                  <a:tcPr marL="64008" marR="64008" marT="27432" marB="27432">
+                    <a:solidFill>
+                      <a:srgbClr val="FFFFFF"/>
+                    </a:solidFill>
+                  </a:tcPr>
+                </a:tc>
+              </a:tr>
+              <a:tr h="431074">
+                <a:tc>
+                  <a:txBody>
+                    <a:bodyPr wrap="square"/>
+                    <a:lstStyle/>
+                    <a:p>
+                      <a:r>
+                        <a:rPr sz="950" b="1">
+                          <a:solidFill>
+                            <a:srgbClr val="111111"/>
+                          </a:solidFill>
+                          <a:latin typeface="Arial"/>
+                        </a:rPr>
+                        <a:t>Message size</a:t>
+                      </a:r>
+                    </a:p>
+                  </a:txBody>
+                  <a:tcPr marL="64008" marR="64008" marT="27432" marB="27432">
+                    <a:solidFill>
+                      <a:srgbClr val="FFFFFF"/>
+                    </a:solidFill>
+                  </a:tcPr>
+                </a:tc>
+                <a:tc>
+                  <a:txBody>
+                    <a:bodyPr wrap="square"/>
+                    <a:lstStyle/>
+                    <a:p>
+                      <a:r>
+                        <a:rPr sz="950" b="0">
+                          <a:solidFill>
+                            <a:srgbClr val="111111"/>
+                          </a:solidFill>
+                          <a:latin typeface="Arial"/>
+                        </a:rPr>
+                        <a:t>1 MB (default) — notices carry IDs only, far below the cap</a:t>
+                      </a:r>
+                    </a:p>
+                  </a:txBody>
+                  <a:tcPr marL="64008" marR="64008" marT="27432" marB="27432">
+                    <a:solidFill>
+                      <a:srgbClr val="FFFFFF"/>
+                    </a:solidFill>
+                  </a:tcPr>
+                </a:tc>
+              </a:tr>
+              <a:tr h="431074">
+                <a:tc>
+                  <a:txBody>
+                    <a:bodyPr wrap="square"/>
+                    <a:lstStyle/>
+                    <a:p>
+                      <a:r>
+                        <a:rPr sz="950" b="1">
+                          <a:solidFill>
+                            <a:srgbClr val="111111"/>
+                          </a:solidFill>
+                          <a:latin typeface="Arial"/>
+                        </a:rPr>
+                        <a:t>Redelivery</a:t>
+                      </a:r>
+                    </a:p>
+                  </a:txBody>
+                  <a:tcPr marL="64008" marR="64008" marT="27432" marB="27432">
+                    <a:solidFill>
+                      <a:srgbClr val="FFFFFF"/>
+                    </a:solidFill>
+                  </a:tcPr>
+                </a:tc>
+                <a:tc>
+                  <a:txBody>
+                    <a:bodyPr wrap="square"/>
+                    <a:lstStyle/>
+                    <a:p>
+                      <a:r>
+                        <a:rPr sz="950" b="0">
+                          <a:solidFill>
+                            <a:srgbClr val="111111"/>
+                          </a:solidFill>
+                          <a:latin typeface="Arial"/>
+                        </a:rPr>
+                        <a:t>Maximum 5 attempts, then move to the dead-message queue</a:t>
+                      </a:r>
+                    </a:p>
+                  </a:txBody>
+                  <a:tcPr marL="64008" marR="64008" marT="27432" marB="27432">
+                    <a:solidFill>
+                      <a:srgbClr val="FFFFFF"/>
+                    </a:solidFill>
+                  </a:tcPr>
+                </a:tc>
+              </a:tr>
+              <a:tr h="431074">
+                <a:tc>
+                  <a:txBody>
+                    <a:bodyPr wrap="square"/>
+                    <a:lstStyle/>
+                    <a:p>
+                      <a:r>
+                        <a:rPr sz="950" b="1">
+                          <a:solidFill>
+                            <a:srgbClr val="111111"/>
+                          </a:solidFill>
+                          <a:latin typeface="Arial"/>
+                        </a:rPr>
+                        <a:t>Dead-message queue</a:t>
+                      </a:r>
+                    </a:p>
+                  </a:txBody>
+                  <a:tcPr marL="64008" marR="64008" marT="27432" marB="27432">
+                    <a:solidFill>
+                      <a:srgbClr val="FFFFFF"/>
+                    </a:solidFill>
+                  </a:tcPr>
+                </a:tc>
+                <a:tc>
+                  <a:txBody>
+                    <a:bodyPr wrap="square"/>
+                    <a:lstStyle/>
+                    <a:p>
+                      <a:r>
+                        <a:rPr sz="950" b="0">
+                          <a:solidFill>
+                            <a:srgbClr val="111111"/>
+                          </a:solidFill>
+                          <a:latin typeface="Arial"/>
+                        </a:rPr>
+                        <a:t>ssm/s4h/{env}/dmq — one per environment. The dialog default “None” must never be used: rejected notices would be discarded silently</a:t>
+                      </a:r>
+                    </a:p>
+                  </a:txBody>
+                  <a:tcPr marL="64008" marR="64008" marT="27432" marB="27432">
+                    <a:solidFill>
+                      <a:srgbClr val="FFFFFF"/>
+                    </a:solidFill>
+                  </a:tcPr>
+                </a:tc>
+              </a:tr>
+              <a:tr h="431076">
+                <a:tc>
+                  <a:txBody>
+                    <a:bodyPr wrap="square"/>
+                    <a:lstStyle/>
+                    <a:p>
+                      <a:r>
+                        <a:rPr sz="950" b="1">
+                          <a:solidFill>
+                            <a:srgbClr val="111111"/>
+                          </a:solidFill>
+                          <a:latin typeface="Arial"/>
+                        </a:rPr>
+                        <a:t>Time to live</a:t>
+                      </a:r>
+                    </a:p>
+                  </a:txBody>
+                  <a:tcPr marL="64008" marR="64008" marT="27432" marB="27432">
+                    <a:solidFill>
+                      <a:srgbClr val="FFFFFF"/>
+                    </a:solidFill>
+                  </a:tcPr>
+                </a:tc>
+                <a:tc>
+                  <a:txBody>
+                    <a:bodyPr wrap="square"/>
+                    <a:lstStyle/>
+                    <a:p>
+                      <a:r>
+                        <a:rPr sz="950" b="0">
+                          <a:solidFill>
+                            <a:srgbClr val="111111"/>
+                          </a:solidFill>
+                          <a:latin typeface="Arial"/>
+                        </a:rPr>
+                        <a:t>604,800 s (7 days) — a notice survives a long-weekend outage</a:t>
+                      </a:r>
+                    </a:p>
+                  </a:txBody>
+                  <a:tcPr marL="64008" marR="64008" marT="27432" marB="27432">
+                    <a:solidFill>
+                      <a:srgbClr val="FFFFFF"/>
+                    </a:solidFill>
+                  </a:tcPr>
+                </a:tc>
+              </a:tr>
+            </a:tbl>
+          </a:graphicData>
+        </a:graphic>
+      </p:graphicFrame>
+      <p:sp>
+        <p:nvSpPr>
+          <p:cNvPr id="9" name="TextBox 8"/>
+          <p:cNvSpPr txBox="1"/>
+          <p:nvPr/>
+        </p:nvSpPr>
+        <p:spPr>
+          <a:xfrm>
+            <a:off x="9418320" y="1371600"/>
+            <a:ext cx="8229600" cy="274320"/>
+          </a:xfrm>
+          <a:prstGeom prst="rect">
+            <a:avLst/>
+          </a:prstGeom>
+          <a:noFill/>
+        </p:spPr>
+        <p:txBody>
+          <a:bodyPr wrap="square" lIns="0" rIns="0" tIns="0" bIns="0">
+            <a:spAutoFit/>
+          </a:bodyPr>
+          <a:lstStyle/>
+          <a:p>
+            <a:pPr algn="l"/>
+            <a:r>
+              <a:rPr sz="1250" b="1">
+                <a:solidFill>
+                  <a:srgbClr val="111111"/>
+                </a:solidFill>
+                <a:latin typeface="Arial"/>
+              </a:rPr>
+              <a:t>CPI consumer settings (one receiver flow per intake queue)</a:t>
+            </a:r>
+          </a:p>
+        </p:txBody>
+      </p:sp>
+      <p:graphicFrame>
+        <p:nvGraphicFramePr>
+          <p:cNvPr id="10" name="Table 9"/>
+          <p:cNvGraphicFramePr>
+            <a:graphicFrameLocks noGrp="1"/>
+          </p:cNvGraphicFramePr>
+          <p:nvPr/>
+        </p:nvGraphicFramePr>
+        <p:xfrm>
+          <a:off x="9418320" y="1691640"/>
+          <a:ext cx="8229600" cy="2502408"/>
+        </p:xfrm>
+        <a:graphic>
+          <a:graphicData uri="http://schemas.openxmlformats.org/drawingml/2006/table">
+            <a:tbl>
+              <a:tblPr firstRow="1" bandRow="1">
+                <a:tableStyleId>{5C22544A-7EE6-4342-B048-85BDC9FD1C3A}</a:tableStyleId>
+              </a:tblPr>
+              <a:tblGrid>
+                <a:gridCol w="1920240"/>
+                <a:gridCol w="1463040"/>
+                <a:gridCol w="4846320"/>
+              </a:tblGrid>
+              <a:tr h="292608">
+                <a:tc>
+                  <a:txBody>
+                    <a:bodyPr wrap="square"/>
+                    <a:lstStyle/>
+                    <a:p>
+                      <a:r>
+                        <a:rPr sz="1050" b="1">
+                          <a:solidFill>
+                            <a:srgbClr val="111111"/>
+                          </a:solidFill>
+                          <a:latin typeface="Arial"/>
+                        </a:rPr>
+                        <a:t>Setting</a:t>
+                      </a:r>
+                    </a:p>
+                  </a:txBody>
+                  <a:tcPr marL="64008" marR="64008" marT="27432" marB="27432">
+                    <a:solidFill>
+                      <a:srgbClr val="92D050"/>
+                    </a:solidFill>
+                  </a:tcPr>
+                </a:tc>
+                <a:tc>
+                  <a:txBody>
+                    <a:bodyPr wrap="square"/>
+                    <a:lstStyle/>
+                    <a:p>
+                      <a:r>
+                        <a:rPr sz="1050" b="1">
+                          <a:solidFill>
+                            <a:srgbClr val="111111"/>
+                          </a:solidFill>
+                          <a:latin typeface="Arial"/>
+                        </a:rPr>
+                        <a:t>Value</a:t>
+                      </a:r>
+                    </a:p>
+                  </a:txBody>
+                  <a:tcPr marL="64008" marR="64008" marT="27432" marB="27432">
+                    <a:solidFill>
+                      <a:srgbClr val="92D050"/>
+                    </a:solidFill>
+                  </a:tcPr>
+                </a:tc>
+                <a:tc>
+                  <a:txBody>
+                    <a:bodyPr wrap="square"/>
+                    <a:lstStyle/>
+                    <a:p>
+                      <a:r>
+                        <a:rPr sz="1050" b="1">
+                          <a:solidFill>
+                            <a:srgbClr val="111111"/>
+                          </a:solidFill>
+                          <a:latin typeface="Arial"/>
+                        </a:rPr>
+                        <a:t>Reason</a:t>
+                      </a:r>
+                    </a:p>
+                  </a:txBody>
+                  <a:tcPr marL="64008" marR="64008" marT="27432" marB="27432">
+                    <a:solidFill>
+                      <a:srgbClr val="92D050"/>
+                    </a:solidFill>
+                  </a:tcPr>
+                </a:tc>
+              </a:tr>
+              <a:tr h="441960">
+                <a:tc>
+                  <a:txBody>
+                    <a:bodyPr wrap="square"/>
+                    <a:lstStyle/>
+                    <a:p>
+                      <a:r>
+                        <a:rPr sz="950" b="1">
+                          <a:solidFill>
+                            <a:srgbClr val="111111"/>
+                          </a:solidFill>
+                          <a:latin typeface="Arial"/>
+                        </a:rPr>
+                        <a:t>Concurrent processes</a:t>
+                      </a:r>
+                    </a:p>
+                  </a:txBody>
+                  <a:tcPr marL="64008" marR="64008" marT="27432" marB="27432">
+                    <a:solidFill>
+                      <a:srgbClr val="FFFFFF"/>
+                    </a:solidFill>
+                  </a:tcPr>
+                </a:tc>
+                <a:tc>
+                  <a:txBody>
+                    <a:bodyPr wrap="square"/>
+                    <a:lstStyle/>
+                    <a:p>
+                      <a:r>
+                        <a:rPr sz="950" b="0">
+                          <a:solidFill>
+                            <a:srgbClr val="111111"/>
+                          </a:solidFill>
+                          <a:latin typeface="Arial"/>
+                        </a:rPr>
+                        <a:t>1</a:t>
+                      </a:r>
+                    </a:p>
+                  </a:txBody>
+                  <a:tcPr marL="64008" marR="64008" marT="27432" marB="27432">
+                    <a:solidFill>
+                      <a:srgbClr val="FFFFFF"/>
+                    </a:solidFill>
+                  </a:tcPr>
+                </a:tc>
+                <a:tc>
+                  <a:txBody>
+                    <a:bodyPr wrap="square"/>
+                    <a:lstStyle/>
+                    <a:p>
+                      <a:r>
+                        <a:rPr sz="950" b="0">
+                          <a:solidFill>
+                            <a:srgbClr val="111111"/>
+                          </a:solidFill>
+                          <a:latin typeface="Arial"/>
+                        </a:rPr>
+                        <a:t>preserves arrival order; safe to raise later — the newest-change-wins rule makes order errors harmless</a:t>
+                      </a:r>
+                    </a:p>
+                  </a:txBody>
+                  <a:tcPr marL="64008" marR="64008" marT="27432" marB="27432">
+                    <a:solidFill>
+                      <a:srgbClr val="FFFFFF"/>
+                    </a:solidFill>
+                  </a:tcPr>
+                </a:tc>
+              </a:tr>
+              <a:tr h="441960">
+                <a:tc>
+                  <a:txBody>
+                    <a:bodyPr wrap="square"/>
+                    <a:lstStyle/>
+                    <a:p>
+                      <a:r>
+                        <a:rPr sz="950" b="1">
+                          <a:solidFill>
+                            <a:srgbClr val="111111"/>
+                          </a:solidFill>
+                          <a:latin typeface="Arial"/>
+                        </a:rPr>
+                        <a:t>Prefetched messages</a:t>
+                      </a:r>
+                    </a:p>
+                  </a:txBody>
+                  <a:tcPr marL="64008" marR="64008" marT="27432" marB="27432">
+                    <a:solidFill>
+                      <a:srgbClr val="FFFFFF"/>
+                    </a:solidFill>
+                  </a:tcPr>
+                </a:tc>
+                <a:tc>
+                  <a:txBody>
+                    <a:bodyPr wrap="square"/>
+                    <a:lstStyle/>
+                    <a:p>
+                      <a:r>
+                        <a:rPr sz="950" b="0">
+                          <a:solidFill>
+                            <a:srgbClr val="111111"/>
+                          </a:solidFill>
+                          <a:latin typeface="Arial"/>
+                        </a:rPr>
+                        <a:t>5 (default)</a:t>
+                      </a:r>
+                    </a:p>
+                  </a:txBody>
+                  <a:tcPr marL="64008" marR="64008" marT="27432" marB="27432">
+                    <a:solidFill>
+                      <a:srgbClr val="FFFFFF"/>
+                    </a:solidFill>
+                  </a:tcPr>
+                </a:tc>
+                <a:tc>
+                  <a:txBody>
+                    <a:bodyPr wrap="square"/>
+                    <a:lstStyle/>
+                    <a:p>
+                      <a:r>
+                        <a:rPr sz="950" b="0">
+                          <a:solidFill>
+                            <a:srgbClr val="111111"/>
+                          </a:solidFill>
+                          <a:latin typeface="Arial"/>
+                        </a:rPr>
+                        <a:t>no reason to change</a:t>
+                      </a:r>
+                    </a:p>
+                  </a:txBody>
+                  <a:tcPr marL="64008" marR="64008" marT="27432" marB="27432">
+                    <a:solidFill>
+                      <a:srgbClr val="FFFFFF"/>
+                    </a:solidFill>
+                  </a:tcPr>
+                </a:tc>
+              </a:tr>
+              <a:tr h="441960">
+                <a:tc>
+                  <a:txBody>
+                    <a:bodyPr wrap="square"/>
+                    <a:lstStyle/>
+                    <a:p>
+                      <a:r>
+                        <a:rPr sz="950" b="1">
+                          <a:solidFill>
+                            <a:srgbClr val="111111"/>
+                          </a:solidFill>
+                          <a:latin typeface="Arial"/>
+                        </a:rPr>
+                        <a:t>Consume expired</a:t>
+                      </a:r>
+                    </a:p>
+                  </a:txBody>
+                  <a:tcPr marL="64008" marR="64008" marT="27432" marB="27432">
+                    <a:solidFill>
+                      <a:srgbClr val="FFFFFF"/>
+                    </a:solidFill>
+                  </a:tcPr>
+                </a:tc>
+                <a:tc>
+                  <a:txBody>
+                    <a:bodyPr wrap="square"/>
+                    <a:lstStyle/>
+                    <a:p>
+                      <a:r>
+                        <a:rPr sz="950" b="0">
+                          <a:solidFill>
+                            <a:srgbClr val="111111"/>
+                          </a:solidFill>
+                          <a:latin typeface="Arial"/>
+                        </a:rPr>
+                        <a:t>Off</a:t>
+                      </a:r>
+                    </a:p>
+                  </a:txBody>
+                  <a:tcPr marL="64008" marR="64008" marT="27432" marB="27432">
+                    <a:solidFill>
+                      <a:srgbClr val="FFFFFF"/>
+                    </a:solidFill>
+                  </a:tcPr>
+                </a:tc>
+                <a:tc>
+                  <a:txBody>
+                    <a:bodyPr wrap="square"/>
+                    <a:lstStyle/>
+                    <a:p>
+                      <a:r>
+                        <a:rPr sz="950" b="0">
+                          <a:solidFill>
+                            <a:srgbClr val="111111"/>
+                          </a:solidFill>
+                          <a:latin typeface="Arial"/>
+                        </a:rPr>
+                        <a:t>an expired notice is covered by the next timed check — never process stale notices</a:t>
+                      </a:r>
+                    </a:p>
+                  </a:txBody>
+                  <a:tcPr marL="64008" marR="64008" marT="27432" marB="27432">
+                    <a:solidFill>
+                      <a:srgbClr val="FFFFFF"/>
+                    </a:solidFill>
+                  </a:tcPr>
+                </a:tc>
+              </a:tr>
+              <a:tr h="441960">
+                <a:tc>
+                  <a:txBody>
+                    <a:bodyPr wrap="square"/>
+                    <a:lstStyle/>
+                    <a:p>
+                      <a:r>
+                        <a:rPr sz="950" b="1">
+                          <a:solidFill>
+                            <a:srgbClr val="111111"/>
+                          </a:solidFill>
+                          <a:latin typeface="Arial"/>
+                        </a:rPr>
+                        <a:t>Max retries</a:t>
+                      </a:r>
+                    </a:p>
+                  </a:txBody>
+                  <a:tcPr marL="64008" marR="64008" marT="27432" marB="27432">
+                    <a:solidFill>
+                      <a:srgbClr val="FFFFFF"/>
+                    </a:solidFill>
+                  </a:tcPr>
+                </a:tc>
+                <a:tc>
+                  <a:txBody>
+                    <a:bodyPr wrap="square"/>
+                    <a:lstStyle/>
+                    <a:p>
+                      <a:r>
+                        <a:rPr sz="950" b="0">
+                          <a:solidFill>
+                            <a:srgbClr val="111111"/>
+                          </a:solidFill>
+                          <a:latin typeface="Arial"/>
+                        </a:rPr>
+                        <a:t>5 → REJECTED</a:t>
+                      </a:r>
+                    </a:p>
+                  </a:txBody>
+                  <a:tcPr marL="64008" marR="64008" marT="27432" marB="27432">
+                    <a:solidFill>
+                      <a:srgbClr val="FFFFFF"/>
+                    </a:solidFill>
+                  </a:tcPr>
+                </a:tc>
+                <a:tc>
+                  <a:txBody>
+                    <a:bodyPr wrap="square"/>
+                    <a:lstStyle/>
+                    <a:p>
+                      <a:r>
+                        <a:rPr sz="950" b="0">
+                          <a:solidFill>
+                            <a:srgbClr val="111111"/>
+                          </a:solidFill>
+                          <a:latin typeface="Arial"/>
+                        </a:rPr>
+                        <a:t>after 5 failures the broker moves the notice to the dead-message queue</a:t>
+                      </a:r>
+                    </a:p>
+                  </a:txBody>
+                  <a:tcPr marL="64008" marR="64008" marT="27432" marB="27432">
+                    <a:solidFill>
+                      <a:srgbClr val="FFFFFF"/>
+                    </a:solidFill>
+                  </a:tcPr>
+                </a:tc>
+              </a:tr>
+              <a:tr h="441960">
+                <a:tc>
+                  <a:txBody>
+                    <a:bodyPr wrap="square"/>
+                    <a:lstStyle/>
+                    <a:p>
+                      <a:r>
+                        <a:rPr sz="950" b="1">
+                          <a:solidFill>
+                            <a:srgbClr val="111111"/>
+                          </a:solidFill>
+                          <a:latin typeface="Arial"/>
+                        </a:rPr>
+                        <a:t>On dead-message queue</a:t>
+                      </a:r>
+                    </a:p>
+                  </a:txBody>
+                  <a:tcPr marL="64008" marR="64008" marT="27432" marB="27432">
+                    <a:solidFill>
+                      <a:srgbClr val="FFFFFF"/>
+                    </a:solidFill>
+                  </a:tcPr>
+                </a:tc>
+                <a:tc>
+                  <a:txBody>
+                    <a:bodyPr wrap="square"/>
+                    <a:lstStyle/>
+                    <a:p>
+                      <a:r>
+                        <a:rPr sz="950" b="0">
+                          <a:solidFill>
+                            <a:srgbClr val="111111"/>
+                          </a:solidFill>
+                          <a:latin typeface="Arial"/>
+                        </a:rPr>
+                        <a:t>Alert</a:t>
+                      </a:r>
+                    </a:p>
+                  </a:txBody>
+                  <a:tcPr marL="64008" marR="64008" marT="27432" marB="27432">
+                    <a:solidFill>
+                      <a:srgbClr val="FFFFFF"/>
+                    </a:solidFill>
+                  </a:tcPr>
+                </a:tc>
+                <a:tc>
+                  <a:txBody>
+                    <a:bodyPr wrap="square"/>
+                    <a:lstStyle/>
+                    <a:p>
+                      <a:r>
+                        <a:rPr sz="950" b="0">
+                          <a:solidFill>
+                            <a:srgbClr val="111111"/>
+                          </a:solidFill>
+                          <a:latin typeface="Arial"/>
+                        </a:rPr>
+                        <a:t>same alert path as the delivery error queues — a named owner is told; nothing is silent</a:t>
+                      </a:r>
+                    </a:p>
+                  </a:txBody>
+                  <a:tcPr marL="64008" marR="64008" marT="27432" marB="27432">
+                    <a:solidFill>
+                      <a:srgbClr val="FFFFFF"/>
+                    </a:solidFill>
+                  </a:tcPr>
+                </a:tc>
+              </a:tr>
+            </a:tbl>
+          </a:graphicData>
+        </a:graphic>
+      </p:graphicFrame>
+      <p:sp>
+        <p:nvSpPr>
+          <p:cNvPr id="11" name="TextBox 10"/>
+          <p:cNvSpPr txBox="1"/>
+          <p:nvPr/>
+        </p:nvSpPr>
+        <p:spPr>
+          <a:xfrm>
+            <a:off x="9418320" y="4572000"/>
+            <a:ext cx="8229600" cy="274320"/>
+          </a:xfrm>
+          <a:prstGeom prst="rect">
+            <a:avLst/>
+          </a:prstGeom>
+          <a:noFill/>
+        </p:spPr>
+        <p:txBody>
+          <a:bodyPr wrap="square" lIns="0" rIns="0" tIns="0" bIns="0">
+            <a:spAutoFit/>
+          </a:bodyPr>
+          <a:lstStyle/>
+          <a:p>
+            <a:pPr algn="l"/>
+            <a:r>
+              <a:rPr sz="1250" b="1">
+                <a:solidFill>
+                  <a:srgbClr val="111111"/>
+                </a:solidFill>
+                <a:latin typeface="Arial"/>
+              </a:rPr>
+              <a:t>The full-payload read — why the notice never carries the data</a:t>
+            </a:r>
+          </a:p>
+        </p:txBody>
+      </p:sp>
+      <p:sp>
+        <p:nvSpPr>
+          <p:cNvPr id="12" name="Rounded Rectangle 11"/>
+          <p:cNvSpPr/>
+          <p:nvPr/>
+        </p:nvSpPr>
+        <p:spPr>
+          <a:xfrm>
+            <a:off x="9418320" y="4892040"/>
+            <a:ext cx="8229600" cy="3017520"/>
+          </a:xfrm>
+          <a:prstGeom prst="roundRect">
+            <a:avLst>
+              <a:gd name="adj" fmla="val 3000"/>
+            </a:avLst>
+          </a:prstGeom>
+          <a:solidFill>
+            <a:srgbClr val="F4F6F9"/>
+          </a:solidFill>
+          <a:ln w="15875">
+            <a:solidFill>
+              <a:srgbClr val="111111"/>
+            </a:solidFill>
+          </a:ln>
+          <a:effectLst/>
+        </p:spPr>
+        <p:style>
+          <a:lnRef idx="1">
+            <a:schemeClr val="accent1"/>
+          </a:lnRef>
+          <a:fillRef idx="3">
+            <a:schemeClr val="accent1"/>
+          </a:fillRef>
+          <a:effectRef idx="2">
+            <a:schemeClr val="accent1"/>
+          </a:effectRef>
+          <a:fontRef idx="minor">
+            <a:schemeClr val="lt1"/>
+          </a:fontRef>
+        </p:style>
+        <p:txBody>
+          <a:bodyPr rtlCol="0" anchor="t" wrap="square" lIns="164592" rIns="164592" tIns="109728" bIns="73152"/>
+          <a:lstStyle/>
+          <a:p>
+            <a:pPr algn="ctr"/>
+            <a:r>
+              <a:rPr sz="1000" b="1">
+                <a:solidFill>
+                  <a:srgbClr val="1F3864"/>
+                </a:solidFill>
+                <a:latin typeface="Arial"/>
+              </a:rPr>
+              <a:t>Sequence: </a:t>
+            </a:r>
+            <a:r>
+              <a:rPr sz="1000">
+                <a:solidFill>
+                  <a:srgbClr val="111111"/>
+                </a:solidFill>
+                <a:latin typeface="Arial"/>
+              </a:rPr>
+              <a:t>notice (record ID) → intake queue → CPI receiver → read the full record from the released S/4 API → wrap in the standard message → subscription check → deliver.</a:t>
+            </a:r>
+          </a:p>
+          <a:p>
+            <a:pPr>
+              <a:spcBef>
+                <a:spcPts val="600"/>
+              </a:spcBef>
+            </a:pPr>
+            <a:r>
+              <a:rPr sz="1000" b="1">
+                <a:solidFill>
+                  <a:srgbClr val="1F3864"/>
+                </a:solidFill>
+                <a:latin typeface="Arial"/>
+              </a:rPr>
+              <a:t>1 · Never stale: </a:t>
+            </a:r>
+            <a:r>
+              <a:rPr sz="1000">
+                <a:solidFill>
+                  <a:srgbClr val="111111"/>
+                </a:solidFill>
+                <a:latin typeface="Arial"/>
+              </a:rPr>
+              <a:t>the record is read at processing time — a late or out-of-order notice cannot deliver old data.</a:t>
+            </a:r>
+          </a:p>
+          <a:p>
+            <a:pPr>
+              <a:spcBef>
+                <a:spcPts val="600"/>
+              </a:spcBef>
+            </a:pPr>
+            <a:r>
+              <a:rPr sz="1000" b="1">
+                <a:solidFill>
+                  <a:srgbClr val="1F3864"/>
+                </a:solidFill>
+                <a:latin typeface="Arial"/>
+              </a:rPr>
+              <a:t>2 · Secure: </a:t>
+            </a:r>
+            <a:r>
+              <a:rPr sz="1000">
+                <a:solidFill>
+                  <a:srgbClr val="111111"/>
+                </a:solidFill>
+                <a:latin typeface="Arial"/>
+              </a:rPr>
+              <a:t>business data never sits on the event broker; it moves only over the authorised API call, after the subscription check.</a:t>
+            </a:r>
+          </a:p>
+          <a:p>
+            <a:pPr>
+              <a:spcBef>
+                <a:spcPts val="600"/>
+              </a:spcBef>
+            </a:pPr>
+            <a:r>
+              <a:rPr sz="1000" b="1">
+                <a:solidFill>
+                  <a:srgbClr val="1F3864"/>
+                </a:solidFill>
+                <a:latin typeface="Arial"/>
+              </a:rPr>
+              <a:t>3 · Within limits by design: </a:t>
+            </a:r>
+            <a:r>
+              <a:rPr sz="1000">
+                <a:solidFill>
+                  <a:srgbClr val="111111"/>
+                </a:solidFill>
+                <a:latin typeface="Arial"/>
+              </a:rPr>
+              <a:t>notices stay tiny — record size never constrains the event path (1 MB cap is irrelevant).</a:t>
+            </a:r>
+          </a:p>
+          <a:p>
+            <a:pPr>
+              <a:spcBef>
+                <a:spcPts val="600"/>
+              </a:spcBef>
+            </a:pPr>
+            <a:r>
+              <a:rPr sz="1000" b="1">
+                <a:solidFill>
+                  <a:srgbClr val="1F3864"/>
+                </a:solidFill>
+                <a:latin typeface="Arial"/>
+              </a:rPr>
+              <a:t>4 · One code path: </a:t>
+            </a:r>
+            <a:r>
+              <a:rPr sz="1000">
+                <a:solidFill>
+                  <a:srgbClr val="111111"/>
+                </a:solidFill>
+                <a:latin typeface="Arial"/>
+              </a:rPr>
+              <a:t>a notice and a timed-check hit produce identical read-and-wrap processing — switching a data set between the two changes nothing downstream.</a:t>
+            </a:r>
+          </a:p>
+        </p:txBody>
+      </p:sp>
+      <p:sp>
+        <p:nvSpPr>
+          <p:cNvPr id="13" name="TextBox 12"/>
+          <p:cNvSpPr txBox="1"/>
+          <p:nvPr/>
+        </p:nvSpPr>
+        <p:spPr>
+          <a:xfrm>
+            <a:off x="640080" y="8183879"/>
+            <a:ext cx="17007840" cy="365760"/>
+          </a:xfrm>
+          <a:prstGeom prst="rect">
+            <a:avLst/>
+          </a:prstGeom>
+          <a:noFill/>
+        </p:spPr>
+        <p:txBody>
+          <a:bodyPr wrap="square" lIns="0" rIns="0" tIns="0" bIns="0">
+            <a:spAutoFit/>
+          </a:bodyPr>
+          <a:lstStyle/>
+          <a:p>
+            <a:pPr algn="l"/>
+            <a:r>
+              <a:rPr sz="1150" b="1">
+                <a:solidFill>
+                  <a:srgbClr val="0F7A3D"/>
+                </a:solidFill>
+                <a:latin typeface="Arial"/>
+              </a:rPr>
+              <a:t>This is SAP’s intended pattern for business events: the notice tells CPI which record changed; the released API is where the data is read. Both halves are already proven in our tenant.</a:t>
+            </a:r>
           </a:p>
         </p:txBody>
       </p:sp>

</xml_diff>

<commit_message>
Outbound event enablement: live bindings evidence + complete to-add list
Event Monitor evidence folded into the build spec (13.1) and a new
deck appendix slide: three topics live and Acknowledged on
EMIS_COM_0092 (ServiceEntrySheet.Changed x5, BusinessPartner.Changed
x1, WarehouseOrder.TaskCreated x2), confirming the full production
topic pattern ssm/s4h/{env}/ce/sap/s4/beh/... The to-add binding list
now covers all eight data needs including the derived job financial
summary (no S/4 object of its own - timed-check composition).

Co-Authored-By: Claude Fable 5 <noreply@anthropic.com>
Claude-Session: https://claude.ai/code/session_01J9sMjqcGkRLhakCptK95KF
</commit_message>
<xml_diff>
--- a/docs/JAMS-WriteBack-Callback-S4-Key-Design-Decision-2.pptx
+++ b/docs/JAMS-WriteBack-Callback-S4-Key-Design-Decision-2.pptx
@@ -32,6 +32,7 @@
     <p:sldId id="269" r:id="rId17"/>
     <p:sldId id="270" r:id="rId18"/>
     <p:sldId id="285" r:id="rId35"/>
+    <p:sldId id="286" r:id="rId36"/>
   </p:sldIdLst>
   <p:sldSz cx="18288000" cy="10287000"/>
   <p:notesSz cx="10287000" cy="18288000"/>
@@ -25045,6 +25046,1389 @@
                 <a:latin typeface="Arial"/>
               </a:rPr>
               <a:t>This is SAP’s intended pattern for business events: the notice tells CPI which record changed; the released API is where the data is read. Both halves are already proven in our tenant.</a:t>
+            </a:r>
+          </a:p>
+        </p:txBody>
+      </p:sp>
+    </p:spTree>
+  </p:cSld>
+  <p:clrMapOvr>
+    <a:masterClrMapping/>
+  </p:clrMapOvr>
+</p:sld>
+</file>
+
+<file path=ppt/slides/slide25.xml><?xml version="1.0" encoding="utf-8"?>
+<p:sld xmlns:a="http://schemas.openxmlformats.org/drawingml/2006/main" xmlns:p="http://schemas.openxmlformats.org/presentationml/2006/main" xmlns:r="http://schemas.openxmlformats.org/officeDocument/2006/relationships">
+  <p:cSld>
+    <p:spTree>
+      <p:nvGrpSpPr>
+        <p:cNvPr id="1" name=""/>
+        <p:cNvGrpSpPr/>
+        <p:nvPr/>
+      </p:nvGrpSpPr>
+      <p:grpSpPr/>
+      <p:pic>
+        <p:nvPicPr>
+          <p:cNvPr id="2" name="Picture 1" descr="image.png"/>
+          <p:cNvPicPr>
+            <a:picLocks noChangeAspect="1"/>
+          </p:cNvPicPr>
+          <p:nvPr/>
+        </p:nvPicPr>
+        <p:blipFill>
+          <a:blip r:embed="rId2"/>
+          <a:stretch>
+            <a:fillRect/>
+          </a:stretch>
+        </p:blipFill>
+        <p:spPr>
+          <a:xfrm>
+            <a:off x="16188779" y="476250"/>
+            <a:ext cx="1337221" cy="419075"/>
+          </a:xfrm>
+          <a:prstGeom prst="rect">
+            <a:avLst/>
+          </a:prstGeom>
+        </p:spPr>
+      </p:pic>
+      <p:sp>
+        <p:nvSpPr>
+          <p:cNvPr id="3" name="TextBox 2"/>
+          <p:cNvSpPr txBox="1"/>
+          <p:nvPr/>
+        </p:nvSpPr>
+        <p:spPr>
+          <a:xfrm>
+            <a:off x="640080" y="320040"/>
+            <a:ext cx="16824960" cy="548640"/>
+          </a:xfrm>
+          <a:prstGeom prst="rect">
+            <a:avLst/>
+          </a:prstGeom>
+          <a:noFill/>
+        </p:spPr>
+        <p:txBody>
+          <a:bodyPr wrap="square" lIns="0" rIns="0" tIns="0" bIns="0">
+            <a:spAutoFit/>
+          </a:bodyPr>
+          <a:lstStyle/>
+          <a:p>
+            <a:r>
+              <a:rPr sz="2100" b="1">
+                <a:solidFill>
+                  <a:srgbClr val="1F3864"/>
+                </a:solidFill>
+                <a:latin typeface="Arial"/>
+              </a:rPr>
+              <a:t>Appendix – Outbound Event Enablement: What Is Live Today, and What to Add</a:t>
+            </a:r>
+          </a:p>
+        </p:txBody>
+      </p:sp>
+      <p:sp>
+        <p:nvSpPr>
+          <p:cNvPr id="4" name="TextBox 3"/>
+          <p:cNvSpPr txBox="1"/>
+          <p:nvPr/>
+        </p:nvSpPr>
+        <p:spPr>
+          <a:xfrm>
+            <a:off x="640080" y="850392"/>
+            <a:ext cx="16824960" cy="365760"/>
+          </a:xfrm>
+          <a:prstGeom prst="rect">
+            <a:avLst/>
+          </a:prstGeom>
+          <a:noFill/>
+        </p:spPr>
+        <p:txBody>
+          <a:bodyPr wrap="square" lIns="0" rIns="0" tIns="0" bIns="0">
+            <a:spAutoFit/>
+          </a:bodyPr>
+          <a:lstStyle/>
+          <a:p>
+            <a:r>
+              <a:rPr sz="1150" b="0">
+                <a:solidFill>
+                  <a:srgbClr val="595959"/>
+                </a:solidFill>
+                <a:latin typeface="Arial"/>
+              </a:rPr>
+              <a:t>From the channel’s own Event Monitor in our tenant. “Acknowledged” means the broker received the event successfully — the S/4-to-broker leg is proven in production configuration, not theory.</a:t>
+            </a:r>
+          </a:p>
+        </p:txBody>
+      </p:sp>
+      <p:sp>
+        <p:nvSpPr>
+          <p:cNvPr id="5" name="TextBox 4"/>
+          <p:cNvSpPr txBox="1"/>
+          <p:nvPr/>
+        </p:nvSpPr>
+        <p:spPr>
+          <a:xfrm>
+            <a:off x="640080" y="1417320"/>
+            <a:ext cx="10972800" cy="274320"/>
+          </a:xfrm>
+          <a:prstGeom prst="rect">
+            <a:avLst/>
+          </a:prstGeom>
+          <a:noFill/>
+        </p:spPr>
+        <p:txBody>
+          <a:bodyPr wrap="square" lIns="0" rIns="0" tIns="0" bIns="0">
+            <a:spAutoFit/>
+          </a:bodyPr>
+          <a:lstStyle/>
+          <a:p>
+            <a:r>
+              <a:rPr sz="1250" b="1">
+                <a:solidFill>
+                  <a:srgbClr val="111111"/>
+                </a:solidFill>
+                <a:latin typeface="Arial"/>
+              </a:rPr>
+              <a:t>Live now on channel EMIS_COM_0092 — all Acknowledged</a:t>
+            </a:r>
+          </a:p>
+        </p:txBody>
+      </p:sp>
+      <p:graphicFrame>
+        <p:nvGraphicFramePr>
+          <p:cNvPr id="6" name="Table 5"/>
+          <p:cNvGraphicFramePr>
+            <a:graphicFrameLocks noGrp="1"/>
+          </p:cNvGraphicFramePr>
+          <p:nvPr/>
+        </p:nvGraphicFramePr>
+        <p:xfrm>
+          <a:off x="640080" y="1737360"/>
+          <a:ext cx="17007840" cy="1458468"/>
+        </p:xfrm>
+        <a:graphic>
+          <a:graphicData uri="http://schemas.openxmlformats.org/drawingml/2006/table">
+            <a:tbl>
+              <a:tblPr firstRow="1" bandRow="1">
+                <a:tableStyleId>{5C22544A-7EE6-4342-B048-85BDC9FD1C3A}</a:tableStyleId>
+              </a:tblPr>
+              <a:tblGrid>
+                <a:gridCol w="10241280"/>
+                <a:gridCol w="1463040"/>
+                <a:gridCol w="5303520"/>
+              </a:tblGrid>
+              <a:tr h="292608">
+                <a:tc>
+                  <a:txBody>
+                    <a:bodyPr wrap="square"/>
+                    <a:lstStyle/>
+                    <a:p>
+                      <a:r>
+                        <a:rPr sz="1050" b="1">
+                          <a:solidFill>
+                            <a:srgbClr val="111111"/>
+                          </a:solidFill>
+                          <a:latin typeface="Arial"/>
+                        </a:rPr>
+                        <a:t>Live topic (full production format confirmed)</a:t>
+                      </a:r>
+                    </a:p>
+                  </a:txBody>
+                  <a:tcPr marL="64008" marR="64008" marT="27432" marB="27432">
+                    <a:solidFill>
+                      <a:srgbClr val="92D050"/>
+                    </a:solidFill>
+                  </a:tcPr>
+                </a:tc>
+                <a:tc>
+                  <a:txBody>
+                    <a:bodyPr wrap="square"/>
+                    <a:lstStyle/>
+                    <a:p>
+                      <a:r>
+                        <a:rPr sz="1050" b="1">
+                          <a:solidFill>
+                            <a:srgbClr val="111111"/>
+                          </a:solidFill>
+                          <a:latin typeface="Arial"/>
+                        </a:rPr>
+                        <a:t>Events seen</a:t>
+                      </a:r>
+                    </a:p>
+                  </a:txBody>
+                  <a:tcPr marL="64008" marR="64008" marT="27432" marB="27432">
+                    <a:solidFill>
+                      <a:srgbClr val="92D050"/>
+                    </a:solidFill>
+                  </a:tcPr>
+                </a:tc>
+                <a:tc>
+                  <a:txBody>
+                    <a:bodyPr wrap="square"/>
+                    <a:lstStyle/>
+                    <a:p>
+                      <a:r>
+                        <a:rPr sz="1050" b="1">
+                          <a:solidFill>
+                            <a:srgbClr val="111111"/>
+                          </a:solidFill>
+                          <a:latin typeface="Arial"/>
+                        </a:rPr>
+                        <a:t>Relevance</a:t>
+                      </a:r>
+                    </a:p>
+                  </a:txBody>
+                  <a:tcPr marL="64008" marR="64008" marT="27432" marB="27432">
+                    <a:solidFill>
+                      <a:srgbClr val="92D050"/>
+                    </a:solidFill>
+                  </a:tcPr>
+                </a:tc>
+              </a:tr>
+              <a:tr h="388620">
+                <a:tc>
+                  <a:txBody>
+                    <a:bodyPr wrap="square"/>
+                    <a:lstStyle/>
+                    <a:p>
+                      <a:r>
+                        <a:rPr sz="850" b="0">
+                          <a:solidFill>
+                            <a:srgbClr val="111111"/>
+                          </a:solidFill>
+                          <a:latin typeface="Consolas"/>
+                        </a:rPr>
+                        <a:t>ssm/s4h/dev/ce/sap/s4/beh/serviceentrysheet/v1/ServiceEntrySheet/Changed/v1</a:t>
+                      </a:r>
+                    </a:p>
+                  </a:txBody>
+                  <a:tcPr marL="64008" marR="64008" marT="27432" marB="27432">
+                    <a:solidFill>
+                      <a:srgbClr val="FFFFFF"/>
+                    </a:solidFill>
+                  </a:tcPr>
+                </a:tc>
+                <a:tc>
+                  <a:txBody>
+                    <a:bodyPr wrap="square"/>
+                    <a:lstStyle/>
+                    <a:p>
+                      <a:r>
+                        <a:rPr sz="950" b="0">
+                          <a:solidFill>
+                            <a:srgbClr val="111111"/>
+                          </a:solidFill>
+                          <a:latin typeface="Arial"/>
+                        </a:rPr>
+                        <a:t>5</a:t>
+                      </a:r>
+                    </a:p>
+                  </a:txBody>
+                  <a:tcPr marL="64008" marR="64008" marT="27432" marB="27432">
+                    <a:solidFill>
+                      <a:srgbClr val="FFFFFF"/>
+                    </a:solidFill>
+                  </a:tcPr>
+                </a:tc>
+                <a:tc>
+                  <a:txBody>
+                    <a:bodyPr wrap="square"/>
+                    <a:lstStyle/>
+                    <a:p>
+                      <a:r>
+                        <a:rPr sz="950" b="0">
+                          <a:solidFill>
+                            <a:srgbClr val="111111"/>
+                          </a:solidFill>
+                          <a:latin typeface="Arial"/>
+                        </a:rPr>
+                        <a:t>Part of the supplier invoice / RCTI flow — directly relevant</a:t>
+                      </a:r>
+                    </a:p>
+                  </a:txBody>
+                  <a:tcPr marL="64008" marR="64008" marT="27432" marB="27432">
+                    <a:solidFill>
+                      <a:srgbClr val="FFFFFF"/>
+                    </a:solidFill>
+                  </a:tcPr>
+                </a:tc>
+              </a:tr>
+              <a:tr h="388620">
+                <a:tc>
+                  <a:txBody>
+                    <a:bodyPr wrap="square"/>
+                    <a:lstStyle/>
+                    <a:p>
+                      <a:r>
+                        <a:rPr sz="850" b="0">
+                          <a:solidFill>
+                            <a:srgbClr val="111111"/>
+                          </a:solidFill>
+                          <a:latin typeface="Consolas"/>
+                        </a:rPr>
+                        <a:t>ssm/s4h/dev/ce/sap/s4/beh/businesspartner/v1/BusinessPartner/Changed/v1</a:t>
+                      </a:r>
+                    </a:p>
+                  </a:txBody>
+                  <a:tcPr marL="64008" marR="64008" marT="27432" marB="27432">
+                    <a:solidFill>
+                      <a:srgbClr val="FFFFFF"/>
+                    </a:solidFill>
+                  </a:tcPr>
+                </a:tc>
+                <a:tc>
+                  <a:txBody>
+                    <a:bodyPr wrap="square"/>
+                    <a:lstStyle/>
+                    <a:p>
+                      <a:r>
+                        <a:rPr sz="950" b="0">
+                          <a:solidFill>
+                            <a:srgbClr val="111111"/>
+                          </a:solidFill>
+                          <a:latin typeface="Arial"/>
+                        </a:rPr>
+                        <a:t>1</a:t>
+                      </a:r>
+                    </a:p>
+                  </a:txBody>
+                  <a:tcPr marL="64008" marR="64008" marT="27432" marB="27432">
+                    <a:solidFill>
+                      <a:srgbClr val="FFFFFF"/>
+                    </a:solidFill>
+                  </a:tcPr>
+                </a:tc>
+                <a:tc>
+                  <a:txBody>
+                    <a:bodyPr wrap="square"/>
+                    <a:lstStyle/>
+                    <a:p>
+                      <a:r>
+                        <a:rPr sz="950" b="0">
+                          <a:solidFill>
+                            <a:srgbClr val="111111"/>
+                          </a:solidFill>
+                          <a:latin typeface="Arial"/>
+                        </a:rPr>
+                        <a:t>Another team’s proof of concept — leave in place, independent</a:t>
+                      </a:r>
+                    </a:p>
+                  </a:txBody>
+                  <a:tcPr marL="64008" marR="64008" marT="27432" marB="27432">
+                    <a:solidFill>
+                      <a:srgbClr val="FFFFFF"/>
+                    </a:solidFill>
+                  </a:tcPr>
+                </a:tc>
+              </a:tr>
+              <a:tr h="388620">
+                <a:tc>
+                  <a:txBody>
+                    <a:bodyPr wrap="square"/>
+                    <a:lstStyle/>
+                    <a:p>
+                      <a:r>
+                        <a:rPr sz="850" b="0">
+                          <a:solidFill>
+                            <a:srgbClr val="111111"/>
+                          </a:solidFill>
+                          <a:latin typeface="Consolas"/>
+                        </a:rPr>
+                        <a:t>ssm/s4h/dev/ce/sap/s4/beh/WarehouseOrder/TaskCreated/v1</a:t>
+                      </a:r>
+                    </a:p>
+                  </a:txBody>
+                  <a:tcPr marL="64008" marR="64008" marT="27432" marB="27432">
+                    <a:solidFill>
+                      <a:srgbClr val="FFFFFF"/>
+                    </a:solidFill>
+                  </a:tcPr>
+                </a:tc>
+                <a:tc>
+                  <a:txBody>
+                    <a:bodyPr wrap="square"/>
+                    <a:lstStyle/>
+                    <a:p>
+                      <a:r>
+                        <a:rPr sz="950" b="0">
+                          <a:solidFill>
+                            <a:srgbClr val="111111"/>
+                          </a:solidFill>
+                          <a:latin typeface="Arial"/>
+                        </a:rPr>
+                        <a:t>2</a:t>
+                      </a:r>
+                    </a:p>
+                  </a:txBody>
+                  <a:tcPr marL="64008" marR="64008" marT="27432" marB="27432">
+                    <a:solidFill>
+                      <a:srgbClr val="FFFFFF"/>
+                    </a:solidFill>
+                  </a:tcPr>
+                </a:tc>
+                <a:tc>
+                  <a:txBody>
+                    <a:bodyPr wrap="square"/>
+                    <a:lstStyle/>
+                    <a:p>
+                      <a:r>
+                        <a:rPr sz="950" b="0">
+                          <a:solidFill>
+                            <a:srgbClr val="111111"/>
+                          </a:solidFill>
+                          <a:latin typeface="Arial"/>
+                        </a:rPr>
+                        <a:t>Another team’s proof of concept — leave in place, independent</a:t>
+                      </a:r>
+                    </a:p>
+                  </a:txBody>
+                  <a:tcPr marL="64008" marR="64008" marT="27432" marB="27432">
+                    <a:solidFill>
+                      <a:srgbClr val="FFFFFF"/>
+                    </a:solidFill>
+                  </a:tcPr>
+                </a:tc>
+              </a:tr>
+            </a:tbl>
+          </a:graphicData>
+        </a:graphic>
+      </p:graphicFrame>
+      <p:sp>
+        <p:nvSpPr>
+          <p:cNvPr id="7" name="TextBox 6"/>
+          <p:cNvSpPr txBox="1"/>
+          <p:nvPr/>
+        </p:nvSpPr>
+        <p:spPr>
+          <a:xfrm>
+            <a:off x="640080" y="3611880"/>
+            <a:ext cx="16824960" cy="320040"/>
+          </a:xfrm>
+          <a:prstGeom prst="rect">
+            <a:avLst/>
+          </a:prstGeom>
+          <a:noFill/>
+        </p:spPr>
+        <p:txBody>
+          <a:bodyPr wrap="square" lIns="0" rIns="0" tIns="0" bIns="0">
+            <a:spAutoFit/>
+          </a:bodyPr>
+          <a:lstStyle/>
+          <a:p>
+            <a:r>
+              <a:rPr sz="1100" b="1">
+                <a:solidFill>
+                  <a:srgbClr val="0F7A3D"/>
+                </a:solidFill>
+                <a:latin typeface="Arial"/>
+              </a:rPr>
+              <a:t>Confirmed topic pattern:  ssm/s4h/{env}/ce/sap/s4/beh/{object}/v1/{Object}/{Event}/v1  — the intake queues subscribe with exactly this pattern.</a:t>
+            </a:r>
+          </a:p>
+        </p:txBody>
+      </p:sp>
+      <p:sp>
+        <p:nvSpPr>
+          <p:cNvPr id="8" name="TextBox 7"/>
+          <p:cNvSpPr txBox="1"/>
+          <p:nvPr/>
+        </p:nvSpPr>
+        <p:spPr>
+          <a:xfrm>
+            <a:off x="640080" y="4114800"/>
+            <a:ext cx="10972800" cy="274320"/>
+          </a:xfrm>
+          <a:prstGeom prst="rect">
+            <a:avLst/>
+          </a:prstGeom>
+          <a:noFill/>
+        </p:spPr>
+        <p:txBody>
+          <a:bodyPr wrap="square" lIns="0" rIns="0" tIns="0" bIns="0">
+            <a:spAutoFit/>
+          </a:bodyPr>
+          <a:lstStyle/>
+          <a:p>
+            <a:r>
+              <a:rPr sz="1250" b="1">
+                <a:solidFill>
+                  <a:srgbClr val="111111"/>
+                </a:solidFill>
+                <a:latin typeface="Arial"/>
+              </a:rPr>
+              <a:t>Bindings to add — same app, same channel, ~2 minutes each</a:t>
+            </a:r>
+          </a:p>
+        </p:txBody>
+      </p:sp>
+      <p:graphicFrame>
+        <p:nvGraphicFramePr>
+          <p:cNvPr id="9" name="Table 8"/>
+          <p:cNvGraphicFramePr>
+            <a:graphicFrameLocks noGrp="1"/>
+          </p:cNvGraphicFramePr>
+          <p:nvPr/>
+        </p:nvGraphicFramePr>
+        <p:xfrm>
+          <a:off x="640080" y="4434840"/>
+          <a:ext cx="17007840" cy="3706368"/>
+        </p:xfrm>
+        <a:graphic>
+          <a:graphicData uri="http://schemas.openxmlformats.org/drawingml/2006/table">
+            <a:tbl>
+              <a:tblPr firstRow="1" bandRow="1">
+                <a:tableStyleId>{5C22544A-7EE6-4342-B048-85BDC9FD1C3A}</a:tableStyleId>
+              </a:tblPr>
+              <a:tblGrid>
+                <a:gridCol w="3108960"/>
+                <a:gridCol w="3108960"/>
+                <a:gridCol w="2194560"/>
+                <a:gridCol w="8595360"/>
+              </a:tblGrid>
+              <a:tr h="292608">
+                <a:tc>
+                  <a:txBody>
+                    <a:bodyPr wrap="square"/>
+                    <a:lstStyle/>
+                    <a:p>
+                      <a:r>
+                        <a:rPr sz="1050" b="1">
+                          <a:solidFill>
+                            <a:srgbClr val="111111"/>
+                          </a:solidFill>
+                          <a:latin typeface="Arial"/>
+                        </a:rPr>
+                        <a:t>Data set</a:t>
+                      </a:r>
+                    </a:p>
+                  </a:txBody>
+                  <a:tcPr marL="64008" marR="64008" marT="27432" marB="27432">
+                    <a:solidFill>
+                      <a:srgbClr val="92D050"/>
+                    </a:solidFill>
+                  </a:tcPr>
+                </a:tc>
+                <a:tc>
+                  <a:txBody>
+                    <a:bodyPr wrap="square"/>
+                    <a:lstStyle/>
+                    <a:p>
+                      <a:r>
+                        <a:rPr sz="1050" b="1">
+                          <a:solidFill>
+                            <a:srgbClr val="111111"/>
+                          </a:solidFill>
+                          <a:latin typeface="Arial"/>
+                        </a:rPr>
+                        <a:t>Object type to select</a:t>
+                      </a:r>
+                    </a:p>
+                  </a:txBody>
+                  <a:tcPr marL="64008" marR="64008" marT="27432" marB="27432">
+                    <a:solidFill>
+                      <a:srgbClr val="92D050"/>
+                    </a:solidFill>
+                  </a:tcPr>
+                </a:tc>
+                <a:tc>
+                  <a:txBody>
+                    <a:bodyPr wrap="square"/>
+                    <a:lstStyle/>
+                    <a:p>
+                      <a:r>
+                        <a:rPr sz="1050" b="1">
+                          <a:solidFill>
+                            <a:srgbClr val="111111"/>
+                          </a:solidFill>
+                          <a:latin typeface="Arial"/>
+                        </a:rPr>
+                        <a:t>Events to tick</a:t>
+                      </a:r>
+                    </a:p>
+                  </a:txBody>
+                  <a:tcPr marL="64008" marR="64008" marT="27432" marB="27432">
+                    <a:solidFill>
+                      <a:srgbClr val="92D050"/>
+                    </a:solidFill>
+                  </a:tcPr>
+                </a:tc>
+                <a:tc>
+                  <a:txBody>
+                    <a:bodyPr wrap="square"/>
+                    <a:lstStyle/>
+                    <a:p>
+                      <a:r>
+                        <a:rPr sz="1050" b="1">
+                          <a:solidFill>
+                            <a:srgbClr val="111111"/>
+                          </a:solidFill>
+                          <a:latin typeface="Arial"/>
+                        </a:rPr>
+                        <a:t>Note</a:t>
+                      </a:r>
+                    </a:p>
+                  </a:txBody>
+                  <a:tcPr marL="64008" marR="64008" marT="27432" marB="27432">
+                    <a:solidFill>
+                      <a:srgbClr val="92D050"/>
+                    </a:solidFill>
+                  </a:tcPr>
+                </a:tc>
+              </a:tr>
+              <a:tr h="426720">
+                <a:tc>
+                  <a:txBody>
+                    <a:bodyPr wrap="square"/>
+                    <a:lstStyle/>
+                    <a:p>
+                      <a:r>
+                        <a:rPr sz="950" b="1">
+                          <a:solidFill>
+                            <a:srgbClr val="111111"/>
+                          </a:solidFill>
+                          <a:latin typeface="Arial"/>
+                        </a:rPr>
+                        <a:t>Service Orders</a:t>
+                      </a:r>
+                    </a:p>
+                  </a:txBody>
+                  <a:tcPr marL="64008" marR="64008" marT="27432" marB="27432">
+                    <a:solidFill>
+                      <a:srgbClr val="FFFFFF"/>
+                    </a:solidFill>
+                  </a:tcPr>
+                </a:tc>
+                <a:tc>
+                  <a:txBody>
+                    <a:bodyPr wrap="square"/>
+                    <a:lstStyle/>
+                    <a:p>
+                      <a:r>
+                        <a:rPr sz="950" b="0">
+                          <a:solidFill>
+                            <a:srgbClr val="111111"/>
+                          </a:solidFill>
+                          <a:latin typeface="Arial"/>
+                        </a:rPr>
+                        <a:t>ServiceOrder</a:t>
+                      </a:r>
+                    </a:p>
+                  </a:txBody>
+                  <a:tcPr marL="64008" marR="64008" marT="27432" marB="27432">
+                    <a:solidFill>
+                      <a:srgbClr val="FFFFFF"/>
+                    </a:solidFill>
+                  </a:tcPr>
+                </a:tc>
+                <a:tc>
+                  <a:txBody>
+                    <a:bodyPr wrap="square"/>
+                    <a:lstStyle/>
+                    <a:p>
+                      <a:r>
+                        <a:rPr sz="950" b="0">
+                          <a:solidFill>
+                            <a:srgbClr val="111111"/>
+                          </a:solidFill>
+                          <a:latin typeface="Arial"/>
+                        </a:rPr>
+                        <a:t>Created · Changed</a:t>
+                      </a:r>
+                    </a:p>
+                  </a:txBody>
+                  <a:tcPr marL="64008" marR="64008" marT="27432" marB="27432">
+                    <a:solidFill>
+                      <a:srgbClr val="FFFFFF"/>
+                    </a:solidFill>
+                  </a:tcPr>
+                </a:tc>
+                <a:tc>
+                  <a:txBody>
+                    <a:bodyPr wrap="square"/>
+                    <a:lstStyle/>
+                    <a:p>
+                      <a:r>
+                        <a:rPr sz="950" b="0">
+                          <a:solidFill>
+                            <a:srgbClr val="111111"/>
+                          </a:solidFill>
+                          <a:latin typeface="Arial"/>
+                        </a:rPr>
+                        <a:t/>
+                      </a:r>
+                    </a:p>
+                  </a:txBody>
+                  <a:tcPr marL="64008" marR="64008" marT="27432" marB="27432">
+                    <a:solidFill>
+                      <a:srgbClr val="FFFFFF"/>
+                    </a:solidFill>
+                  </a:tcPr>
+                </a:tc>
+              </a:tr>
+              <a:tr h="426720">
+                <a:tc>
+                  <a:txBody>
+                    <a:bodyPr wrap="square"/>
+                    <a:lstStyle/>
+                    <a:p>
+                      <a:r>
+                        <a:rPr sz="950" b="1">
+                          <a:solidFill>
+                            <a:srgbClr val="111111"/>
+                          </a:solidFill>
+                          <a:latin typeface="Arial"/>
+                        </a:rPr>
+                        <a:t>Enterprise Project</a:t>
+                      </a:r>
+                    </a:p>
+                  </a:txBody>
+                  <a:tcPr marL="64008" marR="64008" marT="27432" marB="27432">
+                    <a:solidFill>
+                      <a:srgbClr val="FFFFFF"/>
+                    </a:solidFill>
+                  </a:tcPr>
+                </a:tc>
+                <a:tc>
+                  <a:txBody>
+                    <a:bodyPr wrap="square"/>
+                    <a:lstStyle/>
+                    <a:p>
+                      <a:r>
+                        <a:rPr sz="950" b="0">
+                          <a:solidFill>
+                            <a:srgbClr val="111111"/>
+                          </a:solidFill>
+                          <a:latin typeface="Arial"/>
+                        </a:rPr>
+                        <a:t>EnterpriseProject</a:t>
+                      </a:r>
+                    </a:p>
+                  </a:txBody>
+                  <a:tcPr marL="64008" marR="64008" marT="27432" marB="27432">
+                    <a:solidFill>
+                      <a:srgbClr val="FFFFFF"/>
+                    </a:solidFill>
+                  </a:tcPr>
+                </a:tc>
+                <a:tc>
+                  <a:txBody>
+                    <a:bodyPr wrap="square"/>
+                    <a:lstStyle/>
+                    <a:p>
+                      <a:r>
+                        <a:rPr sz="950" b="0">
+                          <a:solidFill>
+                            <a:srgbClr val="111111"/>
+                          </a:solidFill>
+                          <a:latin typeface="Arial"/>
+                        </a:rPr>
+                        <a:t>Created · Changed</a:t>
+                      </a:r>
+                    </a:p>
+                  </a:txBody>
+                  <a:tcPr marL="64008" marR="64008" marT="27432" marB="27432">
+                    <a:solidFill>
+                      <a:srgbClr val="FFFFFF"/>
+                    </a:solidFill>
+                  </a:tcPr>
+                </a:tc>
+                <a:tc>
+                  <a:txBody>
+                    <a:bodyPr wrap="square"/>
+                    <a:lstStyle/>
+                    <a:p>
+                      <a:r>
+                        <a:rPr sz="950" b="0">
+                          <a:solidFill>
+                            <a:srgbClr val="111111"/>
+                          </a:solidFill>
+                          <a:latin typeface="Arial"/>
+                        </a:rPr>
+                        <a:t/>
+                      </a:r>
+                    </a:p>
+                  </a:txBody>
+                  <a:tcPr marL="64008" marR="64008" marT="27432" marB="27432">
+                    <a:solidFill>
+                      <a:srgbClr val="FFFFFF"/>
+                    </a:solidFill>
+                  </a:tcPr>
+                </a:tc>
+              </a:tr>
+              <a:tr h="426720">
+                <a:tc>
+                  <a:txBody>
+                    <a:bodyPr wrap="square"/>
+                    <a:lstStyle/>
+                    <a:p>
+                      <a:r>
+                        <a:rPr sz="950" b="1">
+                          <a:solidFill>
+                            <a:srgbClr val="111111"/>
+                          </a:solidFill>
+                          <a:latin typeface="Arial"/>
+                        </a:rPr>
+                        <a:t>Customer Invoice</a:t>
+                      </a:r>
+                    </a:p>
+                  </a:txBody>
+                  <a:tcPr marL="64008" marR="64008" marT="27432" marB="27432">
+                    <a:solidFill>
+                      <a:srgbClr val="FFFFFF"/>
+                    </a:solidFill>
+                  </a:tcPr>
+                </a:tc>
+                <a:tc>
+                  <a:txBody>
+                    <a:bodyPr wrap="square"/>
+                    <a:lstStyle/>
+                    <a:p>
+                      <a:r>
+                        <a:rPr sz="950" b="0">
+                          <a:solidFill>
+                            <a:srgbClr val="111111"/>
+                          </a:solidFill>
+                          <a:latin typeface="Arial"/>
+                        </a:rPr>
+                        <a:t>BillingDocument</a:t>
+                      </a:r>
+                    </a:p>
+                  </a:txBody>
+                  <a:tcPr marL="64008" marR="64008" marT="27432" marB="27432">
+                    <a:solidFill>
+                      <a:srgbClr val="FFFFFF"/>
+                    </a:solidFill>
+                  </a:tcPr>
+                </a:tc>
+                <a:tc>
+                  <a:txBody>
+                    <a:bodyPr wrap="square"/>
+                    <a:lstStyle/>
+                    <a:p>
+                      <a:r>
+                        <a:rPr sz="950" b="0">
+                          <a:solidFill>
+                            <a:srgbClr val="111111"/>
+                          </a:solidFill>
+                          <a:latin typeface="Arial"/>
+                        </a:rPr>
+                        <a:t>Created · Changed</a:t>
+                      </a:r>
+                    </a:p>
+                  </a:txBody>
+                  <a:tcPr marL="64008" marR="64008" marT="27432" marB="27432">
+                    <a:solidFill>
+                      <a:srgbClr val="FFFFFF"/>
+                    </a:solidFill>
+                  </a:tcPr>
+                </a:tc>
+                <a:tc>
+                  <a:txBody>
+                    <a:bodyPr wrap="square"/>
+                    <a:lstStyle/>
+                    <a:p>
+                      <a:r>
+                        <a:rPr sz="950" b="0">
+                          <a:solidFill>
+                            <a:srgbClr val="111111"/>
+                          </a:solidFill>
+                          <a:latin typeface="Arial"/>
+                        </a:rPr>
+                        <a:t/>
+                      </a:r>
+                    </a:p>
+                  </a:txBody>
+                  <a:tcPr marL="64008" marR="64008" marT="27432" marB="27432">
+                    <a:solidFill>
+                      <a:srgbClr val="FFFFFF"/>
+                    </a:solidFill>
+                  </a:tcPr>
+                </a:tc>
+              </a:tr>
+              <a:tr h="426720">
+                <a:tc>
+                  <a:txBody>
+                    <a:bodyPr wrap="square"/>
+                    <a:lstStyle/>
+                    <a:p>
+                      <a:r>
+                        <a:rPr sz="950" b="1">
+                          <a:solidFill>
+                            <a:srgbClr val="111111"/>
+                          </a:solidFill>
+                          <a:latin typeface="Arial"/>
+                        </a:rPr>
+                        <a:t>Supplier Invoice / RCTI</a:t>
+                      </a:r>
+                    </a:p>
+                  </a:txBody>
+                  <a:tcPr marL="64008" marR="64008" marT="27432" marB="27432">
+                    <a:solidFill>
+                      <a:srgbClr val="FFFFFF"/>
+                    </a:solidFill>
+                  </a:tcPr>
+                </a:tc>
+                <a:tc>
+                  <a:txBody>
+                    <a:bodyPr wrap="square"/>
+                    <a:lstStyle/>
+                    <a:p>
+                      <a:r>
+                        <a:rPr sz="950" b="0">
+                          <a:solidFill>
+                            <a:srgbClr val="111111"/>
+                          </a:solidFill>
+                          <a:latin typeface="Arial"/>
+                        </a:rPr>
+                        <a:t>SupplierInvoice</a:t>
+                      </a:r>
+                    </a:p>
+                  </a:txBody>
+                  <a:tcPr marL="64008" marR="64008" marT="27432" marB="27432">
+                    <a:solidFill>
+                      <a:srgbClr val="FFFFFF"/>
+                    </a:solidFill>
+                  </a:tcPr>
+                </a:tc>
+                <a:tc>
+                  <a:txBody>
+                    <a:bodyPr wrap="square"/>
+                    <a:lstStyle/>
+                    <a:p>
+                      <a:r>
+                        <a:rPr sz="950" b="0">
+                          <a:solidFill>
+                            <a:srgbClr val="111111"/>
+                          </a:solidFill>
+                          <a:latin typeface="Arial"/>
+                        </a:rPr>
+                        <a:t>Created · Changed</a:t>
+                      </a:r>
+                    </a:p>
+                  </a:txBody>
+                  <a:tcPr marL="64008" marR="64008" marT="27432" marB="27432">
+                    <a:solidFill>
+                      <a:srgbClr val="FFFFFF"/>
+                    </a:solidFill>
+                  </a:tcPr>
+                </a:tc>
+                <a:tc>
+                  <a:txBody>
+                    <a:bodyPr wrap="square"/>
+                    <a:lstStyle/>
+                    <a:p>
+                      <a:r>
+                        <a:rPr sz="950" b="0">
+                          <a:solidFill>
+                            <a:srgbClr val="111111"/>
+                          </a:solidFill>
+                          <a:latin typeface="Arial"/>
+                        </a:rPr>
+                        <a:t>ServiceEntrySheet, already live, covers the entry-sheet step of the same flow</a:t>
+                      </a:r>
+                    </a:p>
+                  </a:txBody>
+                  <a:tcPr marL="64008" marR="64008" marT="27432" marB="27432">
+                    <a:solidFill>
+                      <a:srgbClr val="FFFFFF"/>
+                    </a:solidFill>
+                  </a:tcPr>
+                </a:tc>
+              </a:tr>
+              <a:tr h="426720">
+                <a:tc>
+                  <a:txBody>
+                    <a:bodyPr wrap="square"/>
+                    <a:lstStyle/>
+                    <a:p>
+                      <a:r>
+                        <a:rPr sz="950" b="1">
+                          <a:solidFill>
+                            <a:srgbClr val="111111"/>
+                          </a:solidFill>
+                          <a:latin typeface="Arial"/>
+                        </a:rPr>
+                        <a:t>Purchase Orders</a:t>
+                      </a:r>
+                    </a:p>
+                  </a:txBody>
+                  <a:tcPr marL="64008" marR="64008" marT="27432" marB="27432">
+                    <a:solidFill>
+                      <a:srgbClr val="FFFFFF"/>
+                    </a:solidFill>
+                  </a:tcPr>
+                </a:tc>
+                <a:tc>
+                  <a:txBody>
+                    <a:bodyPr wrap="square"/>
+                    <a:lstStyle/>
+                    <a:p>
+                      <a:r>
+                        <a:rPr sz="950" b="0">
+                          <a:solidFill>
+                            <a:srgbClr val="111111"/>
+                          </a:solidFill>
+                          <a:latin typeface="Arial"/>
+                        </a:rPr>
+                        <a:t>PurchaseOrder</a:t>
+                      </a:r>
+                    </a:p>
+                  </a:txBody>
+                  <a:tcPr marL="64008" marR="64008" marT="27432" marB="27432">
+                    <a:solidFill>
+                      <a:srgbClr val="FFFFFF"/>
+                    </a:solidFill>
+                  </a:tcPr>
+                </a:tc>
+                <a:tc>
+                  <a:txBody>
+                    <a:bodyPr wrap="square"/>
+                    <a:lstStyle/>
+                    <a:p>
+                      <a:r>
+                        <a:rPr sz="950" b="0">
+                          <a:solidFill>
+                            <a:srgbClr val="111111"/>
+                          </a:solidFill>
+                          <a:latin typeface="Arial"/>
+                        </a:rPr>
+                        <a:t>Created · Changed</a:t>
+                      </a:r>
+                    </a:p>
+                  </a:txBody>
+                  <a:tcPr marL="64008" marR="64008" marT="27432" marB="27432">
+                    <a:solidFill>
+                      <a:srgbClr val="FFFFFF"/>
+                    </a:solidFill>
+                  </a:tcPr>
+                </a:tc>
+                <a:tc>
+                  <a:txBody>
+                    <a:bodyPr wrap="square"/>
+                    <a:lstStyle/>
+                    <a:p>
+                      <a:r>
+                        <a:rPr sz="950" b="0">
+                          <a:solidFill>
+                            <a:srgbClr val="111111"/>
+                          </a:solidFill>
+                          <a:latin typeface="Arial"/>
+                        </a:rPr>
+                        <a:t/>
+                      </a:r>
+                    </a:p>
+                  </a:txBody>
+                  <a:tcPr marL="64008" marR="64008" marT="27432" marB="27432">
+                    <a:solidFill>
+                      <a:srgbClr val="FFFFFF"/>
+                    </a:solidFill>
+                  </a:tcPr>
+                </a:tc>
+              </a:tr>
+              <a:tr h="426720">
+                <a:tc>
+                  <a:txBody>
+                    <a:bodyPr wrap="square"/>
+                    <a:lstStyle/>
+                    <a:p>
+                      <a:r>
+                        <a:rPr sz="950" b="1">
+                          <a:solidFill>
+                            <a:srgbClr val="111111"/>
+                          </a:solidFill>
+                          <a:latin typeface="Arial"/>
+                        </a:rPr>
+                        <a:t>Available Stock</a:t>
+                      </a:r>
+                    </a:p>
+                  </a:txBody>
+                  <a:tcPr marL="64008" marR="64008" marT="27432" marB="27432">
+                    <a:solidFill>
+                      <a:srgbClr val="FFFFFF"/>
+                    </a:solidFill>
+                  </a:tcPr>
+                </a:tc>
+                <a:tc>
+                  <a:txBody>
+                    <a:bodyPr wrap="square"/>
+                    <a:lstStyle/>
+                    <a:p>
+                      <a:r>
+                        <a:rPr sz="950" b="0">
+                          <a:solidFill>
+                            <a:srgbClr val="111111"/>
+                          </a:solidFill>
+                          <a:latin typeface="Arial"/>
+                        </a:rPr>
+                        <a:t>MaterialDocument</a:t>
+                      </a:r>
+                    </a:p>
+                  </a:txBody>
+                  <a:tcPr marL="64008" marR="64008" marT="27432" marB="27432">
+                    <a:solidFill>
+                      <a:srgbClr val="FFFFFF"/>
+                    </a:solidFill>
+                  </a:tcPr>
+                </a:tc>
+                <a:tc>
+                  <a:txBody>
+                    <a:bodyPr wrap="square"/>
+                    <a:lstStyle/>
+                    <a:p>
+                      <a:r>
+                        <a:rPr sz="950" b="0">
+                          <a:solidFill>
+                            <a:srgbClr val="111111"/>
+                          </a:solidFill>
+                          <a:latin typeface="Arial"/>
+                        </a:rPr>
+                        <a:t>Created</a:t>
+                      </a:r>
+                    </a:p>
+                  </a:txBody>
+                  <a:tcPr marL="64008" marR="64008" marT="27432" marB="27432">
+                    <a:solidFill>
+                      <a:srgbClr val="FFFFFF"/>
+                    </a:solidFill>
+                  </a:tcPr>
+                </a:tc>
+                <a:tc>
+                  <a:txBody>
+                    <a:bodyPr wrap="square"/>
+                    <a:lstStyle/>
+                    <a:p>
+                      <a:r>
+                        <a:rPr sz="950" b="0">
+                          <a:solidFill>
+                            <a:srgbClr val="111111"/>
+                          </a:solidFill>
+                          <a:latin typeface="Arial"/>
+                        </a:rPr>
+                        <a:t>Goods movements are what change stock — verify in the dialog; timed check if unsuitable</a:t>
+                      </a:r>
+                    </a:p>
+                  </a:txBody>
+                  <a:tcPr marL="64008" marR="64008" marT="27432" marB="27432">
+                    <a:solidFill>
+                      <a:srgbClr val="FFFFFF"/>
+                    </a:solidFill>
+                  </a:tcPr>
+                </a:tc>
+              </a:tr>
+              <a:tr h="426720">
+                <a:tc>
+                  <a:txBody>
+                    <a:bodyPr wrap="square"/>
+                    <a:lstStyle/>
+                    <a:p>
+                      <a:r>
+                        <a:rPr sz="950" b="1">
+                          <a:solidFill>
+                            <a:srgbClr val="111111"/>
+                          </a:solidFill>
+                          <a:latin typeface="Arial"/>
+                        </a:rPr>
+                        <a:t>Project Time &amp; Equipment</a:t>
+                      </a:r>
+                    </a:p>
+                  </a:txBody>
+                  <a:tcPr marL="64008" marR="64008" marT="27432" marB="27432">
+                    <a:solidFill>
+                      <a:srgbClr val="FFFFFF"/>
+                    </a:solidFill>
+                  </a:tcPr>
+                </a:tc>
+                <a:tc>
+                  <a:txBody>
+                    <a:bodyPr wrap="square"/>
+                    <a:lstStyle/>
+                    <a:p>
+                      <a:r>
+                        <a:rPr sz="950" b="0">
+                          <a:solidFill>
+                            <a:srgbClr val="111111"/>
+                          </a:solidFill>
+                          <a:latin typeface="Arial"/>
+                        </a:rPr>
+                        <a:t>— no event assumed</a:t>
+                      </a:r>
+                    </a:p>
+                  </a:txBody>
+                  <a:tcPr marL="64008" marR="64008" marT="27432" marB="27432">
+                    <a:solidFill>
+                      <a:srgbClr val="FFFFFF"/>
+                    </a:solidFill>
+                  </a:tcPr>
+                </a:tc>
+                <a:tc>
+                  <a:txBody>
+                    <a:bodyPr wrap="square"/>
+                    <a:lstStyle/>
+                    <a:p>
+                      <a:r>
+                        <a:rPr sz="950" b="0">
+                          <a:solidFill>
+                            <a:srgbClr val="111111"/>
+                          </a:solidFill>
+                          <a:latin typeface="Arial"/>
+                        </a:rPr>
+                        <a:t>—</a:t>
+                      </a:r>
+                    </a:p>
+                  </a:txBody>
+                  <a:tcPr marL="64008" marR="64008" marT="27432" marB="27432">
+                    <a:solidFill>
+                      <a:srgbClr val="FFFFFF"/>
+                    </a:solidFill>
+                  </a:tcPr>
+                </a:tc>
+                <a:tc>
+                  <a:txBody>
+                    <a:bodyPr wrap="square"/>
+                    <a:lstStyle/>
+                    <a:p>
+                      <a:r>
+                        <a:rPr sz="950" b="0">
+                          <a:solidFill>
+                            <a:srgbClr val="111111"/>
+                          </a:solidFill>
+                          <a:latin typeface="Arial"/>
+                        </a:rPr>
+                        <a:t>Timed check is the planned path</a:t>
+                      </a:r>
+                    </a:p>
+                  </a:txBody>
+                  <a:tcPr marL="64008" marR="64008" marT="27432" marB="27432">
+                    <a:solidFill>
+                      <a:srgbClr val="FFFFFF"/>
+                    </a:solidFill>
+                  </a:tcPr>
+                </a:tc>
+              </a:tr>
+              <a:tr h="426720">
+                <a:tc>
+                  <a:txBody>
+                    <a:bodyPr wrap="square"/>
+                    <a:lstStyle/>
+                    <a:p>
+                      <a:r>
+                        <a:rPr sz="950" b="1">
+                          <a:solidFill>
+                            <a:srgbClr val="111111"/>
+                          </a:solidFill>
+                          <a:latin typeface="Arial"/>
+                        </a:rPr>
+                        <a:t>Job financial summary</a:t>
+                      </a:r>
+                    </a:p>
+                  </a:txBody>
+                  <a:tcPr marL="64008" marR="64008" marT="27432" marB="27432">
+                    <a:solidFill>
+                      <a:srgbClr val="FFFFFF"/>
+                    </a:solidFill>
+                  </a:tcPr>
+                </a:tc>
+                <a:tc>
+                  <a:txBody>
+                    <a:bodyPr wrap="square"/>
+                    <a:lstStyle/>
+                    <a:p>
+                      <a:r>
+                        <a:rPr sz="950" b="0">
+                          <a:solidFill>
+                            <a:srgbClr val="111111"/>
+                          </a:solidFill>
+                          <a:latin typeface="Arial"/>
+                        </a:rPr>
+                        <a:t>— no binding of its own</a:t>
+                      </a:r>
+                    </a:p>
+                  </a:txBody>
+                  <a:tcPr marL="64008" marR="64008" marT="27432" marB="27432">
+                    <a:solidFill>
+                      <a:srgbClr val="FFFFFF"/>
+                    </a:solidFill>
+                  </a:tcPr>
+                </a:tc>
+                <a:tc>
+                  <a:txBody>
+                    <a:bodyPr wrap="square"/>
+                    <a:lstStyle/>
+                    <a:p>
+                      <a:r>
+                        <a:rPr sz="950" b="0">
+                          <a:solidFill>
+                            <a:srgbClr val="111111"/>
+                          </a:solidFill>
+                          <a:latin typeface="Arial"/>
+                        </a:rPr>
+                        <a:t>—</a:t>
+                      </a:r>
+                    </a:p>
+                  </a:txBody>
+                  <a:tcPr marL="64008" marR="64008" marT="27432" marB="27432">
+                    <a:solidFill>
+                      <a:srgbClr val="FFFFFF"/>
+                    </a:solidFill>
+                  </a:tcPr>
+                </a:tc>
+                <a:tc>
+                  <a:txBody>
+                    <a:bodyPr wrap="square"/>
+                    <a:lstStyle/>
+                    <a:p>
+                      <a:r>
+                        <a:rPr sz="950" b="0">
+                          <a:solidFill>
+                            <a:srgbClr val="111111"/>
+                          </a:solidFill>
+                          <a:latin typeface="Arial"/>
+                        </a:rPr>
+                        <a:t>Derived data set: built from Enterprise Project + journal entry reads on the timed check — no single S/4 object to bind</a:t>
+                      </a:r>
+                    </a:p>
+                  </a:txBody>
+                  <a:tcPr marL="64008" marR="64008" marT="27432" marB="27432">
+                    <a:solidFill>
+                      <a:srgbClr val="FFFFFF"/>
+                    </a:solidFill>
+                  </a:tcPr>
+                </a:tc>
+              </a:tr>
+            </a:tbl>
+          </a:graphicData>
+        </a:graphic>
+      </p:graphicFrame>
+      <p:sp>
+        <p:nvSpPr>
+          <p:cNvPr id="10" name="TextBox 9"/>
+          <p:cNvSpPr txBox="1"/>
+          <p:nvPr/>
+        </p:nvSpPr>
+        <p:spPr>
+          <a:xfrm>
+            <a:off x="640080" y="8458200"/>
+            <a:ext cx="17007840" cy="365760"/>
+          </a:xfrm>
+          <a:prstGeom prst="rect">
+            <a:avLst/>
+          </a:prstGeom>
+          <a:noFill/>
+        </p:spPr>
+        <p:txBody>
+          <a:bodyPr wrap="square" lIns="0" rIns="0" tIns="0" bIns="0">
+            <a:spAutoFit/>
+          </a:bodyPr>
+          <a:lstStyle/>
+          <a:p>
+            <a:r>
+              <a:rPr sz="1100" b="0">
+                <a:solidFill>
+                  <a:srgbClr val="595959"/>
+                </a:solidFill>
+                <a:latin typeface="Arial"/>
+              </a:rPr>
+              <a:t>The object-type list in the binding dialog (183 entries in our tenant) is the final authority on names. Any data set without a usable event stays on the timed check — no data set is at risk either way.</a:t>
             </a:r>
           </a:p>
         </p:txBody>

</xml_diff>